<commit_message>
feat: slides, completed node algorithms
</commit_message>
<xml_diff>
--- a/presentation.pptx
+++ b/presentation.pptx
@@ -9,6 +9,11 @@
     <p:sldId id="257" r:id="rId3"/>
     <p:sldId id="258" r:id="rId4"/>
     <p:sldId id="259" r:id="rId5"/>
+    <p:sldId id="260" r:id="rId6"/>
+    <p:sldId id="261" r:id="rId7"/>
+    <p:sldId id="262" r:id="rId8"/>
+    <p:sldId id="263" r:id="rId9"/>
+    <p:sldId id="264" r:id="rId10"/>
   </p:sldIdLst>
   <p:sldSz cx="12192000" cy="6858000"/>
   <p:notesSz cx="6858000" cy="9144000"/>
@@ -107,6 +112,11 @@
       </a:defRPr>
     </a:lvl9pPr>
   </p:defaultTextStyle>
+  <p:extLst>
+    <p:ext uri="{EFAFB233-063F-42B5-8137-9DF3F51BA10A}">
+      <p15:sldGuideLst xmlns:p15="http://schemas.microsoft.com/office/powerpoint/2012/main"/>
+    </p:ext>
+  </p:extLst>
 </p:presentation>
 </file>
 
@@ -336,7 +346,7 @@
           <a:p>
             <a:fld id="{1CDE5452-170D-44D1-B161-4C3EAA4B8855}" type="datetimeFigureOut">
               <a:rPr lang="it-IT" smtClean="0"/>
-              <a:t>02/09/2025</a:t>
+              <a:t>03/09/2025</a:t>
             </a:fld>
             <a:endParaRPr lang="it-IT"/>
           </a:p>
@@ -544,7 +554,7 @@
           <a:p>
             <a:fld id="{1CDE5452-170D-44D1-B161-4C3EAA4B8855}" type="datetimeFigureOut">
               <a:rPr lang="it-IT" smtClean="0"/>
-              <a:t>02/09/2025</a:t>
+              <a:t>03/09/2025</a:t>
             </a:fld>
             <a:endParaRPr lang="it-IT"/>
           </a:p>
@@ -800,7 +810,7 @@
           <a:p>
             <a:fld id="{1CDE5452-170D-44D1-B161-4C3EAA4B8855}" type="datetimeFigureOut">
               <a:rPr lang="it-IT" smtClean="0"/>
-              <a:t>02/09/2025</a:t>
+              <a:t>03/09/2025</a:t>
             </a:fld>
             <a:endParaRPr lang="it-IT"/>
           </a:p>
@@ -974,7 +984,7 @@
           <a:p>
             <a:fld id="{1CDE5452-170D-44D1-B161-4C3EAA4B8855}" type="datetimeFigureOut">
               <a:rPr lang="it-IT" smtClean="0"/>
-              <a:t>02/09/2025</a:t>
+              <a:t>03/09/2025</a:t>
             </a:fld>
             <a:endParaRPr lang="it-IT"/>
           </a:p>
@@ -1317,7 +1327,7 @@
           <a:p>
             <a:fld id="{1CDE5452-170D-44D1-B161-4C3EAA4B8855}" type="datetimeFigureOut">
               <a:rPr lang="it-IT" smtClean="0"/>
-              <a:t>02/09/2025</a:t>
+              <a:t>03/09/2025</a:t>
             </a:fld>
             <a:endParaRPr lang="it-IT"/>
           </a:p>
@@ -1592,7 +1602,7 @@
           <a:p>
             <a:fld id="{1CDE5452-170D-44D1-B161-4C3EAA4B8855}" type="datetimeFigureOut">
               <a:rPr lang="it-IT" smtClean="0"/>
-              <a:t>02/09/2025</a:t>
+              <a:t>03/09/2025</a:t>
             </a:fld>
             <a:endParaRPr lang="it-IT"/>
           </a:p>
@@ -1971,7 +1981,7 @@
           <a:p>
             <a:fld id="{1CDE5452-170D-44D1-B161-4C3EAA4B8855}" type="datetimeFigureOut">
               <a:rPr lang="it-IT" smtClean="0"/>
-              <a:t>02/09/2025</a:t>
+              <a:t>03/09/2025</a:t>
             </a:fld>
             <a:endParaRPr lang="it-IT"/>
           </a:p>
@@ -2089,7 +2099,7 @@
           <a:p>
             <a:fld id="{1CDE5452-170D-44D1-B161-4C3EAA4B8855}" type="datetimeFigureOut">
               <a:rPr lang="it-IT" smtClean="0"/>
-              <a:t>02/09/2025</a:t>
+              <a:t>03/09/2025</a:t>
             </a:fld>
             <a:endParaRPr lang="it-IT"/>
           </a:p>
@@ -2260,7 +2270,7 @@
           <a:p>
             <a:fld id="{1CDE5452-170D-44D1-B161-4C3EAA4B8855}" type="datetimeFigureOut">
               <a:rPr lang="it-IT" smtClean="0"/>
-              <a:t>02/09/2025</a:t>
+              <a:t>03/09/2025</a:t>
             </a:fld>
             <a:endParaRPr lang="it-IT"/>
           </a:p>
@@ -2614,7 +2624,7 @@
           <a:p>
             <a:fld id="{1CDE5452-170D-44D1-B161-4C3EAA4B8855}" type="datetimeFigureOut">
               <a:rPr lang="it-IT" smtClean="0"/>
-              <a:t>02/09/2025</a:t>
+              <a:t>03/09/2025</a:t>
             </a:fld>
             <a:endParaRPr lang="it-IT"/>
           </a:p>
@@ -2996,7 +3006,7 @@
           <a:p>
             <a:fld id="{1CDE5452-170D-44D1-B161-4C3EAA4B8855}" type="datetimeFigureOut">
               <a:rPr lang="it-IT" smtClean="0"/>
-              <a:t>02/09/2025</a:t>
+              <a:t>03/09/2025</a:t>
             </a:fld>
             <a:endParaRPr lang="it-IT"/>
           </a:p>
@@ -3283,7 +3293,7 @@
           <a:p>
             <a:fld id="{1CDE5452-170D-44D1-B161-4C3EAA4B8855}" type="datetimeFigureOut">
               <a:rPr lang="it-IT" smtClean="0"/>
-              <a:t>02/09/2025</a:t>
+              <a:t>03/09/2025</a:t>
             </a:fld>
             <a:endParaRPr lang="it-IT"/>
           </a:p>
@@ -4713,6 +4723,2114 @@
 </p:sld>
 </file>
 
+<file path=ppt/slides/slide5.xml><?xml version="1.0" encoding="utf-8"?>
+<p:sld xmlns:a="http://schemas.openxmlformats.org/drawingml/2006/main" xmlns:r="http://schemas.openxmlformats.org/officeDocument/2006/relationships" xmlns:p="http://schemas.openxmlformats.org/presentationml/2006/main">
+  <p:cSld>
+    <p:spTree>
+      <p:nvGrpSpPr>
+        <p:cNvPr id="1" name=""/>
+        <p:cNvGrpSpPr/>
+        <p:nvPr/>
+      </p:nvGrpSpPr>
+      <p:grpSpPr>
+        <a:xfrm>
+          <a:off x="0" y="0"/>
+          <a:ext cx="0" cy="0"/>
+          <a:chOff x="0" y="0"/>
+          <a:chExt cx="0" cy="0"/>
+        </a:xfrm>
+      </p:grpSpPr>
+      <p:sp>
+        <p:nvSpPr>
+          <p:cNvPr id="2" name="Title 1">
+            <a:extLst>
+              <a:ext uri="{FF2B5EF4-FFF2-40B4-BE49-F238E27FC236}">
+                <a16:creationId xmlns:a16="http://schemas.microsoft.com/office/drawing/2014/main" id="{931914BA-ED00-CA01-C357-71913C967E2C}"/>
+              </a:ext>
+            </a:extLst>
+          </p:cNvPr>
+          <p:cNvSpPr>
+            <a:spLocks noGrp="1"/>
+          </p:cNvSpPr>
+          <p:nvPr>
+            <p:ph type="title"/>
+          </p:nvPr>
+        </p:nvSpPr>
+        <p:spPr/>
+        <p:txBody>
+          <a:bodyPr/>
+          <a:lstStyle/>
+          <a:p>
+            <a:r>
+              <a:rPr lang="it-IT" dirty="0" err="1"/>
+              <a:t>Parallel</a:t>
+            </a:r>
+            <a:r>
+              <a:rPr lang="it-IT" dirty="0"/>
+              <a:t> (C++) </a:t>
+            </a:r>
+            <a:r>
+              <a:rPr lang="it-IT" dirty="0" err="1"/>
+              <a:t>Forward</a:t>
+            </a:r>
+            <a:r>
+              <a:rPr lang="it-IT" dirty="0"/>
+              <a:t> </a:t>
+            </a:r>
+            <a:r>
+              <a:rPr lang="it-IT" dirty="0" err="1"/>
+              <a:t>Node</a:t>
+            </a:r>
+            <a:r>
+              <a:rPr lang="it-IT" dirty="0"/>
+              <a:t> </a:t>
+            </a:r>
+            <a:r>
+              <a:rPr lang="it-IT" dirty="0" err="1"/>
+              <a:t>Iteator</a:t>
+            </a:r>
+            <a:r>
+              <a:rPr lang="it-IT" dirty="0"/>
+              <a:t> </a:t>
+            </a:r>
+            <a:r>
+              <a:rPr lang="it-IT" dirty="0" err="1"/>
+              <a:t>Algorithm</a:t>
+            </a:r>
+            <a:r>
+              <a:rPr lang="it-IT" dirty="0"/>
+              <a:t>, V1 </a:t>
+            </a:r>
+          </a:p>
+        </p:txBody>
+      </p:sp>
+      <p:sp>
+        <p:nvSpPr>
+          <p:cNvPr id="9" name="TextBox 8">
+            <a:extLst>
+              <a:ext uri="{FF2B5EF4-FFF2-40B4-BE49-F238E27FC236}">
+                <a16:creationId xmlns:a16="http://schemas.microsoft.com/office/drawing/2014/main" id="{D423A440-85F6-8044-AE8E-B609EF2295F1}"/>
+              </a:ext>
+            </a:extLst>
+          </p:cNvPr>
+          <p:cNvSpPr txBox="1"/>
+          <p:nvPr/>
+        </p:nvSpPr>
+        <p:spPr>
+          <a:xfrm>
+            <a:off x="1097280" y="1871065"/>
+            <a:ext cx="10058400" cy="1477328"/>
+          </a:xfrm>
+          <a:prstGeom prst="rect">
+            <a:avLst/>
+          </a:prstGeom>
+          <a:noFill/>
+        </p:spPr>
+        <p:txBody>
+          <a:bodyPr wrap="square">
+            <a:spAutoFit/>
+          </a:bodyPr>
+          <a:lstStyle/>
+          <a:p>
+            <a:pPr marL="285750" indent="-285750" algn="just">
+              <a:buFont typeface="Arial" panose="020B0604020202020204" pitchFamily="34" charset="0"/>
+              <a:buChar char="•"/>
+            </a:pPr>
+            <a:r>
+              <a:rPr lang="it-IT" dirty="0"/>
+              <a:t>In the </a:t>
+            </a:r>
+            <a:r>
+              <a:rPr lang="it-IT" b="1" dirty="0"/>
+              <a:t>first </a:t>
+            </a:r>
+            <a:r>
+              <a:rPr lang="it-IT" b="1" dirty="0" err="1"/>
+              <a:t>version</a:t>
+            </a:r>
+            <a:r>
+              <a:rPr lang="it-IT" b="1" dirty="0"/>
+              <a:t> </a:t>
+            </a:r>
+            <a:r>
+              <a:rPr lang="it-IT" dirty="0"/>
+              <a:t>of the </a:t>
+            </a:r>
+            <a:r>
+              <a:rPr lang="it-IT" dirty="0" err="1"/>
+              <a:t>algorithm</a:t>
+            </a:r>
+            <a:r>
+              <a:rPr lang="it-IT" dirty="0"/>
+              <a:t>, more </a:t>
+            </a:r>
+            <a:r>
+              <a:rPr lang="it-IT" dirty="0" err="1"/>
+              <a:t>naive</a:t>
+            </a:r>
+            <a:r>
+              <a:rPr lang="it-IT" dirty="0"/>
+              <a:t> and </a:t>
+            </a:r>
+            <a:r>
+              <a:rPr lang="it-IT" dirty="0" err="1"/>
+              <a:t>simple</a:t>
+            </a:r>
+            <a:r>
+              <a:rPr lang="it-IT" dirty="0"/>
+              <a:t> case, the part </a:t>
+            </a:r>
+            <a:r>
+              <a:rPr lang="it-IT" dirty="0" err="1"/>
+              <a:t>that</a:t>
+            </a:r>
+            <a:r>
+              <a:rPr lang="it-IT" dirty="0"/>
+              <a:t> </a:t>
+            </a:r>
+            <a:r>
+              <a:rPr lang="it-IT" dirty="0" err="1"/>
+              <a:t>gets</a:t>
+            </a:r>
+            <a:r>
+              <a:rPr lang="it-IT" dirty="0"/>
+              <a:t> </a:t>
+            </a:r>
+            <a:r>
+              <a:rPr lang="it-IT" dirty="0" err="1"/>
+              <a:t>parallelized</a:t>
+            </a:r>
+            <a:r>
+              <a:rPr lang="it-IT" dirty="0"/>
+              <a:t> </a:t>
+            </a:r>
+            <a:r>
+              <a:rPr lang="it-IT" dirty="0" err="1"/>
+              <a:t>is</a:t>
+            </a:r>
+            <a:r>
+              <a:rPr lang="it-IT" dirty="0"/>
+              <a:t> the For-</a:t>
+            </a:r>
+            <a:r>
+              <a:rPr lang="it-IT" dirty="0" err="1"/>
+              <a:t>ward</a:t>
+            </a:r>
+            <a:r>
+              <a:rPr lang="it-IT" dirty="0"/>
+              <a:t> </a:t>
+            </a:r>
+            <a:r>
+              <a:rPr lang="it-IT" dirty="0" err="1"/>
+              <a:t>algorithm</a:t>
+            </a:r>
+            <a:r>
+              <a:rPr lang="it-IT" dirty="0"/>
+              <a:t> </a:t>
+            </a:r>
+            <a:r>
+              <a:rPr lang="it-IT" dirty="0" err="1"/>
+              <a:t>function</a:t>
+            </a:r>
+            <a:r>
+              <a:rPr lang="it-IT" dirty="0"/>
+              <a:t>. More in </a:t>
+            </a:r>
+            <a:r>
+              <a:rPr lang="it-IT" dirty="0" err="1"/>
+              <a:t>detail</a:t>
+            </a:r>
+            <a:r>
+              <a:rPr lang="it-IT" dirty="0"/>
+              <a:t>, the </a:t>
+            </a:r>
+            <a:r>
+              <a:rPr lang="it-IT" dirty="0" err="1"/>
+              <a:t>outer</a:t>
+            </a:r>
+            <a:r>
+              <a:rPr lang="it-IT" dirty="0"/>
+              <a:t> </a:t>
+            </a:r>
+            <a:r>
+              <a:rPr lang="it-IT" dirty="0" err="1"/>
+              <a:t>loopthat</a:t>
+            </a:r>
+            <a:r>
+              <a:rPr lang="it-IT" dirty="0"/>
+              <a:t> </a:t>
+            </a:r>
+            <a:r>
+              <a:rPr lang="it-IT" dirty="0" err="1"/>
+              <a:t>iterates</a:t>
+            </a:r>
+            <a:r>
+              <a:rPr lang="it-IT" dirty="0"/>
+              <a:t> </a:t>
+            </a:r>
+            <a:r>
+              <a:rPr lang="it-IT" dirty="0" err="1"/>
+              <a:t>through</a:t>
+            </a:r>
+            <a:r>
+              <a:rPr lang="it-IT" dirty="0"/>
+              <a:t> the </a:t>
+            </a:r>
+            <a:r>
+              <a:rPr lang="it-IT" dirty="0" err="1"/>
+              <a:t>nodes</a:t>
+            </a:r>
+            <a:r>
+              <a:rPr lang="it-IT" dirty="0"/>
+              <a:t> in the </a:t>
+            </a:r>
+            <a:r>
+              <a:rPr lang="it-IT" dirty="0" err="1"/>
+              <a:t>ordered</a:t>
+            </a:r>
+            <a:r>
+              <a:rPr lang="it-IT" dirty="0"/>
+              <a:t> list </a:t>
+            </a:r>
+            <a:r>
+              <a:rPr lang="it-IT" dirty="0" err="1"/>
+              <a:t>is</a:t>
+            </a:r>
+            <a:r>
+              <a:rPr lang="it-IT" dirty="0"/>
+              <a:t> </a:t>
+            </a:r>
+            <a:r>
+              <a:rPr lang="it-IT" dirty="0" err="1"/>
+              <a:t>still</a:t>
+            </a:r>
+            <a:r>
+              <a:rPr lang="it-IT" dirty="0"/>
+              <a:t> </a:t>
+            </a:r>
+            <a:r>
+              <a:rPr lang="it-IT" dirty="0" err="1"/>
+              <a:t>sequential</a:t>
+            </a:r>
+            <a:r>
+              <a:rPr lang="it-IT" dirty="0"/>
+              <a:t>, running N times, </a:t>
+            </a:r>
+            <a:r>
+              <a:rPr lang="it-IT" dirty="0" err="1"/>
+              <a:t>but</a:t>
+            </a:r>
+            <a:r>
+              <a:rPr lang="it-IT" dirty="0"/>
+              <a:t> the </a:t>
+            </a:r>
+            <a:r>
+              <a:rPr lang="it-IT" dirty="0" err="1"/>
+              <a:t>iteration</a:t>
+            </a:r>
+            <a:r>
+              <a:rPr lang="it-IT" dirty="0"/>
+              <a:t> </a:t>
+            </a:r>
+            <a:r>
+              <a:rPr lang="it-IT" dirty="0" err="1"/>
+              <a:t>overeach</a:t>
+            </a:r>
+            <a:r>
+              <a:rPr lang="it-IT" dirty="0"/>
+              <a:t> </a:t>
+            </a:r>
+            <a:r>
+              <a:rPr lang="it-IT" dirty="0" err="1"/>
+              <a:t>node</a:t>
+            </a:r>
+            <a:r>
+              <a:rPr lang="it-IT" dirty="0"/>
+              <a:t> </a:t>
+            </a:r>
+            <a:r>
+              <a:rPr lang="it-IT" dirty="0" err="1"/>
+              <a:t>neighbors</a:t>
+            </a:r>
+            <a:r>
+              <a:rPr lang="it-IT" dirty="0"/>
+              <a:t> t </a:t>
+            </a:r>
+            <a:r>
+              <a:rPr lang="it-IT" dirty="0" err="1"/>
+              <a:t>is</a:t>
+            </a:r>
+            <a:r>
+              <a:rPr lang="it-IT" dirty="0"/>
+              <a:t> </a:t>
+            </a:r>
+            <a:r>
+              <a:rPr lang="it-IT" dirty="0" err="1"/>
+              <a:t>parallelized</a:t>
+            </a:r>
+            <a:r>
+              <a:rPr lang="it-IT" dirty="0"/>
+              <a:t>: </a:t>
+            </a:r>
+            <a:r>
+              <a:rPr lang="it-IT" dirty="0" err="1"/>
+              <a:t>this</a:t>
+            </a:r>
+            <a:r>
+              <a:rPr lang="it-IT" dirty="0"/>
+              <a:t> </a:t>
+            </a:r>
+            <a:r>
+              <a:rPr lang="it-IT" dirty="0" err="1"/>
+              <a:t>is</a:t>
+            </a:r>
+            <a:r>
+              <a:rPr lang="it-IT" dirty="0"/>
+              <a:t> </a:t>
+            </a:r>
+            <a:r>
+              <a:rPr lang="it-IT" dirty="0" err="1"/>
+              <a:t>achievedby</a:t>
+            </a:r>
+            <a:r>
+              <a:rPr lang="it-IT" dirty="0"/>
+              <a:t> </a:t>
+            </a:r>
+            <a:r>
+              <a:rPr lang="it-IT" dirty="0" err="1"/>
+              <a:t>dividing</a:t>
+            </a:r>
+            <a:r>
+              <a:rPr lang="it-IT" dirty="0"/>
+              <a:t> the </a:t>
+            </a:r>
+            <a:r>
+              <a:rPr lang="it-IT" dirty="0" err="1"/>
+              <a:t>neighbors</a:t>
+            </a:r>
+            <a:r>
+              <a:rPr lang="it-IT" dirty="0"/>
+              <a:t> of s </a:t>
+            </a:r>
+            <a:r>
+              <a:rPr lang="it-IT" dirty="0" err="1"/>
+              <a:t>into</a:t>
+            </a:r>
+            <a:r>
+              <a:rPr lang="it-IT" dirty="0"/>
+              <a:t> </a:t>
+            </a:r>
+            <a:r>
+              <a:rPr lang="it-IT" dirty="0" err="1"/>
+              <a:t>chunks</a:t>
+            </a:r>
+            <a:r>
+              <a:rPr lang="it-IT" dirty="0"/>
+              <a:t>, with </a:t>
+            </a:r>
+            <a:r>
+              <a:rPr lang="it-IT" dirty="0" err="1"/>
+              <a:t>eachchunk</a:t>
+            </a:r>
+            <a:r>
+              <a:rPr lang="it-IT" dirty="0"/>
+              <a:t> </a:t>
+            </a:r>
+            <a:r>
+              <a:rPr lang="it-IT" dirty="0" err="1"/>
+              <a:t>processed</a:t>
+            </a:r>
+            <a:r>
+              <a:rPr lang="it-IT" dirty="0"/>
+              <a:t> by a separate worker </a:t>
+            </a:r>
+            <a:r>
+              <a:rPr lang="it-IT" dirty="0" err="1"/>
+              <a:t>thread</a:t>
+            </a:r>
+            <a:r>
+              <a:rPr lang="it-IT" dirty="0"/>
+              <a:t> </a:t>
+            </a:r>
+            <a:r>
+              <a:rPr lang="it-IT" dirty="0" err="1"/>
+              <a:t>usingstd</a:t>
+            </a:r>
+            <a:r>
+              <a:rPr lang="it-IT" dirty="0"/>
+              <a:t>::</a:t>
+            </a:r>
+            <a:r>
+              <a:rPr lang="it-IT" dirty="0" err="1"/>
+              <a:t>async</a:t>
+            </a:r>
+            <a:r>
+              <a:rPr lang="it-IT" dirty="0"/>
+              <a:t>.</a:t>
+            </a:r>
+          </a:p>
+        </p:txBody>
+      </p:sp>
+      <p:pic>
+        <p:nvPicPr>
+          <p:cNvPr id="11" name="Picture 10" descr="A graph with a red line&#10;&#10;AI-generated content may be incorrect.">
+            <a:extLst>
+              <a:ext uri="{FF2B5EF4-FFF2-40B4-BE49-F238E27FC236}">
+                <a16:creationId xmlns:a16="http://schemas.microsoft.com/office/drawing/2014/main" id="{98F45AF1-7912-F0C6-6274-6F37E95F7465}"/>
+              </a:ext>
+            </a:extLst>
+          </p:cNvPr>
+          <p:cNvPicPr>
+            <a:picLocks noChangeAspect="1"/>
+          </p:cNvPicPr>
+          <p:nvPr/>
+        </p:nvPicPr>
+        <p:blipFill>
+          <a:blip r:embed="rId2">
+            <a:extLst>
+              <a:ext uri="{28A0092B-C50C-407E-A947-70E740481C1C}">
+                <a14:useLocalDpi xmlns:a14="http://schemas.microsoft.com/office/drawing/2010/main" val="0"/>
+              </a:ext>
+            </a:extLst>
+          </a:blip>
+          <a:stretch>
+            <a:fillRect/>
+          </a:stretch>
+        </p:blipFill>
+        <p:spPr>
+          <a:xfrm>
+            <a:off x="158697" y="3056934"/>
+            <a:ext cx="5552638" cy="3331583"/>
+          </a:xfrm>
+          <a:prstGeom prst="rect">
+            <a:avLst/>
+          </a:prstGeom>
+        </p:spPr>
+      </p:pic>
+      <p:sp>
+        <p:nvSpPr>
+          <p:cNvPr id="13" name="TextBox 12">
+            <a:extLst>
+              <a:ext uri="{FF2B5EF4-FFF2-40B4-BE49-F238E27FC236}">
+                <a16:creationId xmlns:a16="http://schemas.microsoft.com/office/drawing/2014/main" id="{CAB8F91C-5989-43B7-00E6-413A7520DC4E}"/>
+              </a:ext>
+            </a:extLst>
+          </p:cNvPr>
+          <p:cNvSpPr txBox="1"/>
+          <p:nvPr/>
+        </p:nvSpPr>
+        <p:spPr>
+          <a:xfrm>
+            <a:off x="5547360" y="3701479"/>
+            <a:ext cx="6096000" cy="1754326"/>
+          </a:xfrm>
+          <a:prstGeom prst="rect">
+            <a:avLst/>
+          </a:prstGeom>
+          <a:noFill/>
+        </p:spPr>
+        <p:txBody>
+          <a:bodyPr wrap="square">
+            <a:spAutoFit/>
+          </a:bodyPr>
+          <a:lstStyle/>
+          <a:p>
+            <a:r>
+              <a:rPr lang="en-US" dirty="0"/>
+              <a:t>Using multiple threads with mutexes to operate on shared data is often counterproductive. The </a:t>
+            </a:r>
+            <a:r>
+              <a:rPr lang="en-US" b="1" dirty="0"/>
+              <a:t>mutexes</a:t>
+            </a:r>
+            <a:r>
+              <a:rPr lang="en-US" dirty="0"/>
+              <a:t> force the operations to run </a:t>
+            </a:r>
+            <a:r>
+              <a:rPr lang="en-US" b="1" dirty="0"/>
+              <a:t>one after another</a:t>
+            </a:r>
+            <a:r>
+              <a:rPr lang="en-US" dirty="0"/>
+              <a:t> (serially), which eliminates the speed advantage of using parallel threads. Also, the process of creating and managing the threads adds its own </a:t>
+            </a:r>
+            <a:r>
+              <a:rPr lang="en-US" b="1" dirty="0"/>
+              <a:t>computational overhead</a:t>
+            </a:r>
+            <a:r>
+              <a:rPr lang="en-US" dirty="0"/>
+              <a:t>, further slowing down the entire process.</a:t>
+            </a:r>
+            <a:endParaRPr lang="it-IT" dirty="0"/>
+          </a:p>
+        </p:txBody>
+      </p:sp>
+    </p:spTree>
+    <p:extLst>
+      <p:ext uri="{BB962C8B-B14F-4D97-AF65-F5344CB8AC3E}">
+        <p14:creationId xmlns:p14="http://schemas.microsoft.com/office/powerpoint/2010/main" val="1768031576"/>
+      </p:ext>
+    </p:extLst>
+  </p:cSld>
+  <p:clrMapOvr>
+    <a:masterClrMapping/>
+  </p:clrMapOvr>
+</p:sld>
+</file>
+
+<file path=ppt/slides/slide6.xml><?xml version="1.0" encoding="utf-8"?>
+<p:sld xmlns:a="http://schemas.openxmlformats.org/drawingml/2006/main" xmlns:r="http://schemas.openxmlformats.org/officeDocument/2006/relationships" xmlns:p="http://schemas.openxmlformats.org/presentationml/2006/main">
+  <p:cSld>
+    <p:bg>
+      <p:bgPr>
+        <a:solidFill>
+          <a:schemeClr val="bg1"/>
+        </a:solidFill>
+        <a:effectLst/>
+      </p:bgPr>
+    </p:bg>
+    <p:spTree>
+      <p:nvGrpSpPr>
+        <p:cNvPr id="1" name=""/>
+        <p:cNvGrpSpPr/>
+        <p:nvPr/>
+      </p:nvGrpSpPr>
+      <p:grpSpPr>
+        <a:xfrm>
+          <a:off x="0" y="0"/>
+          <a:ext cx="0" cy="0"/>
+          <a:chOff x="0" y="0"/>
+          <a:chExt cx="0" cy="0"/>
+        </a:xfrm>
+      </p:grpSpPr>
+      <p:sp useBgFill="1">
+        <p:nvSpPr>
+          <p:cNvPr id="25" name="Rectangle 24">
+            <a:extLst>
+              <a:ext uri="{FF2B5EF4-FFF2-40B4-BE49-F238E27FC236}">
+                <a16:creationId xmlns:a16="http://schemas.microsoft.com/office/drawing/2014/main" id="{699373FF-C78A-430B-A246-6048999CE98D}"/>
+              </a:ext>
+              <a:ext uri="{C183D7F6-B498-43B3-948B-1728B52AA6E4}">
+                <adec:decorative xmlns:adec="http://schemas.microsoft.com/office/drawing/2017/decorative" val="1"/>
+              </a:ext>
+            </a:extLst>
+          </p:cNvPr>
+          <p:cNvSpPr>
+            <a:spLocks noGrp="1" noRot="1" noChangeAspect="1" noMove="1" noResize="1" noEditPoints="1" noAdjustHandles="1" noChangeArrowheads="1" noChangeShapeType="1" noTextEdit="1"/>
+          </p:cNvSpPr>
+          <p:nvPr>
+            <p:extLst>
+              <p:ext uri="{386F3935-93C4-4BCD-93E2-E3B085C9AB24}">
+                <p16:designElem xmlns:p16="http://schemas.microsoft.com/office/powerpoint/2015/main" val="1"/>
+              </p:ext>
+            </p:extLst>
+          </p:nvPr>
+        </p:nvSpPr>
+        <p:spPr>
+          <a:xfrm>
+            <a:off x="0" y="0"/>
+            <a:ext cx="12192001" cy="6334316"/>
+          </a:xfrm>
+          <a:prstGeom prst="rect">
+            <a:avLst/>
+          </a:prstGeom>
+          <a:ln>
+            <a:noFill/>
+          </a:ln>
+        </p:spPr>
+        <p:style>
+          <a:lnRef idx="2">
+            <a:schemeClr val="accent1">
+              <a:shade val="50000"/>
+            </a:schemeClr>
+          </a:lnRef>
+          <a:fillRef idx="1">
+            <a:schemeClr val="accent1"/>
+          </a:fillRef>
+          <a:effectRef idx="0">
+            <a:schemeClr val="accent1"/>
+          </a:effectRef>
+          <a:fontRef idx="minor">
+            <a:schemeClr val="lt1"/>
+          </a:fontRef>
+        </p:style>
+        <p:txBody>
+          <a:bodyPr rtlCol="0" anchor="ctr"/>
+          <a:lstStyle/>
+          <a:p>
+            <a:pPr algn="ctr"/>
+            <a:endParaRPr lang="en-US"/>
+          </a:p>
+        </p:txBody>
+      </p:sp>
+      <p:sp>
+        <p:nvSpPr>
+          <p:cNvPr id="2" name="Title 1">
+            <a:extLst>
+              <a:ext uri="{FF2B5EF4-FFF2-40B4-BE49-F238E27FC236}">
+                <a16:creationId xmlns:a16="http://schemas.microsoft.com/office/drawing/2014/main" id="{5565E70C-B632-71E3-2389-9DADAF2FC581}"/>
+              </a:ext>
+            </a:extLst>
+          </p:cNvPr>
+          <p:cNvSpPr>
+            <a:spLocks noGrp="1"/>
+          </p:cNvSpPr>
+          <p:nvPr>
+            <p:ph type="title"/>
+          </p:nvPr>
+        </p:nvSpPr>
+        <p:spPr>
+          <a:xfrm>
+            <a:off x="4703577" y="634946"/>
+            <a:ext cx="6846166" cy="1450757"/>
+          </a:xfrm>
+        </p:spPr>
+        <p:txBody>
+          <a:bodyPr vert="horz" lIns="91440" tIns="45720" rIns="91440" bIns="45720" rtlCol="0" anchor="b">
+            <a:normAutofit/>
+          </a:bodyPr>
+          <a:lstStyle/>
+          <a:p>
+            <a:r>
+              <a:rPr lang="en-US" sz="3700"/>
+              <a:t>Parallel (C++) Forward Node Iteator Algorithm, V3 (Final Version) </a:t>
+            </a:r>
+          </a:p>
+        </p:txBody>
+      </p:sp>
+      <p:pic>
+        <p:nvPicPr>
+          <p:cNvPr id="7" name="Picture 6" descr="A graph with red line&#10;&#10;AI-generated content may be incorrect.">
+            <a:extLst>
+              <a:ext uri="{FF2B5EF4-FFF2-40B4-BE49-F238E27FC236}">
+                <a16:creationId xmlns:a16="http://schemas.microsoft.com/office/drawing/2014/main" id="{EA625617-54C3-AE89-CC78-657C003937C1}"/>
+              </a:ext>
+            </a:extLst>
+          </p:cNvPr>
+          <p:cNvPicPr>
+            <a:picLocks noChangeAspect="1"/>
+          </p:cNvPicPr>
+          <p:nvPr/>
+        </p:nvPicPr>
+        <p:blipFill>
+          <a:blip r:embed="rId2">
+            <a:extLst>
+              <a:ext uri="{28A0092B-C50C-407E-A947-70E740481C1C}">
+                <a14:useLocalDpi xmlns:a14="http://schemas.microsoft.com/office/drawing/2010/main" val="0"/>
+              </a:ext>
+            </a:extLst>
+          </a:blip>
+          <a:srcRect r="2581" b="-2"/>
+          <a:stretch>
+            <a:fillRect/>
+          </a:stretch>
+        </p:blipFill>
+        <p:spPr>
+          <a:xfrm>
+            <a:off x="532698" y="-51247"/>
+            <a:ext cx="3638181" cy="2240786"/>
+          </a:xfrm>
+          <a:prstGeom prst="rect">
+            <a:avLst/>
+          </a:prstGeom>
+        </p:spPr>
+      </p:pic>
+      <p:cxnSp>
+        <p:nvCxnSpPr>
+          <p:cNvPr id="27" name="Straight Connector 26">
+            <a:extLst>
+              <a:ext uri="{FF2B5EF4-FFF2-40B4-BE49-F238E27FC236}">
+                <a16:creationId xmlns:a16="http://schemas.microsoft.com/office/drawing/2014/main" id="{03EBB925-FEC3-4CD5-9271-3D75EBB53262}"/>
+              </a:ext>
+              <a:ext uri="{C183D7F6-B498-43B3-948B-1728B52AA6E4}">
+                <adec:decorative xmlns:adec="http://schemas.microsoft.com/office/drawing/2017/decorative" val="1"/>
+              </a:ext>
+            </a:extLst>
+          </p:cNvPr>
+          <p:cNvCxnSpPr>
+            <a:cxnSpLocks noGrp="1" noRot="1" noChangeAspect="1" noMove="1" noResize="1" noEditPoints="1" noAdjustHandles="1" noChangeArrowheads="1" noChangeShapeType="1"/>
+          </p:cNvCxnSpPr>
+          <p:nvPr>
+            <p:extLst>
+              <p:ext uri="{386F3935-93C4-4BCD-93E2-E3B085C9AB24}">
+                <p16:designElem xmlns:p16="http://schemas.microsoft.com/office/powerpoint/2015/main" val="1"/>
+              </p:ext>
+            </p:extLst>
+          </p:nvPr>
+        </p:nvCxnSpPr>
+        <p:spPr>
+          <a:xfrm>
+            <a:off x="4809772" y="2086188"/>
+            <a:ext cx="5852160" cy="0"/>
+          </a:xfrm>
+          <a:prstGeom prst="line">
+            <a:avLst/>
+          </a:prstGeom>
+          <a:ln w="6350">
+            <a:solidFill>
+              <a:schemeClr val="tx1">
+                <a:lumMod val="50000"/>
+                <a:lumOff val="50000"/>
+                <a:alpha val="90000"/>
+              </a:schemeClr>
+            </a:solidFill>
+          </a:ln>
+        </p:spPr>
+        <p:style>
+          <a:lnRef idx="1">
+            <a:schemeClr val="accent1"/>
+          </a:lnRef>
+          <a:fillRef idx="0">
+            <a:schemeClr val="accent1"/>
+          </a:fillRef>
+          <a:effectRef idx="0">
+            <a:schemeClr val="accent1"/>
+          </a:effectRef>
+          <a:fontRef idx="minor">
+            <a:schemeClr val="tx1"/>
+          </a:fontRef>
+        </p:style>
+      </p:cxnSp>
+      <p:pic>
+        <p:nvPicPr>
+          <p:cNvPr id="9" name="Picture 8" descr="A graph with red line&#10;&#10;AI-generated content may be incorrect.">
+            <a:extLst>
+              <a:ext uri="{FF2B5EF4-FFF2-40B4-BE49-F238E27FC236}">
+                <a16:creationId xmlns:a16="http://schemas.microsoft.com/office/drawing/2014/main" id="{96F2FC64-6EE6-8E72-B99C-23B132A0BB64}"/>
+              </a:ext>
+            </a:extLst>
+          </p:cNvPr>
+          <p:cNvPicPr>
+            <a:picLocks noChangeAspect="1"/>
+          </p:cNvPicPr>
+          <p:nvPr/>
+        </p:nvPicPr>
+        <p:blipFill>
+          <a:blip r:embed="rId3">
+            <a:extLst>
+              <a:ext uri="{28A0092B-C50C-407E-A947-70E740481C1C}">
+                <a14:useLocalDpi xmlns:a14="http://schemas.microsoft.com/office/drawing/2010/main" val="0"/>
+              </a:ext>
+            </a:extLst>
+          </a:blip>
+          <a:srcRect r="2581" b="-2"/>
+          <a:stretch>
+            <a:fillRect/>
+          </a:stretch>
+        </p:blipFill>
+        <p:spPr>
+          <a:xfrm>
+            <a:off x="411709" y="2085703"/>
+            <a:ext cx="3811074" cy="2347272"/>
+          </a:xfrm>
+          <a:prstGeom prst="rect">
+            <a:avLst/>
+          </a:prstGeom>
+        </p:spPr>
+      </p:pic>
+      <p:pic>
+        <p:nvPicPr>
+          <p:cNvPr id="11" name="Picture 10">
+            <a:extLst>
+              <a:ext uri="{FF2B5EF4-FFF2-40B4-BE49-F238E27FC236}">
+                <a16:creationId xmlns:a16="http://schemas.microsoft.com/office/drawing/2014/main" id="{277D03B4-6B06-C7F3-D2E9-AB3757A6FE12}"/>
+              </a:ext>
+            </a:extLst>
+          </p:cNvPr>
+          <p:cNvPicPr>
+            <a:picLocks noChangeAspect="1"/>
+          </p:cNvPicPr>
+          <p:nvPr/>
+        </p:nvPicPr>
+        <p:blipFill>
+          <a:blip r:embed="rId4"/>
+          <a:stretch>
+            <a:fillRect/>
+          </a:stretch>
+        </p:blipFill>
+        <p:spPr>
+          <a:xfrm>
+            <a:off x="467752" y="4329254"/>
+            <a:ext cx="3768071" cy="2071546"/>
+          </a:xfrm>
+          <a:prstGeom prst="rect">
+            <a:avLst/>
+          </a:prstGeom>
+        </p:spPr>
+      </p:pic>
+      <p:sp>
+        <p:nvSpPr>
+          <p:cNvPr id="5" name="TextBox 4">
+            <a:extLst>
+              <a:ext uri="{FF2B5EF4-FFF2-40B4-BE49-F238E27FC236}">
+                <a16:creationId xmlns:a16="http://schemas.microsoft.com/office/drawing/2014/main" id="{94F6EBC3-8EBF-AE84-66E9-0CC6673C19DE}"/>
+              </a:ext>
+            </a:extLst>
+          </p:cNvPr>
+          <p:cNvSpPr txBox="1"/>
+          <p:nvPr/>
+        </p:nvSpPr>
+        <p:spPr>
+          <a:xfrm>
+            <a:off x="4701747" y="2198914"/>
+            <a:ext cx="6847996" cy="3670180"/>
+          </a:xfrm>
+          <a:prstGeom prst="rect">
+            <a:avLst/>
+          </a:prstGeom>
+        </p:spPr>
+        <p:txBody>
+          <a:bodyPr vert="horz" lIns="0" tIns="45720" rIns="0" bIns="45720" rtlCol="0">
+            <a:normAutofit/>
+          </a:bodyPr>
+          <a:lstStyle/>
+          <a:p>
+            <a:pPr defTabSz="914400">
+              <a:lnSpc>
+                <a:spcPct val="90000"/>
+              </a:lnSpc>
+              <a:spcAft>
+                <a:spcPts val="600"/>
+              </a:spcAft>
+              <a:buClr>
+                <a:schemeClr val="accent1"/>
+              </a:buClr>
+              <a:buFont typeface="Calibri" panose="020F0502020204030204" pitchFamily="34" charset="0"/>
+            </a:pPr>
+            <a:r>
+              <a:rPr lang="en-US" sz="1700" dirty="0">
+                <a:solidFill>
+                  <a:schemeClr val="tx1">
+                    <a:lumMod val="75000"/>
+                    <a:lumOff val="25000"/>
+                  </a:schemeClr>
+                </a:solidFill>
+              </a:rPr>
+              <a:t>The final version of our algorithm is the most efficient and scalable. Amdahl’s Law states that the speedup of a program from parallelization is limited by the sequential fraction </a:t>
+            </a:r>
+            <a:r>
+              <a:rPr lang="en-US" sz="1700" dirty="0" err="1">
+                <a:solidFill>
+                  <a:schemeClr val="tx1">
+                    <a:lumMod val="75000"/>
+                    <a:lumOff val="25000"/>
+                  </a:schemeClr>
+                </a:solidFill>
+              </a:rPr>
+              <a:t>ofthe</a:t>
+            </a:r>
+            <a:r>
+              <a:rPr lang="en-US" sz="1700" dirty="0">
+                <a:solidFill>
+                  <a:schemeClr val="tx1">
+                    <a:lumMod val="75000"/>
+                    <a:lumOff val="25000"/>
+                  </a:schemeClr>
+                </a:solidFill>
+              </a:rPr>
+              <a:t> program. </a:t>
+            </a:r>
+            <a:r>
+              <a:rPr lang="en-US" sz="1700" b="1" dirty="0">
+                <a:solidFill>
+                  <a:schemeClr val="tx1">
+                    <a:lumMod val="75000"/>
+                    <a:lumOff val="25000"/>
+                  </a:schemeClr>
+                </a:solidFill>
+              </a:rPr>
+              <a:t>The new algorithm has a much smaller sequential fraction.</a:t>
+            </a:r>
+          </a:p>
+          <a:p>
+            <a:pPr defTabSz="914400">
+              <a:lnSpc>
+                <a:spcPct val="90000"/>
+              </a:lnSpc>
+              <a:spcAft>
+                <a:spcPts val="600"/>
+              </a:spcAft>
+              <a:buClr>
+                <a:schemeClr val="accent1"/>
+              </a:buClr>
+              <a:buFont typeface="Calibri" panose="020F0502020204030204" pitchFamily="34" charset="0"/>
+            </a:pPr>
+            <a:r>
+              <a:rPr lang="en-US" sz="1700" dirty="0">
+                <a:solidFill>
+                  <a:schemeClr val="tx1">
+                    <a:lumMod val="75000"/>
+                    <a:lumOff val="25000"/>
+                  </a:schemeClr>
+                </a:solidFill>
+              </a:rPr>
+              <a:t>We resorted to C++ std::async tasks, and </a:t>
+            </a:r>
+            <a:r>
+              <a:rPr lang="en-US" sz="1700" b="1" dirty="0">
+                <a:solidFill>
+                  <a:schemeClr val="tx1">
+                    <a:lumMod val="75000"/>
+                    <a:lumOff val="25000"/>
+                  </a:schemeClr>
+                </a:solidFill>
+              </a:rPr>
+              <a:t>thread-local counts</a:t>
+            </a:r>
+            <a:r>
+              <a:rPr lang="en-US" sz="1700" dirty="0">
+                <a:solidFill>
+                  <a:schemeClr val="tx1">
+                    <a:lumMod val="75000"/>
+                    <a:lumOff val="25000"/>
+                  </a:schemeClr>
+                </a:solidFill>
+              </a:rPr>
+              <a:t> were used to eliminate contention between them (mutexes not needed anymore). The core algorithm was also rewritten using std::</a:t>
+            </a:r>
+            <a:r>
+              <a:rPr lang="en-US" sz="1700" dirty="0" err="1">
+                <a:solidFill>
+                  <a:schemeClr val="tx1">
+                    <a:lumMod val="75000"/>
+                    <a:lumOff val="25000"/>
+                  </a:schemeClr>
+                </a:solidFill>
+              </a:rPr>
+              <a:t>unordered_set</a:t>
+            </a:r>
+            <a:r>
+              <a:rPr lang="en-US" sz="1700" dirty="0">
+                <a:solidFill>
+                  <a:schemeClr val="tx1">
+                    <a:lumMod val="75000"/>
+                    <a:lumOff val="25000"/>
+                  </a:schemeClr>
+                </a:solidFill>
+              </a:rPr>
+              <a:t>, which dramatically improved data lookup speeds from O(</a:t>
+            </a:r>
+            <a:r>
+              <a:rPr lang="en-US" sz="1700" dirty="0" err="1">
+                <a:solidFill>
+                  <a:schemeClr val="tx1">
+                    <a:lumMod val="75000"/>
+                    <a:lumOff val="25000"/>
+                  </a:schemeClr>
+                </a:solidFill>
+              </a:rPr>
+              <a:t>logN</a:t>
+            </a:r>
+            <a:r>
+              <a:rPr lang="en-US" sz="1700" dirty="0">
+                <a:solidFill>
+                  <a:schemeClr val="tx1">
+                    <a:lumMod val="75000"/>
+                    <a:lumOff val="25000"/>
+                  </a:schemeClr>
+                </a:solidFill>
+              </a:rPr>
+              <a:t>) to an average of </a:t>
+            </a:r>
+            <a:r>
+              <a:rPr lang="en-US" sz="1700" b="1" dirty="0">
+                <a:solidFill>
+                  <a:schemeClr val="tx1">
+                    <a:lumMod val="75000"/>
+                    <a:lumOff val="25000"/>
+                  </a:schemeClr>
+                </a:solidFill>
+              </a:rPr>
+              <a:t>O(1)</a:t>
+            </a:r>
+            <a:r>
+              <a:rPr lang="en-US" sz="1700" dirty="0">
+                <a:solidFill>
+                  <a:schemeClr val="tx1">
+                    <a:lumMod val="75000"/>
+                    <a:lumOff val="25000"/>
+                  </a:schemeClr>
+                </a:solidFill>
+              </a:rPr>
+              <a:t> and made memory usage more efficient.</a:t>
+            </a:r>
+          </a:p>
+          <a:p>
+            <a:pPr defTabSz="914400">
+              <a:lnSpc>
+                <a:spcPct val="90000"/>
+              </a:lnSpc>
+              <a:spcAft>
+                <a:spcPts val="600"/>
+              </a:spcAft>
+              <a:buClr>
+                <a:schemeClr val="accent1"/>
+              </a:buClr>
+              <a:buFont typeface="Calibri" panose="020F0502020204030204" pitchFamily="34" charset="0"/>
+            </a:pPr>
+            <a:r>
+              <a:rPr lang="en-US" sz="1700" dirty="0">
+                <a:solidFill>
+                  <a:schemeClr val="tx1">
+                    <a:lumMod val="75000"/>
+                    <a:lumOff val="25000"/>
+                  </a:schemeClr>
+                </a:solidFill>
+              </a:rPr>
+              <a:t>We immediately see the scalability issues are solved: if we increase the thread number, the execution time always gets lower. This also represents a substantial performance gain over the V2 version, with a time reduction of approximately </a:t>
+            </a:r>
+            <a:r>
+              <a:rPr lang="en-US" sz="1700" b="1" dirty="0">
+                <a:solidFill>
+                  <a:schemeClr val="tx1">
+                    <a:lumMod val="75000"/>
+                    <a:lumOff val="25000"/>
+                  </a:schemeClr>
+                </a:solidFill>
+              </a:rPr>
+              <a:t>82-89%</a:t>
+            </a:r>
+            <a:r>
+              <a:rPr lang="en-US" sz="1700" dirty="0">
+                <a:solidFill>
+                  <a:schemeClr val="tx1">
+                    <a:lumMod val="75000"/>
+                    <a:lumOff val="25000"/>
+                  </a:schemeClr>
+                </a:solidFill>
+              </a:rPr>
+              <a:t> observed across all thread configurations for a 10k node graph.</a:t>
+            </a:r>
+          </a:p>
+        </p:txBody>
+      </p:sp>
+      <p:sp>
+        <p:nvSpPr>
+          <p:cNvPr id="29" name="Rectangle 28">
+            <a:extLst>
+              <a:ext uri="{FF2B5EF4-FFF2-40B4-BE49-F238E27FC236}">
+                <a16:creationId xmlns:a16="http://schemas.microsoft.com/office/drawing/2014/main" id="{109B2863-A1A5-4050-8DE8-9BC0AD47F40B}"/>
+              </a:ext>
+              <a:ext uri="{C183D7F6-B498-43B3-948B-1728B52AA6E4}">
+                <adec:decorative xmlns:adec="http://schemas.microsoft.com/office/drawing/2017/decorative" val="1"/>
+              </a:ext>
+            </a:extLst>
+          </p:cNvPr>
+          <p:cNvSpPr>
+            <a:spLocks noGrp="1" noRot="1" noChangeAspect="1" noMove="1" noResize="1" noEditPoints="1" noAdjustHandles="1" noChangeArrowheads="1" noChangeShapeType="1" noTextEdit="1"/>
+          </p:cNvSpPr>
+          <p:nvPr>
+            <p:extLst>
+              <p:ext uri="{386F3935-93C4-4BCD-93E2-E3B085C9AB24}">
+                <p16:designElem xmlns:p16="http://schemas.microsoft.com/office/powerpoint/2015/main" val="1"/>
+              </p:ext>
+            </p:extLst>
+          </p:nvPr>
+        </p:nvSpPr>
+        <p:spPr>
+          <a:xfrm>
+            <a:off x="15" y="6334316"/>
+            <a:ext cx="12191985" cy="66484"/>
+          </a:xfrm>
+          <a:prstGeom prst="rect">
+            <a:avLst/>
+          </a:prstGeom>
+          <a:solidFill>
+            <a:schemeClr val="accent1"/>
+          </a:solidFill>
+          <a:ln>
+            <a:noFill/>
+          </a:ln>
+        </p:spPr>
+        <p:style>
+          <a:lnRef idx="2">
+            <a:schemeClr val="accent1">
+              <a:shade val="50000"/>
+            </a:schemeClr>
+          </a:lnRef>
+          <a:fillRef idx="1">
+            <a:schemeClr val="accent1"/>
+          </a:fillRef>
+          <a:effectRef idx="0">
+            <a:schemeClr val="accent1"/>
+          </a:effectRef>
+          <a:fontRef idx="minor">
+            <a:schemeClr val="lt1"/>
+          </a:fontRef>
+        </p:style>
+        <p:txBody>
+          <a:bodyPr/>
+          <a:lstStyle/>
+          <a:p>
+            <a:endParaRPr lang="it-IT"/>
+          </a:p>
+        </p:txBody>
+      </p:sp>
+      <p:sp>
+        <p:nvSpPr>
+          <p:cNvPr id="31" name="Rectangle 30">
+            <a:extLst>
+              <a:ext uri="{FF2B5EF4-FFF2-40B4-BE49-F238E27FC236}">
+                <a16:creationId xmlns:a16="http://schemas.microsoft.com/office/drawing/2014/main" id="{F1F76955-21E0-4116-A6AA-19DB89B503F7}"/>
+              </a:ext>
+              <a:ext uri="{C183D7F6-B498-43B3-948B-1728B52AA6E4}">
+                <adec:decorative xmlns:adec="http://schemas.microsoft.com/office/drawing/2017/decorative" val="1"/>
+              </a:ext>
+            </a:extLst>
+          </p:cNvPr>
+          <p:cNvSpPr>
+            <a:spLocks noGrp="1" noRot="1" noChangeAspect="1" noMove="1" noResize="1" noEditPoints="1" noAdjustHandles="1" noChangeArrowheads="1" noChangeShapeType="1" noTextEdit="1"/>
+          </p:cNvSpPr>
+          <p:nvPr>
+            <p:extLst>
+              <p:ext uri="{386F3935-93C4-4BCD-93E2-E3B085C9AB24}">
+                <p16:designElem xmlns:p16="http://schemas.microsoft.com/office/powerpoint/2015/main" val="1"/>
+              </p:ext>
+            </p:extLst>
+          </p:nvPr>
+        </p:nvSpPr>
+        <p:spPr>
+          <a:xfrm>
+            <a:off x="1" y="6400800"/>
+            <a:ext cx="12192000" cy="457200"/>
+          </a:xfrm>
+          <a:prstGeom prst="rect">
+            <a:avLst/>
+          </a:prstGeom>
+          <a:solidFill>
+            <a:schemeClr val="accent2"/>
+          </a:solidFill>
+          <a:ln>
+            <a:noFill/>
+          </a:ln>
+        </p:spPr>
+        <p:style>
+          <a:lnRef idx="2">
+            <a:schemeClr val="accent1">
+              <a:shade val="50000"/>
+            </a:schemeClr>
+          </a:lnRef>
+          <a:fillRef idx="1">
+            <a:schemeClr val="accent1"/>
+          </a:fillRef>
+          <a:effectRef idx="0">
+            <a:schemeClr val="accent1"/>
+          </a:effectRef>
+          <a:fontRef idx="minor">
+            <a:schemeClr val="lt1"/>
+          </a:fontRef>
+        </p:style>
+        <p:txBody>
+          <a:bodyPr/>
+          <a:lstStyle/>
+          <a:p>
+            <a:endParaRPr lang="it-IT"/>
+          </a:p>
+        </p:txBody>
+      </p:sp>
+    </p:spTree>
+    <p:extLst>
+      <p:ext uri="{BB962C8B-B14F-4D97-AF65-F5344CB8AC3E}">
+        <p14:creationId xmlns:p14="http://schemas.microsoft.com/office/powerpoint/2010/main" val="3087132600"/>
+      </p:ext>
+    </p:extLst>
+  </p:cSld>
+  <p:clrMapOvr>
+    <a:masterClrMapping/>
+  </p:clrMapOvr>
+</p:sld>
+</file>
+
+<file path=ppt/slides/slide7.xml><?xml version="1.0" encoding="utf-8"?>
+<p:sld xmlns:a="http://schemas.openxmlformats.org/drawingml/2006/main" xmlns:r="http://schemas.openxmlformats.org/officeDocument/2006/relationships" xmlns:p="http://schemas.openxmlformats.org/presentationml/2006/main">
+  <p:cSld>
+    <p:spTree>
+      <p:nvGrpSpPr>
+        <p:cNvPr id="1" name=""/>
+        <p:cNvGrpSpPr/>
+        <p:nvPr/>
+      </p:nvGrpSpPr>
+      <p:grpSpPr>
+        <a:xfrm>
+          <a:off x="0" y="0"/>
+          <a:ext cx="0" cy="0"/>
+          <a:chOff x="0" y="0"/>
+          <a:chExt cx="0" cy="0"/>
+        </a:xfrm>
+      </p:grpSpPr>
+      <p:sp>
+        <p:nvSpPr>
+          <p:cNvPr id="2" name="Title 1">
+            <a:extLst>
+              <a:ext uri="{FF2B5EF4-FFF2-40B4-BE49-F238E27FC236}">
+                <a16:creationId xmlns:a16="http://schemas.microsoft.com/office/drawing/2014/main" id="{CF5FFB68-33E3-C985-5CC2-82626BF76E9A}"/>
+              </a:ext>
+            </a:extLst>
+          </p:cNvPr>
+          <p:cNvSpPr>
+            <a:spLocks noGrp="1"/>
+          </p:cNvSpPr>
+          <p:nvPr>
+            <p:ph type="title"/>
+          </p:nvPr>
+        </p:nvSpPr>
+        <p:spPr/>
+        <p:txBody>
+          <a:bodyPr/>
+          <a:lstStyle/>
+          <a:p>
+            <a:r>
+              <a:rPr lang="it-IT" dirty="0"/>
+              <a:t>CUDA </a:t>
+            </a:r>
+            <a:r>
+              <a:rPr lang="it-IT" dirty="0" err="1"/>
+              <a:t>Parallel</a:t>
+            </a:r>
+            <a:r>
+              <a:rPr lang="it-IT" dirty="0"/>
+              <a:t> </a:t>
+            </a:r>
+            <a:r>
+              <a:rPr lang="it-IT" dirty="0" err="1"/>
+              <a:t>Forward</a:t>
+            </a:r>
+            <a:r>
+              <a:rPr lang="it-IT" dirty="0"/>
+              <a:t> </a:t>
+            </a:r>
+            <a:r>
+              <a:rPr lang="it-IT" dirty="0" err="1"/>
+              <a:t>Node</a:t>
+            </a:r>
+            <a:r>
+              <a:rPr lang="it-IT" dirty="0"/>
+              <a:t> </a:t>
+            </a:r>
+            <a:r>
+              <a:rPr lang="it-IT" dirty="0" err="1"/>
+              <a:t>Algorithm</a:t>
+            </a:r>
+            <a:r>
+              <a:rPr lang="it-IT" dirty="0"/>
+              <a:t> V1</a:t>
+            </a:r>
+          </a:p>
+        </p:txBody>
+      </p:sp>
+      <p:sp>
+        <p:nvSpPr>
+          <p:cNvPr id="5" name="TextBox 4">
+            <a:extLst>
+              <a:ext uri="{FF2B5EF4-FFF2-40B4-BE49-F238E27FC236}">
+                <a16:creationId xmlns:a16="http://schemas.microsoft.com/office/drawing/2014/main" id="{6CBF71C4-F74A-F164-7D5A-C0BFB1355093}"/>
+              </a:ext>
+            </a:extLst>
+          </p:cNvPr>
+          <p:cNvSpPr txBox="1"/>
+          <p:nvPr/>
+        </p:nvSpPr>
+        <p:spPr>
+          <a:xfrm>
+            <a:off x="1097280" y="1809095"/>
+            <a:ext cx="10058400" cy="3416320"/>
+          </a:xfrm>
+          <a:prstGeom prst="rect">
+            <a:avLst/>
+          </a:prstGeom>
+          <a:noFill/>
+        </p:spPr>
+        <p:txBody>
+          <a:bodyPr wrap="square">
+            <a:spAutoFit/>
+          </a:bodyPr>
+          <a:lstStyle/>
+          <a:p>
+            <a:pPr algn="just"/>
+            <a:r>
+              <a:rPr lang="en-US" dirty="0"/>
+              <a:t>The Forward Algorithm was adapted to run on GPUs using CUDA, leveraging their </a:t>
+            </a:r>
+            <a:r>
+              <a:rPr lang="en-US" b="1" dirty="0"/>
+              <a:t>massive parallelism</a:t>
+            </a:r>
+            <a:r>
+              <a:rPr lang="en-US" dirty="0"/>
+              <a:t> to significantly speed up processing for large graphs. To achieve this, the graph's data is converted into a GPU-optimized </a:t>
+            </a:r>
+            <a:r>
+              <a:rPr lang="en-US" b="1" dirty="0"/>
+              <a:t>Compressed Row Storage (CRS)</a:t>
+            </a:r>
+            <a:r>
+              <a:rPr lang="en-US" dirty="0"/>
+              <a:t> format. This dense storage format is well suited for </a:t>
+            </a:r>
+            <a:r>
+              <a:rPr lang="en-US" b="1" dirty="0"/>
+              <a:t>coalesced</a:t>
+            </a:r>
+            <a:r>
+              <a:rPr lang="en-US" dirty="0"/>
+              <a:t> memory access. </a:t>
+            </a:r>
+          </a:p>
+          <a:p>
+            <a:pPr algn="just"/>
+            <a:r>
+              <a:rPr lang="en-US" dirty="0"/>
+              <a:t>The core of the algorithm is performed inside the </a:t>
+            </a:r>
+            <a:r>
+              <a:rPr lang="en-US" b="1" dirty="0" err="1"/>
+              <a:t>ForwardAlgorithmKernel</a:t>
+            </a:r>
+            <a:r>
+              <a:rPr lang="en-US" b="1" dirty="0"/>
+              <a:t> kernel function</a:t>
+            </a:r>
+            <a:r>
+              <a:rPr lang="en-US" dirty="0"/>
+              <a:t>, where we assign each GPU thread to a graph node. Within the function, the approach to identify a potential triangle formed by vertices (s, t, v) remains the same as with the C++ versions. To handle concurrent updates to the global triangle counter from multiple threads, the </a:t>
+            </a:r>
+            <a:r>
+              <a:rPr lang="en-US" b="1" dirty="0" err="1"/>
+              <a:t>atomicAdd</a:t>
+            </a:r>
+            <a:r>
+              <a:rPr lang="en-US" dirty="0"/>
+              <a:t> function is used.</a:t>
+            </a:r>
+          </a:p>
+          <a:p>
+            <a:pPr algn="just"/>
+            <a:r>
+              <a:rPr lang="en-US" dirty="0"/>
+              <a:t>This strategy is heavily dependent on the configuration of its launch parameters, particularly the </a:t>
+            </a:r>
+            <a:r>
+              <a:rPr lang="en-US" b="1" dirty="0" err="1"/>
+              <a:t>blockSize</a:t>
+            </a:r>
+            <a:r>
+              <a:rPr lang="en-US" b="1" dirty="0"/>
+              <a:t>, which serves as a critical hyperparameter for performance tuning. </a:t>
+            </a:r>
+            <a:r>
+              <a:rPr lang="en-US" dirty="0"/>
+              <a:t>Since, in current architectures, a warp is composed of </a:t>
+            </a:r>
+            <a:r>
+              <a:rPr lang="en-US" b="1" dirty="0"/>
+              <a:t>32 threads</a:t>
+            </a:r>
+            <a:r>
+              <a:rPr lang="en-US" dirty="0"/>
+              <a:t>, using multiples of 32 can result in the block containing an exact number of full warps, so the GPU can schedule them more efficiently</a:t>
+            </a:r>
+            <a:endParaRPr lang="it-IT" b="1" dirty="0"/>
+          </a:p>
+        </p:txBody>
+      </p:sp>
+    </p:spTree>
+    <p:extLst>
+      <p:ext uri="{BB962C8B-B14F-4D97-AF65-F5344CB8AC3E}">
+        <p14:creationId xmlns:p14="http://schemas.microsoft.com/office/powerpoint/2010/main" val="2869861090"/>
+      </p:ext>
+    </p:extLst>
+  </p:cSld>
+  <p:clrMapOvr>
+    <a:masterClrMapping/>
+  </p:clrMapOvr>
+</p:sld>
+</file>
+
+<file path=ppt/slides/slide8.xml><?xml version="1.0" encoding="utf-8"?>
+<p:sld xmlns:a="http://schemas.openxmlformats.org/drawingml/2006/main" xmlns:r="http://schemas.openxmlformats.org/officeDocument/2006/relationships" xmlns:p="http://schemas.openxmlformats.org/presentationml/2006/main">
+  <p:cSld>
+    <p:bg>
+      <p:bgPr>
+        <a:solidFill>
+          <a:schemeClr val="bg1"/>
+        </a:solidFill>
+        <a:effectLst/>
+      </p:bgPr>
+    </p:bg>
+    <p:spTree>
+      <p:nvGrpSpPr>
+        <p:cNvPr id="1" name=""/>
+        <p:cNvGrpSpPr/>
+        <p:nvPr/>
+      </p:nvGrpSpPr>
+      <p:grpSpPr>
+        <a:xfrm>
+          <a:off x="0" y="0"/>
+          <a:ext cx="0" cy="0"/>
+          <a:chOff x="0" y="0"/>
+          <a:chExt cx="0" cy="0"/>
+        </a:xfrm>
+      </p:grpSpPr>
+      <p:sp useBgFill="1">
+        <p:nvSpPr>
+          <p:cNvPr id="19" name="Rectangle 18">
+            <a:extLst>
+              <a:ext uri="{FF2B5EF4-FFF2-40B4-BE49-F238E27FC236}">
+                <a16:creationId xmlns:a16="http://schemas.microsoft.com/office/drawing/2014/main" id="{52ABB703-2B0E-4C3B-B4A2-F3973548E561}"/>
+              </a:ext>
+              <a:ext uri="{C183D7F6-B498-43B3-948B-1728B52AA6E4}">
+                <adec:decorative xmlns:adec="http://schemas.microsoft.com/office/drawing/2017/decorative" val="1"/>
+              </a:ext>
+            </a:extLst>
+          </p:cNvPr>
+          <p:cNvSpPr>
+            <a:spLocks noGrp="1" noRot="1" noChangeAspect="1" noMove="1" noResize="1" noEditPoints="1" noAdjustHandles="1" noChangeArrowheads="1" noChangeShapeType="1" noTextEdit="1"/>
+          </p:cNvSpPr>
+          <p:nvPr>
+            <p:extLst>
+              <p:ext uri="{386F3935-93C4-4BCD-93E2-E3B085C9AB24}">
+                <p16:designElem xmlns:p16="http://schemas.microsoft.com/office/powerpoint/2015/main" val="1"/>
+              </p:ext>
+            </p:extLst>
+          </p:nvPr>
+        </p:nvSpPr>
+        <p:spPr>
+          <a:xfrm>
+            <a:off x="0" y="0"/>
+            <a:ext cx="12192001" cy="6334316"/>
+          </a:xfrm>
+          <a:prstGeom prst="rect">
+            <a:avLst/>
+          </a:prstGeom>
+          <a:ln>
+            <a:noFill/>
+          </a:ln>
+        </p:spPr>
+        <p:style>
+          <a:lnRef idx="2">
+            <a:schemeClr val="accent1">
+              <a:shade val="50000"/>
+            </a:schemeClr>
+          </a:lnRef>
+          <a:fillRef idx="1">
+            <a:schemeClr val="accent1"/>
+          </a:fillRef>
+          <a:effectRef idx="0">
+            <a:schemeClr val="accent1"/>
+          </a:effectRef>
+          <a:fontRef idx="minor">
+            <a:schemeClr val="lt1"/>
+          </a:fontRef>
+        </p:style>
+        <p:txBody>
+          <a:bodyPr rtlCol="0" anchor="ctr"/>
+          <a:lstStyle/>
+          <a:p>
+            <a:pPr algn="ctr"/>
+            <a:endParaRPr lang="en-US"/>
+          </a:p>
+        </p:txBody>
+      </p:sp>
+      <p:pic>
+        <p:nvPicPr>
+          <p:cNvPr id="5" name="Picture 4" descr="A graph with a red line&#10;&#10;AI-generated content may be incorrect.">
+            <a:extLst>
+              <a:ext uri="{FF2B5EF4-FFF2-40B4-BE49-F238E27FC236}">
+                <a16:creationId xmlns:a16="http://schemas.microsoft.com/office/drawing/2014/main" id="{8A49B760-2DAC-A5FB-0F87-B275BC28643E}"/>
+              </a:ext>
+            </a:extLst>
+          </p:cNvPr>
+          <p:cNvPicPr>
+            <a:picLocks noChangeAspect="1"/>
+          </p:cNvPicPr>
+          <p:nvPr/>
+        </p:nvPicPr>
+        <p:blipFill>
+          <a:blip r:embed="rId2">
+            <a:extLst>
+              <a:ext uri="{28A0092B-C50C-407E-A947-70E740481C1C}">
+                <a14:useLocalDpi xmlns:a14="http://schemas.microsoft.com/office/drawing/2010/main" val="0"/>
+              </a:ext>
+            </a:extLst>
+          </a:blip>
+          <a:stretch>
+            <a:fillRect/>
+          </a:stretch>
+        </p:blipFill>
+        <p:spPr>
+          <a:xfrm>
+            <a:off x="480029" y="47903"/>
+            <a:ext cx="5451627" cy="3270975"/>
+          </a:xfrm>
+          <a:prstGeom prst="rect">
+            <a:avLst/>
+          </a:prstGeom>
+        </p:spPr>
+      </p:pic>
+      <p:cxnSp>
+        <p:nvCxnSpPr>
+          <p:cNvPr id="20" name="Straight Connector 19">
+            <a:extLst>
+              <a:ext uri="{FF2B5EF4-FFF2-40B4-BE49-F238E27FC236}">
+                <a16:creationId xmlns:a16="http://schemas.microsoft.com/office/drawing/2014/main" id="{9C21570E-E159-49A6-9891-FA397B7A92D3}"/>
+              </a:ext>
+              <a:ext uri="{C183D7F6-B498-43B3-948B-1728B52AA6E4}">
+                <adec:decorative xmlns:adec="http://schemas.microsoft.com/office/drawing/2017/decorative" val="1"/>
+              </a:ext>
+            </a:extLst>
+          </p:cNvPr>
+          <p:cNvCxnSpPr>
+            <a:cxnSpLocks noGrp="1" noRot="1" noChangeAspect="1" noMove="1" noResize="1" noEditPoints="1" noAdjustHandles="1" noChangeArrowheads="1" noChangeShapeType="1"/>
+          </p:cNvCxnSpPr>
+          <p:nvPr>
+            <p:extLst>
+              <p:ext uri="{386F3935-93C4-4BCD-93E2-E3B085C9AB24}">
+                <p16:designElem xmlns:p16="http://schemas.microsoft.com/office/powerpoint/2015/main" val="1"/>
+              </p:ext>
+            </p:extLst>
+          </p:nvPr>
+        </p:nvCxnSpPr>
+        <p:spPr>
+          <a:xfrm>
+            <a:off x="6411684" y="2086188"/>
+            <a:ext cx="4748808" cy="0"/>
+          </a:xfrm>
+          <a:prstGeom prst="line">
+            <a:avLst/>
+          </a:prstGeom>
+          <a:ln w="6350">
+            <a:solidFill>
+              <a:schemeClr val="tx1">
+                <a:lumMod val="50000"/>
+                <a:lumOff val="50000"/>
+                <a:alpha val="90000"/>
+              </a:schemeClr>
+            </a:solidFill>
+          </a:ln>
+        </p:spPr>
+        <p:style>
+          <a:lnRef idx="1">
+            <a:schemeClr val="accent1"/>
+          </a:lnRef>
+          <a:fillRef idx="0">
+            <a:schemeClr val="accent1"/>
+          </a:fillRef>
+          <a:effectRef idx="0">
+            <a:schemeClr val="accent1"/>
+          </a:effectRef>
+          <a:fontRef idx="minor">
+            <a:schemeClr val="tx1"/>
+          </a:fontRef>
+        </p:style>
+      </p:cxnSp>
+      <p:sp>
+        <p:nvSpPr>
+          <p:cNvPr id="7" name="TextBox 6">
+            <a:extLst>
+              <a:ext uri="{FF2B5EF4-FFF2-40B4-BE49-F238E27FC236}">
+                <a16:creationId xmlns:a16="http://schemas.microsoft.com/office/drawing/2014/main" id="{137ACD5B-F23A-24BE-64FF-2DCAB8BBFFE6}"/>
+              </a:ext>
+            </a:extLst>
+          </p:cNvPr>
+          <p:cNvSpPr txBox="1"/>
+          <p:nvPr/>
+        </p:nvSpPr>
+        <p:spPr>
+          <a:xfrm>
+            <a:off x="6411684" y="2198914"/>
+            <a:ext cx="5127172" cy="3670180"/>
+          </a:xfrm>
+          <a:prstGeom prst="rect">
+            <a:avLst/>
+          </a:prstGeom>
+        </p:spPr>
+        <p:txBody>
+          <a:bodyPr vert="horz" lIns="0" tIns="45720" rIns="0" bIns="45720" rtlCol="0">
+            <a:normAutofit/>
+          </a:bodyPr>
+          <a:lstStyle/>
+          <a:p>
+            <a:pPr defTabSz="914400">
+              <a:lnSpc>
+                <a:spcPct val="90000"/>
+              </a:lnSpc>
+              <a:spcAft>
+                <a:spcPts val="600"/>
+              </a:spcAft>
+              <a:buClr>
+                <a:schemeClr val="accent1"/>
+              </a:buClr>
+              <a:buFont typeface="Calibri" panose="020F0502020204030204" pitchFamily="34" charset="0"/>
+            </a:pPr>
+            <a:r>
+              <a:rPr lang="en-US" dirty="0">
+                <a:solidFill>
+                  <a:schemeClr val="tx1">
+                    <a:lumMod val="75000"/>
+                    <a:lumOff val="25000"/>
+                  </a:schemeClr>
+                </a:solidFill>
+              </a:rPr>
+              <a:t>We can see that the </a:t>
+            </a:r>
+            <a:r>
+              <a:rPr lang="en-US" b="1" dirty="0">
+                <a:solidFill>
+                  <a:schemeClr val="tx1">
+                    <a:lumMod val="75000"/>
+                    <a:lumOff val="25000"/>
+                  </a:schemeClr>
+                </a:solidFill>
+              </a:rPr>
+              <a:t>best performance is achieved setting </a:t>
+            </a:r>
+            <a:r>
+              <a:rPr lang="en-US" b="1" dirty="0" err="1">
+                <a:solidFill>
+                  <a:schemeClr val="tx1">
+                    <a:lumMod val="75000"/>
+                    <a:lumOff val="25000"/>
+                  </a:schemeClr>
+                </a:solidFill>
+              </a:rPr>
+              <a:t>blockSize</a:t>
+            </a:r>
+            <a:r>
+              <a:rPr lang="en-US" b="1" dirty="0">
+                <a:solidFill>
+                  <a:schemeClr val="tx1">
+                    <a:lumMod val="75000"/>
+                    <a:lumOff val="25000"/>
+                  </a:schemeClr>
+                </a:solidFill>
+              </a:rPr>
+              <a:t> to 128</a:t>
+            </a:r>
+            <a:r>
+              <a:rPr lang="en-US" dirty="0">
+                <a:solidFill>
+                  <a:schemeClr val="tx1">
+                    <a:lumMod val="75000"/>
+                    <a:lumOff val="25000"/>
+                  </a:schemeClr>
+                </a:solidFill>
+              </a:rPr>
+              <a:t>, resulting in approximately 25 </a:t>
+            </a:r>
+            <a:r>
+              <a:rPr lang="en-US" dirty="0" err="1">
+                <a:solidFill>
+                  <a:schemeClr val="tx1">
+                    <a:lumMod val="75000"/>
+                    <a:lumOff val="25000"/>
+                  </a:schemeClr>
+                </a:solidFill>
+              </a:rPr>
+              <a:t>ms</a:t>
+            </a:r>
+            <a:r>
+              <a:rPr lang="en-US" dirty="0">
+                <a:solidFill>
+                  <a:schemeClr val="tx1">
+                    <a:lumMod val="75000"/>
+                    <a:lumOff val="25000"/>
+                  </a:schemeClr>
+                </a:solidFill>
+              </a:rPr>
+              <a:t> of execution time (this includes also the time spent copying data using from the Host to the Device using the PCIe buffer). Then, the execution time significantly worsens as the size of a block increases to 256, 512, and 1024. In facts, when </a:t>
+            </a:r>
+            <a:r>
+              <a:rPr lang="en-US" dirty="0" err="1">
+                <a:solidFill>
+                  <a:schemeClr val="tx1">
+                    <a:lumMod val="75000"/>
+                    <a:lumOff val="25000"/>
+                  </a:schemeClr>
+                </a:solidFill>
+              </a:rPr>
+              <a:t>blockSize</a:t>
+            </a:r>
+            <a:r>
+              <a:rPr lang="en-US" dirty="0">
+                <a:solidFill>
+                  <a:schemeClr val="tx1">
+                    <a:lumMod val="75000"/>
+                    <a:lumOff val="25000"/>
+                  </a:schemeClr>
+                </a:solidFill>
+              </a:rPr>
+              <a:t> is small to moderate (i.e. 64 or 128) the blocks are "lightweight" and many can be scheduled simultaneously on an SM. This leads to </a:t>
+            </a:r>
+            <a:r>
+              <a:rPr lang="en-US" b="1" dirty="0">
+                <a:solidFill>
+                  <a:schemeClr val="tx1">
+                    <a:lumMod val="75000"/>
+                    <a:lumOff val="25000"/>
+                  </a:schemeClr>
+                </a:solidFill>
+              </a:rPr>
+              <a:t>high occupancy</a:t>
+            </a:r>
+            <a:r>
+              <a:rPr lang="en-US" dirty="0">
+                <a:solidFill>
+                  <a:schemeClr val="tx1">
+                    <a:lumMod val="75000"/>
+                    <a:lumOff val="25000"/>
+                  </a:schemeClr>
+                </a:solidFill>
+              </a:rPr>
+              <a:t>. In facts, we </a:t>
+            </a:r>
+            <a:r>
+              <a:rPr lang="en-US" b="1" dirty="0">
+                <a:solidFill>
+                  <a:schemeClr val="tx1">
+                    <a:lumMod val="75000"/>
+                    <a:lumOff val="25000"/>
+                  </a:schemeClr>
+                </a:solidFill>
+              </a:rPr>
+              <a:t>almost </a:t>
+            </a:r>
+            <a:r>
+              <a:rPr lang="en-US" b="1" dirty="0"/>
+              <a:t>saturate the SM </a:t>
+            </a:r>
+            <a:r>
+              <a:rPr lang="en-US" dirty="0"/>
+              <a:t>(achieving an excellent occupancy of 82.39%)</a:t>
+            </a:r>
+            <a:endParaRPr lang="en-US" dirty="0">
+              <a:solidFill>
+                <a:schemeClr val="tx1">
+                  <a:lumMod val="75000"/>
+                  <a:lumOff val="25000"/>
+                </a:schemeClr>
+              </a:solidFill>
+            </a:endParaRPr>
+          </a:p>
+        </p:txBody>
+      </p:sp>
+      <p:sp>
+        <p:nvSpPr>
+          <p:cNvPr id="21" name="Rectangle 20">
+            <a:extLst>
+              <a:ext uri="{FF2B5EF4-FFF2-40B4-BE49-F238E27FC236}">
+                <a16:creationId xmlns:a16="http://schemas.microsoft.com/office/drawing/2014/main" id="{E95DA498-D9A2-4DA9-B9DA-B3776E08CF7E}"/>
+              </a:ext>
+              <a:ext uri="{C183D7F6-B498-43B3-948B-1728B52AA6E4}">
+                <adec:decorative xmlns:adec="http://schemas.microsoft.com/office/drawing/2017/decorative" val="1"/>
+              </a:ext>
+            </a:extLst>
+          </p:cNvPr>
+          <p:cNvSpPr>
+            <a:spLocks noGrp="1" noRot="1" noChangeAspect="1" noMove="1" noResize="1" noEditPoints="1" noAdjustHandles="1" noChangeArrowheads="1" noChangeShapeType="1" noTextEdit="1"/>
+          </p:cNvSpPr>
+          <p:nvPr>
+            <p:extLst>
+              <p:ext uri="{386F3935-93C4-4BCD-93E2-E3B085C9AB24}">
+                <p16:designElem xmlns:p16="http://schemas.microsoft.com/office/powerpoint/2015/main" val="1"/>
+              </p:ext>
+            </p:extLst>
+          </p:nvPr>
+        </p:nvSpPr>
+        <p:spPr>
+          <a:xfrm>
+            <a:off x="15" y="6334316"/>
+            <a:ext cx="12191985" cy="66484"/>
+          </a:xfrm>
+          <a:prstGeom prst="rect">
+            <a:avLst/>
+          </a:prstGeom>
+          <a:solidFill>
+            <a:schemeClr val="accent1"/>
+          </a:solidFill>
+          <a:ln>
+            <a:noFill/>
+          </a:ln>
+        </p:spPr>
+        <p:style>
+          <a:lnRef idx="2">
+            <a:schemeClr val="accent1">
+              <a:shade val="50000"/>
+            </a:schemeClr>
+          </a:lnRef>
+          <a:fillRef idx="1">
+            <a:schemeClr val="accent1"/>
+          </a:fillRef>
+          <a:effectRef idx="0">
+            <a:schemeClr val="accent1"/>
+          </a:effectRef>
+          <a:fontRef idx="minor">
+            <a:schemeClr val="lt1"/>
+          </a:fontRef>
+        </p:style>
+        <p:txBody>
+          <a:bodyPr/>
+          <a:lstStyle/>
+          <a:p>
+            <a:endParaRPr lang="it-IT"/>
+          </a:p>
+        </p:txBody>
+      </p:sp>
+      <p:sp>
+        <p:nvSpPr>
+          <p:cNvPr id="18" name="Rectangle 17">
+            <a:extLst>
+              <a:ext uri="{FF2B5EF4-FFF2-40B4-BE49-F238E27FC236}">
+                <a16:creationId xmlns:a16="http://schemas.microsoft.com/office/drawing/2014/main" id="{82A73093-4B9D-420D-B17E-52293703A1D4}"/>
+              </a:ext>
+              <a:ext uri="{C183D7F6-B498-43B3-948B-1728B52AA6E4}">
+                <adec:decorative xmlns:adec="http://schemas.microsoft.com/office/drawing/2017/decorative" val="1"/>
+              </a:ext>
+            </a:extLst>
+          </p:cNvPr>
+          <p:cNvSpPr>
+            <a:spLocks noGrp="1" noRot="1" noChangeAspect="1" noMove="1" noResize="1" noEditPoints="1" noAdjustHandles="1" noChangeArrowheads="1" noChangeShapeType="1" noTextEdit="1"/>
+          </p:cNvSpPr>
+          <p:nvPr>
+            <p:extLst>
+              <p:ext uri="{386F3935-93C4-4BCD-93E2-E3B085C9AB24}">
+                <p16:designElem xmlns:p16="http://schemas.microsoft.com/office/powerpoint/2015/main" val="1"/>
+              </p:ext>
+            </p:extLst>
+          </p:nvPr>
+        </p:nvSpPr>
+        <p:spPr>
+          <a:xfrm>
+            <a:off x="1" y="6400800"/>
+            <a:ext cx="12192000" cy="457200"/>
+          </a:xfrm>
+          <a:prstGeom prst="rect">
+            <a:avLst/>
+          </a:prstGeom>
+          <a:solidFill>
+            <a:schemeClr val="accent2"/>
+          </a:solidFill>
+          <a:ln>
+            <a:noFill/>
+          </a:ln>
+        </p:spPr>
+        <p:style>
+          <a:lnRef idx="2">
+            <a:schemeClr val="accent1">
+              <a:shade val="50000"/>
+            </a:schemeClr>
+          </a:lnRef>
+          <a:fillRef idx="1">
+            <a:schemeClr val="accent1"/>
+          </a:fillRef>
+          <a:effectRef idx="0">
+            <a:schemeClr val="accent1"/>
+          </a:effectRef>
+          <a:fontRef idx="minor">
+            <a:schemeClr val="lt1"/>
+          </a:fontRef>
+        </p:style>
+        <p:txBody>
+          <a:bodyPr/>
+          <a:lstStyle/>
+          <a:p>
+            <a:endParaRPr lang="it-IT"/>
+          </a:p>
+        </p:txBody>
+      </p:sp>
+      <p:pic>
+        <p:nvPicPr>
+          <p:cNvPr id="9" name="Picture 8">
+            <a:extLst>
+              <a:ext uri="{FF2B5EF4-FFF2-40B4-BE49-F238E27FC236}">
+                <a16:creationId xmlns:a16="http://schemas.microsoft.com/office/drawing/2014/main" id="{0A00897F-695A-6EA1-E19C-A0ADDEA36F9F}"/>
+              </a:ext>
+            </a:extLst>
+          </p:cNvPr>
+          <p:cNvPicPr>
+            <a:picLocks noChangeAspect="1"/>
+          </p:cNvPicPr>
+          <p:nvPr/>
+        </p:nvPicPr>
+        <p:blipFill>
+          <a:blip r:embed="rId3"/>
+          <a:stretch>
+            <a:fillRect/>
+          </a:stretch>
+        </p:blipFill>
+        <p:spPr>
+          <a:xfrm>
+            <a:off x="753298" y="3366781"/>
+            <a:ext cx="4627999" cy="3055379"/>
+          </a:xfrm>
+          <a:prstGeom prst="rect">
+            <a:avLst/>
+          </a:prstGeom>
+        </p:spPr>
+      </p:pic>
+    </p:spTree>
+    <p:extLst>
+      <p:ext uri="{BB962C8B-B14F-4D97-AF65-F5344CB8AC3E}">
+        <p14:creationId xmlns:p14="http://schemas.microsoft.com/office/powerpoint/2010/main" val="3413654208"/>
+      </p:ext>
+    </p:extLst>
+  </p:cSld>
+  <p:clrMapOvr>
+    <a:masterClrMapping/>
+  </p:clrMapOvr>
+</p:sld>
+</file>
+
+<file path=ppt/slides/slide9.xml><?xml version="1.0" encoding="utf-8"?>
+<p:sld xmlns:a="http://schemas.openxmlformats.org/drawingml/2006/main" xmlns:r="http://schemas.openxmlformats.org/officeDocument/2006/relationships" xmlns:p="http://schemas.openxmlformats.org/presentationml/2006/main">
+  <p:cSld>
+    <p:spTree>
+      <p:nvGrpSpPr>
+        <p:cNvPr id="1" name=""/>
+        <p:cNvGrpSpPr/>
+        <p:nvPr/>
+      </p:nvGrpSpPr>
+      <p:grpSpPr>
+        <a:xfrm>
+          <a:off x="0" y="0"/>
+          <a:ext cx="0" cy="0"/>
+          <a:chOff x="0" y="0"/>
+          <a:chExt cx="0" cy="0"/>
+        </a:xfrm>
+      </p:grpSpPr>
+      <p:sp>
+        <p:nvSpPr>
+          <p:cNvPr id="2" name="Title 1">
+            <a:extLst>
+              <a:ext uri="{FF2B5EF4-FFF2-40B4-BE49-F238E27FC236}">
+                <a16:creationId xmlns:a16="http://schemas.microsoft.com/office/drawing/2014/main" id="{94439772-C12B-D454-97E4-C2D825F2199E}"/>
+              </a:ext>
+            </a:extLst>
+          </p:cNvPr>
+          <p:cNvSpPr>
+            <a:spLocks noGrp="1"/>
+          </p:cNvSpPr>
+          <p:nvPr>
+            <p:ph type="title"/>
+          </p:nvPr>
+        </p:nvSpPr>
+        <p:spPr/>
+        <p:txBody>
+          <a:bodyPr/>
+          <a:lstStyle/>
+          <a:p>
+            <a:r>
+              <a:rPr lang="it-IT" dirty="0"/>
+              <a:t>CUDA </a:t>
+            </a:r>
+            <a:r>
+              <a:rPr lang="it-IT" dirty="0" err="1"/>
+              <a:t>Parallel</a:t>
+            </a:r>
+            <a:r>
+              <a:rPr lang="it-IT" dirty="0"/>
+              <a:t> </a:t>
+            </a:r>
+            <a:r>
+              <a:rPr lang="it-IT" dirty="0" err="1"/>
+              <a:t>Forward</a:t>
+            </a:r>
+            <a:r>
+              <a:rPr lang="it-IT" dirty="0"/>
+              <a:t> </a:t>
+            </a:r>
+            <a:r>
+              <a:rPr lang="it-IT" dirty="0" err="1"/>
+              <a:t>Node</a:t>
+            </a:r>
+            <a:r>
+              <a:rPr lang="it-IT" dirty="0"/>
+              <a:t> </a:t>
+            </a:r>
+            <a:r>
+              <a:rPr lang="it-IT" dirty="0" err="1"/>
+              <a:t>Algorithm</a:t>
+            </a:r>
+            <a:r>
+              <a:rPr lang="it-IT" dirty="0"/>
+              <a:t> V2</a:t>
+            </a:r>
+          </a:p>
+        </p:txBody>
+      </p:sp>
+      <p:sp>
+        <p:nvSpPr>
+          <p:cNvPr id="3" name="Content Placeholder 2">
+            <a:extLst>
+              <a:ext uri="{FF2B5EF4-FFF2-40B4-BE49-F238E27FC236}">
+                <a16:creationId xmlns:a16="http://schemas.microsoft.com/office/drawing/2014/main" id="{E5DCC95D-78B4-25FD-1F9B-C6DD44825131}"/>
+              </a:ext>
+            </a:extLst>
+          </p:cNvPr>
+          <p:cNvSpPr>
+            <a:spLocks noGrp="1"/>
+          </p:cNvSpPr>
+          <p:nvPr>
+            <p:ph idx="1"/>
+          </p:nvPr>
+        </p:nvSpPr>
+        <p:spPr/>
+        <p:txBody>
+          <a:bodyPr/>
+          <a:lstStyle/>
+          <a:p>
+            <a:r>
+              <a:rPr lang="en-US" dirty="0"/>
+              <a:t>The second version of the algorithm introduces a much faster, </a:t>
+            </a:r>
+            <a:r>
+              <a:rPr lang="en-US" b="1" dirty="0"/>
+              <a:t>merge-like</a:t>
+            </a:r>
+            <a:r>
+              <a:rPr lang="en-US" dirty="0"/>
+              <a:t> method to find triangles using two pointers. This new approach is a major algorithmic improvement over a simple nested loop, significantly cutting down on computation.</a:t>
+            </a:r>
+          </a:p>
+          <a:p>
+            <a:r>
+              <a:rPr lang="en-US" dirty="0"/>
+              <a:t>However, this method creates a GPU-specific bottleneck called </a:t>
+            </a:r>
+            <a:r>
+              <a:rPr lang="en-US" b="1" dirty="0"/>
+              <a:t>warp divergence</a:t>
+            </a:r>
+            <a:r>
+              <a:rPr lang="en-US" dirty="0"/>
+              <a:t>. This happens when threads in the same execution group take different if-else paths in the code, forcing the GPU to run them one by one and reducing the benefits of parallelism.</a:t>
+            </a:r>
+          </a:p>
+          <a:p>
+            <a:r>
+              <a:rPr lang="en-US" dirty="0"/>
+              <a:t>Despite this, the new algorithm is a substantial upgrade, even though its full speed is sometimes limited by this divergence.</a:t>
+            </a:r>
+          </a:p>
+          <a:p>
+            <a:endParaRPr lang="it-IT" dirty="0"/>
+          </a:p>
+        </p:txBody>
+      </p:sp>
+    </p:spTree>
+    <p:extLst>
+      <p:ext uri="{BB962C8B-B14F-4D97-AF65-F5344CB8AC3E}">
+        <p14:creationId xmlns:p14="http://schemas.microsoft.com/office/powerpoint/2010/main" val="784252444"/>
+      </p:ext>
+    </p:extLst>
+  </p:cSld>
+  <p:clrMapOvr>
+    <a:masterClrMapping/>
+  </p:clrMapOvr>
+</p:sld>
+</file>
+
 <file path=ppt/theme/theme1.xml><?xml version="1.0" encoding="utf-8"?>
 <a:theme xmlns:a="http://schemas.openxmlformats.org/drawingml/2006/main" name="Retrospect">
   <a:themeElements>

</xml_diff>

<commit_message>
feat: slides parallel edge
</commit_message>
<xml_diff>
--- a/presentation.pptx
+++ b/presentation.pptx
@@ -14,6 +14,9 @@
     <p:sldId id="262" r:id="rId8"/>
     <p:sldId id="263" r:id="rId9"/>
     <p:sldId id="264" r:id="rId10"/>
+    <p:sldId id="265" r:id="rId11"/>
+    <p:sldId id="266" r:id="rId12"/>
+    <p:sldId id="267" r:id="rId13"/>
   </p:sldIdLst>
   <p:sldSz cx="12192000" cy="6858000"/>
   <p:notesSz cx="6858000" cy="9144000"/>
@@ -3933,6 +3936,1440 @@
 </p:sld>
 </file>
 
+<file path=ppt/slides/slide10.xml><?xml version="1.0" encoding="utf-8"?>
+<p:sld xmlns:a="http://schemas.openxmlformats.org/drawingml/2006/main" xmlns:r="http://schemas.openxmlformats.org/officeDocument/2006/relationships" xmlns:p="http://schemas.openxmlformats.org/presentationml/2006/main">
+  <p:cSld>
+    <p:bg>
+      <p:bgPr>
+        <a:solidFill>
+          <a:schemeClr val="bg1"/>
+        </a:solidFill>
+        <a:effectLst/>
+      </p:bgPr>
+    </p:bg>
+    <p:spTree>
+      <p:nvGrpSpPr>
+        <p:cNvPr id="1" name=""/>
+        <p:cNvGrpSpPr/>
+        <p:nvPr/>
+      </p:nvGrpSpPr>
+      <p:grpSpPr>
+        <a:xfrm>
+          <a:off x="0" y="0"/>
+          <a:ext cx="0" cy="0"/>
+          <a:chOff x="0" y="0"/>
+          <a:chExt cx="0" cy="0"/>
+        </a:xfrm>
+      </p:grpSpPr>
+      <p:sp useBgFill="1">
+        <p:nvSpPr>
+          <p:cNvPr id="10" name="Rectangle 9">
+            <a:extLst>
+              <a:ext uri="{FF2B5EF4-FFF2-40B4-BE49-F238E27FC236}">
+                <a16:creationId xmlns:a16="http://schemas.microsoft.com/office/drawing/2014/main" id="{52ABB703-2B0E-4C3B-B4A2-F3973548E561}"/>
+              </a:ext>
+              <a:ext uri="{C183D7F6-B498-43B3-948B-1728B52AA6E4}">
+                <adec:decorative xmlns:adec="http://schemas.microsoft.com/office/drawing/2017/decorative" val="1"/>
+              </a:ext>
+            </a:extLst>
+          </p:cNvPr>
+          <p:cNvSpPr>
+            <a:spLocks noGrp="1" noRot="1" noChangeAspect="1" noMove="1" noResize="1" noEditPoints="1" noAdjustHandles="1" noChangeArrowheads="1" noChangeShapeType="1" noTextEdit="1"/>
+          </p:cNvSpPr>
+          <p:nvPr>
+            <p:extLst>
+              <p:ext uri="{386F3935-93C4-4BCD-93E2-E3B085C9AB24}">
+                <p16:designElem xmlns:p16="http://schemas.microsoft.com/office/powerpoint/2015/main" val="1"/>
+              </p:ext>
+            </p:extLst>
+          </p:nvPr>
+        </p:nvSpPr>
+        <p:spPr>
+          <a:xfrm>
+            <a:off x="0" y="0"/>
+            <a:ext cx="12192001" cy="6334316"/>
+          </a:xfrm>
+          <a:prstGeom prst="rect">
+            <a:avLst/>
+          </a:prstGeom>
+          <a:ln>
+            <a:noFill/>
+          </a:ln>
+        </p:spPr>
+        <p:style>
+          <a:lnRef idx="2">
+            <a:schemeClr val="accent1">
+              <a:shade val="50000"/>
+            </a:schemeClr>
+          </a:lnRef>
+          <a:fillRef idx="1">
+            <a:schemeClr val="accent1"/>
+          </a:fillRef>
+          <a:effectRef idx="0">
+            <a:schemeClr val="accent1"/>
+          </a:effectRef>
+          <a:fontRef idx="minor">
+            <a:schemeClr val="lt1"/>
+          </a:fontRef>
+        </p:style>
+        <p:txBody>
+          <a:bodyPr rtlCol="0" anchor="ctr"/>
+          <a:lstStyle/>
+          <a:p>
+            <a:pPr algn="ctr"/>
+            <a:endParaRPr lang="en-US"/>
+          </a:p>
+        </p:txBody>
+      </p:sp>
+      <p:sp>
+        <p:nvSpPr>
+          <p:cNvPr id="2" name="Title 1">
+            <a:extLst>
+              <a:ext uri="{FF2B5EF4-FFF2-40B4-BE49-F238E27FC236}">
+                <a16:creationId xmlns:a16="http://schemas.microsoft.com/office/drawing/2014/main" id="{F5E09325-060E-D984-EF9C-686A057AD822}"/>
+              </a:ext>
+            </a:extLst>
+          </p:cNvPr>
+          <p:cNvSpPr>
+            <a:spLocks noGrp="1"/>
+          </p:cNvSpPr>
+          <p:nvPr>
+            <p:ph type="title"/>
+          </p:nvPr>
+        </p:nvSpPr>
+        <p:spPr>
+          <a:xfrm>
+            <a:off x="6411685" y="634946"/>
+            <a:ext cx="5127171" cy="1450757"/>
+          </a:xfrm>
+        </p:spPr>
+        <p:txBody>
+          <a:bodyPr>
+            <a:normAutofit/>
+          </a:bodyPr>
+          <a:lstStyle/>
+          <a:p>
+            <a:r>
+              <a:rPr lang="en-US" dirty="0"/>
+              <a:t>Parallel Forward Edge Iterator V1</a:t>
+            </a:r>
+            <a:endParaRPr lang="it-IT" dirty="0"/>
+          </a:p>
+        </p:txBody>
+      </p:sp>
+      <p:pic>
+        <p:nvPicPr>
+          <p:cNvPr id="5" name="Picture 4" descr="A graph with red line&#10;&#10;AI-generated content may be incorrect.">
+            <a:extLst>
+              <a:ext uri="{FF2B5EF4-FFF2-40B4-BE49-F238E27FC236}">
+                <a16:creationId xmlns:a16="http://schemas.microsoft.com/office/drawing/2014/main" id="{12ABAC31-DEB7-1FF9-EC99-A8076CBB56E6}"/>
+              </a:ext>
+            </a:extLst>
+          </p:cNvPr>
+          <p:cNvPicPr>
+            <a:picLocks noChangeAspect="1"/>
+          </p:cNvPicPr>
+          <p:nvPr/>
+        </p:nvPicPr>
+        <p:blipFill>
+          <a:blip r:embed="rId2">
+            <a:extLst>
+              <a:ext uri="{28A0092B-C50C-407E-A947-70E740481C1C}">
+                <a14:useLocalDpi xmlns:a14="http://schemas.microsoft.com/office/drawing/2010/main" val="0"/>
+              </a:ext>
+            </a:extLst>
+          </a:blip>
+          <a:stretch>
+            <a:fillRect/>
+          </a:stretch>
+        </p:blipFill>
+        <p:spPr>
+          <a:xfrm>
+            <a:off x="643192" y="1633492"/>
+            <a:ext cx="5451627" cy="3270975"/>
+          </a:xfrm>
+          <a:prstGeom prst="rect">
+            <a:avLst/>
+          </a:prstGeom>
+        </p:spPr>
+      </p:pic>
+      <p:cxnSp>
+        <p:nvCxnSpPr>
+          <p:cNvPr id="12" name="Straight Connector 11">
+            <a:extLst>
+              <a:ext uri="{FF2B5EF4-FFF2-40B4-BE49-F238E27FC236}">
+                <a16:creationId xmlns:a16="http://schemas.microsoft.com/office/drawing/2014/main" id="{9C21570E-E159-49A6-9891-FA397B7A92D3}"/>
+              </a:ext>
+              <a:ext uri="{C183D7F6-B498-43B3-948B-1728B52AA6E4}">
+                <adec:decorative xmlns:adec="http://schemas.microsoft.com/office/drawing/2017/decorative" val="1"/>
+              </a:ext>
+            </a:extLst>
+          </p:cNvPr>
+          <p:cNvCxnSpPr>
+            <a:cxnSpLocks noGrp="1" noRot="1" noChangeAspect="1" noMove="1" noResize="1" noEditPoints="1" noAdjustHandles="1" noChangeArrowheads="1" noChangeShapeType="1"/>
+          </p:cNvCxnSpPr>
+          <p:nvPr>
+            <p:extLst>
+              <p:ext uri="{386F3935-93C4-4BCD-93E2-E3B085C9AB24}">
+                <p16:designElem xmlns:p16="http://schemas.microsoft.com/office/powerpoint/2015/main" val="1"/>
+              </p:ext>
+            </p:extLst>
+          </p:nvPr>
+        </p:nvCxnSpPr>
+        <p:spPr>
+          <a:xfrm>
+            <a:off x="6411684" y="2086188"/>
+            <a:ext cx="4748808" cy="0"/>
+          </a:xfrm>
+          <a:prstGeom prst="line">
+            <a:avLst/>
+          </a:prstGeom>
+          <a:ln w="6350">
+            <a:solidFill>
+              <a:schemeClr val="tx1">
+                <a:lumMod val="50000"/>
+                <a:lumOff val="50000"/>
+                <a:alpha val="90000"/>
+              </a:schemeClr>
+            </a:solidFill>
+          </a:ln>
+        </p:spPr>
+        <p:style>
+          <a:lnRef idx="1">
+            <a:schemeClr val="accent1"/>
+          </a:lnRef>
+          <a:fillRef idx="0">
+            <a:schemeClr val="accent1"/>
+          </a:fillRef>
+          <a:effectRef idx="0">
+            <a:schemeClr val="accent1"/>
+          </a:effectRef>
+          <a:fontRef idx="minor">
+            <a:schemeClr val="tx1"/>
+          </a:fontRef>
+        </p:style>
+      </p:cxnSp>
+      <p:sp>
+        <p:nvSpPr>
+          <p:cNvPr id="3" name="Content Placeholder 2">
+            <a:extLst>
+              <a:ext uri="{FF2B5EF4-FFF2-40B4-BE49-F238E27FC236}">
+                <a16:creationId xmlns:a16="http://schemas.microsoft.com/office/drawing/2014/main" id="{06AD68A9-B486-2C91-6983-081E8547D265}"/>
+              </a:ext>
+            </a:extLst>
+          </p:cNvPr>
+          <p:cNvSpPr>
+            <a:spLocks noGrp="1"/>
+          </p:cNvSpPr>
+          <p:nvPr>
+            <p:ph idx="1"/>
+          </p:nvPr>
+        </p:nvSpPr>
+        <p:spPr>
+          <a:xfrm>
+            <a:off x="6411684" y="2198914"/>
+            <a:ext cx="5127172" cy="3670180"/>
+          </a:xfrm>
+        </p:spPr>
+        <p:txBody>
+          <a:bodyPr>
+            <a:normAutofit/>
+          </a:bodyPr>
+          <a:lstStyle/>
+          <a:p>
+            <a:r>
+              <a:rPr lang="en-US" sz="1700" dirty="0"/>
+              <a:t>In this more naive version (Parallel Edge V1), we parallelize the outer loop that iterates over each edge. We distribute the edges among threads, and each thread is responsible for processing its assigned chunk. For a given edge (</a:t>
+            </a:r>
+            <a:r>
+              <a:rPr lang="en-US" sz="1700" dirty="0" err="1"/>
+              <a:t>s,t</a:t>
+            </a:r>
+            <a:r>
+              <a:rPr lang="en-US" sz="1700" dirty="0"/>
+              <a:t>), the thread finds common neighbors by performing a naive nested-loop intersection on the neighbor lists of s and t. This method of finding common neighbors has a worst-case time complexity of O(d(s) · d(t)) per edge, where d(s) and d(t) are the degrees of the vertices. The total count of triangles is managed using an std::atomic, which significantly reduces contention compared to using mutexes. However, as shown in our experimental tests, the effectiveness of this approach is highly dependent on the </a:t>
+            </a:r>
+            <a:r>
+              <a:rPr lang="en-US" sz="1700" b="1" dirty="0"/>
+              <a:t>graph size</a:t>
+            </a:r>
+            <a:r>
+              <a:rPr lang="en-US" sz="1700" dirty="0"/>
+              <a:t>.</a:t>
+            </a:r>
+            <a:endParaRPr lang="it-IT" sz="1700" dirty="0"/>
+          </a:p>
+        </p:txBody>
+      </p:sp>
+      <p:sp>
+        <p:nvSpPr>
+          <p:cNvPr id="14" name="Rectangle 13">
+            <a:extLst>
+              <a:ext uri="{FF2B5EF4-FFF2-40B4-BE49-F238E27FC236}">
+                <a16:creationId xmlns:a16="http://schemas.microsoft.com/office/drawing/2014/main" id="{E95DA498-D9A2-4DA9-B9DA-B3776E08CF7E}"/>
+              </a:ext>
+              <a:ext uri="{C183D7F6-B498-43B3-948B-1728B52AA6E4}">
+                <adec:decorative xmlns:adec="http://schemas.microsoft.com/office/drawing/2017/decorative" val="1"/>
+              </a:ext>
+            </a:extLst>
+          </p:cNvPr>
+          <p:cNvSpPr>
+            <a:spLocks noGrp="1" noRot="1" noChangeAspect="1" noMove="1" noResize="1" noEditPoints="1" noAdjustHandles="1" noChangeArrowheads="1" noChangeShapeType="1" noTextEdit="1"/>
+          </p:cNvSpPr>
+          <p:nvPr>
+            <p:extLst>
+              <p:ext uri="{386F3935-93C4-4BCD-93E2-E3B085C9AB24}">
+                <p16:designElem xmlns:p16="http://schemas.microsoft.com/office/powerpoint/2015/main" val="1"/>
+              </p:ext>
+            </p:extLst>
+          </p:nvPr>
+        </p:nvSpPr>
+        <p:spPr>
+          <a:xfrm>
+            <a:off x="15" y="6334316"/>
+            <a:ext cx="12191985" cy="66484"/>
+          </a:xfrm>
+          <a:prstGeom prst="rect">
+            <a:avLst/>
+          </a:prstGeom>
+          <a:solidFill>
+            <a:schemeClr val="accent1"/>
+          </a:solidFill>
+          <a:ln>
+            <a:noFill/>
+          </a:ln>
+        </p:spPr>
+        <p:style>
+          <a:lnRef idx="2">
+            <a:schemeClr val="accent1">
+              <a:shade val="50000"/>
+            </a:schemeClr>
+          </a:lnRef>
+          <a:fillRef idx="1">
+            <a:schemeClr val="accent1"/>
+          </a:fillRef>
+          <a:effectRef idx="0">
+            <a:schemeClr val="accent1"/>
+          </a:effectRef>
+          <a:fontRef idx="minor">
+            <a:schemeClr val="lt1"/>
+          </a:fontRef>
+        </p:style>
+        <p:txBody>
+          <a:bodyPr/>
+          <a:lstStyle/>
+          <a:p>
+            <a:endParaRPr lang="it-IT"/>
+          </a:p>
+        </p:txBody>
+      </p:sp>
+      <p:sp>
+        <p:nvSpPr>
+          <p:cNvPr id="16" name="Rectangle 15">
+            <a:extLst>
+              <a:ext uri="{FF2B5EF4-FFF2-40B4-BE49-F238E27FC236}">
+                <a16:creationId xmlns:a16="http://schemas.microsoft.com/office/drawing/2014/main" id="{82A73093-4B9D-420D-B17E-52293703A1D4}"/>
+              </a:ext>
+              <a:ext uri="{C183D7F6-B498-43B3-948B-1728B52AA6E4}">
+                <adec:decorative xmlns:adec="http://schemas.microsoft.com/office/drawing/2017/decorative" val="1"/>
+              </a:ext>
+            </a:extLst>
+          </p:cNvPr>
+          <p:cNvSpPr>
+            <a:spLocks noGrp="1" noRot="1" noChangeAspect="1" noMove="1" noResize="1" noEditPoints="1" noAdjustHandles="1" noChangeArrowheads="1" noChangeShapeType="1" noTextEdit="1"/>
+          </p:cNvSpPr>
+          <p:nvPr>
+            <p:extLst>
+              <p:ext uri="{386F3935-93C4-4BCD-93E2-E3B085C9AB24}">
+                <p16:designElem xmlns:p16="http://schemas.microsoft.com/office/powerpoint/2015/main" val="1"/>
+              </p:ext>
+            </p:extLst>
+          </p:nvPr>
+        </p:nvSpPr>
+        <p:spPr>
+          <a:xfrm>
+            <a:off x="1" y="6400800"/>
+            <a:ext cx="12192000" cy="457200"/>
+          </a:xfrm>
+          <a:prstGeom prst="rect">
+            <a:avLst/>
+          </a:prstGeom>
+          <a:solidFill>
+            <a:schemeClr val="accent2"/>
+          </a:solidFill>
+          <a:ln>
+            <a:noFill/>
+          </a:ln>
+        </p:spPr>
+        <p:style>
+          <a:lnRef idx="2">
+            <a:schemeClr val="accent1">
+              <a:shade val="50000"/>
+            </a:schemeClr>
+          </a:lnRef>
+          <a:fillRef idx="1">
+            <a:schemeClr val="accent1"/>
+          </a:fillRef>
+          <a:effectRef idx="0">
+            <a:schemeClr val="accent1"/>
+          </a:effectRef>
+          <a:fontRef idx="minor">
+            <a:schemeClr val="lt1"/>
+          </a:fontRef>
+        </p:style>
+        <p:txBody>
+          <a:bodyPr/>
+          <a:lstStyle/>
+          <a:p>
+            <a:endParaRPr lang="it-IT"/>
+          </a:p>
+        </p:txBody>
+      </p:sp>
+    </p:spTree>
+    <p:extLst>
+      <p:ext uri="{BB962C8B-B14F-4D97-AF65-F5344CB8AC3E}">
+        <p14:creationId xmlns:p14="http://schemas.microsoft.com/office/powerpoint/2010/main" val="1794176197"/>
+      </p:ext>
+    </p:extLst>
+  </p:cSld>
+  <p:clrMapOvr>
+    <a:masterClrMapping/>
+  </p:clrMapOvr>
+</p:sld>
+</file>
+
+<file path=ppt/slides/slide11.xml><?xml version="1.0" encoding="utf-8"?>
+<p:sld xmlns:a="http://schemas.openxmlformats.org/drawingml/2006/main" xmlns:r="http://schemas.openxmlformats.org/officeDocument/2006/relationships" xmlns:p="http://schemas.openxmlformats.org/presentationml/2006/main">
+  <p:cSld>
+    <p:bg>
+      <p:bgPr>
+        <a:solidFill>
+          <a:schemeClr val="bg1"/>
+        </a:solidFill>
+        <a:effectLst/>
+      </p:bgPr>
+    </p:bg>
+    <p:spTree>
+      <p:nvGrpSpPr>
+        <p:cNvPr id="1" name=""/>
+        <p:cNvGrpSpPr/>
+        <p:nvPr/>
+      </p:nvGrpSpPr>
+      <p:grpSpPr>
+        <a:xfrm>
+          <a:off x="0" y="0"/>
+          <a:ext cx="0" cy="0"/>
+          <a:chOff x="0" y="0"/>
+          <a:chExt cx="0" cy="0"/>
+        </a:xfrm>
+      </p:grpSpPr>
+      <p:sp useBgFill="1">
+        <p:nvSpPr>
+          <p:cNvPr id="21" name="Rectangle 20">
+            <a:extLst>
+              <a:ext uri="{FF2B5EF4-FFF2-40B4-BE49-F238E27FC236}">
+                <a16:creationId xmlns:a16="http://schemas.microsoft.com/office/drawing/2014/main" id="{E5958DBC-F4DA-42A8-8C52-860179790ECD}"/>
+              </a:ext>
+              <a:ext uri="{C183D7F6-B498-43B3-948B-1728B52AA6E4}">
+                <adec:decorative xmlns:adec="http://schemas.microsoft.com/office/drawing/2017/decorative" val="1"/>
+              </a:ext>
+            </a:extLst>
+          </p:cNvPr>
+          <p:cNvSpPr>
+            <a:spLocks noGrp="1" noRot="1" noChangeAspect="1" noMove="1" noResize="1" noEditPoints="1" noAdjustHandles="1" noChangeArrowheads="1" noChangeShapeType="1" noTextEdit="1"/>
+          </p:cNvSpPr>
+          <p:nvPr>
+            <p:extLst>
+              <p:ext uri="{386F3935-93C4-4BCD-93E2-E3B085C9AB24}">
+                <p16:designElem xmlns:p16="http://schemas.microsoft.com/office/powerpoint/2015/main" val="1"/>
+              </p:ext>
+            </p:extLst>
+          </p:nvPr>
+        </p:nvSpPr>
+        <p:spPr>
+          <a:xfrm>
+            <a:off x="0" y="0"/>
+            <a:ext cx="12192001" cy="6334316"/>
+          </a:xfrm>
+          <a:prstGeom prst="rect">
+            <a:avLst/>
+          </a:prstGeom>
+          <a:ln>
+            <a:noFill/>
+          </a:ln>
+        </p:spPr>
+        <p:style>
+          <a:lnRef idx="2">
+            <a:schemeClr val="accent1">
+              <a:shade val="50000"/>
+            </a:schemeClr>
+          </a:lnRef>
+          <a:fillRef idx="1">
+            <a:schemeClr val="accent1"/>
+          </a:fillRef>
+          <a:effectRef idx="0">
+            <a:schemeClr val="accent1"/>
+          </a:effectRef>
+          <a:fontRef idx="minor">
+            <a:schemeClr val="lt1"/>
+          </a:fontRef>
+        </p:style>
+        <p:txBody>
+          <a:bodyPr rtlCol="0" anchor="ctr"/>
+          <a:lstStyle/>
+          <a:p>
+            <a:pPr algn="ctr"/>
+            <a:endParaRPr lang="en-US"/>
+          </a:p>
+        </p:txBody>
+      </p:sp>
+      <p:sp>
+        <p:nvSpPr>
+          <p:cNvPr id="2" name="Title 1">
+            <a:extLst>
+              <a:ext uri="{FF2B5EF4-FFF2-40B4-BE49-F238E27FC236}">
+                <a16:creationId xmlns:a16="http://schemas.microsoft.com/office/drawing/2014/main" id="{7DD582FB-E379-9712-32D5-288FECE008E6}"/>
+              </a:ext>
+            </a:extLst>
+          </p:cNvPr>
+          <p:cNvSpPr>
+            <a:spLocks noGrp="1"/>
+          </p:cNvSpPr>
+          <p:nvPr>
+            <p:ph type="title"/>
+          </p:nvPr>
+        </p:nvSpPr>
+        <p:spPr>
+          <a:xfrm>
+            <a:off x="5144679" y="634946"/>
+            <a:ext cx="6405063" cy="1450757"/>
+          </a:xfrm>
+        </p:spPr>
+        <p:txBody>
+          <a:bodyPr>
+            <a:normAutofit/>
+          </a:bodyPr>
+          <a:lstStyle/>
+          <a:p>
+            <a:r>
+              <a:rPr lang="en-US" dirty="0"/>
+              <a:t>Parallel Forward Edge Iterator V2</a:t>
+            </a:r>
+            <a:endParaRPr lang="it-IT" dirty="0"/>
+          </a:p>
+        </p:txBody>
+      </p:sp>
+      <p:pic>
+        <p:nvPicPr>
+          <p:cNvPr id="5" name="Picture 4" descr="A graph with red line&#10;&#10;AI-generated content may be incorrect.">
+            <a:extLst>
+              <a:ext uri="{FF2B5EF4-FFF2-40B4-BE49-F238E27FC236}">
+                <a16:creationId xmlns:a16="http://schemas.microsoft.com/office/drawing/2014/main" id="{8714C398-C77E-116F-7394-91022842CCC1}"/>
+              </a:ext>
+            </a:extLst>
+          </p:cNvPr>
+          <p:cNvPicPr>
+            <a:picLocks noChangeAspect="1"/>
+          </p:cNvPicPr>
+          <p:nvPr/>
+        </p:nvPicPr>
+        <p:blipFill>
+          <a:blip r:embed="rId2">
+            <a:extLst>
+              <a:ext uri="{28A0092B-C50C-407E-A947-70E740481C1C}">
+                <a14:useLocalDpi xmlns:a14="http://schemas.microsoft.com/office/drawing/2010/main" val="0"/>
+              </a:ext>
+            </a:extLst>
+          </a:blip>
+          <a:stretch>
+            <a:fillRect/>
+          </a:stretch>
+        </p:blipFill>
+        <p:spPr>
+          <a:xfrm>
+            <a:off x="189823" y="184561"/>
+            <a:ext cx="4987054" cy="2992231"/>
+          </a:xfrm>
+          <a:prstGeom prst="rect">
+            <a:avLst/>
+          </a:prstGeom>
+        </p:spPr>
+      </p:pic>
+      <p:cxnSp>
+        <p:nvCxnSpPr>
+          <p:cNvPr id="23" name="Straight Connector 22">
+            <a:extLst>
+              <a:ext uri="{FF2B5EF4-FFF2-40B4-BE49-F238E27FC236}">
+                <a16:creationId xmlns:a16="http://schemas.microsoft.com/office/drawing/2014/main" id="{79FCC9A9-2031-4283-9B27-34B62BB7F305}"/>
+              </a:ext>
+              <a:ext uri="{C183D7F6-B498-43B3-948B-1728B52AA6E4}">
+                <adec:decorative xmlns:adec="http://schemas.microsoft.com/office/drawing/2017/decorative" val="1"/>
+              </a:ext>
+            </a:extLst>
+          </p:cNvPr>
+          <p:cNvCxnSpPr>
+            <a:cxnSpLocks noGrp="1" noRot="1" noChangeAspect="1" noMove="1" noResize="1" noEditPoints="1" noAdjustHandles="1" noChangeArrowheads="1" noChangeShapeType="1"/>
+          </p:cNvCxnSpPr>
+          <p:nvPr>
+            <p:extLst>
+              <p:ext uri="{386F3935-93C4-4BCD-93E2-E3B085C9AB24}">
+                <p16:designElem xmlns:p16="http://schemas.microsoft.com/office/powerpoint/2015/main" val="1"/>
+              </p:ext>
+            </p:extLst>
+          </p:nvPr>
+        </p:nvCxnSpPr>
+        <p:spPr>
+          <a:xfrm>
+            <a:off x="5181247" y="2086188"/>
+            <a:ext cx="5852160" cy="0"/>
+          </a:xfrm>
+          <a:prstGeom prst="line">
+            <a:avLst/>
+          </a:prstGeom>
+          <a:ln w="6350">
+            <a:solidFill>
+              <a:schemeClr val="tx1">
+                <a:lumMod val="50000"/>
+                <a:lumOff val="50000"/>
+                <a:alpha val="90000"/>
+              </a:schemeClr>
+            </a:solidFill>
+          </a:ln>
+        </p:spPr>
+        <p:style>
+          <a:lnRef idx="1">
+            <a:schemeClr val="accent1"/>
+          </a:lnRef>
+          <a:fillRef idx="0">
+            <a:schemeClr val="accent1"/>
+          </a:fillRef>
+          <a:effectRef idx="0">
+            <a:schemeClr val="accent1"/>
+          </a:effectRef>
+          <a:fontRef idx="minor">
+            <a:schemeClr val="tx1"/>
+          </a:fontRef>
+        </p:style>
+      </p:cxnSp>
+      <p:pic>
+        <p:nvPicPr>
+          <p:cNvPr id="7" name="Picture 6" descr="A graph with red line&#10;&#10;AI-generated content may be incorrect.">
+            <a:extLst>
+              <a:ext uri="{FF2B5EF4-FFF2-40B4-BE49-F238E27FC236}">
+                <a16:creationId xmlns:a16="http://schemas.microsoft.com/office/drawing/2014/main" id="{92853D59-DE87-318B-9972-9757C69FEC28}"/>
+              </a:ext>
+            </a:extLst>
+          </p:cNvPr>
+          <p:cNvPicPr>
+            <a:picLocks noChangeAspect="1"/>
+          </p:cNvPicPr>
+          <p:nvPr/>
+        </p:nvPicPr>
+        <p:blipFill>
+          <a:blip r:embed="rId3">
+            <a:extLst>
+              <a:ext uri="{28A0092B-C50C-407E-A947-70E740481C1C}">
+                <a14:useLocalDpi xmlns:a14="http://schemas.microsoft.com/office/drawing/2010/main" val="0"/>
+              </a:ext>
+            </a:extLst>
+          </a:blip>
+          <a:stretch>
+            <a:fillRect/>
+          </a:stretch>
+        </p:blipFill>
+        <p:spPr>
+          <a:xfrm>
+            <a:off x="189822" y="3176792"/>
+            <a:ext cx="4950015" cy="2970008"/>
+          </a:xfrm>
+          <a:prstGeom prst="rect">
+            <a:avLst/>
+          </a:prstGeom>
+        </p:spPr>
+      </p:pic>
+      <p:sp>
+        <p:nvSpPr>
+          <p:cNvPr id="3" name="Content Placeholder 2">
+            <a:extLst>
+              <a:ext uri="{FF2B5EF4-FFF2-40B4-BE49-F238E27FC236}">
+                <a16:creationId xmlns:a16="http://schemas.microsoft.com/office/drawing/2014/main" id="{5E07C57F-9265-87D1-43AF-649248002964}"/>
+              </a:ext>
+            </a:extLst>
+          </p:cNvPr>
+          <p:cNvSpPr>
+            <a:spLocks noGrp="1"/>
+          </p:cNvSpPr>
+          <p:nvPr>
+            <p:ph idx="1"/>
+          </p:nvPr>
+        </p:nvSpPr>
+        <p:spPr>
+          <a:xfrm>
+            <a:off x="5144679" y="2198913"/>
+            <a:ext cx="6955881" cy="4024131"/>
+          </a:xfrm>
+        </p:spPr>
+        <p:txBody>
+          <a:bodyPr>
+            <a:normAutofit/>
+          </a:bodyPr>
+          <a:lstStyle/>
+          <a:p>
+            <a:pPr marL="0" indent="0">
+              <a:buNone/>
+            </a:pPr>
+            <a:r>
+              <a:rPr lang="en-US" sz="1300" dirty="0"/>
+              <a:t>This version uses an adjacency list representation and employs a crucial preprocessing step to ensure all neighbor lists are sorted. With sorted lists, each thread can find the common neighbors for its assigned edges using a </a:t>
+            </a:r>
+            <a:r>
+              <a:rPr lang="en-US" sz="1300" b="1" dirty="0"/>
+              <a:t>two-pointer merge-like algorithm</a:t>
+            </a:r>
+            <a:r>
+              <a:rPr lang="en-US" sz="1300" dirty="0"/>
+              <a:t>, which has a linear time complexity of </a:t>
+            </a:r>
+            <a:r>
+              <a:rPr lang="en-US" sz="1300" b="1" dirty="0"/>
+              <a:t>O(d(s) + d(t)). </a:t>
+            </a:r>
+            <a:r>
+              <a:rPr lang="en-US" sz="1300" dirty="0"/>
+              <a:t>This significant improvement in the intersection process allows the algorithm to achieve a speedup proportional to the number of threads used, P, with very low synchronization overhead from the std::atomic variable.</a:t>
+            </a:r>
+          </a:p>
+          <a:p>
+            <a:pPr marL="0" indent="0">
+              <a:buNone/>
+            </a:pPr>
+            <a:r>
+              <a:rPr lang="en-US" sz="1300" dirty="0"/>
+              <a:t>On a 10k-node graph, </a:t>
+            </a:r>
+            <a:r>
+              <a:rPr lang="en-US" sz="1300" b="1" dirty="0"/>
+              <a:t>we observe a dramatic and consistent drop in execution time as the number of threads increases</a:t>
+            </a:r>
+            <a:r>
+              <a:rPr lang="en-US" sz="1300" dirty="0"/>
+              <a:t>, with an optimal point around 8 threads. The performance is </a:t>
+            </a:r>
+            <a:r>
+              <a:rPr lang="en-US" sz="1300" b="1" dirty="0"/>
+              <a:t>consistently better than the V1 version on the same graph</a:t>
+            </a:r>
+            <a:r>
+              <a:rPr lang="en-US" sz="1300" dirty="0"/>
+              <a:t>, demonstrating that the linear-time intersection is far superior to the naive nested-loop approach.</a:t>
+            </a:r>
+          </a:p>
+          <a:p>
+            <a:pPr marL="0" indent="0">
+              <a:buNone/>
+            </a:pPr>
+            <a:r>
+              <a:rPr lang="en-US" sz="1300" dirty="0"/>
+              <a:t>The scaling benefits of the V2 algorithm become even more apparent on extremely large graphs. For a graph with 1 million nodes, the performance curve shows a near-linear decrease as the number of threads increases up to 8. </a:t>
+            </a:r>
+            <a:r>
+              <a:rPr lang="en-US" sz="1300" b="1" dirty="0"/>
+              <a:t>This indicates a near-perfect parallel speedup </a:t>
+            </a:r>
+            <a:r>
+              <a:rPr lang="en-US" sz="1300" dirty="0"/>
+              <a:t>where the workload is large enough that the benefits of parallelization far outweigh the overhead.</a:t>
+            </a:r>
+            <a:endParaRPr lang="it-IT" sz="1300" dirty="0"/>
+          </a:p>
+        </p:txBody>
+      </p:sp>
+      <p:sp>
+        <p:nvSpPr>
+          <p:cNvPr id="25" name="Rectangle 24">
+            <a:extLst>
+              <a:ext uri="{FF2B5EF4-FFF2-40B4-BE49-F238E27FC236}">
+                <a16:creationId xmlns:a16="http://schemas.microsoft.com/office/drawing/2014/main" id="{51DDD252-D7C8-4CE5-9C61-D60D722BC217}"/>
+              </a:ext>
+              <a:ext uri="{C183D7F6-B498-43B3-948B-1728B52AA6E4}">
+                <adec:decorative xmlns:adec="http://schemas.microsoft.com/office/drawing/2017/decorative" val="1"/>
+              </a:ext>
+            </a:extLst>
+          </p:cNvPr>
+          <p:cNvSpPr>
+            <a:spLocks noGrp="1" noRot="1" noChangeAspect="1" noMove="1" noResize="1" noEditPoints="1" noAdjustHandles="1" noChangeArrowheads="1" noChangeShapeType="1" noTextEdit="1"/>
+          </p:cNvSpPr>
+          <p:nvPr>
+            <p:extLst>
+              <p:ext uri="{386F3935-93C4-4BCD-93E2-E3B085C9AB24}">
+                <p16:designElem xmlns:p16="http://schemas.microsoft.com/office/powerpoint/2015/main" val="1"/>
+              </p:ext>
+            </p:extLst>
+          </p:nvPr>
+        </p:nvSpPr>
+        <p:spPr>
+          <a:xfrm>
+            <a:off x="15" y="6334316"/>
+            <a:ext cx="12191985" cy="66484"/>
+          </a:xfrm>
+          <a:prstGeom prst="rect">
+            <a:avLst/>
+          </a:prstGeom>
+          <a:solidFill>
+            <a:schemeClr val="accent1"/>
+          </a:solidFill>
+          <a:ln>
+            <a:noFill/>
+          </a:ln>
+        </p:spPr>
+        <p:style>
+          <a:lnRef idx="2">
+            <a:schemeClr val="accent1">
+              <a:shade val="50000"/>
+            </a:schemeClr>
+          </a:lnRef>
+          <a:fillRef idx="1">
+            <a:schemeClr val="accent1"/>
+          </a:fillRef>
+          <a:effectRef idx="0">
+            <a:schemeClr val="accent1"/>
+          </a:effectRef>
+          <a:fontRef idx="minor">
+            <a:schemeClr val="lt1"/>
+          </a:fontRef>
+        </p:style>
+        <p:txBody>
+          <a:bodyPr/>
+          <a:lstStyle/>
+          <a:p>
+            <a:endParaRPr lang="it-IT"/>
+          </a:p>
+        </p:txBody>
+      </p:sp>
+      <p:sp>
+        <p:nvSpPr>
+          <p:cNvPr id="27" name="Rectangle 26">
+            <a:extLst>
+              <a:ext uri="{FF2B5EF4-FFF2-40B4-BE49-F238E27FC236}">
+                <a16:creationId xmlns:a16="http://schemas.microsoft.com/office/drawing/2014/main" id="{2FBD75F5-C49C-4F6A-8D43-7A5939C23307}"/>
+              </a:ext>
+              <a:ext uri="{C183D7F6-B498-43B3-948B-1728B52AA6E4}">
+                <adec:decorative xmlns:adec="http://schemas.microsoft.com/office/drawing/2017/decorative" val="1"/>
+              </a:ext>
+            </a:extLst>
+          </p:cNvPr>
+          <p:cNvSpPr>
+            <a:spLocks noGrp="1" noRot="1" noChangeAspect="1" noMove="1" noResize="1" noEditPoints="1" noAdjustHandles="1" noChangeArrowheads="1" noChangeShapeType="1" noTextEdit="1"/>
+          </p:cNvSpPr>
+          <p:nvPr>
+            <p:extLst>
+              <p:ext uri="{386F3935-93C4-4BCD-93E2-E3B085C9AB24}">
+                <p16:designElem xmlns:p16="http://schemas.microsoft.com/office/powerpoint/2015/main" val="1"/>
+              </p:ext>
+            </p:extLst>
+          </p:nvPr>
+        </p:nvSpPr>
+        <p:spPr>
+          <a:xfrm>
+            <a:off x="1" y="6400800"/>
+            <a:ext cx="12192000" cy="457200"/>
+          </a:xfrm>
+          <a:prstGeom prst="rect">
+            <a:avLst/>
+          </a:prstGeom>
+          <a:solidFill>
+            <a:schemeClr val="accent2"/>
+          </a:solidFill>
+          <a:ln>
+            <a:noFill/>
+          </a:ln>
+        </p:spPr>
+        <p:style>
+          <a:lnRef idx="2">
+            <a:schemeClr val="accent1">
+              <a:shade val="50000"/>
+            </a:schemeClr>
+          </a:lnRef>
+          <a:fillRef idx="1">
+            <a:schemeClr val="accent1"/>
+          </a:fillRef>
+          <a:effectRef idx="0">
+            <a:schemeClr val="accent1"/>
+          </a:effectRef>
+          <a:fontRef idx="minor">
+            <a:schemeClr val="lt1"/>
+          </a:fontRef>
+        </p:style>
+        <p:txBody>
+          <a:bodyPr/>
+          <a:lstStyle/>
+          <a:p>
+            <a:endParaRPr lang="it-IT"/>
+          </a:p>
+        </p:txBody>
+      </p:sp>
+    </p:spTree>
+    <p:extLst>
+      <p:ext uri="{BB962C8B-B14F-4D97-AF65-F5344CB8AC3E}">
+        <p14:creationId xmlns:p14="http://schemas.microsoft.com/office/powerpoint/2010/main" val="2048141876"/>
+      </p:ext>
+    </p:extLst>
+  </p:cSld>
+  <p:clrMapOvr>
+    <a:masterClrMapping/>
+  </p:clrMapOvr>
+</p:sld>
+</file>
+
+<file path=ppt/slides/slide12.xml><?xml version="1.0" encoding="utf-8"?>
+<p:sld xmlns:a="http://schemas.openxmlformats.org/drawingml/2006/main" xmlns:r="http://schemas.openxmlformats.org/officeDocument/2006/relationships" xmlns:p="http://schemas.openxmlformats.org/presentationml/2006/main">
+  <p:cSld>
+    <p:bg>
+      <p:bgPr>
+        <a:solidFill>
+          <a:schemeClr val="bg1"/>
+        </a:solidFill>
+        <a:effectLst/>
+      </p:bgPr>
+    </p:bg>
+    <p:spTree>
+      <p:nvGrpSpPr>
+        <p:cNvPr id="1" name=""/>
+        <p:cNvGrpSpPr/>
+        <p:nvPr/>
+      </p:nvGrpSpPr>
+      <p:grpSpPr>
+        <a:xfrm>
+          <a:off x="0" y="0"/>
+          <a:ext cx="0" cy="0"/>
+          <a:chOff x="0" y="0"/>
+          <a:chExt cx="0" cy="0"/>
+        </a:xfrm>
+      </p:grpSpPr>
+      <p:sp useBgFill="1">
+        <p:nvSpPr>
+          <p:cNvPr id="21" name="Rectangle 20">
+            <a:extLst>
+              <a:ext uri="{FF2B5EF4-FFF2-40B4-BE49-F238E27FC236}">
+                <a16:creationId xmlns:a16="http://schemas.microsoft.com/office/drawing/2014/main" id="{699373FF-C78A-430B-A246-6048999CE98D}"/>
+              </a:ext>
+              <a:ext uri="{C183D7F6-B498-43B3-948B-1728B52AA6E4}">
+                <adec:decorative xmlns:adec="http://schemas.microsoft.com/office/drawing/2017/decorative" val="1"/>
+              </a:ext>
+            </a:extLst>
+          </p:cNvPr>
+          <p:cNvSpPr>
+            <a:spLocks noGrp="1" noRot="1" noChangeAspect="1" noMove="1" noResize="1" noEditPoints="1" noAdjustHandles="1" noChangeArrowheads="1" noChangeShapeType="1" noTextEdit="1"/>
+          </p:cNvSpPr>
+          <p:nvPr>
+            <p:extLst>
+              <p:ext uri="{386F3935-93C4-4BCD-93E2-E3B085C9AB24}">
+                <p16:designElem xmlns:p16="http://schemas.microsoft.com/office/powerpoint/2015/main" val="1"/>
+              </p:ext>
+            </p:extLst>
+          </p:nvPr>
+        </p:nvSpPr>
+        <p:spPr>
+          <a:xfrm>
+            <a:off x="0" y="0"/>
+            <a:ext cx="12192001" cy="6334316"/>
+          </a:xfrm>
+          <a:prstGeom prst="rect">
+            <a:avLst/>
+          </a:prstGeom>
+          <a:ln>
+            <a:noFill/>
+          </a:ln>
+        </p:spPr>
+        <p:style>
+          <a:lnRef idx="2">
+            <a:schemeClr val="accent1">
+              <a:shade val="50000"/>
+            </a:schemeClr>
+          </a:lnRef>
+          <a:fillRef idx="1">
+            <a:schemeClr val="accent1"/>
+          </a:fillRef>
+          <a:effectRef idx="0">
+            <a:schemeClr val="accent1"/>
+          </a:effectRef>
+          <a:fontRef idx="minor">
+            <a:schemeClr val="lt1"/>
+          </a:fontRef>
+        </p:style>
+        <p:txBody>
+          <a:bodyPr rtlCol="0" anchor="ctr"/>
+          <a:lstStyle/>
+          <a:p>
+            <a:pPr algn="ctr"/>
+            <a:endParaRPr lang="en-US"/>
+          </a:p>
+        </p:txBody>
+      </p:sp>
+      <p:sp>
+        <p:nvSpPr>
+          <p:cNvPr id="2" name="Title 1">
+            <a:extLst>
+              <a:ext uri="{FF2B5EF4-FFF2-40B4-BE49-F238E27FC236}">
+                <a16:creationId xmlns:a16="http://schemas.microsoft.com/office/drawing/2014/main" id="{50572CD8-ACB1-8B57-B1F8-888041DDA7EC}"/>
+              </a:ext>
+            </a:extLst>
+          </p:cNvPr>
+          <p:cNvSpPr>
+            <a:spLocks noGrp="1"/>
+          </p:cNvSpPr>
+          <p:nvPr>
+            <p:ph type="title"/>
+          </p:nvPr>
+        </p:nvSpPr>
+        <p:spPr>
+          <a:xfrm>
+            <a:off x="4703577" y="634946"/>
+            <a:ext cx="6846166" cy="1450757"/>
+          </a:xfrm>
+        </p:spPr>
+        <p:txBody>
+          <a:bodyPr>
+            <a:normAutofit/>
+          </a:bodyPr>
+          <a:lstStyle/>
+          <a:p>
+            <a:r>
+              <a:rPr lang="en-US" dirty="0"/>
+              <a:t>Parallel Forward Edge Iterator V3</a:t>
+            </a:r>
+            <a:endParaRPr lang="it-IT" dirty="0"/>
+          </a:p>
+        </p:txBody>
+      </p:sp>
+      <p:pic>
+        <p:nvPicPr>
+          <p:cNvPr id="7" name="Picture 6" descr="A graph with red line&#10;&#10;AI-generated content may be incorrect.">
+            <a:extLst>
+              <a:ext uri="{FF2B5EF4-FFF2-40B4-BE49-F238E27FC236}">
+                <a16:creationId xmlns:a16="http://schemas.microsoft.com/office/drawing/2014/main" id="{4A3BC75B-3430-0244-CB41-C4EF5F189F66}"/>
+              </a:ext>
+            </a:extLst>
+          </p:cNvPr>
+          <p:cNvPicPr>
+            <a:picLocks noChangeAspect="1"/>
+          </p:cNvPicPr>
+          <p:nvPr/>
+        </p:nvPicPr>
+        <p:blipFill>
+          <a:blip r:embed="rId2">
+            <a:extLst>
+              <a:ext uri="{28A0092B-C50C-407E-A947-70E740481C1C}">
+                <a14:useLocalDpi xmlns:a14="http://schemas.microsoft.com/office/drawing/2010/main" val="0"/>
+              </a:ext>
+            </a:extLst>
+          </a:blip>
+          <a:stretch>
+            <a:fillRect/>
+          </a:stretch>
+        </p:blipFill>
+        <p:spPr>
+          <a:xfrm>
+            <a:off x="214762" y="0"/>
+            <a:ext cx="4101973" cy="2461184"/>
+          </a:xfrm>
+          <a:prstGeom prst="rect">
+            <a:avLst/>
+          </a:prstGeom>
+        </p:spPr>
+      </p:pic>
+      <p:cxnSp>
+        <p:nvCxnSpPr>
+          <p:cNvPr id="23" name="Straight Connector 22">
+            <a:extLst>
+              <a:ext uri="{FF2B5EF4-FFF2-40B4-BE49-F238E27FC236}">
+                <a16:creationId xmlns:a16="http://schemas.microsoft.com/office/drawing/2014/main" id="{03EBB925-FEC3-4CD5-9271-3D75EBB53262}"/>
+              </a:ext>
+              <a:ext uri="{C183D7F6-B498-43B3-948B-1728B52AA6E4}">
+                <adec:decorative xmlns:adec="http://schemas.microsoft.com/office/drawing/2017/decorative" val="1"/>
+              </a:ext>
+            </a:extLst>
+          </p:cNvPr>
+          <p:cNvCxnSpPr>
+            <a:cxnSpLocks noGrp="1" noRot="1" noChangeAspect="1" noMove="1" noResize="1" noEditPoints="1" noAdjustHandles="1" noChangeArrowheads="1" noChangeShapeType="1"/>
+          </p:cNvCxnSpPr>
+          <p:nvPr>
+            <p:extLst>
+              <p:ext uri="{386F3935-93C4-4BCD-93E2-E3B085C9AB24}">
+                <p16:designElem xmlns:p16="http://schemas.microsoft.com/office/powerpoint/2015/main" val="1"/>
+              </p:ext>
+            </p:extLst>
+          </p:nvPr>
+        </p:nvCxnSpPr>
+        <p:spPr>
+          <a:xfrm>
+            <a:off x="4809772" y="2086188"/>
+            <a:ext cx="5852160" cy="0"/>
+          </a:xfrm>
+          <a:prstGeom prst="line">
+            <a:avLst/>
+          </a:prstGeom>
+          <a:ln w="6350">
+            <a:solidFill>
+              <a:schemeClr val="tx1">
+                <a:lumMod val="50000"/>
+                <a:lumOff val="50000"/>
+                <a:alpha val="90000"/>
+              </a:schemeClr>
+            </a:solidFill>
+          </a:ln>
+        </p:spPr>
+        <p:style>
+          <a:lnRef idx="1">
+            <a:schemeClr val="accent1"/>
+          </a:lnRef>
+          <a:fillRef idx="0">
+            <a:schemeClr val="accent1"/>
+          </a:fillRef>
+          <a:effectRef idx="0">
+            <a:schemeClr val="accent1"/>
+          </a:effectRef>
+          <a:fontRef idx="minor">
+            <a:schemeClr val="tx1"/>
+          </a:fontRef>
+        </p:style>
+      </p:cxnSp>
+      <p:pic>
+        <p:nvPicPr>
+          <p:cNvPr id="9" name="Picture 8" descr="A graph with red line&#10;&#10;AI-generated content may be incorrect.">
+            <a:extLst>
+              <a:ext uri="{FF2B5EF4-FFF2-40B4-BE49-F238E27FC236}">
+                <a16:creationId xmlns:a16="http://schemas.microsoft.com/office/drawing/2014/main" id="{20482C44-DF3F-9E6C-0FA6-5ADBF10777DF}"/>
+              </a:ext>
+            </a:extLst>
+          </p:cNvPr>
+          <p:cNvPicPr>
+            <a:picLocks noChangeAspect="1"/>
+          </p:cNvPicPr>
+          <p:nvPr/>
+        </p:nvPicPr>
+        <p:blipFill>
+          <a:blip r:embed="rId3">
+            <a:extLst>
+              <a:ext uri="{28A0092B-C50C-407E-A947-70E740481C1C}">
+                <a14:useLocalDpi xmlns:a14="http://schemas.microsoft.com/office/drawing/2010/main" val="0"/>
+              </a:ext>
+            </a:extLst>
+          </a:blip>
+          <a:stretch>
+            <a:fillRect/>
+          </a:stretch>
+        </p:blipFill>
+        <p:spPr>
+          <a:xfrm>
+            <a:off x="214762" y="2198914"/>
+            <a:ext cx="4101973" cy="2461184"/>
+          </a:xfrm>
+          <a:prstGeom prst="rect">
+            <a:avLst/>
+          </a:prstGeom>
+        </p:spPr>
+      </p:pic>
+      <p:pic>
+        <p:nvPicPr>
+          <p:cNvPr id="5" name="Picture 4">
+            <a:extLst>
+              <a:ext uri="{FF2B5EF4-FFF2-40B4-BE49-F238E27FC236}">
+                <a16:creationId xmlns:a16="http://schemas.microsoft.com/office/drawing/2014/main" id="{C6A37598-569A-E241-7D74-1DA27E813734}"/>
+              </a:ext>
+            </a:extLst>
+          </p:cNvPr>
+          <p:cNvPicPr>
+            <a:picLocks noChangeAspect="1"/>
+          </p:cNvPicPr>
+          <p:nvPr/>
+        </p:nvPicPr>
+        <p:blipFill>
+          <a:blip r:embed="rId4"/>
+          <a:stretch>
+            <a:fillRect/>
+          </a:stretch>
+        </p:blipFill>
+        <p:spPr>
+          <a:xfrm>
+            <a:off x="296872" y="4539243"/>
+            <a:ext cx="3634851" cy="1861557"/>
+          </a:xfrm>
+          <a:prstGeom prst="rect">
+            <a:avLst/>
+          </a:prstGeom>
+        </p:spPr>
+      </p:pic>
+      <p:sp>
+        <p:nvSpPr>
+          <p:cNvPr id="3" name="Content Placeholder 2">
+            <a:extLst>
+              <a:ext uri="{FF2B5EF4-FFF2-40B4-BE49-F238E27FC236}">
+                <a16:creationId xmlns:a16="http://schemas.microsoft.com/office/drawing/2014/main" id="{B02BA261-F6BB-5B21-E1B4-22192CCF2015}"/>
+              </a:ext>
+            </a:extLst>
+          </p:cNvPr>
+          <p:cNvSpPr>
+            <a:spLocks noGrp="1"/>
+          </p:cNvSpPr>
+          <p:nvPr>
+            <p:ph idx="1"/>
+          </p:nvPr>
+        </p:nvSpPr>
+        <p:spPr>
+          <a:xfrm>
+            <a:off x="4701747" y="2198914"/>
+            <a:ext cx="6847996" cy="3670180"/>
+          </a:xfrm>
+        </p:spPr>
+        <p:txBody>
+          <a:bodyPr>
+            <a:normAutofit/>
+          </a:bodyPr>
+          <a:lstStyle/>
+          <a:p>
+            <a:r>
+              <a:rPr lang="en-US" sz="1400"/>
+              <a:t>This highly optimized version of the Edge Algorithm incorporates several key enhancements for maximum performance.</a:t>
+            </a:r>
+          </a:p>
+          <a:p>
+            <a:r>
+              <a:rPr lang="en-US" sz="1400"/>
+              <a:t>First, it uses std::</a:t>
+            </a:r>
+            <a:r>
+              <a:rPr lang="en-US" sz="1400" err="1"/>
+              <a:t>unordered_map</a:t>
+            </a:r>
+            <a:r>
+              <a:rPr lang="en-US" sz="1400"/>
+              <a:t> for data storage, which provides near-instantaneous </a:t>
+            </a:r>
+            <a:r>
+              <a:rPr lang="en-US" sz="1400" b="1"/>
+              <a:t>O(1)</a:t>
+            </a:r>
+            <a:r>
+              <a:rPr lang="en-US" sz="1400"/>
+              <a:t> average lookup times, a significant improvement over the O(</a:t>
+            </a:r>
+            <a:r>
+              <a:rPr lang="en-US" sz="1400" err="1"/>
+              <a:t>logN</a:t>
+            </a:r>
+            <a:r>
+              <a:rPr lang="en-US" sz="1400"/>
+              <a:t>) of previous versions. For parallelism, it uses std::async to create tasks managed by the OS. Crucially, each thread uses a </a:t>
+            </a:r>
+            <a:r>
+              <a:rPr lang="en-US" sz="1400" b="1"/>
+              <a:t>local triangle counter</a:t>
+            </a:r>
+            <a:r>
+              <a:rPr lang="en-US" sz="1400"/>
+              <a:t>, completely eliminating the need for slow synchronization tools like mutexes or atomic operations. ⚡</a:t>
+            </a:r>
+          </a:p>
+          <a:p>
+            <a:r>
+              <a:rPr lang="en-US" sz="1400"/>
+              <a:t>Further optimizations include:</a:t>
+            </a:r>
+          </a:p>
+          <a:p>
+            <a:pPr marL="0" indent="0">
+              <a:buNone/>
+            </a:pPr>
+            <a:r>
+              <a:rPr lang="en-US" sz="1400"/>
+              <a:t>1) A fast </a:t>
+            </a:r>
+            <a:r>
+              <a:rPr lang="en-US" sz="1400" b="1"/>
+              <a:t>two-pointer intersection</a:t>
+            </a:r>
+            <a:r>
+              <a:rPr lang="en-US" sz="1400"/>
+              <a:t> method to find common neighbors on pre-sorted lists.</a:t>
+            </a:r>
+          </a:p>
+          <a:p>
+            <a:pPr marL="0" indent="0">
+              <a:buNone/>
+            </a:pPr>
+            <a:r>
+              <a:rPr lang="en-US" sz="1400"/>
+              <a:t>2) </a:t>
+            </a:r>
+            <a:r>
+              <a:rPr lang="en-US" sz="1400" b="1"/>
+              <a:t>Pre-filtering edges</a:t>
+            </a:r>
+            <a:r>
+              <a:rPr lang="en-US" sz="1400"/>
+              <a:t> at the start to remove redundant checks from the main loop.</a:t>
+            </a:r>
+          </a:p>
+          <a:p>
+            <a:pPr marL="0" indent="0">
+              <a:buNone/>
+            </a:pPr>
+            <a:r>
+              <a:rPr lang="en-US" sz="1400"/>
+              <a:t>3) Passing data by </a:t>
+            </a:r>
+            <a:r>
+              <a:rPr lang="en-US" sz="1400" b="1"/>
+              <a:t>constant reference</a:t>
+            </a:r>
+            <a:r>
+              <a:rPr lang="en-US" sz="1400"/>
+              <a:t> (const &amp;) to avoid expensive data copying between threads.</a:t>
+            </a:r>
+          </a:p>
+          <a:p>
+            <a:endParaRPr lang="it-IT" sz="1400"/>
+          </a:p>
+        </p:txBody>
+      </p:sp>
+      <p:sp>
+        <p:nvSpPr>
+          <p:cNvPr id="25" name="Rectangle 24">
+            <a:extLst>
+              <a:ext uri="{FF2B5EF4-FFF2-40B4-BE49-F238E27FC236}">
+                <a16:creationId xmlns:a16="http://schemas.microsoft.com/office/drawing/2014/main" id="{109B2863-A1A5-4050-8DE8-9BC0AD47F40B}"/>
+              </a:ext>
+              <a:ext uri="{C183D7F6-B498-43B3-948B-1728B52AA6E4}">
+                <adec:decorative xmlns:adec="http://schemas.microsoft.com/office/drawing/2017/decorative" val="1"/>
+              </a:ext>
+            </a:extLst>
+          </p:cNvPr>
+          <p:cNvSpPr>
+            <a:spLocks noGrp="1" noRot="1" noChangeAspect="1" noMove="1" noResize="1" noEditPoints="1" noAdjustHandles="1" noChangeArrowheads="1" noChangeShapeType="1" noTextEdit="1"/>
+          </p:cNvSpPr>
+          <p:nvPr>
+            <p:extLst>
+              <p:ext uri="{386F3935-93C4-4BCD-93E2-E3B085C9AB24}">
+                <p16:designElem xmlns:p16="http://schemas.microsoft.com/office/powerpoint/2015/main" val="1"/>
+              </p:ext>
+            </p:extLst>
+          </p:nvPr>
+        </p:nvSpPr>
+        <p:spPr>
+          <a:xfrm>
+            <a:off x="15" y="6334316"/>
+            <a:ext cx="12191985" cy="66484"/>
+          </a:xfrm>
+          <a:prstGeom prst="rect">
+            <a:avLst/>
+          </a:prstGeom>
+          <a:solidFill>
+            <a:schemeClr val="accent1"/>
+          </a:solidFill>
+          <a:ln>
+            <a:noFill/>
+          </a:ln>
+        </p:spPr>
+        <p:style>
+          <a:lnRef idx="2">
+            <a:schemeClr val="accent1">
+              <a:shade val="50000"/>
+            </a:schemeClr>
+          </a:lnRef>
+          <a:fillRef idx="1">
+            <a:schemeClr val="accent1"/>
+          </a:fillRef>
+          <a:effectRef idx="0">
+            <a:schemeClr val="accent1"/>
+          </a:effectRef>
+          <a:fontRef idx="minor">
+            <a:schemeClr val="lt1"/>
+          </a:fontRef>
+        </p:style>
+        <p:txBody>
+          <a:bodyPr/>
+          <a:lstStyle/>
+          <a:p>
+            <a:endParaRPr lang="it-IT"/>
+          </a:p>
+        </p:txBody>
+      </p:sp>
+      <p:sp>
+        <p:nvSpPr>
+          <p:cNvPr id="27" name="Rectangle 26">
+            <a:extLst>
+              <a:ext uri="{FF2B5EF4-FFF2-40B4-BE49-F238E27FC236}">
+                <a16:creationId xmlns:a16="http://schemas.microsoft.com/office/drawing/2014/main" id="{F1F76955-21E0-4116-A6AA-19DB89B503F7}"/>
+              </a:ext>
+              <a:ext uri="{C183D7F6-B498-43B3-948B-1728B52AA6E4}">
+                <adec:decorative xmlns:adec="http://schemas.microsoft.com/office/drawing/2017/decorative" val="1"/>
+              </a:ext>
+            </a:extLst>
+          </p:cNvPr>
+          <p:cNvSpPr>
+            <a:spLocks noGrp="1" noRot="1" noChangeAspect="1" noMove="1" noResize="1" noEditPoints="1" noAdjustHandles="1" noChangeArrowheads="1" noChangeShapeType="1" noTextEdit="1"/>
+          </p:cNvSpPr>
+          <p:nvPr>
+            <p:extLst>
+              <p:ext uri="{386F3935-93C4-4BCD-93E2-E3B085C9AB24}">
+                <p16:designElem xmlns:p16="http://schemas.microsoft.com/office/powerpoint/2015/main" val="1"/>
+              </p:ext>
+            </p:extLst>
+          </p:nvPr>
+        </p:nvSpPr>
+        <p:spPr>
+          <a:xfrm>
+            <a:off x="1" y="6400800"/>
+            <a:ext cx="12192000" cy="457200"/>
+          </a:xfrm>
+          <a:prstGeom prst="rect">
+            <a:avLst/>
+          </a:prstGeom>
+          <a:solidFill>
+            <a:schemeClr val="accent2"/>
+          </a:solidFill>
+          <a:ln>
+            <a:noFill/>
+          </a:ln>
+        </p:spPr>
+        <p:style>
+          <a:lnRef idx="2">
+            <a:schemeClr val="accent1">
+              <a:shade val="50000"/>
+            </a:schemeClr>
+          </a:lnRef>
+          <a:fillRef idx="1">
+            <a:schemeClr val="accent1"/>
+          </a:fillRef>
+          <a:effectRef idx="0">
+            <a:schemeClr val="accent1"/>
+          </a:effectRef>
+          <a:fontRef idx="minor">
+            <a:schemeClr val="lt1"/>
+          </a:fontRef>
+        </p:style>
+        <p:txBody>
+          <a:bodyPr/>
+          <a:lstStyle/>
+          <a:p>
+            <a:endParaRPr lang="it-IT"/>
+          </a:p>
+        </p:txBody>
+      </p:sp>
+    </p:spTree>
+    <p:extLst>
+      <p:ext uri="{BB962C8B-B14F-4D97-AF65-F5344CB8AC3E}">
+        <p14:creationId xmlns:p14="http://schemas.microsoft.com/office/powerpoint/2010/main" val="1547577232"/>
+      </p:ext>
+    </p:extLst>
+  </p:cSld>
+  <p:clrMapOvr>
+    <a:masterClrMapping/>
+  </p:clrMapOvr>
+</p:sld>
+</file>
+
 <file path=ppt/slides/slide2.xml><?xml version="1.0" encoding="utf-8"?>
 <p:sld xmlns:a="http://schemas.openxmlformats.org/drawingml/2006/main" xmlns:r="http://schemas.openxmlformats.org/officeDocument/2006/relationships" xmlns:p="http://schemas.openxmlformats.org/presentationml/2006/main">
   <p:cSld>

</xml_diff>

<commit_message>
CUDA parallel edge added on presentation
</commit_message>
<xml_diff>
--- a/presentation.pptx
+++ b/presentation.pptx
@@ -17,6 +17,12 @@
     <p:sldId id="265" r:id="rId11"/>
     <p:sldId id="266" r:id="rId12"/>
     <p:sldId id="267" r:id="rId13"/>
+    <p:sldId id="268" r:id="rId14"/>
+    <p:sldId id="269" r:id="rId15"/>
+    <p:sldId id="270" r:id="rId16"/>
+    <p:sldId id="271" r:id="rId17"/>
+    <p:sldId id="272" r:id="rId18"/>
+    <p:sldId id="273" r:id="rId19"/>
   </p:sldIdLst>
   <p:sldSz cx="12192000" cy="6858000"/>
   <p:notesSz cx="6858000" cy="9144000"/>
@@ -349,7 +355,7 @@
           <a:p>
             <a:fld id="{1CDE5452-170D-44D1-B161-4C3EAA4B8855}" type="datetimeFigureOut">
               <a:rPr lang="it-IT" smtClean="0"/>
-              <a:t>03/09/2025</a:t>
+              <a:t>04/09/2025</a:t>
             </a:fld>
             <a:endParaRPr lang="it-IT"/>
           </a:p>
@@ -557,7 +563,7 @@
           <a:p>
             <a:fld id="{1CDE5452-170D-44D1-B161-4C3EAA4B8855}" type="datetimeFigureOut">
               <a:rPr lang="it-IT" smtClean="0"/>
-              <a:t>03/09/2025</a:t>
+              <a:t>04/09/2025</a:t>
             </a:fld>
             <a:endParaRPr lang="it-IT"/>
           </a:p>
@@ -813,7 +819,7 @@
           <a:p>
             <a:fld id="{1CDE5452-170D-44D1-B161-4C3EAA4B8855}" type="datetimeFigureOut">
               <a:rPr lang="it-IT" smtClean="0"/>
-              <a:t>03/09/2025</a:t>
+              <a:t>04/09/2025</a:t>
             </a:fld>
             <a:endParaRPr lang="it-IT"/>
           </a:p>
@@ -987,7 +993,7 @@
           <a:p>
             <a:fld id="{1CDE5452-170D-44D1-B161-4C3EAA4B8855}" type="datetimeFigureOut">
               <a:rPr lang="it-IT" smtClean="0"/>
-              <a:t>03/09/2025</a:t>
+              <a:t>04/09/2025</a:t>
             </a:fld>
             <a:endParaRPr lang="it-IT"/>
           </a:p>
@@ -1330,7 +1336,7 @@
           <a:p>
             <a:fld id="{1CDE5452-170D-44D1-B161-4C3EAA4B8855}" type="datetimeFigureOut">
               <a:rPr lang="it-IT" smtClean="0"/>
-              <a:t>03/09/2025</a:t>
+              <a:t>04/09/2025</a:t>
             </a:fld>
             <a:endParaRPr lang="it-IT"/>
           </a:p>
@@ -1605,7 +1611,7 @@
           <a:p>
             <a:fld id="{1CDE5452-170D-44D1-B161-4C3EAA4B8855}" type="datetimeFigureOut">
               <a:rPr lang="it-IT" smtClean="0"/>
-              <a:t>03/09/2025</a:t>
+              <a:t>04/09/2025</a:t>
             </a:fld>
             <a:endParaRPr lang="it-IT"/>
           </a:p>
@@ -1984,7 +1990,7 @@
           <a:p>
             <a:fld id="{1CDE5452-170D-44D1-B161-4C3EAA4B8855}" type="datetimeFigureOut">
               <a:rPr lang="it-IT" smtClean="0"/>
-              <a:t>03/09/2025</a:t>
+              <a:t>04/09/2025</a:t>
             </a:fld>
             <a:endParaRPr lang="it-IT"/>
           </a:p>
@@ -2102,7 +2108,7 @@
           <a:p>
             <a:fld id="{1CDE5452-170D-44D1-B161-4C3EAA4B8855}" type="datetimeFigureOut">
               <a:rPr lang="it-IT" smtClean="0"/>
-              <a:t>03/09/2025</a:t>
+              <a:t>04/09/2025</a:t>
             </a:fld>
             <a:endParaRPr lang="it-IT"/>
           </a:p>
@@ -2273,7 +2279,7 @@
           <a:p>
             <a:fld id="{1CDE5452-170D-44D1-B161-4C3EAA4B8855}" type="datetimeFigureOut">
               <a:rPr lang="it-IT" smtClean="0"/>
-              <a:t>03/09/2025</a:t>
+              <a:t>04/09/2025</a:t>
             </a:fld>
             <a:endParaRPr lang="it-IT"/>
           </a:p>
@@ -2627,7 +2633,7 @@
           <a:p>
             <a:fld id="{1CDE5452-170D-44D1-B161-4C3EAA4B8855}" type="datetimeFigureOut">
               <a:rPr lang="it-IT" smtClean="0"/>
-              <a:t>03/09/2025</a:t>
+              <a:t>04/09/2025</a:t>
             </a:fld>
             <a:endParaRPr lang="it-IT"/>
           </a:p>
@@ -3009,7 +3015,7 @@
           <a:p>
             <a:fld id="{1CDE5452-170D-44D1-B161-4C3EAA4B8855}" type="datetimeFigureOut">
               <a:rPr lang="it-IT" smtClean="0"/>
-              <a:t>03/09/2025</a:t>
+              <a:t>04/09/2025</a:t>
             </a:fld>
             <a:endParaRPr lang="it-IT"/>
           </a:p>
@@ -3296,7 +3302,7 @@
           <a:p>
             <a:fld id="{1CDE5452-170D-44D1-B161-4C3EAA4B8855}" type="datetimeFigureOut">
               <a:rPr lang="it-IT" smtClean="0"/>
-              <a:t>03/09/2025</a:t>
+              <a:t>04/09/2025</a:t>
             </a:fld>
             <a:endParaRPr lang="it-IT"/>
           </a:p>
@@ -4970,7 +4976,7 @@
         </p:blipFill>
         <p:spPr>
           <a:xfrm>
-            <a:off x="214762" y="0"/>
+            <a:off x="214762" y="-17698"/>
             <a:ext cx="4101973" cy="2461184"/>
           </a:xfrm>
           <a:prstGeom prst="rect">
@@ -5361,6 +5367,1320 @@
     <p:extLst>
       <p:ext uri="{BB962C8B-B14F-4D97-AF65-F5344CB8AC3E}">
         <p14:creationId xmlns:p14="http://schemas.microsoft.com/office/powerpoint/2010/main" val="1547577232"/>
+      </p:ext>
+    </p:extLst>
+  </p:cSld>
+  <p:clrMapOvr>
+    <a:masterClrMapping/>
+  </p:clrMapOvr>
+</p:sld>
+</file>
+
+<file path=ppt/slides/slide13.xml><?xml version="1.0" encoding="utf-8"?>
+<p:sld xmlns:a="http://schemas.openxmlformats.org/drawingml/2006/main" xmlns:r="http://schemas.openxmlformats.org/officeDocument/2006/relationships" xmlns:p="http://schemas.openxmlformats.org/presentationml/2006/main">
+  <p:cSld>
+    <p:spTree>
+      <p:nvGrpSpPr>
+        <p:cNvPr id="1" name=""/>
+        <p:cNvGrpSpPr/>
+        <p:nvPr/>
+      </p:nvGrpSpPr>
+      <p:grpSpPr>
+        <a:xfrm>
+          <a:off x="0" y="0"/>
+          <a:ext cx="0" cy="0"/>
+          <a:chOff x="0" y="0"/>
+          <a:chExt cx="0" cy="0"/>
+        </a:xfrm>
+      </p:grpSpPr>
+      <p:sp>
+        <p:nvSpPr>
+          <p:cNvPr id="2" name="Title 1">
+            <a:extLst>
+              <a:ext uri="{FF2B5EF4-FFF2-40B4-BE49-F238E27FC236}">
+                <a16:creationId xmlns:a16="http://schemas.microsoft.com/office/drawing/2014/main" id="{71A50906-B844-4BFE-8647-BDCF17A3AF80}"/>
+              </a:ext>
+            </a:extLst>
+          </p:cNvPr>
+          <p:cNvSpPr>
+            <a:spLocks noGrp="1"/>
+          </p:cNvSpPr>
+          <p:nvPr>
+            <p:ph type="title"/>
+          </p:nvPr>
+        </p:nvSpPr>
+        <p:spPr>
+          <a:xfrm>
+            <a:off x="4908262" y="1073683"/>
+            <a:ext cx="6247418" cy="663677"/>
+          </a:xfrm>
+        </p:spPr>
+        <p:txBody>
+          <a:bodyPr>
+            <a:normAutofit fontScale="90000"/>
+          </a:bodyPr>
+          <a:lstStyle/>
+          <a:p>
+            <a:r>
+              <a:rPr lang="en-US" dirty="0"/>
+              <a:t>CUDA Parallel Forward Edge Iterator V1</a:t>
+            </a:r>
+            <a:endParaRPr lang="it-IT" dirty="0"/>
+          </a:p>
+        </p:txBody>
+      </p:sp>
+      <p:sp>
+        <p:nvSpPr>
+          <p:cNvPr id="3" name="Content Placeholder 2">
+            <a:extLst>
+              <a:ext uri="{FF2B5EF4-FFF2-40B4-BE49-F238E27FC236}">
+                <a16:creationId xmlns:a16="http://schemas.microsoft.com/office/drawing/2014/main" id="{18C7CF8C-4187-4FF0-AADA-8E3647C37F11}"/>
+              </a:ext>
+            </a:extLst>
+          </p:cNvPr>
+          <p:cNvSpPr>
+            <a:spLocks noGrp="1"/>
+          </p:cNvSpPr>
+          <p:nvPr>
+            <p:ph idx="1"/>
+          </p:nvPr>
+        </p:nvSpPr>
+        <p:spPr>
+          <a:xfrm>
+            <a:off x="4908262" y="1846498"/>
+            <a:ext cx="6247417" cy="4022596"/>
+          </a:xfrm>
+        </p:spPr>
+        <p:txBody>
+          <a:bodyPr>
+            <a:normAutofit fontScale="92500" lnSpcReduction="10000"/>
+          </a:bodyPr>
+          <a:lstStyle/>
+          <a:p>
+            <a:r>
+              <a:rPr lang="en-US" dirty="0"/>
+              <a:t>The </a:t>
+            </a:r>
+            <a:r>
+              <a:rPr lang="en-US" b="1" dirty="0"/>
+              <a:t>Forward Edge Iterator</a:t>
+            </a:r>
+            <a:r>
+              <a:rPr lang="en-US" dirty="0"/>
+              <a:t> has also been implemented in CUDA, similar to the Forward Node Algorithm. It uses the </a:t>
+            </a:r>
+            <a:r>
+              <a:rPr lang="en-US" b="1" dirty="0"/>
+              <a:t>CRS (Compressed Row Storage)</a:t>
+            </a:r>
+            <a:r>
+              <a:rPr lang="en-US" dirty="0"/>
+              <a:t> format to represent the graph data. The implementation assigns </a:t>
+            </a:r>
+            <a:r>
+              <a:rPr lang="en-US" b="1" dirty="0"/>
+              <a:t>one thread to manage one edge</a:t>
+            </a:r>
+            <a:r>
+              <a:rPr lang="en-US" dirty="0"/>
+              <a:t>, handled through the function </a:t>
+            </a:r>
+            <a:r>
+              <a:rPr lang="en-US" i="1" dirty="0" err="1"/>
+              <a:t>EdgeIteratorAlgorithmKernel</a:t>
+            </a:r>
+            <a:r>
+              <a:rPr lang="en-US" dirty="0"/>
+              <a:t>. Since each edge connects two nodes in the graph, the function iterates over the neighbors of both nodes, and whenever two neighbors match, a new triangle is counted.</a:t>
+            </a:r>
+          </a:p>
+          <a:p>
+            <a:r>
+              <a:rPr lang="en-US" dirty="0"/>
+              <a:t>In the graph shown, we observe a significant reduction in execution time as </a:t>
+            </a:r>
+            <a:r>
+              <a:rPr lang="en-US" b="1" dirty="0"/>
+              <a:t>BLOCK_SIZE</a:t>
+            </a:r>
+            <a:r>
+              <a:rPr lang="en-US" dirty="0"/>
+              <a:t> increases from 8 to 128, where the function achieves its minimum execution time. Beyond this point, further increases in </a:t>
+            </a:r>
+            <a:r>
+              <a:rPr lang="en-US" b="1" dirty="0"/>
+              <a:t>BLOCK_SIZE</a:t>
+            </a:r>
+            <a:r>
+              <a:rPr lang="en-US" dirty="0"/>
+              <a:t> lead to longer execution times. This behavior is due to </a:t>
+            </a:r>
+            <a:r>
+              <a:rPr lang="en-US" b="1" dirty="0"/>
+              <a:t>resource limitations</a:t>
+            </a:r>
+            <a:r>
+              <a:rPr lang="en-US" dirty="0"/>
+              <a:t>, which reduce the number of active warps available.</a:t>
+            </a:r>
+          </a:p>
+          <a:p>
+            <a:endParaRPr lang="it-IT" dirty="0"/>
+          </a:p>
+        </p:txBody>
+      </p:sp>
+      <p:pic>
+        <p:nvPicPr>
+          <p:cNvPr id="4" name="Picture 3">
+            <a:extLst>
+              <a:ext uri="{FF2B5EF4-FFF2-40B4-BE49-F238E27FC236}">
+                <a16:creationId xmlns:a16="http://schemas.microsoft.com/office/drawing/2014/main" id="{C59DFCE3-567F-4B74-8016-E48DD22B303C}"/>
+              </a:ext>
+            </a:extLst>
+          </p:cNvPr>
+          <p:cNvPicPr>
+            <a:picLocks noChangeAspect="1"/>
+          </p:cNvPicPr>
+          <p:nvPr/>
+        </p:nvPicPr>
+        <p:blipFill>
+          <a:blip r:embed="rId2"/>
+          <a:stretch>
+            <a:fillRect/>
+          </a:stretch>
+        </p:blipFill>
+        <p:spPr>
+          <a:xfrm>
+            <a:off x="155056" y="1737360"/>
+            <a:ext cx="4753206" cy="3013544"/>
+          </a:xfrm>
+          <a:prstGeom prst="rect">
+            <a:avLst/>
+          </a:prstGeom>
+        </p:spPr>
+      </p:pic>
+    </p:spTree>
+    <p:extLst>
+      <p:ext uri="{BB962C8B-B14F-4D97-AF65-F5344CB8AC3E}">
+        <p14:creationId xmlns:p14="http://schemas.microsoft.com/office/powerpoint/2010/main" val="3421887235"/>
+      </p:ext>
+    </p:extLst>
+  </p:cSld>
+  <p:clrMapOvr>
+    <a:masterClrMapping/>
+  </p:clrMapOvr>
+</p:sld>
+</file>
+
+<file path=ppt/slides/slide14.xml><?xml version="1.0" encoding="utf-8"?>
+<p:sld xmlns:a="http://schemas.openxmlformats.org/drawingml/2006/main" xmlns:r="http://schemas.openxmlformats.org/officeDocument/2006/relationships" xmlns:p="http://schemas.openxmlformats.org/presentationml/2006/main">
+  <p:cSld>
+    <p:spTree>
+      <p:nvGrpSpPr>
+        <p:cNvPr id="1" name=""/>
+        <p:cNvGrpSpPr/>
+        <p:nvPr/>
+      </p:nvGrpSpPr>
+      <p:grpSpPr>
+        <a:xfrm>
+          <a:off x="0" y="0"/>
+          <a:ext cx="0" cy="0"/>
+          <a:chOff x="0" y="0"/>
+          <a:chExt cx="0" cy="0"/>
+        </a:xfrm>
+      </p:grpSpPr>
+      <p:sp>
+        <p:nvSpPr>
+          <p:cNvPr id="2" name="Title 1">
+            <a:extLst>
+              <a:ext uri="{FF2B5EF4-FFF2-40B4-BE49-F238E27FC236}">
+                <a16:creationId xmlns:a16="http://schemas.microsoft.com/office/drawing/2014/main" id="{AB737B48-0C32-42E8-821E-4DAB55EF75E4}"/>
+              </a:ext>
+            </a:extLst>
+          </p:cNvPr>
+          <p:cNvSpPr>
+            <a:spLocks noGrp="1"/>
+          </p:cNvSpPr>
+          <p:nvPr>
+            <p:ph type="title"/>
+          </p:nvPr>
+        </p:nvSpPr>
+        <p:spPr>
+          <a:xfrm>
+            <a:off x="4943658" y="371659"/>
+            <a:ext cx="6212021" cy="1365701"/>
+          </a:xfrm>
+        </p:spPr>
+        <p:txBody>
+          <a:bodyPr/>
+          <a:lstStyle/>
+          <a:p>
+            <a:r>
+              <a:rPr lang="en-US" dirty="0"/>
+              <a:t>CUDA Parallel Forward Edge Iterator V1_1</a:t>
+            </a:r>
+            <a:endParaRPr lang="it-IT" dirty="0"/>
+          </a:p>
+        </p:txBody>
+      </p:sp>
+      <p:sp>
+        <p:nvSpPr>
+          <p:cNvPr id="3" name="Content Placeholder 2">
+            <a:extLst>
+              <a:ext uri="{FF2B5EF4-FFF2-40B4-BE49-F238E27FC236}">
+                <a16:creationId xmlns:a16="http://schemas.microsoft.com/office/drawing/2014/main" id="{7478F246-FEDA-4B80-B6DD-D2E52B0FB123}"/>
+              </a:ext>
+            </a:extLst>
+          </p:cNvPr>
+          <p:cNvSpPr>
+            <a:spLocks noGrp="1"/>
+          </p:cNvSpPr>
+          <p:nvPr>
+            <p:ph idx="1"/>
+          </p:nvPr>
+        </p:nvSpPr>
+        <p:spPr>
+          <a:xfrm>
+            <a:off x="4849270" y="1845734"/>
+            <a:ext cx="6306409" cy="4023360"/>
+          </a:xfrm>
+        </p:spPr>
+        <p:txBody>
+          <a:bodyPr>
+            <a:normAutofit fontScale="92500" lnSpcReduction="20000"/>
+          </a:bodyPr>
+          <a:lstStyle/>
+          <a:p>
+            <a:r>
+              <a:rPr lang="en-US" dirty="0"/>
+              <a:t>The </a:t>
+            </a:r>
+            <a:r>
+              <a:rPr lang="en-US" b="1" dirty="0"/>
+              <a:t>V1_1 version</a:t>
+            </a:r>
+            <a:r>
+              <a:rPr lang="en-US" dirty="0"/>
+              <a:t> builds directly on the original CUDA Forward Edge Iterator. The core function (</a:t>
+            </a:r>
+            <a:r>
+              <a:rPr lang="en-US" i="1" dirty="0" err="1"/>
+              <a:t>EdgeIteratorAlgorithmKernel</a:t>
+            </a:r>
+            <a:r>
+              <a:rPr lang="en-US" dirty="0"/>
+              <a:t>) remains unchanged. The key modification is in how edges are assigned: Instead of one thread handling exactly one edge, the full edge set is divided into </a:t>
+            </a:r>
+            <a:r>
+              <a:rPr lang="en-US" b="1" dirty="0"/>
+              <a:t>chunks</a:t>
+            </a:r>
+            <a:r>
+              <a:rPr lang="en-US" dirty="0"/>
+              <a:t>, with each thread responsible for one chunk. This design aims to improve </a:t>
+            </a:r>
+            <a:r>
+              <a:rPr lang="en-US" b="1" dirty="0"/>
+              <a:t>GPU resource utilization</a:t>
+            </a:r>
+            <a:r>
+              <a:rPr lang="en-US" dirty="0"/>
+              <a:t> and reduce latency by lowering the number of tasks the scheduler must manage in parallel.</a:t>
+            </a:r>
+          </a:p>
+          <a:p>
+            <a:r>
+              <a:rPr lang="en-US" dirty="0"/>
+              <a:t>The graph illustrates the total execution time as a function of the number of </a:t>
+            </a:r>
+            <a:r>
+              <a:rPr lang="en-US" b="1" dirty="0"/>
+              <a:t>kernel launches</a:t>
+            </a:r>
+            <a:r>
+              <a:rPr lang="en-US" dirty="0"/>
+              <a:t> for different </a:t>
+            </a:r>
+            <a:r>
+              <a:rPr lang="en-US" b="1" dirty="0"/>
+              <a:t>BLOCK_SIZE</a:t>
+            </a:r>
+            <a:r>
+              <a:rPr lang="en-US" dirty="0"/>
+              <a:t> configurations. Execution time </a:t>
+            </a:r>
+            <a:r>
+              <a:rPr lang="en-US" b="1" dirty="0"/>
+              <a:t>increases consistently</a:t>
+            </a:r>
+            <a:r>
+              <a:rPr lang="en-US" dirty="0"/>
+              <a:t> as the number of kernel launches grows, due to overhead from setup, scheduling, and synchronization. While chunking can sometimes improve GPU occupancy, here the </a:t>
+            </a:r>
+            <a:r>
+              <a:rPr lang="en-US" b="1" dirty="0"/>
+              <a:t>launch overhead dominates</a:t>
+            </a:r>
+            <a:r>
+              <a:rPr lang="en-US" dirty="0"/>
+              <a:t>, negating potential benefits. Different </a:t>
+            </a:r>
+            <a:r>
+              <a:rPr lang="en-US" b="1" dirty="0"/>
+              <a:t>BLOCK_SIZE</a:t>
+            </a:r>
+            <a:r>
+              <a:rPr lang="en-US" dirty="0"/>
+              <a:t> values exhibit similar trends, though </a:t>
+            </a:r>
+            <a:r>
+              <a:rPr lang="en-US" b="1" dirty="0"/>
+              <a:t>BLOCK_SIZE = 16</a:t>
+            </a:r>
+            <a:r>
+              <a:rPr lang="en-US" dirty="0"/>
+              <a:t> and </a:t>
+            </a:r>
+            <a:r>
+              <a:rPr lang="en-US" b="1" dirty="0"/>
+              <a:t>32</a:t>
+            </a:r>
+            <a:r>
+              <a:rPr lang="en-US" dirty="0"/>
+              <a:t> show slightly better performance at lower launch counts.</a:t>
+            </a:r>
+          </a:p>
+          <a:p>
+            <a:endParaRPr lang="en-US" dirty="0"/>
+          </a:p>
+        </p:txBody>
+      </p:sp>
+      <p:pic>
+        <p:nvPicPr>
+          <p:cNvPr id="4" name="Picture 3">
+            <a:extLst>
+              <a:ext uri="{FF2B5EF4-FFF2-40B4-BE49-F238E27FC236}">
+                <a16:creationId xmlns:a16="http://schemas.microsoft.com/office/drawing/2014/main" id="{9A59FA78-B03A-4CA7-B577-2ABC83606275}"/>
+              </a:ext>
+            </a:extLst>
+          </p:cNvPr>
+          <p:cNvPicPr>
+            <a:picLocks noChangeAspect="1"/>
+          </p:cNvPicPr>
+          <p:nvPr/>
+        </p:nvPicPr>
+        <p:blipFill>
+          <a:blip r:embed="rId2"/>
+          <a:stretch>
+            <a:fillRect/>
+          </a:stretch>
+        </p:blipFill>
+        <p:spPr>
+          <a:xfrm>
+            <a:off x="185030" y="1580262"/>
+            <a:ext cx="4664240" cy="2891449"/>
+          </a:xfrm>
+          <a:prstGeom prst="rect">
+            <a:avLst/>
+          </a:prstGeom>
+        </p:spPr>
+      </p:pic>
+    </p:spTree>
+    <p:extLst>
+      <p:ext uri="{BB962C8B-B14F-4D97-AF65-F5344CB8AC3E}">
+        <p14:creationId xmlns:p14="http://schemas.microsoft.com/office/powerpoint/2010/main" val="544973999"/>
+      </p:ext>
+    </p:extLst>
+  </p:cSld>
+  <p:clrMapOvr>
+    <a:masterClrMapping/>
+  </p:clrMapOvr>
+</p:sld>
+</file>
+
+<file path=ppt/slides/slide15.xml><?xml version="1.0" encoding="utf-8"?>
+<p:sld xmlns:a="http://schemas.openxmlformats.org/drawingml/2006/main" xmlns:r="http://schemas.openxmlformats.org/officeDocument/2006/relationships" xmlns:p="http://schemas.openxmlformats.org/presentationml/2006/main">
+  <p:cSld>
+    <p:spTree>
+      <p:nvGrpSpPr>
+        <p:cNvPr id="1" name=""/>
+        <p:cNvGrpSpPr/>
+        <p:nvPr/>
+      </p:nvGrpSpPr>
+      <p:grpSpPr>
+        <a:xfrm>
+          <a:off x="0" y="0"/>
+          <a:ext cx="0" cy="0"/>
+          <a:chOff x="0" y="0"/>
+          <a:chExt cx="0" cy="0"/>
+        </a:xfrm>
+      </p:grpSpPr>
+      <p:sp>
+        <p:nvSpPr>
+          <p:cNvPr id="2" name="Title 1">
+            <a:extLst>
+              <a:ext uri="{FF2B5EF4-FFF2-40B4-BE49-F238E27FC236}">
+                <a16:creationId xmlns:a16="http://schemas.microsoft.com/office/drawing/2014/main" id="{4EFDE9B1-0271-46CE-B282-36987546B4BC}"/>
+              </a:ext>
+            </a:extLst>
+          </p:cNvPr>
+          <p:cNvSpPr>
+            <a:spLocks noGrp="1"/>
+          </p:cNvSpPr>
+          <p:nvPr>
+            <p:ph type="title"/>
+          </p:nvPr>
+        </p:nvSpPr>
+        <p:spPr>
+          <a:xfrm>
+            <a:off x="5043948" y="286603"/>
+            <a:ext cx="6111732" cy="1450757"/>
+          </a:xfrm>
+        </p:spPr>
+        <p:txBody>
+          <a:bodyPr/>
+          <a:lstStyle/>
+          <a:p>
+            <a:r>
+              <a:rPr lang="en-US" dirty="0"/>
+              <a:t>CUDA Parallel Forward Edge Iterator V2</a:t>
+            </a:r>
+            <a:endParaRPr lang="it-IT" dirty="0"/>
+          </a:p>
+        </p:txBody>
+      </p:sp>
+      <p:sp>
+        <p:nvSpPr>
+          <p:cNvPr id="3" name="Content Placeholder 2">
+            <a:extLst>
+              <a:ext uri="{FF2B5EF4-FFF2-40B4-BE49-F238E27FC236}">
+                <a16:creationId xmlns:a16="http://schemas.microsoft.com/office/drawing/2014/main" id="{100EA725-890B-4ED8-9437-261DD2F6C130}"/>
+              </a:ext>
+            </a:extLst>
+          </p:cNvPr>
+          <p:cNvSpPr>
+            <a:spLocks noGrp="1"/>
+          </p:cNvSpPr>
+          <p:nvPr>
+            <p:ph idx="1"/>
+          </p:nvPr>
+        </p:nvSpPr>
+        <p:spPr>
+          <a:xfrm>
+            <a:off x="5043948" y="1845734"/>
+            <a:ext cx="6111732" cy="4023360"/>
+          </a:xfrm>
+        </p:spPr>
+        <p:txBody>
+          <a:bodyPr/>
+          <a:lstStyle/>
+          <a:p>
+            <a:r>
+              <a:rPr lang="en-US" dirty="0"/>
+              <a:t>Unlike V1, the </a:t>
+            </a:r>
+            <a:r>
+              <a:rPr lang="en-US" b="1" dirty="0"/>
+              <a:t>V2 CUDA Edge Iterator</a:t>
+            </a:r>
+            <a:r>
+              <a:rPr lang="en-US" dirty="0"/>
+              <a:t> uses a </a:t>
+            </a:r>
+            <a:r>
+              <a:rPr lang="en-US" b="1" dirty="0"/>
+              <a:t>two-pointer merge-like algorithm</a:t>
+            </a:r>
+            <a:r>
+              <a:rPr lang="en-US" dirty="0"/>
+              <a:t> for neighbor intersection with linear complexity (d(u) + d(v)). Each thread still processes one edge, and all edges are handled in a </a:t>
+            </a:r>
+            <a:r>
+              <a:rPr lang="en-US" b="1" dirty="0"/>
+              <a:t>single kernel launch</a:t>
+            </a:r>
+            <a:r>
+              <a:rPr lang="en-US" dirty="0"/>
+              <a:t>, which greatly improves efficiency, especially for high-degree nodes.</a:t>
+            </a:r>
+          </a:p>
+          <a:p>
+            <a:r>
+              <a:rPr lang="en-US" dirty="0"/>
+              <a:t>On a </a:t>
+            </a:r>
+            <a:r>
+              <a:rPr lang="en-US" b="1" dirty="0"/>
+              <a:t>100M-node graph</a:t>
+            </a:r>
+            <a:r>
+              <a:rPr lang="en-US" dirty="0"/>
+              <a:t>, performance improves sharply as </a:t>
+            </a:r>
+            <a:r>
+              <a:rPr lang="en-US" b="1" dirty="0"/>
+              <a:t>BLOCK_SIZE</a:t>
+            </a:r>
+            <a:r>
+              <a:rPr lang="en-US" dirty="0"/>
+              <a:t> increases from 8 to 32 (best time: </a:t>
+            </a:r>
+            <a:r>
+              <a:rPr lang="en-US" b="1" dirty="0"/>
+              <a:t>3441 </a:t>
+            </a:r>
+            <a:r>
+              <a:rPr lang="en-US" b="1" dirty="0" err="1"/>
+              <a:t>μs</a:t>
+            </a:r>
+            <a:r>
+              <a:rPr lang="en-US" dirty="0"/>
+              <a:t>), then fluctuates at higher sizes due to GPU resource contention. Despite this, V2 consistently outperforms V1, whose best time was </a:t>
+            </a:r>
+            <a:r>
+              <a:rPr lang="en-US" b="1" dirty="0"/>
+              <a:t>5534 </a:t>
+            </a:r>
+            <a:r>
+              <a:rPr lang="en-US" b="1" dirty="0" err="1"/>
+              <a:t>μs</a:t>
+            </a:r>
+            <a:r>
+              <a:rPr lang="en-US" dirty="0"/>
+              <a:t>, showing the benefit of the new intersection strategy.</a:t>
+            </a:r>
+          </a:p>
+          <a:p>
+            <a:endParaRPr lang="it-IT" dirty="0"/>
+          </a:p>
+        </p:txBody>
+      </p:sp>
+      <p:pic>
+        <p:nvPicPr>
+          <p:cNvPr id="4" name="Picture 3">
+            <a:extLst>
+              <a:ext uri="{FF2B5EF4-FFF2-40B4-BE49-F238E27FC236}">
+                <a16:creationId xmlns:a16="http://schemas.microsoft.com/office/drawing/2014/main" id="{57A3E4A9-64C2-4937-B870-6D8BBB1D9DE2}"/>
+              </a:ext>
+            </a:extLst>
+          </p:cNvPr>
+          <p:cNvPicPr>
+            <a:picLocks noChangeAspect="1"/>
+          </p:cNvPicPr>
+          <p:nvPr/>
+        </p:nvPicPr>
+        <p:blipFill>
+          <a:blip r:embed="rId2"/>
+          <a:stretch>
+            <a:fillRect/>
+          </a:stretch>
+        </p:blipFill>
+        <p:spPr>
+          <a:xfrm>
+            <a:off x="184387" y="1492536"/>
+            <a:ext cx="4859561" cy="3099237"/>
+          </a:xfrm>
+          <a:prstGeom prst="rect">
+            <a:avLst/>
+          </a:prstGeom>
+        </p:spPr>
+      </p:pic>
+    </p:spTree>
+    <p:extLst>
+      <p:ext uri="{BB962C8B-B14F-4D97-AF65-F5344CB8AC3E}">
+        <p14:creationId xmlns:p14="http://schemas.microsoft.com/office/powerpoint/2010/main" val="2301302843"/>
+      </p:ext>
+    </p:extLst>
+  </p:cSld>
+  <p:clrMapOvr>
+    <a:masterClrMapping/>
+  </p:clrMapOvr>
+</p:sld>
+</file>
+
+<file path=ppt/slides/slide16.xml><?xml version="1.0" encoding="utf-8"?>
+<p:sld xmlns:a="http://schemas.openxmlformats.org/drawingml/2006/main" xmlns:r="http://schemas.openxmlformats.org/officeDocument/2006/relationships" xmlns:p="http://schemas.openxmlformats.org/presentationml/2006/main">
+  <p:cSld>
+    <p:spTree>
+      <p:nvGrpSpPr>
+        <p:cNvPr id="1" name=""/>
+        <p:cNvGrpSpPr/>
+        <p:nvPr/>
+      </p:nvGrpSpPr>
+      <p:grpSpPr>
+        <a:xfrm>
+          <a:off x="0" y="0"/>
+          <a:ext cx="0" cy="0"/>
+          <a:chOff x="0" y="0"/>
+          <a:chExt cx="0" cy="0"/>
+        </a:xfrm>
+      </p:grpSpPr>
+      <p:sp>
+        <p:nvSpPr>
+          <p:cNvPr id="2" name="Title 1">
+            <a:extLst>
+              <a:ext uri="{FF2B5EF4-FFF2-40B4-BE49-F238E27FC236}">
+                <a16:creationId xmlns:a16="http://schemas.microsoft.com/office/drawing/2014/main" id="{DB1384A2-6BB9-4BB9-96E5-54AF290803E1}"/>
+              </a:ext>
+            </a:extLst>
+          </p:cNvPr>
+          <p:cNvSpPr>
+            <a:spLocks noGrp="1"/>
+          </p:cNvSpPr>
+          <p:nvPr>
+            <p:ph type="title"/>
+          </p:nvPr>
+        </p:nvSpPr>
+        <p:spPr>
+          <a:xfrm>
+            <a:off x="5014452" y="286603"/>
+            <a:ext cx="6141228" cy="1450757"/>
+          </a:xfrm>
+        </p:spPr>
+        <p:txBody>
+          <a:bodyPr/>
+          <a:lstStyle/>
+          <a:p>
+            <a:r>
+              <a:rPr lang="en-US" dirty="0"/>
+              <a:t>CUDA Parallel Forward Edge Iterator V2_1</a:t>
+            </a:r>
+            <a:endParaRPr lang="it-IT" dirty="0"/>
+          </a:p>
+        </p:txBody>
+      </p:sp>
+      <p:sp>
+        <p:nvSpPr>
+          <p:cNvPr id="3" name="Content Placeholder 2">
+            <a:extLst>
+              <a:ext uri="{FF2B5EF4-FFF2-40B4-BE49-F238E27FC236}">
+                <a16:creationId xmlns:a16="http://schemas.microsoft.com/office/drawing/2014/main" id="{63ED9ADA-ED18-4450-8BA1-2287E59E3E77}"/>
+              </a:ext>
+            </a:extLst>
+          </p:cNvPr>
+          <p:cNvSpPr>
+            <a:spLocks noGrp="1"/>
+          </p:cNvSpPr>
+          <p:nvPr>
+            <p:ph idx="1"/>
+          </p:nvPr>
+        </p:nvSpPr>
+        <p:spPr>
+          <a:xfrm>
+            <a:off x="4914162" y="1845734"/>
+            <a:ext cx="6241517" cy="4023360"/>
+          </a:xfrm>
+        </p:spPr>
+        <p:txBody>
+          <a:bodyPr>
+            <a:normAutofit fontScale="92500" lnSpcReduction="10000"/>
+          </a:bodyPr>
+          <a:lstStyle/>
+          <a:p>
+            <a:r>
+              <a:rPr lang="en-US" dirty="0"/>
+              <a:t>The </a:t>
+            </a:r>
+            <a:r>
+              <a:rPr lang="en-US" b="1" dirty="0"/>
+              <a:t>V2_1 CUDA Edge Iterator</a:t>
+            </a:r>
+            <a:r>
+              <a:rPr lang="en-US" dirty="0"/>
+              <a:t> extends V2 by adding a </a:t>
+            </a:r>
+            <a:r>
+              <a:rPr lang="en-US" b="1" dirty="0"/>
+              <a:t>shared memory optimization</a:t>
+            </a:r>
+            <a:r>
+              <a:rPr lang="en-US" dirty="0"/>
+              <a:t>. Instead of one thread per edge, </a:t>
+            </a:r>
+            <a:r>
+              <a:rPr lang="en-US" b="1" dirty="0"/>
+              <a:t>each block manages a single edge</a:t>
+            </a:r>
+            <a:r>
+              <a:rPr lang="en-US" dirty="0"/>
+              <a:t>. Threads cooperatively load the adjacency lists of the edge’s endpoints into </a:t>
+            </a:r>
+            <a:r>
+              <a:rPr lang="en-US" b="1" dirty="0"/>
+              <a:t>shared memory</a:t>
+            </a:r>
+            <a:r>
+              <a:rPr lang="en-US" dirty="0"/>
+              <a:t>, synchronize, and then a single thread performs the </a:t>
+            </a:r>
+            <a:r>
+              <a:rPr lang="en-US" b="1" dirty="0"/>
+              <a:t>two-pointer merge-like intersection</a:t>
+            </a:r>
+            <a:r>
+              <a:rPr lang="en-US" dirty="0"/>
+              <a:t> on this faster local data. This reduces global memory latency when neighbor lists fit in shared memory.</a:t>
+            </a:r>
+          </a:p>
+          <a:p>
+            <a:r>
+              <a:rPr lang="en-US" dirty="0"/>
+              <a:t>The graph shows performance as a function of </a:t>
+            </a:r>
+            <a:r>
+              <a:rPr lang="en-US" b="1" dirty="0"/>
+              <a:t>Max Shared List Per Edge Combined</a:t>
+            </a:r>
+            <a:r>
+              <a:rPr lang="en-US" dirty="0"/>
+              <a:t> for different </a:t>
+            </a:r>
+            <a:r>
+              <a:rPr lang="en-US" b="1" dirty="0"/>
+              <a:t>BLOCK_SIZE</a:t>
+            </a:r>
+            <a:r>
+              <a:rPr lang="en-US" dirty="0"/>
+              <a:t> values. Increasing this limit generally increases execution time, since reserving more shared memory per block reduces occupancy and parallelism. Smaller </a:t>
+            </a:r>
+            <a:r>
+              <a:rPr lang="en-US" b="1" dirty="0"/>
+              <a:t>BLOCK_SIZE</a:t>
+            </a:r>
+            <a:r>
+              <a:rPr lang="en-US" dirty="0"/>
+              <a:t> values (8, 16) achieve better performance at lower thresholds, while larger sizes (256, 512) suffer sharp slowdowns from resource constraints.</a:t>
+            </a:r>
+          </a:p>
+          <a:p>
+            <a:endParaRPr lang="it-IT" dirty="0"/>
+          </a:p>
+        </p:txBody>
+      </p:sp>
+      <p:pic>
+        <p:nvPicPr>
+          <p:cNvPr id="4" name="Picture 3">
+            <a:extLst>
+              <a:ext uri="{FF2B5EF4-FFF2-40B4-BE49-F238E27FC236}">
+                <a16:creationId xmlns:a16="http://schemas.microsoft.com/office/drawing/2014/main" id="{06B0E4D5-7D7C-4FEB-97F7-0EAF0DDA8C06}"/>
+              </a:ext>
+            </a:extLst>
+          </p:cNvPr>
+          <p:cNvPicPr>
+            <a:picLocks noChangeAspect="1"/>
+          </p:cNvPicPr>
+          <p:nvPr/>
+        </p:nvPicPr>
+        <p:blipFill>
+          <a:blip r:embed="rId2"/>
+          <a:stretch>
+            <a:fillRect/>
+          </a:stretch>
+        </p:blipFill>
+        <p:spPr>
+          <a:xfrm>
+            <a:off x="7403" y="1589935"/>
+            <a:ext cx="4906759" cy="3002493"/>
+          </a:xfrm>
+          <a:prstGeom prst="rect">
+            <a:avLst/>
+          </a:prstGeom>
+        </p:spPr>
+      </p:pic>
+    </p:spTree>
+    <p:extLst>
+      <p:ext uri="{BB962C8B-B14F-4D97-AF65-F5344CB8AC3E}">
+        <p14:creationId xmlns:p14="http://schemas.microsoft.com/office/powerpoint/2010/main" val="3401121369"/>
+      </p:ext>
+    </p:extLst>
+  </p:cSld>
+  <p:clrMapOvr>
+    <a:masterClrMapping/>
+  </p:clrMapOvr>
+</p:sld>
+</file>
+
+<file path=ppt/slides/slide17.xml><?xml version="1.0" encoding="utf-8"?>
+<p:sld xmlns:a="http://schemas.openxmlformats.org/drawingml/2006/main" xmlns:r="http://schemas.openxmlformats.org/officeDocument/2006/relationships" xmlns:p="http://schemas.openxmlformats.org/presentationml/2006/main">
+  <p:cSld>
+    <p:spTree>
+      <p:nvGrpSpPr>
+        <p:cNvPr id="1" name=""/>
+        <p:cNvGrpSpPr/>
+        <p:nvPr/>
+      </p:nvGrpSpPr>
+      <p:grpSpPr>
+        <a:xfrm>
+          <a:off x="0" y="0"/>
+          <a:ext cx="0" cy="0"/>
+          <a:chOff x="0" y="0"/>
+          <a:chExt cx="0" cy="0"/>
+        </a:xfrm>
+      </p:grpSpPr>
+      <p:sp>
+        <p:nvSpPr>
+          <p:cNvPr id="2" name="Title 1">
+            <a:extLst>
+              <a:ext uri="{FF2B5EF4-FFF2-40B4-BE49-F238E27FC236}">
+                <a16:creationId xmlns:a16="http://schemas.microsoft.com/office/drawing/2014/main" id="{DF4A7642-9F59-4268-AF08-990F77A20AF9}"/>
+              </a:ext>
+            </a:extLst>
+          </p:cNvPr>
+          <p:cNvSpPr>
+            <a:spLocks noGrp="1"/>
+          </p:cNvSpPr>
+          <p:nvPr>
+            <p:ph type="title"/>
+          </p:nvPr>
+        </p:nvSpPr>
+        <p:spPr>
+          <a:xfrm>
+            <a:off x="4949559" y="286603"/>
+            <a:ext cx="6206121" cy="1450757"/>
+          </a:xfrm>
+        </p:spPr>
+        <p:txBody>
+          <a:bodyPr/>
+          <a:lstStyle/>
+          <a:p>
+            <a:r>
+              <a:rPr lang="en-US" dirty="0"/>
+              <a:t>CUDA Parallel Forward Edge Iterator V2_2</a:t>
+            </a:r>
+            <a:endParaRPr lang="it-IT" dirty="0"/>
+          </a:p>
+        </p:txBody>
+      </p:sp>
+      <p:sp>
+        <p:nvSpPr>
+          <p:cNvPr id="3" name="Content Placeholder 2">
+            <a:extLst>
+              <a:ext uri="{FF2B5EF4-FFF2-40B4-BE49-F238E27FC236}">
+                <a16:creationId xmlns:a16="http://schemas.microsoft.com/office/drawing/2014/main" id="{F30128A7-AB09-4286-859D-705813F4D2BA}"/>
+              </a:ext>
+            </a:extLst>
+          </p:cNvPr>
+          <p:cNvSpPr>
+            <a:spLocks noGrp="1"/>
+          </p:cNvSpPr>
+          <p:nvPr>
+            <p:ph idx="1"/>
+          </p:nvPr>
+        </p:nvSpPr>
+        <p:spPr>
+          <a:xfrm>
+            <a:off x="4949559" y="1845734"/>
+            <a:ext cx="6206121" cy="4023360"/>
+          </a:xfrm>
+        </p:spPr>
+        <p:txBody>
+          <a:bodyPr>
+            <a:normAutofit fontScale="92500" lnSpcReduction="20000"/>
+          </a:bodyPr>
+          <a:lstStyle/>
+          <a:p>
+            <a:r>
+              <a:rPr lang="en-US" dirty="0"/>
+              <a:t>The </a:t>
+            </a:r>
+            <a:r>
+              <a:rPr lang="en-US" b="1" dirty="0"/>
+              <a:t>V2_2 CUDA Edge Iterator</a:t>
+            </a:r>
+            <a:r>
+              <a:rPr lang="en-US" dirty="0"/>
+              <a:t> keeps the </a:t>
+            </a:r>
+            <a:r>
+              <a:rPr lang="en-US" b="1" dirty="0"/>
+              <a:t>two-pointer merge-like algorithm</a:t>
+            </a:r>
+            <a:r>
+              <a:rPr lang="en-US" dirty="0"/>
+              <a:t> and also uses </a:t>
+            </a:r>
+            <a:r>
+              <a:rPr lang="en-US" b="1" dirty="0"/>
+              <a:t>shared memory</a:t>
+            </a:r>
+            <a:r>
+              <a:rPr lang="en-US" dirty="0"/>
+              <a:t>, but with a different mapping than V2_1. Here, </a:t>
+            </a:r>
+            <a:r>
+              <a:rPr lang="en-US" b="1" dirty="0"/>
+              <a:t>one thread manages one edge</a:t>
+            </a:r>
+            <a:r>
+              <a:rPr lang="en-US" dirty="0"/>
+              <a:t> (like V2), but each thread tries to load its edge’s adjacency lists into a </a:t>
+            </a:r>
+            <a:r>
+              <a:rPr lang="en-US" b="1" dirty="0"/>
+              <a:t>dynamically allocated portion of shared memory</a:t>
+            </a:r>
+            <a:r>
+              <a:rPr lang="en-US" dirty="0"/>
+              <a:t> before performing the intersection. This allows multiple edges to be processed in parallel within a block, each gaining faster access if their lists fit in memory.</a:t>
+            </a:r>
+          </a:p>
+          <a:p>
+            <a:r>
+              <a:rPr lang="en-US" dirty="0"/>
+              <a:t>The performance graph shows total execution time versus </a:t>
+            </a:r>
+            <a:r>
+              <a:rPr lang="en-US" b="1" dirty="0"/>
+              <a:t>Max Shared List Per Edge Combined</a:t>
+            </a:r>
+            <a:r>
+              <a:rPr lang="en-US" dirty="0"/>
+              <a:t> for different </a:t>
+            </a:r>
+            <a:r>
+              <a:rPr lang="en-US" b="1" dirty="0"/>
+              <a:t>BLOCK_SIZE</a:t>
+            </a:r>
+            <a:r>
+              <a:rPr lang="en-US" dirty="0"/>
+              <a:t> values. Smaller block sizes (8, 16, 32) achieve lower durations and are less sensitive at low thresholds, while larger block sizes slow down more as memory usage grows. Excessive shared memory per thread reduces concurrency and occupancy, limiting performance. The best results come from </a:t>
+            </a:r>
+            <a:r>
+              <a:rPr lang="en-US" b="1" dirty="0"/>
+              <a:t>small BLOCK_SIZE values</a:t>
+            </a:r>
+            <a:r>
+              <a:rPr lang="en-US" dirty="0"/>
+              <a:t> with </a:t>
+            </a:r>
+            <a:r>
+              <a:rPr lang="en-US" b="1" dirty="0"/>
+              <a:t>low shared memory thresholds</a:t>
+            </a:r>
+            <a:r>
+              <a:rPr lang="en-US" dirty="0"/>
+              <a:t>, where faster memory access is balanced against GPU resource constraints.</a:t>
+            </a:r>
+          </a:p>
+          <a:p>
+            <a:endParaRPr lang="it-IT" dirty="0"/>
+          </a:p>
+        </p:txBody>
+      </p:sp>
+      <p:pic>
+        <p:nvPicPr>
+          <p:cNvPr id="4" name="Picture 3">
+            <a:extLst>
+              <a:ext uri="{FF2B5EF4-FFF2-40B4-BE49-F238E27FC236}">
+                <a16:creationId xmlns:a16="http://schemas.microsoft.com/office/drawing/2014/main" id="{604A612A-6E22-4E05-B287-B93E210C97EA}"/>
+              </a:ext>
+            </a:extLst>
+          </p:cNvPr>
+          <p:cNvPicPr>
+            <a:picLocks noChangeAspect="1"/>
+          </p:cNvPicPr>
+          <p:nvPr/>
+        </p:nvPicPr>
+        <p:blipFill>
+          <a:blip r:embed="rId2"/>
+          <a:stretch>
+            <a:fillRect/>
+          </a:stretch>
+        </p:blipFill>
+        <p:spPr>
+          <a:xfrm>
+            <a:off x="247126" y="1672467"/>
+            <a:ext cx="4702433" cy="2862759"/>
+          </a:xfrm>
+          <a:prstGeom prst="rect">
+            <a:avLst/>
+          </a:prstGeom>
+        </p:spPr>
+      </p:pic>
+    </p:spTree>
+    <p:extLst>
+      <p:ext uri="{BB962C8B-B14F-4D97-AF65-F5344CB8AC3E}">
+        <p14:creationId xmlns:p14="http://schemas.microsoft.com/office/powerpoint/2010/main" val="448385802"/>
+      </p:ext>
+    </p:extLst>
+  </p:cSld>
+  <p:clrMapOvr>
+    <a:masterClrMapping/>
+  </p:clrMapOvr>
+</p:sld>
+</file>
+
+<file path=ppt/slides/slide18.xml><?xml version="1.0" encoding="utf-8"?>
+<p:sld xmlns:a="http://schemas.openxmlformats.org/drawingml/2006/main" xmlns:r="http://schemas.openxmlformats.org/officeDocument/2006/relationships" xmlns:p="http://schemas.openxmlformats.org/presentationml/2006/main">
+  <p:cSld>
+    <p:spTree>
+      <p:nvGrpSpPr>
+        <p:cNvPr id="1" name=""/>
+        <p:cNvGrpSpPr/>
+        <p:nvPr/>
+      </p:nvGrpSpPr>
+      <p:grpSpPr>
+        <a:xfrm>
+          <a:off x="0" y="0"/>
+          <a:ext cx="0" cy="0"/>
+          <a:chOff x="0" y="0"/>
+          <a:chExt cx="0" cy="0"/>
+        </a:xfrm>
+      </p:grpSpPr>
+      <p:sp>
+        <p:nvSpPr>
+          <p:cNvPr id="2" name="Title 1">
+            <a:extLst>
+              <a:ext uri="{FF2B5EF4-FFF2-40B4-BE49-F238E27FC236}">
+                <a16:creationId xmlns:a16="http://schemas.microsoft.com/office/drawing/2014/main" id="{6C6BF2FE-CE66-4CEA-BB81-604B68FFD6A7}"/>
+              </a:ext>
+            </a:extLst>
+          </p:cNvPr>
+          <p:cNvSpPr>
+            <a:spLocks noGrp="1"/>
+          </p:cNvSpPr>
+          <p:nvPr>
+            <p:ph type="title"/>
+          </p:nvPr>
+        </p:nvSpPr>
+        <p:spPr>
+          <a:xfrm>
+            <a:off x="4760778" y="286603"/>
+            <a:ext cx="6394902" cy="1450757"/>
+          </a:xfrm>
+        </p:spPr>
+        <p:txBody>
+          <a:bodyPr/>
+          <a:lstStyle/>
+          <a:p>
+            <a:r>
+              <a:rPr lang="en-US" dirty="0"/>
+              <a:t>CUDA Parallel Forward Edge Iterator V3</a:t>
+            </a:r>
+            <a:endParaRPr lang="it-IT" dirty="0"/>
+          </a:p>
+        </p:txBody>
+      </p:sp>
+      <p:sp>
+        <p:nvSpPr>
+          <p:cNvPr id="3" name="Content Placeholder 2">
+            <a:extLst>
+              <a:ext uri="{FF2B5EF4-FFF2-40B4-BE49-F238E27FC236}">
+                <a16:creationId xmlns:a16="http://schemas.microsoft.com/office/drawing/2014/main" id="{471618AD-BFE7-483C-8BAD-DD77CFCA196E}"/>
+              </a:ext>
+            </a:extLst>
+          </p:cNvPr>
+          <p:cNvSpPr>
+            <a:spLocks noGrp="1"/>
+          </p:cNvSpPr>
+          <p:nvPr>
+            <p:ph idx="1"/>
+          </p:nvPr>
+        </p:nvSpPr>
+        <p:spPr>
+          <a:xfrm>
+            <a:off x="4760778" y="1845734"/>
+            <a:ext cx="6394901" cy="4023360"/>
+          </a:xfrm>
+        </p:spPr>
+        <p:txBody>
+          <a:bodyPr>
+            <a:normAutofit fontScale="92500" lnSpcReduction="20000"/>
+          </a:bodyPr>
+          <a:lstStyle/>
+          <a:p>
+            <a:r>
+              <a:rPr lang="en-US" dirty="0"/>
+              <a:t>The </a:t>
+            </a:r>
+            <a:r>
+              <a:rPr lang="en-US" b="1" dirty="0"/>
+              <a:t>V3 CUDA Edge Iterator</a:t>
+            </a:r>
+            <a:r>
+              <a:rPr lang="en-US" dirty="0"/>
+              <a:t> addresses the </a:t>
+            </a:r>
+            <a:r>
+              <a:rPr lang="en-US" b="1" dirty="0"/>
+              <a:t>scalability issues</a:t>
+            </a:r>
+            <a:r>
+              <a:rPr lang="en-US" dirty="0"/>
+              <a:t> of previous versions, where larger block sizes caused performance degradation. V3 introduces a </a:t>
+            </a:r>
+            <a:r>
+              <a:rPr lang="en-US" b="1" dirty="0"/>
+              <a:t>dynamic work queue</a:t>
+            </a:r>
+            <a:r>
+              <a:rPr lang="en-US" dirty="0"/>
+              <a:t> for edge iteration: threads fetch new edges from a global queue as they finish previous work. This improves </a:t>
+            </a:r>
+            <a:r>
+              <a:rPr lang="en-US" b="1" dirty="0"/>
+              <a:t>load balancing</a:t>
+            </a:r>
+            <a:r>
+              <a:rPr lang="en-US" dirty="0"/>
+              <a:t>, since threads handling lighter edges can continue working instead of remaining idle, leading to better resource utilization.</a:t>
+            </a:r>
+          </a:p>
+          <a:p>
+            <a:r>
+              <a:rPr lang="en-US" dirty="0"/>
+              <a:t>Performance tests show that V3 is far more scalable and robust: as </a:t>
+            </a:r>
+            <a:r>
+              <a:rPr lang="en-US" b="1" dirty="0"/>
+              <a:t>BLOCK_SIZE</a:t>
+            </a:r>
+            <a:r>
+              <a:rPr lang="en-US" dirty="0"/>
+              <a:t> increases, execution either improves or stabilizes, avoiding the sharp slowdowns of earlier versions. However, this comes at a cost—execution time increases by about </a:t>
+            </a:r>
+            <a:r>
+              <a:rPr lang="en-US" b="1" dirty="0"/>
+              <a:t>10×</a:t>
+            </a:r>
+            <a:r>
+              <a:rPr lang="en-US" dirty="0"/>
+              <a:t> on the 100M-node graph (from ~3 </a:t>
+            </a:r>
+            <a:r>
+              <a:rPr lang="en-US" dirty="0" err="1"/>
+              <a:t>ms</a:t>
+            </a:r>
+            <a:r>
+              <a:rPr lang="en-US" dirty="0"/>
+              <a:t> to ~30 </a:t>
+            </a:r>
+            <a:r>
+              <a:rPr lang="en-US" dirty="0" err="1"/>
+              <a:t>ms</a:t>
+            </a:r>
+            <a:r>
+              <a:rPr lang="en-US" dirty="0"/>
+              <a:t>), mainly due to </a:t>
+            </a:r>
+            <a:r>
+              <a:rPr lang="en-US" b="1" dirty="0"/>
+              <a:t>atomic contention</a:t>
+            </a:r>
+            <a:r>
+              <a:rPr lang="en-US" dirty="0"/>
+              <a:t> when threads access the global queue. A hybrid variant (</a:t>
+            </a:r>
+            <a:r>
+              <a:rPr lang="en-US" b="1" dirty="0"/>
+              <a:t>V3_1</a:t>
+            </a:r>
+            <a:r>
+              <a:rPr lang="en-US" dirty="0"/>
+              <a:t>) combines static block assignment with dynamic scheduling inside each block using </a:t>
+            </a:r>
+            <a:r>
+              <a:rPr lang="en-US" b="1" dirty="0"/>
+              <a:t>shared memory</a:t>
+            </a:r>
+            <a:r>
+              <a:rPr lang="en-US" dirty="0"/>
+              <a:t>, reducing execution time by ~</a:t>
+            </a:r>
+            <a:r>
+              <a:rPr lang="en-US" b="1" dirty="0"/>
+              <a:t>15%</a:t>
+            </a:r>
+            <a:r>
+              <a:rPr lang="en-US" dirty="0"/>
+              <a:t> (from 35 </a:t>
+            </a:r>
+            <a:r>
+              <a:rPr lang="en-US" dirty="0" err="1"/>
+              <a:t>ms</a:t>
+            </a:r>
+            <a:r>
+              <a:rPr lang="en-US" dirty="0"/>
+              <a:t> to 30 </a:t>
+            </a:r>
+            <a:r>
+              <a:rPr lang="en-US" dirty="0" err="1"/>
+              <a:t>ms</a:t>
+            </a:r>
+            <a:r>
+              <a:rPr lang="en-US" dirty="0"/>
+              <a:t> at BLOCK_SIZE = 8).</a:t>
+            </a:r>
+          </a:p>
+          <a:p>
+            <a:endParaRPr lang="it-IT" dirty="0"/>
+          </a:p>
+        </p:txBody>
+      </p:sp>
+      <p:pic>
+        <p:nvPicPr>
+          <p:cNvPr id="4" name="Picture 3">
+            <a:extLst>
+              <a:ext uri="{FF2B5EF4-FFF2-40B4-BE49-F238E27FC236}">
+                <a16:creationId xmlns:a16="http://schemas.microsoft.com/office/drawing/2014/main" id="{555C4CDB-A45B-4BC8-9541-5AB2D6DE7859}"/>
+              </a:ext>
+            </a:extLst>
+          </p:cNvPr>
+          <p:cNvPicPr>
+            <a:picLocks noChangeAspect="1"/>
+          </p:cNvPicPr>
+          <p:nvPr/>
+        </p:nvPicPr>
+        <p:blipFill>
+          <a:blip r:embed="rId2"/>
+          <a:stretch>
+            <a:fillRect/>
+          </a:stretch>
+        </p:blipFill>
+        <p:spPr>
+          <a:xfrm>
+            <a:off x="326742" y="485311"/>
+            <a:ext cx="4300561" cy="2720846"/>
+          </a:xfrm>
+          <a:prstGeom prst="rect">
+            <a:avLst/>
+          </a:prstGeom>
+        </p:spPr>
+      </p:pic>
+      <p:pic>
+        <p:nvPicPr>
+          <p:cNvPr id="5" name="Picture 4">
+            <a:extLst>
+              <a:ext uri="{FF2B5EF4-FFF2-40B4-BE49-F238E27FC236}">
+                <a16:creationId xmlns:a16="http://schemas.microsoft.com/office/drawing/2014/main" id="{18638F9A-B453-4CC5-9435-0F8549470ABF}"/>
+              </a:ext>
+            </a:extLst>
+          </p:cNvPr>
+          <p:cNvPicPr>
+            <a:picLocks noChangeAspect="1"/>
+          </p:cNvPicPr>
+          <p:nvPr/>
+        </p:nvPicPr>
+        <p:blipFill>
+          <a:blip r:embed="rId3"/>
+          <a:stretch>
+            <a:fillRect/>
+          </a:stretch>
+        </p:blipFill>
+        <p:spPr>
+          <a:xfrm>
+            <a:off x="238250" y="3229554"/>
+            <a:ext cx="4407239" cy="2775989"/>
+          </a:xfrm>
+          <a:prstGeom prst="rect">
+            <a:avLst/>
+          </a:prstGeom>
+        </p:spPr>
+      </p:pic>
+    </p:spTree>
+    <p:extLst>
+      <p:ext uri="{BB962C8B-B14F-4D97-AF65-F5344CB8AC3E}">
+        <p14:creationId xmlns:p14="http://schemas.microsoft.com/office/powerpoint/2010/main" val="3282439189"/>
       </p:ext>
     </p:extLst>
   </p:cSld>

</xml_diff>

<commit_message>
Matrix Multiplication Algorithm added on presentation
</commit_message>
<xml_diff>
--- a/presentation.pptx
+++ b/presentation.pptx
@@ -23,6 +23,10 @@
     <p:sldId id="271" r:id="rId17"/>
     <p:sldId id="272" r:id="rId18"/>
     <p:sldId id="273" r:id="rId19"/>
+    <p:sldId id="274" r:id="rId20"/>
+    <p:sldId id="275" r:id="rId21"/>
+    <p:sldId id="276" r:id="rId22"/>
+    <p:sldId id="277" r:id="rId23"/>
   </p:sldIdLst>
   <p:sldSz cx="12192000" cy="6858000"/>
   <p:notesSz cx="6858000" cy="9144000"/>
@@ -6690,6 +6694,510 @@
 </p:sld>
 </file>
 
+<file path=ppt/slides/slide19.xml><?xml version="1.0" encoding="utf-8"?>
+<p:sld xmlns:a="http://schemas.openxmlformats.org/drawingml/2006/main" xmlns:r="http://schemas.openxmlformats.org/officeDocument/2006/relationships" xmlns:p="http://schemas.openxmlformats.org/presentationml/2006/main">
+  <p:cSld>
+    <p:spTree>
+      <p:nvGrpSpPr>
+        <p:cNvPr id="1" name=""/>
+        <p:cNvGrpSpPr/>
+        <p:nvPr/>
+      </p:nvGrpSpPr>
+      <p:grpSpPr>
+        <a:xfrm>
+          <a:off x="0" y="0"/>
+          <a:ext cx="0" cy="0"/>
+          <a:chOff x="0" y="0"/>
+          <a:chExt cx="0" cy="0"/>
+        </a:xfrm>
+      </p:grpSpPr>
+      <p:sp>
+        <p:nvSpPr>
+          <p:cNvPr id="2" name="Title 1">
+            <a:extLst>
+              <a:ext uri="{FF2B5EF4-FFF2-40B4-BE49-F238E27FC236}">
+                <a16:creationId xmlns:a16="http://schemas.microsoft.com/office/drawing/2014/main" id="{2E3898EA-F552-4AE4-BACD-867703F5652C}"/>
+              </a:ext>
+            </a:extLst>
+          </p:cNvPr>
+          <p:cNvSpPr>
+            <a:spLocks noGrp="1"/>
+          </p:cNvSpPr>
+          <p:nvPr>
+            <p:ph type="title"/>
+          </p:nvPr>
+        </p:nvSpPr>
+        <p:spPr/>
+        <p:txBody>
+          <a:bodyPr/>
+          <a:lstStyle/>
+          <a:p>
+            <a:r>
+              <a:rPr lang="it-IT" dirty="0"/>
+              <a:t>Matrix </a:t>
+            </a:r>
+            <a:r>
+              <a:rPr lang="it-IT" dirty="0" err="1"/>
+              <a:t>Multiplication</a:t>
+            </a:r>
+            <a:r>
+              <a:rPr lang="it-IT" dirty="0"/>
+              <a:t> </a:t>
+            </a:r>
+            <a:r>
+              <a:rPr lang="it-IT" dirty="0" err="1"/>
+              <a:t>Algorithm</a:t>
+            </a:r>
+            <a:endParaRPr lang="it-IT" dirty="0"/>
+          </a:p>
+        </p:txBody>
+      </p:sp>
+      <mc:AlternateContent xmlns:mc="http://schemas.openxmlformats.org/markup-compatibility/2006">
+        <mc:Choice xmlns:a14="http://schemas.microsoft.com/office/drawing/2010/main" Requires="a14">
+          <p:sp>
+            <p:nvSpPr>
+              <p:cNvPr id="3" name="Content Placeholder 2">
+                <a:extLst>
+                  <a:ext uri="{FF2B5EF4-FFF2-40B4-BE49-F238E27FC236}">
+                    <a16:creationId xmlns:a16="http://schemas.microsoft.com/office/drawing/2014/main" id="{AF8F5947-64B4-47FD-84EB-E71FC8F5B4EA}"/>
+                  </a:ext>
+                </a:extLst>
+              </p:cNvPr>
+              <p:cNvSpPr>
+                <a:spLocks noGrp="1"/>
+              </p:cNvSpPr>
+              <p:nvPr>
+                <p:ph idx="1"/>
+              </p:nvPr>
+            </p:nvSpPr>
+            <p:spPr/>
+            <p:txBody>
+              <a:bodyPr/>
+              <a:lstStyle/>
+              <a:p>
+                <a:r>
+                  <a:rPr lang="it-IT" dirty="0"/>
+                  <a:t>The </a:t>
+                </a:r>
+                <a:r>
+                  <a:rPr lang="it-IT" b="1" dirty="0" err="1"/>
+                  <a:t>matrix</a:t>
+                </a:r>
+                <a:r>
+                  <a:rPr lang="it-IT" b="1" dirty="0"/>
+                  <a:t> </a:t>
+                </a:r>
+                <a:r>
+                  <a:rPr lang="it-IT" b="1" dirty="0" err="1"/>
+                  <a:t>multiplication</a:t>
+                </a:r>
+                <a:r>
+                  <a:rPr lang="it-IT" b="1" dirty="0"/>
+                  <a:t> </a:t>
+                </a:r>
+                <a:r>
+                  <a:rPr lang="it-IT" dirty="0" err="1"/>
+                  <a:t>algorithm</a:t>
+                </a:r>
+                <a:r>
+                  <a:rPr lang="it-IT" dirty="0"/>
+                  <a:t> </a:t>
+                </a:r>
+                <a:r>
+                  <a:rPr lang="it-IT" dirty="0" err="1"/>
+                  <a:t>is</a:t>
+                </a:r>
+                <a:r>
+                  <a:rPr lang="it-IT" dirty="0"/>
+                  <a:t> </a:t>
+                </a:r>
+                <a:r>
+                  <a:rPr lang="it-IT" dirty="0" err="1"/>
+                  <a:t>implemented</a:t>
+                </a:r>
+                <a:r>
+                  <a:rPr lang="it-IT" dirty="0"/>
+                  <a:t> by </a:t>
+                </a:r>
+                <a:r>
+                  <a:rPr lang="it-IT" dirty="0" err="1"/>
+                  <a:t>using</a:t>
+                </a:r>
+                <a:r>
+                  <a:rPr lang="it-IT" dirty="0"/>
+                  <a:t> a </a:t>
+                </a:r>
+                <a:r>
+                  <a:rPr lang="it-IT" dirty="0" err="1"/>
+                  <a:t>matrix</a:t>
+                </a:r>
+                <a:r>
+                  <a:rPr lang="it-IT" dirty="0"/>
+                  <a:t> data </a:t>
+                </a:r>
+                <a:r>
+                  <a:rPr lang="it-IT" dirty="0" err="1"/>
+                  <a:t>structure</a:t>
+                </a:r>
+                <a:r>
+                  <a:rPr lang="it-IT" dirty="0"/>
+                  <a:t> </a:t>
+                </a:r>
+                <a:r>
+                  <a:rPr lang="it-IT" dirty="0" err="1"/>
+                  <a:t>where</a:t>
+                </a:r>
+                <a:r>
+                  <a:rPr lang="it-IT" dirty="0"/>
+                  <a:t> </a:t>
+                </a:r>
+                <a:r>
+                  <a:rPr lang="it-IT" dirty="0" err="1"/>
+                  <a:t>each</a:t>
+                </a:r>
+                <a:r>
+                  <a:rPr lang="it-IT" dirty="0"/>
+                  <a:t> </a:t>
+                </a:r>
+                <a:r>
+                  <a:rPr lang="it-IT" b="1" dirty="0" err="1"/>
+                  <a:t>row</a:t>
+                </a:r>
+                <a:r>
+                  <a:rPr lang="it-IT" b="1" dirty="0"/>
+                  <a:t> and </a:t>
+                </a:r>
+                <a:r>
+                  <a:rPr lang="it-IT" b="1" dirty="0" err="1"/>
+                  <a:t>column</a:t>
+                </a:r>
+                <a:r>
+                  <a:rPr lang="it-IT" b="1" dirty="0"/>
+                  <a:t> </a:t>
+                </a:r>
+                <a:r>
+                  <a:rPr lang="it-IT" b="1" dirty="0" err="1"/>
+                  <a:t>represents</a:t>
+                </a:r>
+                <a:r>
+                  <a:rPr lang="it-IT" b="1" dirty="0"/>
+                  <a:t> a </a:t>
+                </a:r>
+                <a:r>
+                  <a:rPr lang="it-IT" b="1" dirty="0" err="1"/>
+                  <a:t>node</a:t>
+                </a:r>
+                <a:r>
+                  <a:rPr lang="it-IT" dirty="0"/>
+                  <a:t>, and </a:t>
+                </a:r>
+                <a:r>
+                  <a:rPr lang="it-IT" dirty="0" err="1"/>
+                  <a:t>each</a:t>
+                </a:r>
+                <a:r>
+                  <a:rPr lang="it-IT" dirty="0"/>
+                  <a:t> </a:t>
+                </a:r>
+                <a:r>
+                  <a:rPr lang="it-IT" dirty="0" err="1"/>
+                  <a:t>element</a:t>
+                </a:r>
+                <a:r>
+                  <a:rPr lang="it-IT" dirty="0"/>
+                  <a:t> of the </a:t>
+                </a:r>
+                <a:r>
+                  <a:rPr lang="it-IT" dirty="0" err="1"/>
+                  <a:t>matrix</a:t>
+                </a:r>
+                <a:r>
+                  <a:rPr lang="it-IT" dirty="0"/>
+                  <a:t> </a:t>
+                </a:r>
+                <a:r>
+                  <a:rPr lang="it-IT" dirty="0" err="1"/>
+                  <a:t>is</a:t>
+                </a:r>
+                <a:r>
+                  <a:rPr lang="it-IT" dirty="0"/>
+                  <a:t> 1 </a:t>
+                </a:r>
+                <a:r>
+                  <a:rPr lang="it-IT" dirty="0" err="1"/>
+                  <a:t>if</a:t>
+                </a:r>
+                <a:r>
+                  <a:rPr lang="it-IT" dirty="0"/>
+                  <a:t> </a:t>
+                </a:r>
+                <a:r>
+                  <a:rPr lang="it-IT" dirty="0" err="1"/>
+                  <a:t>there</a:t>
+                </a:r>
+                <a:r>
+                  <a:rPr lang="it-IT" dirty="0"/>
+                  <a:t> </a:t>
+                </a:r>
+                <a:r>
+                  <a:rPr lang="it-IT" dirty="0" err="1"/>
+                  <a:t>is</a:t>
+                </a:r>
+                <a:r>
+                  <a:rPr lang="it-IT" dirty="0"/>
+                  <a:t> an </a:t>
+                </a:r>
+                <a:r>
+                  <a:rPr lang="it-IT" dirty="0" err="1"/>
+                  <a:t>edge</a:t>
+                </a:r>
+                <a:r>
+                  <a:rPr lang="it-IT" dirty="0"/>
+                  <a:t> </a:t>
+                </a:r>
+                <a:r>
+                  <a:rPr lang="it-IT" dirty="0" err="1"/>
+                  <a:t>between</a:t>
+                </a:r>
+                <a:r>
+                  <a:rPr lang="it-IT" dirty="0"/>
+                  <a:t> the </a:t>
+                </a:r>
+                <a:r>
+                  <a:rPr lang="it-IT" dirty="0" err="1"/>
+                  <a:t>respective</a:t>
+                </a:r>
+                <a:r>
+                  <a:rPr lang="it-IT" dirty="0"/>
+                  <a:t> </a:t>
+                </a:r>
+                <a:r>
+                  <a:rPr lang="it-IT" dirty="0" err="1"/>
+                  <a:t>nodes</a:t>
+                </a:r>
+                <a:r>
+                  <a:rPr lang="it-IT" dirty="0"/>
+                  <a:t>, 0 </a:t>
+                </a:r>
+                <a:r>
+                  <a:rPr lang="it-IT" dirty="0" err="1"/>
+                  <a:t>otherwise</a:t>
+                </a:r>
+                <a:r>
+                  <a:rPr lang="it-IT" dirty="0"/>
+                  <a:t>. The </a:t>
+                </a:r>
+                <a:r>
+                  <a:rPr lang="it-IT" b="1" dirty="0" err="1"/>
+                  <a:t>total</a:t>
+                </a:r>
+                <a:r>
+                  <a:rPr lang="it-IT" b="1" dirty="0"/>
+                  <a:t> </a:t>
+                </a:r>
+                <a:r>
+                  <a:rPr lang="it-IT" b="1" dirty="0" err="1"/>
+                  <a:t>number</a:t>
+                </a:r>
+                <a:r>
+                  <a:rPr lang="it-IT" b="1" dirty="0"/>
+                  <a:t> of </a:t>
+                </a:r>
+                <a:r>
+                  <a:rPr lang="it-IT" b="1" dirty="0" err="1"/>
+                  <a:t>triangles</a:t>
+                </a:r>
+                <a:r>
+                  <a:rPr lang="it-IT" b="1" dirty="0"/>
+                  <a:t> </a:t>
+                </a:r>
+                <a:r>
+                  <a:rPr lang="it-IT" dirty="0"/>
+                  <a:t>are </a:t>
+                </a:r>
+                <a:r>
+                  <a:rPr lang="it-IT" dirty="0" err="1"/>
+                  <a:t>computed</a:t>
+                </a:r>
+                <a:r>
+                  <a:rPr lang="it-IT" dirty="0"/>
+                  <a:t> </a:t>
+                </a:r>
+                <a:r>
+                  <a:rPr lang="it-IT" dirty="0" err="1"/>
+                  <a:t>using</a:t>
+                </a:r>
+                <a:r>
+                  <a:rPr lang="it-IT" dirty="0"/>
+                  <a:t> the formula</a:t>
+                </a:r>
+                <a:r>
+                  <a:rPr lang="it-IT" b="1" dirty="0"/>
+                  <a:t> </a:t>
+                </a:r>
+                <a14:m>
+                  <m:oMath xmlns:m="http://schemas.openxmlformats.org/officeDocument/2006/math">
+                    <m:f>
+                      <m:fPr>
+                        <m:ctrlPr>
+                          <a:rPr lang="it-IT" b="1" i="1" smtClean="0">
+                            <a:latin typeface="Cambria Math" panose="02040503050406030204" pitchFamily="18" charset="0"/>
+                          </a:rPr>
+                        </m:ctrlPr>
+                      </m:fPr>
+                      <m:num>
+                        <m:r>
+                          <a:rPr lang="it-IT" b="1" i="1" smtClean="0">
+                            <a:latin typeface="Cambria Math" panose="02040503050406030204" pitchFamily="18" charset="0"/>
+                          </a:rPr>
+                          <m:t>𝟏</m:t>
+                        </m:r>
+                      </m:num>
+                      <m:den>
+                        <m:r>
+                          <a:rPr lang="it-IT" b="1" i="1" smtClean="0">
+                            <a:latin typeface="Cambria Math" panose="02040503050406030204" pitchFamily="18" charset="0"/>
+                          </a:rPr>
+                          <m:t>𝟔</m:t>
+                        </m:r>
+                      </m:den>
+                    </m:f>
+                    <m:r>
+                      <a:rPr lang="it-IT" b="1" i="1" smtClean="0">
+                        <a:latin typeface="Cambria Math" panose="02040503050406030204" pitchFamily="18" charset="0"/>
+                      </a:rPr>
+                      <m:t>∗</m:t>
+                    </m:r>
+                    <m:r>
+                      <a:rPr lang="it-IT" b="1" i="1" smtClean="0">
+                        <a:latin typeface="Cambria Math" panose="02040503050406030204" pitchFamily="18" charset="0"/>
+                      </a:rPr>
+                      <m:t>𝑻𝒓𝒂𝒄𝒆</m:t>
+                    </m:r>
+                    <m:r>
+                      <a:rPr lang="it-IT" b="1" i="1" smtClean="0">
+                        <a:latin typeface="Cambria Math" panose="02040503050406030204" pitchFamily="18" charset="0"/>
+                      </a:rPr>
+                      <m:t>(</m:t>
+                    </m:r>
+                    <m:sSup>
+                      <m:sSupPr>
+                        <m:ctrlPr>
+                          <a:rPr lang="it-IT" b="1" i="1" smtClean="0">
+                            <a:latin typeface="Cambria Math" panose="02040503050406030204" pitchFamily="18" charset="0"/>
+                          </a:rPr>
+                        </m:ctrlPr>
+                      </m:sSupPr>
+                      <m:e>
+                        <m:r>
+                          <a:rPr lang="it-IT" b="1" i="1" smtClean="0">
+                            <a:latin typeface="Cambria Math" panose="02040503050406030204" pitchFamily="18" charset="0"/>
+                          </a:rPr>
+                          <m:t>𝑨</m:t>
+                        </m:r>
+                      </m:e>
+                      <m:sup>
+                        <m:r>
+                          <a:rPr lang="it-IT" b="1" i="1" smtClean="0">
+                            <a:latin typeface="Cambria Math" panose="02040503050406030204" pitchFamily="18" charset="0"/>
+                          </a:rPr>
+                          <m:t>𝟑</m:t>
+                        </m:r>
+                      </m:sup>
+                    </m:sSup>
+                    <m:r>
+                      <a:rPr lang="it-IT" b="1" i="1" smtClean="0">
+                        <a:latin typeface="Cambria Math" panose="02040503050406030204" pitchFamily="18" charset="0"/>
+                      </a:rPr>
+                      <m:t>)</m:t>
+                    </m:r>
+                  </m:oMath>
+                </a14:m>
+                <a:r>
+                  <a:rPr lang="it-IT" b="1" dirty="0"/>
+                  <a:t> </a:t>
+                </a:r>
+                <a:r>
+                  <a:rPr lang="it-IT" dirty="0" err="1"/>
+                  <a:t>where</a:t>
+                </a:r>
+                <a:r>
+                  <a:rPr lang="it-IT" dirty="0"/>
+                  <a:t> A </a:t>
+                </a:r>
+                <a:r>
+                  <a:rPr lang="it-IT" dirty="0" err="1"/>
+                  <a:t>is</a:t>
+                </a:r>
+                <a:r>
+                  <a:rPr lang="it-IT" dirty="0"/>
+                  <a:t> the </a:t>
+                </a:r>
+                <a:r>
+                  <a:rPr lang="it-IT" dirty="0" err="1"/>
+                  <a:t>matrix</a:t>
+                </a:r>
+                <a:r>
+                  <a:rPr lang="it-IT" dirty="0"/>
+                  <a:t>.</a:t>
+                </a:r>
+              </a:p>
+            </p:txBody>
+          </p:sp>
+        </mc:Choice>
+        <mc:Fallback>
+          <p:sp>
+            <p:nvSpPr>
+              <p:cNvPr id="3" name="Content Placeholder 2">
+                <a:extLst>
+                  <a:ext uri="{FF2B5EF4-FFF2-40B4-BE49-F238E27FC236}">
+                    <a16:creationId xmlns:a16="http://schemas.microsoft.com/office/drawing/2014/main" id="{AF8F5947-64B4-47FD-84EB-E71FC8F5B4EA}"/>
+                  </a:ext>
+                </a:extLst>
+              </p:cNvPr>
+              <p:cNvSpPr>
+                <a:spLocks noGrp="1" noRot="1" noChangeAspect="1" noMove="1" noResize="1" noEditPoints="1" noAdjustHandles="1" noChangeArrowheads="1" noChangeShapeType="1" noTextEdit="1"/>
+              </p:cNvSpPr>
+              <p:nvPr>
+                <p:ph idx="1"/>
+              </p:nvPr>
+            </p:nvSpPr>
+            <p:spPr>
+              <a:blipFill>
+                <a:blip r:embed="rId2"/>
+                <a:stretch>
+                  <a:fillRect l="-606" t="-1667" r="-1394"/>
+                </a:stretch>
+              </a:blipFill>
+            </p:spPr>
+            <p:txBody>
+              <a:bodyPr/>
+              <a:lstStyle/>
+              <a:p>
+                <a:r>
+                  <a:rPr lang="it-IT">
+                    <a:noFill/>
+                  </a:rPr>
+                  <a:t> </a:t>
+                </a:r>
+              </a:p>
+            </p:txBody>
+          </p:sp>
+        </mc:Fallback>
+      </mc:AlternateContent>
+    </p:spTree>
+    <p:extLst>
+      <p:ext uri="{BB962C8B-B14F-4D97-AF65-F5344CB8AC3E}">
+        <p14:creationId xmlns:p14="http://schemas.microsoft.com/office/powerpoint/2010/main" val="3974039581"/>
+      </p:ext>
+    </p:extLst>
+  </p:cSld>
+  <p:clrMapOvr>
+    <a:masterClrMapping/>
+  </p:clrMapOvr>
+</p:sld>
+</file>
+
 <file path=ppt/slides/slide2.xml><?xml version="1.0" encoding="utf-8"?>
 <p:sld xmlns:a="http://schemas.openxmlformats.org/drawingml/2006/main" xmlns:r="http://schemas.openxmlformats.org/officeDocument/2006/relationships" xmlns:p="http://schemas.openxmlformats.org/presentationml/2006/main">
   <p:cSld>
@@ -6864,6 +7372,1091 @@
     <p:extLst>
       <p:ext uri="{BB962C8B-B14F-4D97-AF65-F5344CB8AC3E}">
         <p14:creationId xmlns:p14="http://schemas.microsoft.com/office/powerpoint/2010/main" val="828355328"/>
+      </p:ext>
+    </p:extLst>
+  </p:cSld>
+  <p:clrMapOvr>
+    <a:masterClrMapping/>
+  </p:clrMapOvr>
+</p:sld>
+</file>
+
+<file path=ppt/slides/slide20.xml><?xml version="1.0" encoding="utf-8"?>
+<p:sld xmlns:a="http://schemas.openxmlformats.org/drawingml/2006/main" xmlns:r="http://schemas.openxmlformats.org/officeDocument/2006/relationships" xmlns:p="http://schemas.openxmlformats.org/presentationml/2006/main">
+  <p:cSld>
+    <p:spTree>
+      <p:nvGrpSpPr>
+        <p:cNvPr id="1" name=""/>
+        <p:cNvGrpSpPr/>
+        <p:nvPr/>
+      </p:nvGrpSpPr>
+      <p:grpSpPr>
+        <a:xfrm>
+          <a:off x="0" y="0"/>
+          <a:ext cx="0" cy="0"/>
+          <a:chOff x="0" y="0"/>
+          <a:chExt cx="0" cy="0"/>
+        </a:xfrm>
+      </p:grpSpPr>
+      <p:sp>
+        <p:nvSpPr>
+          <p:cNvPr id="2" name="Title 1">
+            <a:extLst>
+              <a:ext uri="{FF2B5EF4-FFF2-40B4-BE49-F238E27FC236}">
+                <a16:creationId xmlns:a16="http://schemas.microsoft.com/office/drawing/2014/main" id="{4D63F785-B55B-4D96-9F53-A2B146065996}"/>
+              </a:ext>
+            </a:extLst>
+          </p:cNvPr>
+          <p:cNvSpPr>
+            <a:spLocks noGrp="1"/>
+          </p:cNvSpPr>
+          <p:nvPr>
+            <p:ph type="title"/>
+          </p:nvPr>
+        </p:nvSpPr>
+        <p:spPr>
+          <a:xfrm>
+            <a:off x="4790276" y="286603"/>
+            <a:ext cx="6365404" cy="1450757"/>
+          </a:xfrm>
+        </p:spPr>
+        <p:txBody>
+          <a:bodyPr/>
+          <a:lstStyle/>
+          <a:p>
+            <a:r>
+              <a:rPr lang="it-IT" dirty="0" err="1"/>
+              <a:t>Parallel</a:t>
+            </a:r>
+            <a:r>
+              <a:rPr lang="it-IT" dirty="0"/>
+              <a:t> (C++) Matrix </a:t>
+            </a:r>
+            <a:r>
+              <a:rPr lang="it-IT" dirty="0" err="1"/>
+              <a:t>Multiplication</a:t>
+            </a:r>
+            <a:endParaRPr lang="it-IT" dirty="0"/>
+          </a:p>
+        </p:txBody>
+      </p:sp>
+      <mc:AlternateContent xmlns:mc="http://schemas.openxmlformats.org/markup-compatibility/2006">
+        <mc:Choice xmlns:a14="http://schemas.microsoft.com/office/drawing/2010/main" Requires="a14">
+          <p:sp>
+            <p:nvSpPr>
+              <p:cNvPr id="3" name="Content Placeholder 2">
+                <a:extLst>
+                  <a:ext uri="{FF2B5EF4-FFF2-40B4-BE49-F238E27FC236}">
+                    <a16:creationId xmlns:a16="http://schemas.microsoft.com/office/drawing/2014/main" id="{C0C4B41C-E9A6-4425-906F-C7EB1D1F7102}"/>
+                  </a:ext>
+                </a:extLst>
+              </p:cNvPr>
+              <p:cNvSpPr>
+                <a:spLocks noGrp="1"/>
+              </p:cNvSpPr>
+              <p:nvPr>
+                <p:ph idx="1"/>
+              </p:nvPr>
+            </p:nvSpPr>
+            <p:spPr>
+              <a:xfrm>
+                <a:off x="4849270" y="1845734"/>
+                <a:ext cx="6306410" cy="4023360"/>
+              </a:xfrm>
+            </p:spPr>
+            <p:txBody>
+              <a:bodyPr>
+                <a:noAutofit/>
+              </a:bodyPr>
+              <a:lstStyle/>
+              <a:p>
+                <a:pPr marL="0" indent="0">
+                  <a:buNone/>
+                </a:pPr>
+                <a:r>
+                  <a:rPr lang="en-US" sz="1600" dirty="0"/>
+                  <a:t>The </a:t>
+                </a:r>
+                <a:r>
+                  <a:rPr lang="en-US" sz="1600" b="1" dirty="0"/>
+                  <a:t>Parallel Matrix Multiplication Algorithm</a:t>
+                </a:r>
+                <a:r>
+                  <a:rPr lang="en-US" sz="1600" dirty="0"/>
+                  <a:t> distributes the computation across multiple threads, as the sequential approach is infeasible for large graphs. The multiplication is divided into two phases:</a:t>
+                </a:r>
+                <a:r>
+                  <a:rPr lang="it-IT" sz="1600" i="1" dirty="0">
+                    <a:latin typeface="Cambria Math" panose="02040503050406030204" pitchFamily="18" charset="0"/>
+                    <a:ea typeface="Cambria Math" panose="02040503050406030204" pitchFamily="18" charset="0"/>
+                  </a:rPr>
+                  <a:t>A * A</a:t>
+                </a:r>
+                <a:r>
+                  <a:rPr lang="it-IT" sz="1600" dirty="0">
+                    <a:latin typeface="Cambria Math" panose="02040503050406030204" pitchFamily="18" charset="0"/>
+                    <a:ea typeface="Cambria Math" panose="02040503050406030204" pitchFamily="18" charset="0"/>
+                  </a:rPr>
+                  <a:t> </a:t>
+                </a:r>
+                <a:r>
+                  <a:rPr lang="it-IT" sz="1600" dirty="0"/>
+                  <a:t>and </a:t>
+                </a:r>
+                <a14:m>
+                  <m:oMath xmlns:m="http://schemas.openxmlformats.org/officeDocument/2006/math">
+                    <m:sSup>
+                      <m:sSupPr>
+                        <m:ctrlPr>
+                          <a:rPr lang="it-IT" sz="1600" i="1" smtClean="0">
+                            <a:latin typeface="Cambria Math" panose="02040503050406030204" pitchFamily="18" charset="0"/>
+                          </a:rPr>
+                        </m:ctrlPr>
+                      </m:sSupPr>
+                      <m:e>
+                        <m:r>
+                          <a:rPr lang="it-IT" sz="1600" b="0" i="1" smtClean="0">
+                            <a:latin typeface="Cambria Math" panose="02040503050406030204" pitchFamily="18" charset="0"/>
+                          </a:rPr>
+                          <m:t>𝐴</m:t>
+                        </m:r>
+                      </m:e>
+                      <m:sup>
+                        <m:r>
+                          <a:rPr lang="it-IT" sz="1600" b="0" i="1" smtClean="0">
+                            <a:latin typeface="Cambria Math" panose="02040503050406030204" pitchFamily="18" charset="0"/>
+                          </a:rPr>
+                          <m:t>2</m:t>
+                        </m:r>
+                      </m:sup>
+                    </m:sSup>
+                    <m:r>
+                      <a:rPr lang="it-IT" sz="1600" b="0" i="1" smtClean="0">
+                        <a:latin typeface="Cambria Math" panose="02040503050406030204" pitchFamily="18" charset="0"/>
+                      </a:rPr>
+                      <m:t>∗</m:t>
+                    </m:r>
+                    <m:r>
+                      <a:rPr lang="it-IT" sz="1600" b="0" i="1" smtClean="0">
+                        <a:latin typeface="Cambria Math" panose="02040503050406030204" pitchFamily="18" charset="0"/>
+                      </a:rPr>
+                      <m:t>𝐴</m:t>
+                    </m:r>
+                  </m:oMath>
+                </a14:m>
+                <a:r>
+                  <a:rPr lang="it-IT" sz="1600" dirty="0"/>
+                  <a:t>, </a:t>
+                </a:r>
+                <a:r>
+                  <a:rPr lang="en-US" sz="1600" dirty="0"/>
+                  <a:t>with synchronization barriers ensuring that all threads complete before proceeding. </a:t>
+                </a:r>
+              </a:p>
+              <a:p>
+                <a:pPr marL="0" indent="0">
+                  <a:buNone/>
+                </a:pPr>
+                <a:r>
+                  <a:rPr lang="en-US" sz="1600" dirty="0"/>
+                  <a:t>The computational complexity can be approximated as </a:t>
+                </a:r>
+                <a:r>
+                  <a:rPr lang="it-IT" sz="1600" dirty="0">
+                    <a:latin typeface="Cambria Math" panose="02040503050406030204" pitchFamily="18" charset="0"/>
+                    <a:ea typeface="Cambria Math" panose="02040503050406030204" pitchFamily="18" charset="0"/>
+                  </a:rPr>
+                  <a:t>O(</a:t>
+                </a:r>
+                <a14:m>
+                  <m:oMath xmlns:m="http://schemas.openxmlformats.org/officeDocument/2006/math">
+                    <m:f>
+                      <m:fPr>
+                        <m:ctrlPr>
+                          <a:rPr lang="it-IT" sz="1600" smtClean="0">
+                            <a:latin typeface="Cambria Math" panose="02040503050406030204" pitchFamily="18" charset="0"/>
+                            <a:ea typeface="Cambria Math" panose="02040503050406030204" pitchFamily="18" charset="0"/>
+                          </a:rPr>
+                        </m:ctrlPr>
+                      </m:fPr>
+                      <m:num>
+                        <m:sSup>
+                          <m:sSupPr>
+                            <m:ctrlPr>
+                              <a:rPr lang="it-IT" sz="1600">
+                                <a:latin typeface="Cambria Math" panose="02040503050406030204" pitchFamily="18" charset="0"/>
+                                <a:ea typeface="Cambria Math" panose="02040503050406030204" pitchFamily="18" charset="0"/>
+                              </a:rPr>
+                            </m:ctrlPr>
+                          </m:sSupPr>
+                          <m:e>
+                            <m:r>
+                              <m:rPr>
+                                <m:sty m:val="p"/>
+                              </m:rPr>
+                              <a:rPr lang="it-IT" sz="1600" b="0" i="0" smtClean="0">
+                                <a:latin typeface="Cambria Math" panose="02040503050406030204" pitchFamily="18" charset="0"/>
+                                <a:ea typeface="Cambria Math" panose="02040503050406030204" pitchFamily="18" charset="0"/>
+                              </a:rPr>
+                              <m:t>n</m:t>
+                            </m:r>
+                          </m:e>
+                          <m:sup>
+                            <m:r>
+                              <a:rPr lang="it-IT" sz="1600" b="0" i="0" smtClean="0">
+                                <a:latin typeface="Cambria Math" panose="02040503050406030204" pitchFamily="18" charset="0"/>
+                                <a:ea typeface="Cambria Math" panose="02040503050406030204" pitchFamily="18" charset="0"/>
+                              </a:rPr>
+                              <m:t>3</m:t>
+                            </m:r>
+                          </m:sup>
+                        </m:sSup>
+                      </m:num>
+                      <m:den>
+                        <m:r>
+                          <m:rPr>
+                            <m:sty m:val="p"/>
+                          </m:rPr>
+                          <a:rPr lang="it-IT" sz="1600" b="0" i="0" smtClean="0">
+                            <a:latin typeface="Cambria Math" panose="02040503050406030204" pitchFamily="18" charset="0"/>
+                            <a:ea typeface="Cambria Math" panose="02040503050406030204" pitchFamily="18" charset="0"/>
+                          </a:rPr>
+                          <m:t>p</m:t>
+                        </m:r>
+                      </m:den>
+                    </m:f>
+                  </m:oMath>
+                </a14:m>
+                <a:r>
+                  <a:rPr lang="it-IT" sz="1600" dirty="0">
+                    <a:latin typeface="Cambria Math" panose="02040503050406030204" pitchFamily="18" charset="0"/>
+                    <a:ea typeface="Cambria Math" panose="02040503050406030204" pitchFamily="18" charset="0"/>
+                  </a:rPr>
+                  <a:t>) </a:t>
+                </a:r>
+                <a:r>
+                  <a:rPr lang="en-US" sz="1600" dirty="0"/>
+                  <a:t>where </a:t>
+                </a:r>
+                <a:r>
+                  <a:rPr lang="en-US" sz="1600" i="1" dirty="0"/>
+                  <a:t>p</a:t>
+                </a:r>
+                <a:r>
+                  <a:rPr lang="en-US" sz="1600" dirty="0"/>
+                  <a:t> denotes the number of threads.</a:t>
+                </a:r>
+              </a:p>
+              <a:p>
+                <a:pPr marL="0" indent="0">
+                  <a:buNone/>
+                </a:pPr>
+                <a:r>
+                  <a:rPr lang="en-US" sz="1600" dirty="0"/>
+                  <a:t>The performance results are shown for graphs of </a:t>
+                </a:r>
+                <a:r>
+                  <a:rPr lang="en-US" sz="1600" b="1" dirty="0"/>
+                  <a:t>100 and 10k nodes</a:t>
+                </a:r>
+                <a:r>
+                  <a:rPr lang="en-US" sz="1600" dirty="0"/>
+                  <a:t>, executed on two different Intel processors (tests on larger graphs were limited by RAM). In both cases, the execution time reaches a minimum with approximately </a:t>
+                </a:r>
+                <a:r>
+                  <a:rPr lang="en-US" sz="1600" b="1" dirty="0"/>
+                  <a:t>8–10 threads</a:t>
+                </a:r>
+                <a:r>
+                  <a:rPr lang="en-US" sz="1600" dirty="0"/>
+                  <a:t>. Notably, for the 10k-node graph, the </a:t>
+                </a:r>
+                <a:r>
+                  <a:rPr lang="en-US" sz="1600" b="1" dirty="0"/>
+                  <a:t>Parallel Matrix Multiplication Algorithm outperforms all other tested algorithms</a:t>
+                </a:r>
+                <a:r>
+                  <a:rPr lang="en-US" sz="1600" dirty="0"/>
+                  <a:t>, including the CUDA-based implementations.</a:t>
+                </a:r>
+                <a:endParaRPr lang="it-IT" sz="1600" dirty="0">
+                  <a:latin typeface="Cambria Math" panose="02040503050406030204" pitchFamily="18" charset="0"/>
+                  <a:ea typeface="Cambria Math" panose="02040503050406030204" pitchFamily="18" charset="0"/>
+                </a:endParaRPr>
+              </a:p>
+            </p:txBody>
+          </p:sp>
+        </mc:Choice>
+        <mc:Fallback>
+          <p:sp>
+            <p:nvSpPr>
+              <p:cNvPr id="3" name="Content Placeholder 2">
+                <a:extLst>
+                  <a:ext uri="{FF2B5EF4-FFF2-40B4-BE49-F238E27FC236}">
+                    <a16:creationId xmlns:a16="http://schemas.microsoft.com/office/drawing/2014/main" id="{C0C4B41C-E9A6-4425-906F-C7EB1D1F7102}"/>
+                  </a:ext>
+                </a:extLst>
+              </p:cNvPr>
+              <p:cNvSpPr>
+                <a:spLocks noGrp="1" noRot="1" noChangeAspect="1" noMove="1" noResize="1" noEditPoints="1" noAdjustHandles="1" noChangeArrowheads="1" noChangeShapeType="1" noTextEdit="1"/>
+              </p:cNvSpPr>
+              <p:nvPr>
+                <p:ph idx="1"/>
+              </p:nvPr>
+            </p:nvSpPr>
+            <p:spPr>
+              <a:xfrm>
+                <a:off x="4849270" y="1845734"/>
+                <a:ext cx="6306410" cy="4023360"/>
+              </a:xfrm>
+              <a:blipFill>
+                <a:blip r:embed="rId2"/>
+                <a:stretch>
+                  <a:fillRect l="-1932" t="-1061" r="-1449"/>
+                </a:stretch>
+              </a:blipFill>
+            </p:spPr>
+            <p:txBody>
+              <a:bodyPr/>
+              <a:lstStyle/>
+              <a:p>
+                <a:r>
+                  <a:rPr lang="it-IT">
+                    <a:noFill/>
+                  </a:rPr>
+                  <a:t> </a:t>
+                </a:r>
+              </a:p>
+            </p:txBody>
+          </p:sp>
+        </mc:Fallback>
+      </mc:AlternateContent>
+      <p:pic>
+        <p:nvPicPr>
+          <p:cNvPr id="4" name="Picture 3">
+            <a:extLst>
+              <a:ext uri="{FF2B5EF4-FFF2-40B4-BE49-F238E27FC236}">
+                <a16:creationId xmlns:a16="http://schemas.microsoft.com/office/drawing/2014/main" id="{ABCA1324-3A2B-4913-8776-3175C4B1F828}"/>
+              </a:ext>
+            </a:extLst>
+          </p:cNvPr>
+          <p:cNvPicPr>
+            <a:picLocks noChangeAspect="1"/>
+          </p:cNvPicPr>
+          <p:nvPr/>
+        </p:nvPicPr>
+        <p:blipFill>
+          <a:blip r:embed="rId3"/>
+          <a:stretch>
+            <a:fillRect/>
+          </a:stretch>
+        </p:blipFill>
+        <p:spPr>
+          <a:xfrm>
+            <a:off x="153383" y="467261"/>
+            <a:ext cx="4484564" cy="2787970"/>
+          </a:xfrm>
+          <a:prstGeom prst="rect">
+            <a:avLst/>
+          </a:prstGeom>
+        </p:spPr>
+      </p:pic>
+      <p:pic>
+        <p:nvPicPr>
+          <p:cNvPr id="5" name="Picture 4">
+            <a:extLst>
+              <a:ext uri="{FF2B5EF4-FFF2-40B4-BE49-F238E27FC236}">
+                <a16:creationId xmlns:a16="http://schemas.microsoft.com/office/drawing/2014/main" id="{6B5B5435-CCC1-4B3E-9B3E-8C174E74183C}"/>
+              </a:ext>
+            </a:extLst>
+          </p:cNvPr>
+          <p:cNvPicPr>
+            <a:picLocks noChangeAspect="1"/>
+          </p:cNvPicPr>
+          <p:nvPr/>
+        </p:nvPicPr>
+        <p:blipFill>
+          <a:blip r:embed="rId4"/>
+          <a:stretch>
+            <a:fillRect/>
+          </a:stretch>
+        </p:blipFill>
+        <p:spPr>
+          <a:xfrm>
+            <a:off x="147483" y="3257402"/>
+            <a:ext cx="4532043" cy="2827469"/>
+          </a:xfrm>
+          <a:prstGeom prst="rect">
+            <a:avLst/>
+          </a:prstGeom>
+        </p:spPr>
+      </p:pic>
+    </p:spTree>
+    <p:extLst>
+      <p:ext uri="{BB962C8B-B14F-4D97-AF65-F5344CB8AC3E}">
+        <p14:creationId xmlns:p14="http://schemas.microsoft.com/office/powerpoint/2010/main" val="1126481971"/>
+      </p:ext>
+    </p:extLst>
+  </p:cSld>
+  <p:clrMapOvr>
+    <a:masterClrMapping/>
+  </p:clrMapOvr>
+</p:sld>
+</file>
+
+<file path=ppt/slides/slide21.xml><?xml version="1.0" encoding="utf-8"?>
+<p:sld xmlns:a="http://schemas.openxmlformats.org/drawingml/2006/main" xmlns:r="http://schemas.openxmlformats.org/officeDocument/2006/relationships" xmlns:p="http://schemas.openxmlformats.org/presentationml/2006/main">
+  <p:cSld>
+    <p:spTree>
+      <p:nvGrpSpPr>
+        <p:cNvPr id="1" name=""/>
+        <p:cNvGrpSpPr/>
+        <p:nvPr/>
+      </p:nvGrpSpPr>
+      <p:grpSpPr>
+        <a:xfrm>
+          <a:off x="0" y="0"/>
+          <a:ext cx="0" cy="0"/>
+          <a:chOff x="0" y="0"/>
+          <a:chExt cx="0" cy="0"/>
+        </a:xfrm>
+      </p:grpSpPr>
+      <p:sp>
+        <p:nvSpPr>
+          <p:cNvPr id="2" name="Title 1">
+            <a:extLst>
+              <a:ext uri="{FF2B5EF4-FFF2-40B4-BE49-F238E27FC236}">
+                <a16:creationId xmlns:a16="http://schemas.microsoft.com/office/drawing/2014/main" id="{499B3BC5-0B5E-4145-9AA3-AF55C5F634DB}"/>
+              </a:ext>
+            </a:extLst>
+          </p:cNvPr>
+          <p:cNvSpPr>
+            <a:spLocks noGrp="1"/>
+          </p:cNvSpPr>
+          <p:nvPr>
+            <p:ph type="title"/>
+          </p:nvPr>
+        </p:nvSpPr>
+        <p:spPr>
+          <a:xfrm>
+            <a:off x="4754878" y="286603"/>
+            <a:ext cx="6400801" cy="1450757"/>
+          </a:xfrm>
+        </p:spPr>
+        <p:txBody>
+          <a:bodyPr/>
+          <a:lstStyle/>
+          <a:p>
+            <a:r>
+              <a:rPr lang="it-IT" dirty="0"/>
+              <a:t>CUDA </a:t>
+            </a:r>
+            <a:r>
+              <a:rPr lang="it-IT" dirty="0" err="1"/>
+              <a:t>Parallel</a:t>
+            </a:r>
+            <a:r>
+              <a:rPr lang="it-IT" dirty="0"/>
+              <a:t> Matrix </a:t>
+            </a:r>
+            <a:r>
+              <a:rPr lang="it-IT" dirty="0" err="1"/>
+              <a:t>Multiplication</a:t>
+            </a:r>
+            <a:r>
+              <a:rPr lang="it-IT" dirty="0"/>
+              <a:t> V1</a:t>
+            </a:r>
+          </a:p>
+        </p:txBody>
+      </p:sp>
+      <p:sp>
+        <p:nvSpPr>
+          <p:cNvPr id="3" name="Content Placeholder 2">
+            <a:extLst>
+              <a:ext uri="{FF2B5EF4-FFF2-40B4-BE49-F238E27FC236}">
+                <a16:creationId xmlns:a16="http://schemas.microsoft.com/office/drawing/2014/main" id="{A7F4EF09-2BC4-4F24-A76A-37689AF72D00}"/>
+              </a:ext>
+            </a:extLst>
+          </p:cNvPr>
+          <p:cNvSpPr>
+            <a:spLocks noGrp="1"/>
+          </p:cNvSpPr>
+          <p:nvPr>
+            <p:ph idx="1"/>
+          </p:nvPr>
+        </p:nvSpPr>
+        <p:spPr>
+          <a:xfrm>
+            <a:off x="4754881" y="1845734"/>
+            <a:ext cx="6400800" cy="4023360"/>
+          </a:xfrm>
+        </p:spPr>
+        <p:txBody>
+          <a:bodyPr>
+            <a:normAutofit fontScale="85000" lnSpcReduction="10000"/>
+          </a:bodyPr>
+          <a:lstStyle/>
+          <a:p>
+            <a:r>
+              <a:rPr lang="en-US" dirty="0"/>
+              <a:t>The </a:t>
+            </a:r>
+            <a:r>
+              <a:rPr lang="en-US" b="1" dirty="0"/>
+              <a:t>CUDA Matrix Multiplication V1</a:t>
+            </a:r>
+            <a:r>
+              <a:rPr lang="en-US" dirty="0"/>
+              <a:t> algorithm implements a direct row-major strategy. In the </a:t>
+            </a:r>
+            <a:r>
+              <a:rPr lang="en-US" b="1" dirty="0" err="1"/>
+              <a:t>multiplyMatricesKernel</a:t>
+            </a:r>
+            <a:r>
+              <a:rPr lang="en-US" dirty="0"/>
+              <a:t>, each GPU thread computes a single element of the output matrix </a:t>
+            </a:r>
+            <a:r>
+              <a:rPr lang="en-US" b="1" dirty="0"/>
+              <a:t>C</a:t>
+            </a:r>
+            <a:r>
+              <a:rPr lang="en-US" dirty="0"/>
+              <a:t> by mapping its (row, col) indices from </a:t>
+            </a:r>
+            <a:r>
+              <a:rPr lang="en-US" b="1" dirty="0" err="1"/>
+              <a:t>blockIdx</a:t>
+            </a:r>
+            <a:r>
+              <a:rPr lang="en-US" dirty="0"/>
+              <a:t> and </a:t>
+            </a:r>
+            <a:r>
+              <a:rPr lang="en-US" b="1" dirty="0" err="1"/>
+              <a:t>threadIdx</a:t>
+            </a:r>
+            <a:r>
+              <a:rPr lang="en-US" dirty="0"/>
+              <a:t>. Each thread performs a dot product between one row of </a:t>
+            </a:r>
+            <a:r>
+              <a:rPr lang="en-US" b="1" dirty="0"/>
+              <a:t>A</a:t>
+            </a:r>
+            <a:r>
+              <a:rPr lang="en-US" dirty="0"/>
+              <a:t> and one column of </a:t>
+            </a:r>
+            <a:r>
+              <a:rPr lang="en-US" b="1" dirty="0"/>
+              <a:t>B</a:t>
+            </a:r>
+            <a:r>
+              <a:rPr lang="en-US" dirty="0"/>
+              <a:t>. The multiplication proceeds in the two phases previously explained. A separate </a:t>
+            </a:r>
+            <a:r>
+              <a:rPr lang="en-US" b="1" dirty="0" err="1"/>
+              <a:t>traceKernel</a:t>
+            </a:r>
+            <a:r>
+              <a:rPr lang="en-US" dirty="0"/>
+              <a:t> computes the trace of </a:t>
+            </a:r>
+            <a:r>
+              <a:rPr lang="en-US" b="1" dirty="0"/>
+              <a:t>A³</a:t>
+            </a:r>
+            <a:r>
+              <a:rPr lang="en-US" dirty="0"/>
+              <a:t> using </a:t>
+            </a:r>
+            <a:r>
+              <a:rPr lang="en-US" b="1" dirty="0" err="1"/>
+              <a:t>atomicAdd</a:t>
+            </a:r>
+            <a:r>
+              <a:rPr lang="en-US" dirty="0"/>
+              <a:t> for thread-safe accumulation. While conceptually simple, this approach incurs frequent global memory accesses, with </a:t>
+            </a:r>
+            <a:r>
+              <a:rPr lang="en-US" b="1" dirty="0"/>
+              <a:t>uncoalesced reads from B</a:t>
+            </a:r>
+            <a:r>
+              <a:rPr lang="en-US" dirty="0"/>
+              <a:t> limiting memory bandwidth efficiency.</a:t>
+            </a:r>
+          </a:p>
+          <a:p>
+            <a:r>
+              <a:rPr lang="en-US" dirty="0"/>
+              <a:t>Performance strongly depends on graph size. For a </a:t>
+            </a:r>
+            <a:r>
+              <a:rPr lang="en-US" b="1" dirty="0"/>
+              <a:t>100-node graph</a:t>
+            </a:r>
+            <a:r>
+              <a:rPr lang="en-US" dirty="0"/>
+              <a:t>, execution time increases with </a:t>
+            </a:r>
+            <a:r>
+              <a:rPr lang="en-US" b="1" dirty="0"/>
+              <a:t>BLOCK_SIZE</a:t>
+            </a:r>
+            <a:r>
+              <a:rPr lang="en-US" dirty="0"/>
+              <a:t>, as the overhead of large thread blocks dominates the minimal workload. In contrast, for a </a:t>
+            </a:r>
+            <a:r>
+              <a:rPr lang="en-US" b="1" dirty="0"/>
+              <a:t>10k-node graph</a:t>
+            </a:r>
+            <a:r>
+              <a:rPr lang="en-US" dirty="0"/>
+              <a:t>, performance improves as </a:t>
+            </a:r>
+            <a:r>
+              <a:rPr lang="en-US" b="1" dirty="0"/>
+              <a:t>BLOCK_SIZE</a:t>
+            </a:r>
+            <a:r>
+              <a:rPr lang="en-US" dirty="0"/>
+              <a:t> increases (up to 32), since larger blocks enable better </a:t>
+            </a:r>
+            <a:r>
+              <a:rPr lang="en-US" b="1" dirty="0"/>
+              <a:t>SM occupancy</a:t>
+            </a:r>
+            <a:r>
+              <a:rPr lang="en-US" dirty="0"/>
+              <a:t> and more effective latency hiding. This highlights the scalability limits of V1 for small workloads and its efficiency gains on larger graphs.</a:t>
+            </a:r>
+          </a:p>
+          <a:p>
+            <a:endParaRPr lang="it-IT" dirty="0"/>
+          </a:p>
+        </p:txBody>
+      </p:sp>
+      <p:pic>
+        <p:nvPicPr>
+          <p:cNvPr id="5" name="Picture 4">
+            <a:extLst>
+              <a:ext uri="{FF2B5EF4-FFF2-40B4-BE49-F238E27FC236}">
+                <a16:creationId xmlns:a16="http://schemas.microsoft.com/office/drawing/2014/main" id="{EF1FFEA7-E1B3-46E4-BFC2-D1853F176E9D}"/>
+              </a:ext>
+            </a:extLst>
+          </p:cNvPr>
+          <p:cNvPicPr>
+            <a:picLocks noChangeAspect="1"/>
+          </p:cNvPicPr>
+          <p:nvPr/>
+        </p:nvPicPr>
+        <p:blipFill>
+          <a:blip r:embed="rId2"/>
+          <a:stretch>
+            <a:fillRect/>
+          </a:stretch>
+        </p:blipFill>
+        <p:spPr>
+          <a:xfrm>
+            <a:off x="206478" y="451408"/>
+            <a:ext cx="4496210" cy="2846593"/>
+          </a:xfrm>
+          <a:prstGeom prst="rect">
+            <a:avLst/>
+          </a:prstGeom>
+        </p:spPr>
+      </p:pic>
+      <p:pic>
+        <p:nvPicPr>
+          <p:cNvPr id="6" name="Picture 5">
+            <a:extLst>
+              <a:ext uri="{FF2B5EF4-FFF2-40B4-BE49-F238E27FC236}">
+                <a16:creationId xmlns:a16="http://schemas.microsoft.com/office/drawing/2014/main" id="{0CFFB1E4-F142-4223-9A70-28C8F9BC570A}"/>
+              </a:ext>
+            </a:extLst>
+          </p:cNvPr>
+          <p:cNvPicPr>
+            <a:picLocks noChangeAspect="1"/>
+          </p:cNvPicPr>
+          <p:nvPr/>
+        </p:nvPicPr>
+        <p:blipFill>
+          <a:blip r:embed="rId3"/>
+          <a:stretch>
+            <a:fillRect/>
+          </a:stretch>
+        </p:blipFill>
+        <p:spPr>
+          <a:xfrm>
+            <a:off x="206477" y="3304031"/>
+            <a:ext cx="4480784" cy="2838164"/>
+          </a:xfrm>
+          <a:prstGeom prst="rect">
+            <a:avLst/>
+          </a:prstGeom>
+        </p:spPr>
+      </p:pic>
+    </p:spTree>
+    <p:extLst>
+      <p:ext uri="{BB962C8B-B14F-4D97-AF65-F5344CB8AC3E}">
+        <p14:creationId xmlns:p14="http://schemas.microsoft.com/office/powerpoint/2010/main" val="3404338982"/>
+      </p:ext>
+    </p:extLst>
+  </p:cSld>
+  <p:clrMapOvr>
+    <a:masterClrMapping/>
+  </p:clrMapOvr>
+</p:sld>
+</file>
+
+<file path=ppt/slides/slide22.xml><?xml version="1.0" encoding="utf-8"?>
+<p:sld xmlns:a="http://schemas.openxmlformats.org/drawingml/2006/main" xmlns:r="http://schemas.openxmlformats.org/officeDocument/2006/relationships" xmlns:p="http://schemas.openxmlformats.org/presentationml/2006/main">
+  <p:cSld>
+    <p:spTree>
+      <p:nvGrpSpPr>
+        <p:cNvPr id="1" name=""/>
+        <p:cNvGrpSpPr/>
+        <p:nvPr/>
+      </p:nvGrpSpPr>
+      <p:grpSpPr>
+        <a:xfrm>
+          <a:off x="0" y="0"/>
+          <a:ext cx="0" cy="0"/>
+          <a:chOff x="0" y="0"/>
+          <a:chExt cx="0" cy="0"/>
+        </a:xfrm>
+      </p:grpSpPr>
+      <p:sp>
+        <p:nvSpPr>
+          <p:cNvPr id="2" name="Title 1">
+            <a:extLst>
+              <a:ext uri="{FF2B5EF4-FFF2-40B4-BE49-F238E27FC236}">
+                <a16:creationId xmlns:a16="http://schemas.microsoft.com/office/drawing/2014/main" id="{286BFA14-65F6-4C0F-8B9D-78965F3144DD}"/>
+              </a:ext>
+            </a:extLst>
+          </p:cNvPr>
+          <p:cNvSpPr>
+            <a:spLocks noGrp="1"/>
+          </p:cNvSpPr>
+          <p:nvPr>
+            <p:ph type="title"/>
+          </p:nvPr>
+        </p:nvSpPr>
+        <p:spPr>
+          <a:xfrm>
+            <a:off x="4713584" y="286603"/>
+            <a:ext cx="6442095" cy="1450757"/>
+          </a:xfrm>
+        </p:spPr>
+        <p:txBody>
+          <a:bodyPr/>
+          <a:lstStyle/>
+          <a:p>
+            <a:r>
+              <a:rPr lang="it-IT" dirty="0"/>
+              <a:t>CUDA </a:t>
+            </a:r>
+            <a:r>
+              <a:rPr lang="it-IT" dirty="0" err="1"/>
+              <a:t>Parallel</a:t>
+            </a:r>
+            <a:r>
+              <a:rPr lang="it-IT" dirty="0"/>
+              <a:t> Matrix </a:t>
+            </a:r>
+            <a:r>
+              <a:rPr lang="it-IT" dirty="0" err="1"/>
+              <a:t>Multiplication</a:t>
+            </a:r>
+            <a:r>
+              <a:rPr lang="it-IT" dirty="0"/>
+              <a:t> V2</a:t>
+            </a:r>
+          </a:p>
+        </p:txBody>
+      </p:sp>
+      <p:sp>
+        <p:nvSpPr>
+          <p:cNvPr id="3" name="Content Placeholder 2">
+            <a:extLst>
+              <a:ext uri="{FF2B5EF4-FFF2-40B4-BE49-F238E27FC236}">
+                <a16:creationId xmlns:a16="http://schemas.microsoft.com/office/drawing/2014/main" id="{468B9D47-36C9-4C9D-894E-E22BAE2D2A47}"/>
+              </a:ext>
+            </a:extLst>
+          </p:cNvPr>
+          <p:cNvSpPr>
+            <a:spLocks noGrp="1"/>
+          </p:cNvSpPr>
+          <p:nvPr>
+            <p:ph idx="1"/>
+          </p:nvPr>
+        </p:nvSpPr>
+        <p:spPr>
+          <a:xfrm>
+            <a:off x="4713585" y="1845734"/>
+            <a:ext cx="6442094" cy="4023360"/>
+          </a:xfrm>
+        </p:spPr>
+        <p:txBody>
+          <a:bodyPr>
+            <a:normAutofit fontScale="85000" lnSpcReduction="20000"/>
+          </a:bodyPr>
+          <a:lstStyle/>
+          <a:p>
+            <a:r>
+              <a:rPr lang="en-US" dirty="0"/>
+              <a:t>The </a:t>
+            </a:r>
+            <a:r>
+              <a:rPr lang="en-US" b="1" dirty="0"/>
+              <a:t>CUDA Matrix Multiplication V2</a:t>
+            </a:r>
+            <a:r>
+              <a:rPr lang="en-US" dirty="0"/>
+              <a:t> algorithm significantly improves performance by introducing a </a:t>
+            </a:r>
+            <a:r>
+              <a:rPr lang="en-US" b="1" dirty="0"/>
+              <a:t>tiled matrix multiplication</a:t>
+            </a:r>
+            <a:r>
+              <a:rPr lang="en-US" dirty="0"/>
+              <a:t> strategy that leverages </a:t>
+            </a:r>
+            <a:r>
+              <a:rPr lang="en-US" b="1" dirty="0"/>
+              <a:t>shared memory</a:t>
+            </a:r>
+            <a:r>
+              <a:rPr lang="en-US" dirty="0"/>
+              <a:t>. In the </a:t>
+            </a:r>
+            <a:r>
+              <a:rPr lang="en-US" b="1" dirty="0" err="1"/>
+              <a:t>multiplyMatricesSharedMemoryKernel</a:t>
+            </a:r>
+            <a:r>
+              <a:rPr lang="en-US" dirty="0"/>
+              <a:t>, matrices are partitioned into square tiles, with each thread block computing a sub-matrix of the output. Threads within a block cooperatively load tiles of </a:t>
+            </a:r>
+            <a:r>
+              <a:rPr lang="en-US" b="1" dirty="0"/>
+              <a:t>A</a:t>
+            </a:r>
+            <a:r>
+              <a:rPr lang="en-US" dirty="0"/>
+              <a:t> and </a:t>
+            </a:r>
+            <a:r>
+              <a:rPr lang="en-US" b="1" dirty="0"/>
+              <a:t>B</a:t>
+            </a:r>
+            <a:r>
+              <a:rPr lang="en-US" dirty="0"/>
+              <a:t> into shared memory (</a:t>
+            </a:r>
+            <a:r>
+              <a:rPr lang="en-US" b="1" dirty="0" err="1"/>
+              <a:t>s_A</a:t>
+            </a:r>
+            <a:r>
+              <a:rPr lang="en-US" dirty="0"/>
+              <a:t>, </a:t>
+            </a:r>
+            <a:r>
+              <a:rPr lang="en-US" b="1" dirty="0" err="1"/>
+              <a:t>s_B</a:t>
+            </a:r>
+            <a:r>
+              <a:rPr lang="en-US" dirty="0"/>
+              <a:t>) and synchronize with </a:t>
+            </a:r>
+            <a:r>
+              <a:rPr lang="en-US" b="1" dirty="0"/>
+              <a:t>__</a:t>
+            </a:r>
+            <a:r>
+              <a:rPr lang="en-US" b="1" dirty="0" err="1"/>
+              <a:t>syncthreads</a:t>
+            </a:r>
+            <a:r>
+              <a:rPr lang="en-US" b="1" dirty="0"/>
+              <a:t>()</a:t>
+            </a:r>
+            <a:r>
+              <a:rPr lang="en-US" dirty="0"/>
+              <a:t> before computation. Each output element is then computed from shared memory, reducing global memory traffic and improving data locality. The </a:t>
+            </a:r>
+            <a:r>
+              <a:rPr lang="en-US" b="1" dirty="0"/>
+              <a:t>TILE_SIZE</a:t>
+            </a:r>
+            <a:r>
+              <a:rPr lang="en-US" dirty="0"/>
+              <a:t> parameter defines the tile dimensions and block size. As in V1, the final trace of </a:t>
+            </a:r>
+            <a:r>
+              <a:rPr lang="en-US" b="1" dirty="0"/>
+              <a:t>A³</a:t>
+            </a:r>
+            <a:r>
+              <a:rPr lang="en-US" dirty="0"/>
+              <a:t> is computed by a dedicated </a:t>
+            </a:r>
+            <a:r>
+              <a:rPr lang="en-US" b="1" dirty="0" err="1"/>
+              <a:t>traceKernel</a:t>
+            </a:r>
+            <a:r>
+              <a:rPr lang="en-US" dirty="0"/>
+              <a:t>, with </a:t>
+            </a:r>
+            <a:r>
+              <a:rPr lang="en-US" b="1" dirty="0"/>
+              <a:t>TRACE_BLOCKSIZE</a:t>
+            </a:r>
+            <a:r>
+              <a:rPr lang="en-US" dirty="0"/>
+              <a:t> providing additional tuning for parallel execution.</a:t>
+            </a:r>
+          </a:p>
+          <a:p>
+            <a:r>
+              <a:rPr lang="en-US" dirty="0"/>
+              <a:t>Performance results show clear benefits of tiling. For a </a:t>
+            </a:r>
+            <a:r>
+              <a:rPr lang="en-US" b="1" dirty="0"/>
+              <a:t>100-node graph</a:t>
+            </a:r>
+            <a:r>
+              <a:rPr lang="en-US" dirty="0"/>
+              <a:t>, execution time drops sharply when </a:t>
+            </a:r>
+            <a:r>
+              <a:rPr lang="en-US" b="1" dirty="0"/>
+              <a:t>TILE_SIZE</a:t>
+            </a:r>
+            <a:r>
+              <a:rPr lang="en-US" dirty="0"/>
+              <a:t> increases from 8 to 16, then remains consistently low. This demonstrates that even small graphs benefit from reduced global memory usage and better data locality. For a </a:t>
+            </a:r>
+            <a:r>
+              <a:rPr lang="en-US" b="1" dirty="0"/>
+              <a:t>10k-node graph</a:t>
+            </a:r>
+            <a:r>
+              <a:rPr lang="en-US" dirty="0"/>
+              <a:t>, performance improves steadily with larger </a:t>
+            </a:r>
+            <a:r>
+              <a:rPr lang="en-US" b="1" dirty="0"/>
+              <a:t>TILE_SIZE</a:t>
+            </a:r>
+            <a:r>
+              <a:rPr lang="en-US" dirty="0"/>
+              <a:t>, achieving the lowest times at </a:t>
+            </a:r>
+            <a:r>
+              <a:rPr lang="en-US" b="1" dirty="0"/>
+              <a:t>TILE_SIZE = 32</a:t>
+            </a:r>
+            <a:r>
+              <a:rPr lang="en-US" dirty="0"/>
+              <a:t>. While </a:t>
+            </a:r>
+            <a:r>
+              <a:rPr lang="en-US" b="1" dirty="0"/>
+              <a:t>TILE_SIZE</a:t>
+            </a:r>
+            <a:r>
+              <a:rPr lang="en-US" dirty="0"/>
+              <a:t> is the dominant factor, tuning </a:t>
+            </a:r>
+            <a:r>
+              <a:rPr lang="en-US" b="1" dirty="0"/>
+              <a:t>TRACE_BLOCKSIZE</a:t>
+            </a:r>
+            <a:r>
+              <a:rPr lang="en-US" dirty="0"/>
+              <a:t> (best at 32) provides further optimization for the trace computation.</a:t>
+            </a:r>
+          </a:p>
+          <a:p>
+            <a:endParaRPr lang="it-IT" dirty="0"/>
+          </a:p>
+        </p:txBody>
+      </p:sp>
+      <p:pic>
+        <p:nvPicPr>
+          <p:cNvPr id="4" name="Picture 3">
+            <a:extLst>
+              <a:ext uri="{FF2B5EF4-FFF2-40B4-BE49-F238E27FC236}">
+                <a16:creationId xmlns:a16="http://schemas.microsoft.com/office/drawing/2014/main" id="{9618BD25-105D-4886-BBF6-998F3603A1E5}"/>
+              </a:ext>
+            </a:extLst>
+          </p:cNvPr>
+          <p:cNvPicPr>
+            <a:picLocks noChangeAspect="1"/>
+          </p:cNvPicPr>
+          <p:nvPr/>
+        </p:nvPicPr>
+        <p:blipFill>
+          <a:blip r:embed="rId2"/>
+          <a:stretch>
+            <a:fillRect/>
+          </a:stretch>
+        </p:blipFill>
+        <p:spPr>
+          <a:xfrm>
+            <a:off x="182880" y="522515"/>
+            <a:ext cx="4530704" cy="2767504"/>
+          </a:xfrm>
+          <a:prstGeom prst="rect">
+            <a:avLst/>
+          </a:prstGeom>
+        </p:spPr>
+      </p:pic>
+      <p:pic>
+        <p:nvPicPr>
+          <p:cNvPr id="5" name="Picture 4">
+            <a:extLst>
+              <a:ext uri="{FF2B5EF4-FFF2-40B4-BE49-F238E27FC236}">
+                <a16:creationId xmlns:a16="http://schemas.microsoft.com/office/drawing/2014/main" id="{ADD684CF-E56C-4B5B-AE96-1695D61FB2F0}"/>
+              </a:ext>
+            </a:extLst>
+          </p:cNvPr>
+          <p:cNvPicPr>
+            <a:picLocks noChangeAspect="1"/>
+          </p:cNvPicPr>
+          <p:nvPr/>
+        </p:nvPicPr>
+        <p:blipFill>
+          <a:blip r:embed="rId3"/>
+          <a:stretch>
+            <a:fillRect/>
+          </a:stretch>
+        </p:blipFill>
+        <p:spPr>
+          <a:xfrm>
+            <a:off x="318565" y="3290018"/>
+            <a:ext cx="4341925" cy="2755817"/>
+          </a:xfrm>
+          <a:prstGeom prst="rect">
+            <a:avLst/>
+          </a:prstGeom>
+        </p:spPr>
+      </p:pic>
+    </p:spTree>
+    <p:extLst>
+      <p:ext uri="{BB962C8B-B14F-4D97-AF65-F5344CB8AC3E}">
+        <p14:creationId xmlns:p14="http://schemas.microsoft.com/office/powerpoint/2010/main" val="4063111365"/>
       </p:ext>
     </p:extLst>
   </p:cSld>

</xml_diff>

<commit_message>
feat: added charts for comparison of parallel vs sequential edge
</commit_message>
<xml_diff>
--- a/presentation.pptx
+++ b/presentation.pptx
@@ -19,16 +19,17 @@
     <p:sldId id="265" r:id="rId13"/>
     <p:sldId id="266" r:id="rId14"/>
     <p:sldId id="267" r:id="rId15"/>
-    <p:sldId id="268" r:id="rId16"/>
-    <p:sldId id="269" r:id="rId17"/>
-    <p:sldId id="270" r:id="rId18"/>
-    <p:sldId id="271" r:id="rId19"/>
-    <p:sldId id="272" r:id="rId20"/>
-    <p:sldId id="273" r:id="rId21"/>
-    <p:sldId id="274" r:id="rId22"/>
-    <p:sldId id="275" r:id="rId23"/>
-    <p:sldId id="276" r:id="rId24"/>
-    <p:sldId id="277" r:id="rId25"/>
+    <p:sldId id="280" r:id="rId16"/>
+    <p:sldId id="268" r:id="rId17"/>
+    <p:sldId id="269" r:id="rId18"/>
+    <p:sldId id="270" r:id="rId19"/>
+    <p:sldId id="271" r:id="rId20"/>
+    <p:sldId id="272" r:id="rId21"/>
+    <p:sldId id="273" r:id="rId22"/>
+    <p:sldId id="274" r:id="rId23"/>
+    <p:sldId id="275" r:id="rId24"/>
+    <p:sldId id="276" r:id="rId25"/>
+    <p:sldId id="277" r:id="rId26"/>
   </p:sldIdLst>
   <p:sldSz cx="12192000" cy="6858000"/>
   <p:notesSz cx="6858000" cy="9144000"/>
@@ -6153,6 +6154,14 @@
 <file path=ppt/slides/slide15.xml><?xml version="1.0" encoding="utf-8"?>
 <p:sld xmlns:a="http://schemas.openxmlformats.org/drawingml/2006/main" xmlns:r="http://schemas.openxmlformats.org/officeDocument/2006/relationships" xmlns:p="http://schemas.openxmlformats.org/presentationml/2006/main">
   <p:cSld>
+    <p:bg>
+      <p:bgPr>
+        <a:solidFill>
+          <a:schemeClr val="bg1"/>
+        </a:solidFill>
+        <a:effectLst/>
+      </p:bgPr>
+    </p:bg>
     <p:spTree>
       <p:nvGrpSpPr>
         <p:cNvPr id="1" name=""/>
@@ -6169,10 +6178,249 @@
       </p:grpSpPr>
       <p:sp>
         <p:nvSpPr>
+          <p:cNvPr id="12" name="Rectangle 11">
+            <a:extLst>
+              <a:ext uri="{FF2B5EF4-FFF2-40B4-BE49-F238E27FC236}">
+                <a16:creationId xmlns:a16="http://schemas.microsoft.com/office/drawing/2014/main" id="{BB2B8762-61F0-4F1B-9364-D633EE9D6AF5}"/>
+              </a:ext>
+              <a:ext uri="{C183D7F6-B498-43B3-948B-1728B52AA6E4}">
+                <adec:decorative xmlns:adec="http://schemas.microsoft.com/office/drawing/2017/decorative" val="1"/>
+              </a:ext>
+            </a:extLst>
+          </p:cNvPr>
+          <p:cNvSpPr>
+            <a:spLocks noGrp="1" noRot="1" noChangeAspect="1" noMove="1" noResize="1" noEditPoints="1" noAdjustHandles="1" noChangeArrowheads="1" noChangeShapeType="1" noTextEdit="1"/>
+          </p:cNvSpPr>
+          <p:nvPr>
+            <p:extLst>
+              <p:ext uri="{386F3935-93C4-4BCD-93E2-E3B085C9AB24}">
+                <p16:designElem xmlns:p16="http://schemas.microsoft.com/office/powerpoint/2015/main" val="1"/>
+              </p:ext>
+            </p:extLst>
+          </p:nvPr>
+        </p:nvSpPr>
+        <p:spPr>
+          <a:xfrm>
+            <a:off x="3175" y="6400800"/>
+            <a:ext cx="12188825" cy="457200"/>
+          </a:xfrm>
+          <a:prstGeom prst="rect">
+            <a:avLst/>
+          </a:prstGeom>
+          <a:solidFill>
+            <a:schemeClr val="accent2"/>
+          </a:solidFill>
+          <a:ln>
+            <a:noFill/>
+          </a:ln>
+        </p:spPr>
+        <p:style>
+          <a:lnRef idx="2">
+            <a:schemeClr val="accent1">
+              <a:shade val="50000"/>
+            </a:schemeClr>
+          </a:lnRef>
+          <a:fillRef idx="1">
+            <a:schemeClr val="accent1"/>
+          </a:fillRef>
+          <a:effectRef idx="0">
+            <a:schemeClr val="accent1"/>
+          </a:effectRef>
+          <a:fontRef idx="minor">
+            <a:schemeClr val="lt1"/>
+          </a:fontRef>
+        </p:style>
+        <p:txBody>
+          <a:bodyPr/>
+          <a:lstStyle/>
+          <a:p>
+            <a:endParaRPr lang="it-IT"/>
+          </a:p>
+        </p:txBody>
+      </p:sp>
+      <p:sp>
+        <p:nvSpPr>
+          <p:cNvPr id="14" name="Rectangle 13">
+            <a:extLst>
+              <a:ext uri="{FF2B5EF4-FFF2-40B4-BE49-F238E27FC236}">
+                <a16:creationId xmlns:a16="http://schemas.microsoft.com/office/drawing/2014/main" id="{E97675C8-1328-460C-9EBF-6B446B67EAD3}"/>
+              </a:ext>
+              <a:ext uri="{C183D7F6-B498-43B3-948B-1728B52AA6E4}">
+                <adec:decorative xmlns:adec="http://schemas.microsoft.com/office/drawing/2017/decorative" val="1"/>
+              </a:ext>
+            </a:extLst>
+          </p:cNvPr>
+          <p:cNvSpPr>
+            <a:spLocks noGrp="1" noRot="1" noChangeAspect="1" noMove="1" noResize="1" noEditPoints="1" noAdjustHandles="1" noChangeArrowheads="1" noChangeShapeType="1" noTextEdit="1"/>
+          </p:cNvSpPr>
+          <p:nvPr>
+            <p:extLst>
+              <p:ext uri="{386F3935-93C4-4BCD-93E2-E3B085C9AB24}">
+                <p16:designElem xmlns:p16="http://schemas.microsoft.com/office/powerpoint/2015/main" val="1"/>
+              </p:ext>
+            </p:extLst>
+          </p:nvPr>
+        </p:nvSpPr>
+        <p:spPr>
+          <a:xfrm>
+            <a:off x="15" y="6334316"/>
+            <a:ext cx="12188825" cy="64008"/>
+          </a:xfrm>
+          <a:prstGeom prst="rect">
+            <a:avLst/>
+          </a:prstGeom>
+          <a:solidFill>
+            <a:schemeClr val="accent1"/>
+          </a:solidFill>
+          <a:ln>
+            <a:noFill/>
+          </a:ln>
+        </p:spPr>
+        <p:style>
+          <a:lnRef idx="2">
+            <a:schemeClr val="accent1">
+              <a:shade val="50000"/>
+            </a:schemeClr>
+          </a:lnRef>
+          <a:fillRef idx="1">
+            <a:schemeClr val="accent1"/>
+          </a:fillRef>
+          <a:effectRef idx="0">
+            <a:schemeClr val="accent1"/>
+          </a:effectRef>
+          <a:fontRef idx="minor">
+            <a:schemeClr val="lt1"/>
+          </a:fontRef>
+        </p:style>
+        <p:txBody>
+          <a:bodyPr/>
+          <a:lstStyle/>
+          <a:p>
+            <a:endParaRPr lang="it-IT"/>
+          </a:p>
+        </p:txBody>
+      </p:sp>
+      <p:cxnSp>
+        <p:nvCxnSpPr>
+          <p:cNvPr id="16" name="Straight Connector 15">
+            <a:extLst>
+              <a:ext uri="{FF2B5EF4-FFF2-40B4-BE49-F238E27FC236}">
+                <a16:creationId xmlns:a16="http://schemas.microsoft.com/office/drawing/2014/main" id="{514EE78B-AF71-4195-A01B-F1165D9233BF}"/>
+              </a:ext>
+              <a:ext uri="{C183D7F6-B498-43B3-948B-1728B52AA6E4}">
+                <adec:decorative xmlns:adec="http://schemas.microsoft.com/office/drawing/2017/decorative" val="1"/>
+              </a:ext>
+            </a:extLst>
+          </p:cNvPr>
+          <p:cNvCxnSpPr>
+            <a:cxnSpLocks noGrp="1" noRot="1" noChangeAspect="1" noMove="1" noResize="1" noEditPoints="1" noAdjustHandles="1" noChangeArrowheads="1" noChangeShapeType="1"/>
+          </p:cNvCxnSpPr>
+          <p:nvPr>
+            <p:extLst>
+              <p:ext uri="{386F3935-93C4-4BCD-93E2-E3B085C9AB24}">
+                <p16:designElem xmlns:p16="http://schemas.microsoft.com/office/powerpoint/2015/main" val="1"/>
+              </p:ext>
+            </p:extLst>
+          </p:nvPr>
+        </p:nvCxnSpPr>
+        <p:spPr>
+          <a:xfrm>
+            <a:off x="1207658" y="4343400"/>
+            <a:ext cx="9875520" cy="0"/>
+          </a:xfrm>
+          <a:prstGeom prst="line">
+            <a:avLst/>
+          </a:prstGeom>
+          <a:ln w="6350">
+            <a:solidFill>
+              <a:schemeClr val="tx1">
+                <a:lumMod val="50000"/>
+                <a:lumOff val="50000"/>
+              </a:schemeClr>
+            </a:solidFill>
+          </a:ln>
+        </p:spPr>
+        <p:style>
+          <a:lnRef idx="1">
+            <a:schemeClr val="accent1"/>
+          </a:lnRef>
+          <a:fillRef idx="0">
+            <a:schemeClr val="accent1"/>
+          </a:fillRef>
+          <a:effectRef idx="0">
+            <a:schemeClr val="accent1"/>
+          </a:effectRef>
+          <a:fontRef idx="minor">
+            <a:schemeClr val="tx1"/>
+          </a:fontRef>
+        </p:style>
+      </p:cxnSp>
+      <p:sp useBgFill="1">
+        <p:nvSpPr>
+          <p:cNvPr id="18" name="Rectangle 17">
+            <a:extLst>
+              <a:ext uri="{FF2B5EF4-FFF2-40B4-BE49-F238E27FC236}">
+                <a16:creationId xmlns:a16="http://schemas.microsoft.com/office/drawing/2014/main" id="{C6417104-D4C1-4710-9982-2154A7F48492}"/>
+              </a:ext>
+              <a:ext uri="{C183D7F6-B498-43B3-948B-1728B52AA6E4}">
+                <adec:decorative xmlns:adec="http://schemas.microsoft.com/office/drawing/2017/decorative" val="1"/>
+              </a:ext>
+            </a:extLst>
+          </p:cNvPr>
+          <p:cNvSpPr>
+            <a:spLocks noGrp="1" noRot="1" noChangeAspect="1" noMove="1" noResize="1" noEditPoints="1" noAdjustHandles="1" noChangeArrowheads="1" noChangeShapeType="1" noTextEdit="1"/>
+          </p:cNvSpPr>
+          <p:nvPr>
+            <p:extLst>
+              <p:ext uri="{386F3935-93C4-4BCD-93E2-E3B085C9AB24}">
+                <p16:designElem xmlns:p16="http://schemas.microsoft.com/office/powerpoint/2015/main" val="1"/>
+              </p:ext>
+            </p:extLst>
+          </p:nvPr>
+        </p:nvSpPr>
+        <p:spPr>
+          <a:xfrm>
+            <a:off x="0" y="0"/>
+            <a:ext cx="12192001" cy="6334316"/>
+          </a:xfrm>
+          <a:prstGeom prst="rect">
+            <a:avLst/>
+          </a:prstGeom>
+          <a:ln>
+            <a:noFill/>
+          </a:ln>
+        </p:spPr>
+        <p:style>
+          <a:lnRef idx="2">
+            <a:schemeClr val="accent1">
+              <a:shade val="50000"/>
+            </a:schemeClr>
+          </a:lnRef>
+          <a:fillRef idx="1">
+            <a:schemeClr val="accent1"/>
+          </a:fillRef>
+          <a:effectRef idx="0">
+            <a:schemeClr val="accent1"/>
+          </a:effectRef>
+          <a:fontRef idx="minor">
+            <a:schemeClr val="lt1"/>
+          </a:fontRef>
+        </p:style>
+        <p:txBody>
+          <a:bodyPr rtlCol="0" anchor="ctr"/>
+          <a:lstStyle/>
+          <a:p>
+            <a:pPr algn="ctr"/>
+            <a:endParaRPr lang="en-US"/>
+          </a:p>
+        </p:txBody>
+      </p:sp>
+      <p:sp>
+        <p:nvSpPr>
           <p:cNvPr id="2" name="Title 1">
             <a:extLst>
               <a:ext uri="{FF2B5EF4-FFF2-40B4-BE49-F238E27FC236}">
-                <a16:creationId xmlns:a16="http://schemas.microsoft.com/office/drawing/2014/main" id="{71A50906-B844-4BFE-8647-BDCF17A3AF80}"/>
+                <a16:creationId xmlns:a16="http://schemas.microsoft.com/office/drawing/2014/main" id="{976C48AE-8D35-CB5A-C5AA-8EAC79603438}"/>
               </a:ext>
             </a:extLst>
           </p:cNvPr>
@@ -6185,130 +6433,36 @@
         </p:nvSpPr>
         <p:spPr>
           <a:xfrm>
-            <a:off x="4908262" y="1073683"/>
-            <a:ext cx="6247418" cy="663677"/>
-          </a:xfrm>
-        </p:spPr>
-        <p:txBody>
-          <a:bodyPr>
-            <a:normAutofit fontScale="90000"/>
+            <a:off x="633999" y="4550229"/>
+            <a:ext cx="10909073" cy="1057655"/>
+          </a:xfrm>
+        </p:spPr>
+        <p:txBody>
+          <a:bodyPr vert="horz" lIns="91440" tIns="45720" rIns="91440" bIns="45720" rtlCol="0" anchor="b">
+            <a:normAutofit/>
           </a:bodyPr>
           <a:lstStyle/>
           <a:p>
             <a:r>
-              <a:rPr lang="en-US" dirty="0"/>
-              <a:t>CUDA Parallel Forward Edge Iterator V1</a:t>
-            </a:r>
-            <a:endParaRPr lang="it-IT" dirty="0"/>
-          </a:p>
-        </p:txBody>
-      </p:sp>
-      <p:sp>
-        <p:nvSpPr>
-          <p:cNvPr id="3" name="Content Placeholder 2">
-            <a:extLst>
-              <a:ext uri="{FF2B5EF4-FFF2-40B4-BE49-F238E27FC236}">
-                <a16:creationId xmlns:a16="http://schemas.microsoft.com/office/drawing/2014/main" id="{18C7CF8C-4187-4FF0-AADA-8E3647C37F11}"/>
-              </a:ext>
-            </a:extLst>
-          </p:cNvPr>
-          <p:cNvSpPr>
-            <a:spLocks noGrp="1"/>
-          </p:cNvSpPr>
-          <p:nvPr>
-            <p:ph idx="1"/>
-          </p:nvPr>
-        </p:nvSpPr>
-        <p:spPr>
-          <a:xfrm>
-            <a:off x="4908262" y="1846498"/>
-            <a:ext cx="6247417" cy="4022596"/>
-          </a:xfrm>
-        </p:spPr>
-        <p:txBody>
-          <a:bodyPr>
-            <a:normAutofit fontScale="92500" lnSpcReduction="10000"/>
-          </a:bodyPr>
-          <a:lstStyle/>
-          <a:p>
-            <a:r>
-              <a:rPr lang="en-US" dirty="0"/>
-              <a:t>The </a:t>
-            </a:r>
-            <a:r>
-              <a:rPr lang="en-US" b="1" dirty="0"/>
-              <a:t>Forward Edge Iterator</a:t>
-            </a:r>
-            <a:r>
-              <a:rPr lang="en-US" dirty="0"/>
-              <a:t> has also been implemented in CUDA, similar to the Forward Node Algorithm. It uses the </a:t>
-            </a:r>
-            <a:r>
-              <a:rPr lang="en-US" b="1" dirty="0"/>
-              <a:t>CRS (Compressed Row Storage)</a:t>
-            </a:r>
-            <a:r>
-              <a:rPr lang="en-US" dirty="0"/>
-              <a:t> format to represent the graph data. The implementation assigns </a:t>
-            </a:r>
-            <a:r>
-              <a:rPr lang="en-US" b="1" dirty="0"/>
-              <a:t>one thread to manage one edge</a:t>
-            </a:r>
-            <a:r>
-              <a:rPr lang="en-US" dirty="0"/>
-              <a:t>, handled through the function </a:t>
-            </a:r>
-            <a:r>
-              <a:rPr lang="en-US" i="1" dirty="0" err="1"/>
-              <a:t>EdgeIteratorAlgorithmKernel</a:t>
-            </a:r>
-            <a:r>
-              <a:rPr lang="en-US" dirty="0"/>
-              <a:t>. Since each edge connects two nodes in the graph, the function iterates over the neighbors of both nodes, and whenever two neighbors match, a new triangle is counted.</a:t>
-            </a:r>
-          </a:p>
-          <a:p>
-            <a:r>
-              <a:rPr lang="en-US" dirty="0"/>
-              <a:t>In the graph shown, we observe a significant reduction in execution time as </a:t>
-            </a:r>
-            <a:r>
-              <a:rPr lang="en-US" b="1" dirty="0"/>
-              <a:t>BLOCK_SIZE</a:t>
-            </a:r>
-            <a:r>
-              <a:rPr lang="en-US" dirty="0"/>
-              <a:t> increases from 8 to 128, where the function achieves its minimum execution time. Beyond this point, further increases in </a:t>
-            </a:r>
-            <a:r>
-              <a:rPr lang="en-US" b="1" dirty="0"/>
-              <a:t>BLOCK_SIZE</a:t>
-            </a:r>
-            <a:r>
-              <a:rPr lang="en-US" dirty="0"/>
-              <a:t> lead to longer execution times. This behavior is due to </a:t>
-            </a:r>
-            <a:r>
-              <a:rPr lang="en-US" b="1" dirty="0"/>
-              <a:t>resource limitations</a:t>
-            </a:r>
-            <a:r>
-              <a:rPr lang="en-US" dirty="0"/>
-              <a:t>, which reduce the number of active warps available.</a:t>
-            </a:r>
-          </a:p>
-          <a:p>
-            <a:endParaRPr lang="it-IT" dirty="0"/>
+              <a:rPr lang="en-US" sz="3300">
+                <a:solidFill>
+                  <a:schemeClr val="tx1">
+                    <a:lumMod val="85000"/>
+                    <a:lumOff val="15000"/>
+                  </a:schemeClr>
+                </a:solidFill>
+              </a:rPr>
+              <a:t>Comparison between Parallel Edge v3 and sequential version</a:t>
+            </a:r>
           </a:p>
         </p:txBody>
       </p:sp>
       <p:pic>
         <p:nvPicPr>
-          <p:cNvPr id="4" name="Picture 3">
+          <p:cNvPr id="7" name="Picture 6">
             <a:extLst>
               <a:ext uri="{FF2B5EF4-FFF2-40B4-BE49-F238E27FC236}">
-                <a16:creationId xmlns:a16="http://schemas.microsoft.com/office/drawing/2014/main" id="{C59DFCE3-567F-4B74-8016-E48DD22B303C}"/>
+                <a16:creationId xmlns:a16="http://schemas.microsoft.com/office/drawing/2014/main" id="{DC10C1FF-4FC9-2F91-4FAF-2542BD252A1F}"/>
               </a:ext>
             </a:extLst>
           </p:cNvPr>
@@ -6325,18 +6479,286 @@
         </p:blipFill>
         <p:spPr>
           <a:xfrm>
-            <a:off x="155056" y="1737360"/>
-            <a:ext cx="4753206" cy="3013544"/>
+            <a:off x="635457" y="844221"/>
+            <a:ext cx="5131653" cy="3194453"/>
           </a:xfrm>
           <a:prstGeom prst="rect">
             <a:avLst/>
           </a:prstGeom>
         </p:spPr>
       </p:pic>
+      <p:sp>
+        <p:nvSpPr>
+          <p:cNvPr id="20" name="Rectangle 19">
+            <a:extLst>
+              <a:ext uri="{FF2B5EF4-FFF2-40B4-BE49-F238E27FC236}">
+                <a16:creationId xmlns:a16="http://schemas.microsoft.com/office/drawing/2014/main" id="{626F1402-2DEC-4071-84AF-350C7BF00D43}"/>
+              </a:ext>
+              <a:ext uri="{C183D7F6-B498-43B3-948B-1728B52AA6E4}">
+                <adec:decorative xmlns:adec="http://schemas.microsoft.com/office/drawing/2017/decorative" val="1"/>
+              </a:ext>
+            </a:extLst>
+          </p:cNvPr>
+          <p:cNvSpPr>
+            <a:spLocks noGrp="1" noRot="1" noChangeAspect="1" noMove="1" noResize="1" noEditPoints="1" noAdjustHandles="1" noChangeArrowheads="1" noChangeShapeType="1" noTextEdit="1"/>
+          </p:cNvSpPr>
+          <p:nvPr>
+            <p:extLst>
+              <p:ext uri="{386F3935-93C4-4BCD-93E2-E3B085C9AB24}">
+                <p16:designElem xmlns:p16="http://schemas.microsoft.com/office/powerpoint/2015/main" val="1"/>
+              </p:ext>
+            </p:extLst>
+          </p:nvPr>
+        </p:nvSpPr>
+        <p:spPr>
+          <a:xfrm>
+            <a:off x="6063996" y="886968"/>
+            <a:ext cx="64008" cy="3108960"/>
+          </a:xfrm>
+          <a:prstGeom prst="rect">
+            <a:avLst/>
+          </a:prstGeom>
+          <a:ln>
+            <a:noFill/>
+          </a:ln>
+        </p:spPr>
+        <p:style>
+          <a:lnRef idx="2">
+            <a:schemeClr val="accent1">
+              <a:shade val="50000"/>
+            </a:schemeClr>
+          </a:lnRef>
+          <a:fillRef idx="1">
+            <a:schemeClr val="accent1"/>
+          </a:fillRef>
+          <a:effectRef idx="0">
+            <a:schemeClr val="accent1"/>
+          </a:effectRef>
+          <a:fontRef idx="minor">
+            <a:schemeClr val="lt1"/>
+          </a:fontRef>
+        </p:style>
+        <p:txBody>
+          <a:bodyPr rtlCol="0" anchor="ctr"/>
+          <a:lstStyle/>
+          <a:p>
+            <a:pPr algn="ctr"/>
+            <a:endParaRPr lang="en-US"/>
+          </a:p>
+        </p:txBody>
+      </p:sp>
+      <p:pic>
+        <p:nvPicPr>
+          <p:cNvPr id="5" name="Picture 4">
+            <a:extLst>
+              <a:ext uri="{FF2B5EF4-FFF2-40B4-BE49-F238E27FC236}">
+                <a16:creationId xmlns:a16="http://schemas.microsoft.com/office/drawing/2014/main" id="{EFA1B7A4-C699-1B94-59E1-03E001B15932}"/>
+              </a:ext>
+            </a:extLst>
+          </p:cNvPr>
+          <p:cNvPicPr>
+            <a:picLocks noChangeAspect="1"/>
+          </p:cNvPicPr>
+          <p:nvPr/>
+        </p:nvPicPr>
+        <p:blipFill>
+          <a:blip r:embed="rId3"/>
+          <a:stretch>
+            <a:fillRect/>
+          </a:stretch>
+        </p:blipFill>
+        <p:spPr>
+          <a:xfrm>
+            <a:off x="6424891" y="790834"/>
+            <a:ext cx="5118182" cy="3301227"/>
+          </a:xfrm>
+          <a:prstGeom prst="rect">
+            <a:avLst/>
+          </a:prstGeom>
+        </p:spPr>
+      </p:pic>
+      <p:cxnSp>
+        <p:nvCxnSpPr>
+          <p:cNvPr id="22" name="Straight Connector 21">
+            <a:extLst>
+              <a:ext uri="{FF2B5EF4-FFF2-40B4-BE49-F238E27FC236}">
+                <a16:creationId xmlns:a16="http://schemas.microsoft.com/office/drawing/2014/main" id="{04733B62-1719-4677-A612-CA0AC0AD7482}"/>
+              </a:ext>
+              <a:ext uri="{C183D7F6-B498-43B3-948B-1728B52AA6E4}">
+                <adec:decorative xmlns:adec="http://schemas.microsoft.com/office/drawing/2017/decorative" val="1"/>
+              </a:ext>
+            </a:extLst>
+          </p:cNvPr>
+          <p:cNvCxnSpPr>
+            <a:cxnSpLocks noGrp="1" noRot="1" noChangeAspect="1" noMove="1" noResize="1" noEditPoints="1" noAdjustHandles="1" noChangeArrowheads="1" noChangeShapeType="1"/>
+          </p:cNvCxnSpPr>
+          <p:nvPr>
+            <p:extLst>
+              <p:ext uri="{386F3935-93C4-4BCD-93E2-E3B085C9AB24}">
+                <p16:designElem xmlns:p16="http://schemas.microsoft.com/office/powerpoint/2015/main" val="1"/>
+              </p:ext>
+            </p:extLst>
+          </p:nvPr>
+        </p:nvCxnSpPr>
+        <p:spPr>
+          <a:xfrm>
+            <a:off x="721086" y="5618770"/>
+            <a:ext cx="10515600" cy="0"/>
+          </a:xfrm>
+          <a:prstGeom prst="line">
+            <a:avLst/>
+          </a:prstGeom>
+          <a:ln w="6350">
+            <a:solidFill>
+              <a:schemeClr val="tx2">
+                <a:alpha val="90000"/>
+              </a:schemeClr>
+            </a:solidFill>
+          </a:ln>
+        </p:spPr>
+        <p:style>
+          <a:lnRef idx="1">
+            <a:schemeClr val="accent1"/>
+          </a:lnRef>
+          <a:fillRef idx="0">
+            <a:schemeClr val="accent1"/>
+          </a:fillRef>
+          <a:effectRef idx="0">
+            <a:schemeClr val="accent1"/>
+          </a:effectRef>
+          <a:fontRef idx="minor">
+            <a:schemeClr val="tx1"/>
+          </a:fontRef>
+        </p:style>
+      </p:cxnSp>
+      <p:sp>
+        <p:nvSpPr>
+          <p:cNvPr id="24" name="Rectangle 23">
+            <a:extLst>
+              <a:ext uri="{FF2B5EF4-FFF2-40B4-BE49-F238E27FC236}">
+                <a16:creationId xmlns:a16="http://schemas.microsoft.com/office/drawing/2014/main" id="{DA52A394-10F4-4AA5-90E4-634D1E919DBA}"/>
+              </a:ext>
+              <a:ext uri="{C183D7F6-B498-43B3-948B-1728B52AA6E4}">
+                <adec:decorative xmlns:adec="http://schemas.microsoft.com/office/drawing/2017/decorative" val="1"/>
+              </a:ext>
+            </a:extLst>
+          </p:cNvPr>
+          <p:cNvSpPr>
+            <a:spLocks noGrp="1" noRot="1" noChangeAspect="1" noMove="1" noResize="1" noEditPoints="1" noAdjustHandles="1" noChangeArrowheads="1" noChangeShapeType="1" noTextEdit="1"/>
+          </p:cNvSpPr>
+          <p:nvPr>
+            <p:extLst>
+              <p:ext uri="{386F3935-93C4-4BCD-93E2-E3B085C9AB24}">
+                <p16:designElem xmlns:p16="http://schemas.microsoft.com/office/powerpoint/2015/main" val="1"/>
+              </p:ext>
+            </p:extLst>
+          </p:nvPr>
+        </p:nvSpPr>
+        <p:spPr>
+          <a:xfrm>
+            <a:off x="15" y="6334316"/>
+            <a:ext cx="12191985" cy="66484"/>
+          </a:xfrm>
+          <a:prstGeom prst="rect">
+            <a:avLst/>
+          </a:prstGeom>
+          <a:solidFill>
+            <a:schemeClr val="accent1"/>
+          </a:solidFill>
+          <a:ln>
+            <a:noFill/>
+          </a:ln>
+        </p:spPr>
+        <p:style>
+          <a:lnRef idx="2">
+            <a:schemeClr val="accent1">
+              <a:shade val="50000"/>
+            </a:schemeClr>
+          </a:lnRef>
+          <a:fillRef idx="1">
+            <a:schemeClr val="accent1"/>
+          </a:fillRef>
+          <a:effectRef idx="0">
+            <a:schemeClr val="accent1"/>
+          </a:effectRef>
+          <a:fontRef idx="minor">
+            <a:schemeClr val="lt1"/>
+          </a:fontRef>
+        </p:style>
+        <p:txBody>
+          <a:bodyPr/>
+          <a:lstStyle/>
+          <a:p>
+            <a:endParaRPr lang="it-IT"/>
+          </a:p>
+        </p:txBody>
+      </p:sp>
+      <p:sp>
+        <p:nvSpPr>
+          <p:cNvPr id="26" name="Rectangle 25">
+            <a:extLst>
+              <a:ext uri="{FF2B5EF4-FFF2-40B4-BE49-F238E27FC236}">
+                <a16:creationId xmlns:a16="http://schemas.microsoft.com/office/drawing/2014/main" id="{07BDDC51-8BB2-42BE-8EA8-39B3E9AC1EF6}"/>
+              </a:ext>
+              <a:ext uri="{C183D7F6-B498-43B3-948B-1728B52AA6E4}">
+                <adec:decorative xmlns:adec="http://schemas.microsoft.com/office/drawing/2017/decorative" val="1"/>
+              </a:ext>
+            </a:extLst>
+          </p:cNvPr>
+          <p:cNvSpPr>
+            <a:spLocks noGrp="1" noRot="1" noChangeAspect="1" noMove="1" noResize="1" noEditPoints="1" noAdjustHandles="1" noChangeArrowheads="1" noChangeShapeType="1" noTextEdit="1"/>
+          </p:cNvSpPr>
+          <p:nvPr>
+            <p:extLst>
+              <p:ext uri="{386F3935-93C4-4BCD-93E2-E3B085C9AB24}">
+                <p16:designElem xmlns:p16="http://schemas.microsoft.com/office/powerpoint/2015/main" val="1"/>
+              </p:ext>
+            </p:extLst>
+          </p:nvPr>
+        </p:nvSpPr>
+        <p:spPr>
+          <a:xfrm>
+            <a:off x="1" y="6400800"/>
+            <a:ext cx="12192000" cy="457200"/>
+          </a:xfrm>
+          <a:prstGeom prst="rect">
+            <a:avLst/>
+          </a:prstGeom>
+          <a:solidFill>
+            <a:schemeClr val="accent2"/>
+          </a:solidFill>
+          <a:ln>
+            <a:noFill/>
+          </a:ln>
+        </p:spPr>
+        <p:style>
+          <a:lnRef idx="2">
+            <a:schemeClr val="accent1">
+              <a:shade val="50000"/>
+            </a:schemeClr>
+          </a:lnRef>
+          <a:fillRef idx="1">
+            <a:schemeClr val="accent1"/>
+          </a:fillRef>
+          <a:effectRef idx="0">
+            <a:schemeClr val="accent1"/>
+          </a:effectRef>
+          <a:fontRef idx="minor">
+            <a:schemeClr val="lt1"/>
+          </a:fontRef>
+        </p:style>
+        <p:txBody>
+          <a:bodyPr/>
+          <a:lstStyle/>
+          <a:p>
+            <a:endParaRPr lang="it-IT"/>
+          </a:p>
+        </p:txBody>
+      </p:sp>
     </p:spTree>
     <p:extLst>
       <p:ext uri="{BB962C8B-B14F-4D97-AF65-F5344CB8AC3E}">
-        <p14:creationId xmlns:p14="http://schemas.microsoft.com/office/powerpoint/2010/main" val="3421887235"/>
+        <p14:creationId xmlns:p14="http://schemas.microsoft.com/office/powerpoint/2010/main" val="432938699"/>
       </p:ext>
     </p:extLst>
   </p:cSld>
@@ -6368,7 +6790,7 @@
           <p:cNvPr id="2" name="Title 1">
             <a:extLst>
               <a:ext uri="{FF2B5EF4-FFF2-40B4-BE49-F238E27FC236}">
-                <a16:creationId xmlns:a16="http://schemas.microsoft.com/office/drawing/2014/main" id="{AB737B48-0C32-42E8-821E-4DAB55EF75E4}"/>
+                <a16:creationId xmlns:a16="http://schemas.microsoft.com/office/drawing/2014/main" id="{71A50906-B844-4BFE-8647-BDCF17A3AF80}"/>
               </a:ext>
             </a:extLst>
           </p:cNvPr>
@@ -6381,61 +6803,79 @@
         </p:nvSpPr>
         <p:spPr>
           <a:xfrm>
-            <a:off x="4943658" y="371659"/>
-            <a:ext cx="6212021" cy="1365701"/>
-          </a:xfrm>
-        </p:spPr>
-        <p:txBody>
-          <a:bodyPr/>
-          <a:lstStyle/>
-          <a:p>
-            <a:r>
-              <a:rPr lang="en-US" dirty="0"/>
-              <a:t>CUDA Parallel Forward Edge Iterator V1_1</a:t>
-            </a:r>
-            <a:endParaRPr lang="it-IT" dirty="0"/>
-          </a:p>
-        </p:txBody>
-      </p:sp>
-      <p:sp>
-        <p:nvSpPr>
-          <p:cNvPr id="3" name="Content Placeholder 2">
-            <a:extLst>
-              <a:ext uri="{FF2B5EF4-FFF2-40B4-BE49-F238E27FC236}">
-                <a16:creationId xmlns:a16="http://schemas.microsoft.com/office/drawing/2014/main" id="{7478F246-FEDA-4B80-B6DD-D2E52B0FB123}"/>
-              </a:ext>
-            </a:extLst>
-          </p:cNvPr>
-          <p:cNvSpPr>
-            <a:spLocks noGrp="1"/>
-          </p:cNvSpPr>
-          <p:nvPr>
-            <p:ph idx="1"/>
-          </p:nvPr>
-        </p:nvSpPr>
-        <p:spPr>
-          <a:xfrm>
-            <a:off x="4849270" y="1845734"/>
-            <a:ext cx="6306409" cy="4023360"/>
+            <a:off x="4908262" y="1073683"/>
+            <a:ext cx="6247418" cy="663677"/>
           </a:xfrm>
         </p:spPr>
         <p:txBody>
           <a:bodyPr>
-            <a:normAutofit fontScale="92500" lnSpcReduction="20000"/>
+            <a:normAutofit fontScale="90000"/>
           </a:bodyPr>
           <a:lstStyle/>
           <a:p>
             <a:r>
               <a:rPr lang="en-US" dirty="0"/>
+              <a:t>CUDA Parallel Forward Edge Iterator V1</a:t>
+            </a:r>
+            <a:endParaRPr lang="it-IT" dirty="0"/>
+          </a:p>
+        </p:txBody>
+      </p:sp>
+      <p:sp>
+        <p:nvSpPr>
+          <p:cNvPr id="3" name="Content Placeholder 2">
+            <a:extLst>
+              <a:ext uri="{FF2B5EF4-FFF2-40B4-BE49-F238E27FC236}">
+                <a16:creationId xmlns:a16="http://schemas.microsoft.com/office/drawing/2014/main" id="{18C7CF8C-4187-4FF0-AADA-8E3647C37F11}"/>
+              </a:ext>
+            </a:extLst>
+          </p:cNvPr>
+          <p:cNvSpPr>
+            <a:spLocks noGrp="1"/>
+          </p:cNvSpPr>
+          <p:nvPr>
+            <p:ph idx="1"/>
+          </p:nvPr>
+        </p:nvSpPr>
+        <p:spPr>
+          <a:xfrm>
+            <a:off x="4908262" y="1846498"/>
+            <a:ext cx="6247417" cy="4022596"/>
+          </a:xfrm>
+        </p:spPr>
+        <p:txBody>
+          <a:bodyPr>
+            <a:normAutofit fontScale="92500" lnSpcReduction="10000"/>
+          </a:bodyPr>
+          <a:lstStyle/>
+          <a:p>
+            <a:r>
+              <a:rPr lang="en-US" dirty="0"/>
               <a:t>The </a:t>
             </a:r>
             <a:r>
               <a:rPr lang="en-US" b="1" dirty="0"/>
-              <a:t>V1_1 version</a:t>
-            </a:r>
-            <a:r>
-              <a:rPr lang="en-US" dirty="0"/>
-              <a:t> builds directly on the original CUDA Forward Edge Iterator. The core function (</a:t>
+              <a:t>Forward Edge Iterator</a:t>
+            </a:r>
+            <a:r>
+              <a:rPr lang="en-US" dirty="0"/>
+              <a:t> has also been implemented in CUDA, similar to the Forward Node Algorithm. It uses the </a:t>
+            </a:r>
+            <a:r>
+              <a:rPr lang="en-US" b="1" dirty="0"/>
+              <a:t>CRS (Compressed Row Storage)</a:t>
+            </a:r>
+            <a:r>
+              <a:rPr lang="en-US" dirty="0"/>
+              <a:t> format to represent the graph data. The implementation assigns </a:t>
+            </a:r>
+            <a:r>
+              <a:rPr lang="en-US" b="1" dirty="0"/>
+              <a:t>one thread to manage one edge</a:t>
+            </a:r>
+            <a:r>
+              <a:rPr lang="en-US" dirty="0"/>
+              <a:t>, handled through the function </a:t>
             </a:r>
             <a:r>
               <a:rPr lang="en-US" i="1" dirty="0" err="1"/>
@@ -6443,37 +6883,13 @@
             </a:r>
             <a:r>
               <a:rPr lang="en-US" dirty="0"/>
-              <a:t>) remains unchanged. The key modification is in how edges are assigned: Instead of one thread handling exactly one edge, the full edge set is divided into </a:t>
-            </a:r>
-            <a:r>
-              <a:rPr lang="en-US" b="1" dirty="0"/>
-              <a:t>chunks</a:t>
-            </a:r>
-            <a:r>
-              <a:rPr lang="en-US" dirty="0"/>
-              <a:t>, with each thread responsible for one chunk. This design aims to improve </a:t>
-            </a:r>
-            <a:r>
-              <a:rPr lang="en-US" b="1" dirty="0"/>
-              <a:t>GPU resource utilization</a:t>
-            </a:r>
-            <a:r>
-              <a:rPr lang="en-US" dirty="0"/>
-              <a:t> and reduce latency by lowering the number of tasks the scheduler must manage in parallel.</a:t>
-            </a:r>
-          </a:p>
-          <a:p>
-            <a:r>
-              <a:rPr lang="en-US" dirty="0"/>
-              <a:t>The graph illustrates the total execution time as a function of the number of </a:t>
-            </a:r>
-            <a:r>
-              <a:rPr lang="en-US" b="1" dirty="0"/>
-              <a:t>kernel launches</a:t>
-            </a:r>
-            <a:r>
-              <a:rPr lang="en-US" dirty="0"/>
-              <a:t> for different </a:t>
+              <a:t>. Since each edge connects two nodes in the graph, the function iterates over the neighbors of both nodes, and whenever two neighbors match, a new triangle is counted.</a:t>
+            </a:r>
+          </a:p>
+          <a:p>
+            <a:r>
+              <a:rPr lang="en-US" dirty="0"/>
+              <a:t>In the graph shown, we observe a significant reduction in execution time as </a:t>
             </a:r>
             <a:r>
               <a:rPr lang="en-US" b="1" dirty="0"/>
@@ -6481,23 +6897,7 @@
             </a:r>
             <a:r>
               <a:rPr lang="en-US" dirty="0"/>
-              <a:t> configurations. Execution time </a:t>
-            </a:r>
-            <a:r>
-              <a:rPr lang="en-US" b="1" dirty="0"/>
-              <a:t>increases consistently</a:t>
-            </a:r>
-            <a:r>
-              <a:rPr lang="en-US" dirty="0"/>
-              <a:t> as the number of kernel launches grows, due to overhead from setup, scheduling, and synchronization. While chunking can sometimes improve GPU occupancy, here the </a:t>
-            </a:r>
-            <a:r>
-              <a:rPr lang="en-US" b="1" dirty="0"/>
-              <a:t>launch overhead dominates</a:t>
-            </a:r>
-            <a:r>
-              <a:rPr lang="en-US" dirty="0"/>
-              <a:t>, negating potential benefits. Different </a:t>
+              <a:t> increases from 8 to 128, where the function achieves its minimum execution time. Beyond this point, further increases in </a:t>
             </a:r>
             <a:r>
               <a:rPr lang="en-US" b="1" dirty="0"/>
@@ -6505,27 +6905,19 @@
             </a:r>
             <a:r>
               <a:rPr lang="en-US" dirty="0"/>
-              <a:t> values exhibit similar trends, though </a:t>
+              <a:t> lead to longer execution times. This behavior is due to </a:t>
             </a:r>
             <a:r>
               <a:rPr lang="en-US" b="1" dirty="0"/>
-              <a:t>BLOCK_SIZE = 16</a:t>
-            </a:r>
-            <a:r>
-              <a:rPr lang="en-US" dirty="0"/>
-              <a:t> and </a:t>
-            </a:r>
-            <a:r>
-              <a:rPr lang="en-US" b="1" dirty="0"/>
-              <a:t>32</a:t>
-            </a:r>
-            <a:r>
-              <a:rPr lang="en-US" dirty="0"/>
-              <a:t> show slightly better performance at lower launch counts.</a:t>
-            </a:r>
-          </a:p>
-          <a:p>
-            <a:endParaRPr lang="en-US" dirty="0"/>
+              <a:t>resource limitations</a:t>
+            </a:r>
+            <a:r>
+              <a:rPr lang="en-US" dirty="0"/>
+              <a:t>, which reduce the number of active warps available.</a:t>
+            </a:r>
+          </a:p>
+          <a:p>
+            <a:endParaRPr lang="it-IT" dirty="0"/>
           </a:p>
         </p:txBody>
       </p:sp>
@@ -6534,7 +6926,7 @@
           <p:cNvPr id="4" name="Picture 3">
             <a:extLst>
               <a:ext uri="{FF2B5EF4-FFF2-40B4-BE49-F238E27FC236}">
-                <a16:creationId xmlns:a16="http://schemas.microsoft.com/office/drawing/2014/main" id="{9A59FA78-B03A-4CA7-B577-2ABC83606275}"/>
+                <a16:creationId xmlns:a16="http://schemas.microsoft.com/office/drawing/2014/main" id="{C59DFCE3-567F-4B74-8016-E48DD22B303C}"/>
               </a:ext>
             </a:extLst>
           </p:cNvPr>
@@ -6551,8 +6943,8 @@
         </p:blipFill>
         <p:spPr>
           <a:xfrm>
-            <a:off x="185030" y="1580262"/>
-            <a:ext cx="4664240" cy="2891449"/>
+            <a:off x="155056" y="1737360"/>
+            <a:ext cx="4753206" cy="3013544"/>
           </a:xfrm>
           <a:prstGeom prst="rect">
             <a:avLst/>
@@ -6562,7 +6954,7 @@
     </p:spTree>
     <p:extLst>
       <p:ext uri="{BB962C8B-B14F-4D97-AF65-F5344CB8AC3E}">
-        <p14:creationId xmlns:p14="http://schemas.microsoft.com/office/powerpoint/2010/main" val="544973999"/>
+        <p14:creationId xmlns:p14="http://schemas.microsoft.com/office/powerpoint/2010/main" val="3421887235"/>
       </p:ext>
     </p:extLst>
   </p:cSld>
@@ -6594,7 +6986,7 @@
           <p:cNvPr id="2" name="Title 1">
             <a:extLst>
               <a:ext uri="{FF2B5EF4-FFF2-40B4-BE49-F238E27FC236}">
-                <a16:creationId xmlns:a16="http://schemas.microsoft.com/office/drawing/2014/main" id="{4EFDE9B1-0271-46CE-B282-36987546B4BC}"/>
+                <a16:creationId xmlns:a16="http://schemas.microsoft.com/office/drawing/2014/main" id="{AB737B48-0C32-42E8-821E-4DAB55EF75E4}"/>
               </a:ext>
             </a:extLst>
           </p:cNvPr>
@@ -6607,8 +6999,8 @@
         </p:nvSpPr>
         <p:spPr>
           <a:xfrm>
-            <a:off x="5043948" y="286603"/>
-            <a:ext cx="6111732" cy="1450757"/>
+            <a:off x="4943658" y="371659"/>
+            <a:ext cx="6212021" cy="1365701"/>
           </a:xfrm>
         </p:spPr>
         <p:txBody>
@@ -6617,7 +7009,7 @@
           <a:p>
             <a:r>
               <a:rPr lang="en-US" dirty="0"/>
-              <a:t>CUDA Parallel Forward Edge Iterator V2</a:t>
+              <a:t>CUDA Parallel Forward Edge Iterator V1_1</a:t>
             </a:r>
             <a:endParaRPr lang="it-IT" dirty="0"/>
           </a:p>
@@ -6628,7 +7020,7 @@
           <p:cNvPr id="3" name="Content Placeholder 2">
             <a:extLst>
               <a:ext uri="{FF2B5EF4-FFF2-40B4-BE49-F238E27FC236}">
-                <a16:creationId xmlns:a16="http://schemas.microsoft.com/office/drawing/2014/main" id="{100EA725-890B-4ED8-9437-261DD2F6C130}"/>
+                <a16:creationId xmlns:a16="http://schemas.microsoft.com/office/drawing/2014/main" id="{7478F246-FEDA-4B80-B6DD-D2E52B0FB123}"/>
               </a:ext>
             </a:extLst>
           </p:cNvPr>
@@ -6641,55 +7033,65 @@
         </p:nvSpPr>
         <p:spPr>
           <a:xfrm>
-            <a:off x="5043948" y="1845734"/>
-            <a:ext cx="6111732" cy="4023360"/>
-          </a:xfrm>
-        </p:spPr>
-        <p:txBody>
-          <a:bodyPr/>
+            <a:off x="4849270" y="1845734"/>
+            <a:ext cx="6306409" cy="4023360"/>
+          </a:xfrm>
+        </p:spPr>
+        <p:txBody>
+          <a:bodyPr>
+            <a:normAutofit fontScale="92500" lnSpcReduction="20000"/>
+          </a:bodyPr>
           <a:lstStyle/>
           <a:p>
             <a:r>
               <a:rPr lang="en-US" dirty="0"/>
-              <a:t>Unlike V1, the </a:t>
+              <a:t>The </a:t>
             </a:r>
             <a:r>
               <a:rPr lang="en-US" b="1" dirty="0"/>
-              <a:t>V2 CUDA Edge Iterator</a:t>
-            </a:r>
-            <a:r>
-              <a:rPr lang="en-US" dirty="0"/>
-              <a:t> uses a </a:t>
+              <a:t>V1_1 version</a:t>
+            </a:r>
+            <a:r>
+              <a:rPr lang="en-US" dirty="0"/>
+              <a:t> builds directly on the original CUDA Forward Edge Iterator. The core function (</a:t>
+            </a:r>
+            <a:r>
+              <a:rPr lang="en-US" i="1" dirty="0" err="1"/>
+              <a:t>EdgeIteratorAlgorithmKernel</a:t>
+            </a:r>
+            <a:r>
+              <a:rPr lang="en-US" dirty="0"/>
+              <a:t>) remains unchanged. The key modification is in how edges are assigned: Instead of one thread handling exactly one edge, the full edge set is divided into </a:t>
             </a:r>
             <a:r>
               <a:rPr lang="en-US" b="1" dirty="0"/>
-              <a:t>two-pointer merge-like algorithm</a:t>
-            </a:r>
-            <a:r>
-              <a:rPr lang="en-US" dirty="0"/>
-              <a:t> for neighbor intersection with linear complexity (d(u) + d(v)). Each thread still processes one edge, and all edges are handled in a </a:t>
+              <a:t>chunks</a:t>
+            </a:r>
+            <a:r>
+              <a:rPr lang="en-US" dirty="0"/>
+              <a:t>, with each thread responsible for one chunk. This design aims to improve </a:t>
             </a:r>
             <a:r>
               <a:rPr lang="en-US" b="1" dirty="0"/>
-              <a:t>single kernel launch</a:t>
-            </a:r>
-            <a:r>
-              <a:rPr lang="en-US" dirty="0"/>
-              <a:t>, which greatly improves efficiency, especially for high-degree nodes.</a:t>
-            </a:r>
-          </a:p>
-          <a:p>
-            <a:r>
-              <a:rPr lang="en-US" dirty="0"/>
-              <a:t>On a </a:t>
+              <a:t>GPU resource utilization</a:t>
+            </a:r>
+            <a:r>
+              <a:rPr lang="en-US" dirty="0"/>
+              <a:t> and reduce latency by lowering the number of tasks the scheduler must manage in parallel.</a:t>
+            </a:r>
+          </a:p>
+          <a:p>
+            <a:r>
+              <a:rPr lang="en-US" dirty="0"/>
+              <a:t>The graph illustrates the total execution time as a function of the number of </a:t>
             </a:r>
             <a:r>
               <a:rPr lang="en-US" b="1" dirty="0"/>
-              <a:t>100M-node graph</a:t>
-            </a:r>
-            <a:r>
-              <a:rPr lang="en-US" dirty="0"/>
-              <a:t>, performance improves sharply as </a:t>
+              <a:t>kernel launches</a:t>
+            </a:r>
+            <a:r>
+              <a:rPr lang="en-US" dirty="0"/>
+              <a:t> for different </a:t>
             </a:r>
             <a:r>
               <a:rPr lang="en-US" b="1" dirty="0"/>
@@ -6697,35 +7099,51 @@
             </a:r>
             <a:r>
               <a:rPr lang="en-US" dirty="0"/>
-              <a:t> increases from 8 to 32 (best time: </a:t>
+              <a:t> configurations. Execution time </a:t>
             </a:r>
             <a:r>
               <a:rPr lang="en-US" b="1" dirty="0"/>
-              <a:t>3441 </a:t>
-            </a:r>
-            <a:r>
-              <a:rPr lang="en-US" b="1" dirty="0" err="1"/>
-              <a:t>μs</a:t>
-            </a:r>
-            <a:r>
-              <a:rPr lang="en-US" dirty="0"/>
-              <a:t>), then fluctuates at higher sizes due to GPU resource contention. Despite this, V2 consistently outperforms V1, whose best time was </a:t>
+              <a:t>increases consistently</a:t>
+            </a:r>
+            <a:r>
+              <a:rPr lang="en-US" dirty="0"/>
+              <a:t> as the number of kernel launches grows, due to overhead from setup, scheduling, and synchronization. While chunking can sometimes improve GPU occupancy, here the </a:t>
             </a:r>
             <a:r>
               <a:rPr lang="en-US" b="1" dirty="0"/>
-              <a:t>5534 </a:t>
-            </a:r>
-            <a:r>
-              <a:rPr lang="en-US" b="1" dirty="0" err="1"/>
-              <a:t>μs</a:t>
-            </a:r>
-            <a:r>
-              <a:rPr lang="en-US" dirty="0"/>
-              <a:t>, showing the benefit of the new intersection strategy.</a:t>
-            </a:r>
-          </a:p>
-          <a:p>
-            <a:endParaRPr lang="it-IT" dirty="0"/>
+              <a:t>launch overhead dominates</a:t>
+            </a:r>
+            <a:r>
+              <a:rPr lang="en-US" dirty="0"/>
+              <a:t>, negating potential benefits. Different </a:t>
+            </a:r>
+            <a:r>
+              <a:rPr lang="en-US" b="1" dirty="0"/>
+              <a:t>BLOCK_SIZE</a:t>
+            </a:r>
+            <a:r>
+              <a:rPr lang="en-US" dirty="0"/>
+              <a:t> values exhibit similar trends, though </a:t>
+            </a:r>
+            <a:r>
+              <a:rPr lang="en-US" b="1" dirty="0"/>
+              <a:t>BLOCK_SIZE = 16</a:t>
+            </a:r>
+            <a:r>
+              <a:rPr lang="en-US" dirty="0"/>
+              <a:t> and </a:t>
+            </a:r>
+            <a:r>
+              <a:rPr lang="en-US" b="1" dirty="0"/>
+              <a:t>32</a:t>
+            </a:r>
+            <a:r>
+              <a:rPr lang="en-US" dirty="0"/>
+              <a:t> show slightly better performance at lower launch counts.</a:t>
+            </a:r>
+          </a:p>
+          <a:p>
+            <a:endParaRPr lang="en-US" dirty="0"/>
           </a:p>
         </p:txBody>
       </p:sp>
@@ -6734,7 +7152,7 @@
           <p:cNvPr id="4" name="Picture 3">
             <a:extLst>
               <a:ext uri="{FF2B5EF4-FFF2-40B4-BE49-F238E27FC236}">
-                <a16:creationId xmlns:a16="http://schemas.microsoft.com/office/drawing/2014/main" id="{57A3E4A9-64C2-4937-B870-6D8BBB1D9DE2}"/>
+                <a16:creationId xmlns:a16="http://schemas.microsoft.com/office/drawing/2014/main" id="{9A59FA78-B03A-4CA7-B577-2ABC83606275}"/>
               </a:ext>
             </a:extLst>
           </p:cNvPr>
@@ -6751,8 +7169,8 @@
         </p:blipFill>
         <p:spPr>
           <a:xfrm>
-            <a:off x="184387" y="1492536"/>
-            <a:ext cx="4859561" cy="3099237"/>
+            <a:off x="185030" y="1580262"/>
+            <a:ext cx="4664240" cy="2891449"/>
           </a:xfrm>
           <a:prstGeom prst="rect">
             <a:avLst/>
@@ -6762,7 +7180,7 @@
     </p:spTree>
     <p:extLst>
       <p:ext uri="{BB962C8B-B14F-4D97-AF65-F5344CB8AC3E}">
-        <p14:creationId xmlns:p14="http://schemas.microsoft.com/office/powerpoint/2010/main" val="2301302843"/>
+        <p14:creationId xmlns:p14="http://schemas.microsoft.com/office/powerpoint/2010/main" val="544973999"/>
       </p:ext>
     </p:extLst>
   </p:cSld>
@@ -6794,7 +7212,7 @@
           <p:cNvPr id="2" name="Title 1">
             <a:extLst>
               <a:ext uri="{FF2B5EF4-FFF2-40B4-BE49-F238E27FC236}">
-                <a16:creationId xmlns:a16="http://schemas.microsoft.com/office/drawing/2014/main" id="{DB1384A2-6BB9-4BB9-96E5-54AF290803E1}"/>
+                <a16:creationId xmlns:a16="http://schemas.microsoft.com/office/drawing/2014/main" id="{4EFDE9B1-0271-46CE-B282-36987546B4BC}"/>
               </a:ext>
             </a:extLst>
           </p:cNvPr>
@@ -6807,8 +7225,8 @@
         </p:nvSpPr>
         <p:spPr>
           <a:xfrm>
-            <a:off x="5014452" y="286603"/>
-            <a:ext cx="6141228" cy="1450757"/>
+            <a:off x="5043948" y="286603"/>
+            <a:ext cx="6111732" cy="1450757"/>
           </a:xfrm>
         </p:spPr>
         <p:txBody>
@@ -6817,7 +7235,7 @@
           <a:p>
             <a:r>
               <a:rPr lang="en-US" dirty="0"/>
-              <a:t>CUDA Parallel Forward Edge Iterator V2_1</a:t>
+              <a:t>CUDA Parallel Forward Edge Iterator V2</a:t>
             </a:r>
             <a:endParaRPr lang="it-IT" dirty="0"/>
           </a:p>
@@ -6828,7 +7246,7 @@
           <p:cNvPr id="3" name="Content Placeholder 2">
             <a:extLst>
               <a:ext uri="{FF2B5EF4-FFF2-40B4-BE49-F238E27FC236}">
-                <a16:creationId xmlns:a16="http://schemas.microsoft.com/office/drawing/2014/main" id="{63ED9ADA-ED18-4450-8BA1-2287E59E3E77}"/>
+                <a16:creationId xmlns:a16="http://schemas.microsoft.com/office/drawing/2014/main" id="{100EA725-890B-4ED8-9437-261DD2F6C130}"/>
               </a:ext>
             </a:extLst>
           </p:cNvPr>
@@ -6841,73 +7259,55 @@
         </p:nvSpPr>
         <p:spPr>
           <a:xfrm>
-            <a:off x="4914162" y="1845734"/>
-            <a:ext cx="6241517" cy="4023360"/>
-          </a:xfrm>
-        </p:spPr>
-        <p:txBody>
-          <a:bodyPr>
-            <a:normAutofit fontScale="92500" lnSpcReduction="10000"/>
-          </a:bodyPr>
+            <a:off x="5043948" y="1845734"/>
+            <a:ext cx="6111732" cy="4023360"/>
+          </a:xfrm>
+        </p:spPr>
+        <p:txBody>
+          <a:bodyPr/>
           <a:lstStyle/>
           <a:p>
             <a:r>
               <a:rPr lang="en-US" dirty="0"/>
-              <a:t>The </a:t>
+              <a:t>Unlike V1, the </a:t>
             </a:r>
             <a:r>
               <a:rPr lang="en-US" b="1" dirty="0"/>
-              <a:t>V2_1 CUDA Edge Iterator</a:t>
-            </a:r>
-            <a:r>
-              <a:rPr lang="en-US" dirty="0"/>
-              <a:t> extends V2 by adding a </a:t>
+              <a:t>V2 CUDA Edge Iterator</a:t>
+            </a:r>
+            <a:r>
+              <a:rPr lang="en-US" dirty="0"/>
+              <a:t> uses a </a:t>
             </a:r>
             <a:r>
               <a:rPr lang="en-US" b="1" dirty="0"/>
-              <a:t>shared memory optimization</a:t>
-            </a:r>
-            <a:r>
-              <a:rPr lang="en-US" dirty="0"/>
-              <a:t>. Instead of one thread per edge, </a:t>
+              <a:t>two-pointer merge-like algorithm</a:t>
+            </a:r>
+            <a:r>
+              <a:rPr lang="en-US" dirty="0"/>
+              <a:t> for neighbor intersection with linear complexity (d(u) + d(v)). Each thread still processes one edge, and all edges are handled in a </a:t>
             </a:r>
             <a:r>
               <a:rPr lang="en-US" b="1" dirty="0"/>
-              <a:t>each block manages a single edge</a:t>
-            </a:r>
-            <a:r>
-              <a:rPr lang="en-US" dirty="0"/>
-              <a:t>. Threads cooperatively load the adjacency lists of the edge’s endpoints into </a:t>
+              <a:t>single kernel launch</a:t>
+            </a:r>
+            <a:r>
+              <a:rPr lang="en-US" dirty="0"/>
+              <a:t>, which greatly improves efficiency, especially for high-degree nodes.</a:t>
+            </a:r>
+          </a:p>
+          <a:p>
+            <a:r>
+              <a:rPr lang="en-US" dirty="0"/>
+              <a:t>On a </a:t>
             </a:r>
             <a:r>
               <a:rPr lang="en-US" b="1" dirty="0"/>
-              <a:t>shared memory</a:t>
-            </a:r>
-            <a:r>
-              <a:rPr lang="en-US" dirty="0"/>
-              <a:t>, synchronize, and then a single thread performs the </a:t>
-            </a:r>
-            <a:r>
-              <a:rPr lang="en-US" b="1" dirty="0"/>
-              <a:t>two-pointer merge-like intersection</a:t>
-            </a:r>
-            <a:r>
-              <a:rPr lang="en-US" dirty="0"/>
-              <a:t> on this faster local data. This reduces global memory latency when neighbor lists fit in shared memory.</a:t>
-            </a:r>
-          </a:p>
-          <a:p>
-            <a:r>
-              <a:rPr lang="en-US" dirty="0"/>
-              <a:t>The graph shows performance as a function of </a:t>
-            </a:r>
-            <a:r>
-              <a:rPr lang="en-US" b="1" dirty="0"/>
-              <a:t>Max Shared List Per Edge Combined</a:t>
-            </a:r>
-            <a:r>
-              <a:rPr lang="en-US" dirty="0"/>
-              <a:t> for different </a:t>
+              <a:t>100M-node graph</a:t>
+            </a:r>
+            <a:r>
+              <a:rPr lang="en-US" dirty="0"/>
+              <a:t>, performance improves sharply as </a:t>
             </a:r>
             <a:r>
               <a:rPr lang="en-US" b="1" dirty="0"/>
@@ -6915,15 +7315,31 @@
             </a:r>
             <a:r>
               <a:rPr lang="en-US" dirty="0"/>
-              <a:t> values. Increasing this limit generally increases execution time, since reserving more shared memory per block reduces occupancy and parallelism. Smaller </a:t>
+              <a:t> increases from 8 to 32 (best time: </a:t>
             </a:r>
             <a:r>
               <a:rPr lang="en-US" b="1" dirty="0"/>
-              <a:t>BLOCK_SIZE</a:t>
-            </a:r>
-            <a:r>
-              <a:rPr lang="en-US" dirty="0"/>
-              <a:t> values (8, 16) achieve better performance at lower thresholds, while larger sizes (256, 512) suffer sharp slowdowns from resource constraints.</a:t>
+              <a:t>3441 </a:t>
+            </a:r>
+            <a:r>
+              <a:rPr lang="en-US" b="1" dirty="0" err="1"/>
+              <a:t>μs</a:t>
+            </a:r>
+            <a:r>
+              <a:rPr lang="en-US" dirty="0"/>
+              <a:t>), then fluctuates at higher sizes due to GPU resource contention. Despite this, V2 consistently outperforms V1, whose best time was </a:t>
+            </a:r>
+            <a:r>
+              <a:rPr lang="en-US" b="1" dirty="0"/>
+              <a:t>5534 </a:t>
+            </a:r>
+            <a:r>
+              <a:rPr lang="en-US" b="1" dirty="0" err="1"/>
+              <a:t>μs</a:t>
+            </a:r>
+            <a:r>
+              <a:rPr lang="en-US" dirty="0"/>
+              <a:t>, showing the benefit of the new intersection strategy.</a:t>
             </a:r>
           </a:p>
           <a:p>
@@ -6936,7 +7352,7 @@
           <p:cNvPr id="4" name="Picture 3">
             <a:extLst>
               <a:ext uri="{FF2B5EF4-FFF2-40B4-BE49-F238E27FC236}">
-                <a16:creationId xmlns:a16="http://schemas.microsoft.com/office/drawing/2014/main" id="{06B0E4D5-7D7C-4FEB-97F7-0EAF0DDA8C06}"/>
+                <a16:creationId xmlns:a16="http://schemas.microsoft.com/office/drawing/2014/main" id="{57A3E4A9-64C2-4937-B870-6D8BBB1D9DE2}"/>
               </a:ext>
             </a:extLst>
           </p:cNvPr>
@@ -6953,8 +7369,8 @@
         </p:blipFill>
         <p:spPr>
           <a:xfrm>
-            <a:off x="7403" y="1589935"/>
-            <a:ext cx="4906759" cy="3002493"/>
+            <a:off x="184387" y="1492536"/>
+            <a:ext cx="4859561" cy="3099237"/>
           </a:xfrm>
           <a:prstGeom prst="rect">
             <a:avLst/>
@@ -6964,7 +7380,7 @@
     </p:spTree>
     <p:extLst>
       <p:ext uri="{BB962C8B-B14F-4D97-AF65-F5344CB8AC3E}">
-        <p14:creationId xmlns:p14="http://schemas.microsoft.com/office/powerpoint/2010/main" val="3401121369"/>
+        <p14:creationId xmlns:p14="http://schemas.microsoft.com/office/powerpoint/2010/main" val="2301302843"/>
       </p:ext>
     </p:extLst>
   </p:cSld>
@@ -6996,7 +7412,7 @@
           <p:cNvPr id="2" name="Title 1">
             <a:extLst>
               <a:ext uri="{FF2B5EF4-FFF2-40B4-BE49-F238E27FC236}">
-                <a16:creationId xmlns:a16="http://schemas.microsoft.com/office/drawing/2014/main" id="{DF4A7642-9F59-4268-AF08-990F77A20AF9}"/>
+                <a16:creationId xmlns:a16="http://schemas.microsoft.com/office/drawing/2014/main" id="{DB1384A2-6BB9-4BB9-96E5-54AF290803E1}"/>
               </a:ext>
             </a:extLst>
           </p:cNvPr>
@@ -7009,8 +7425,8 @@
         </p:nvSpPr>
         <p:spPr>
           <a:xfrm>
-            <a:off x="4949559" y="286603"/>
-            <a:ext cx="6206121" cy="1450757"/>
+            <a:off x="5014452" y="286603"/>
+            <a:ext cx="6141228" cy="1450757"/>
           </a:xfrm>
         </p:spPr>
         <p:txBody>
@@ -7019,7 +7435,7 @@
           <a:p>
             <a:r>
               <a:rPr lang="en-US" dirty="0"/>
-              <a:t>CUDA Parallel Forward Edge Iterator V2_2</a:t>
+              <a:t>CUDA Parallel Forward Edge Iterator V2_1</a:t>
             </a:r>
             <a:endParaRPr lang="it-IT" dirty="0"/>
           </a:p>
@@ -7030,7 +7446,7 @@
           <p:cNvPr id="3" name="Content Placeholder 2">
             <a:extLst>
               <a:ext uri="{FF2B5EF4-FFF2-40B4-BE49-F238E27FC236}">
-                <a16:creationId xmlns:a16="http://schemas.microsoft.com/office/drawing/2014/main" id="{F30128A7-AB09-4286-859D-705813F4D2BA}"/>
+                <a16:creationId xmlns:a16="http://schemas.microsoft.com/office/drawing/2014/main" id="{63ED9ADA-ED18-4450-8BA1-2287E59E3E77}"/>
               </a:ext>
             </a:extLst>
           </p:cNvPr>
@@ -7043,13 +7459,13 @@
         </p:nvSpPr>
         <p:spPr>
           <a:xfrm>
-            <a:off x="4949559" y="1845734"/>
-            <a:ext cx="6206121" cy="4023360"/>
+            <a:off x="4914162" y="1845734"/>
+            <a:ext cx="6241517" cy="4023360"/>
           </a:xfrm>
         </p:spPr>
         <p:txBody>
           <a:bodyPr>
-            <a:normAutofit fontScale="92500" lnSpcReduction="20000"/>
+            <a:normAutofit fontScale="92500" lnSpcReduction="10000"/>
           </a:bodyPr>
           <a:lstStyle/>
           <a:p>
@@ -7059,19 +7475,27 @@
             </a:r>
             <a:r>
               <a:rPr lang="en-US" b="1" dirty="0"/>
-              <a:t>V2_2 CUDA Edge Iterator</a:t>
-            </a:r>
-            <a:r>
-              <a:rPr lang="en-US" dirty="0"/>
-              <a:t> keeps the </a:t>
+              <a:t>V2_1 CUDA Edge Iterator</a:t>
+            </a:r>
+            <a:r>
+              <a:rPr lang="en-US" dirty="0"/>
+              <a:t> extends V2 by adding a </a:t>
             </a:r>
             <a:r>
               <a:rPr lang="en-US" b="1" dirty="0"/>
-              <a:t>two-pointer merge-like algorithm</a:t>
-            </a:r>
-            <a:r>
-              <a:rPr lang="en-US" dirty="0"/>
-              <a:t> and also uses </a:t>
+              <a:t>shared memory optimization</a:t>
+            </a:r>
+            <a:r>
+              <a:rPr lang="en-US" dirty="0"/>
+              <a:t>. Instead of one thread per edge, </a:t>
+            </a:r>
+            <a:r>
+              <a:rPr lang="en-US" b="1" dirty="0"/>
+              <a:t>each block manages a single edge</a:t>
+            </a:r>
+            <a:r>
+              <a:rPr lang="en-US" dirty="0"/>
+              <a:t>. Threads cooperatively load the adjacency lists of the edge’s endpoints into </a:t>
             </a:r>
             <a:r>
               <a:rPr lang="en-US" b="1" dirty="0"/>
@@ -7079,29 +7503,21 @@
             </a:r>
             <a:r>
               <a:rPr lang="en-US" dirty="0"/>
-              <a:t>, but with a different mapping than V2_1. Here, </a:t>
+              <a:t>, synchronize, and then a single thread performs the </a:t>
             </a:r>
             <a:r>
               <a:rPr lang="en-US" b="1" dirty="0"/>
-              <a:t>one thread manages one edge</a:t>
-            </a:r>
-            <a:r>
-              <a:rPr lang="en-US" dirty="0"/>
-              <a:t> (like V2), but each thread tries to load its edge’s adjacency lists into a </a:t>
-            </a:r>
-            <a:r>
-              <a:rPr lang="en-US" b="1" dirty="0"/>
-              <a:t>dynamically allocated portion of shared memory</a:t>
-            </a:r>
-            <a:r>
-              <a:rPr lang="en-US" dirty="0"/>
-              <a:t> before performing the intersection. This allows multiple edges to be processed in parallel within a block, each gaining faster access if their lists fit in memory.</a:t>
-            </a:r>
-          </a:p>
-          <a:p>
-            <a:r>
-              <a:rPr lang="en-US" dirty="0"/>
-              <a:t>The performance graph shows total execution time versus </a:t>
+              <a:t>two-pointer merge-like intersection</a:t>
+            </a:r>
+            <a:r>
+              <a:rPr lang="en-US" dirty="0"/>
+              <a:t> on this faster local data. This reduces global memory latency when neighbor lists fit in shared memory.</a:t>
+            </a:r>
+          </a:p>
+          <a:p>
+            <a:r>
+              <a:rPr lang="en-US" dirty="0"/>
+              <a:t>The graph shows performance as a function of </a:t>
             </a:r>
             <a:r>
               <a:rPr lang="en-US" b="1" dirty="0"/>
@@ -7117,23 +7533,15 @@
             </a:r>
             <a:r>
               <a:rPr lang="en-US" dirty="0"/>
-              <a:t> values. Smaller block sizes (8, 16, 32) achieve lower durations and are less sensitive at low thresholds, while larger block sizes slow down more as memory usage grows. Excessive shared memory per thread reduces concurrency and occupancy, limiting performance. The best results come from </a:t>
+              <a:t> values. Increasing this limit generally increases execution time, since reserving more shared memory per block reduces occupancy and parallelism. Smaller </a:t>
             </a:r>
             <a:r>
               <a:rPr lang="en-US" b="1" dirty="0"/>
-              <a:t>small BLOCK_SIZE values</a:t>
-            </a:r>
-            <a:r>
-              <a:rPr lang="en-US" dirty="0"/>
-              <a:t> with </a:t>
-            </a:r>
-            <a:r>
-              <a:rPr lang="en-US" b="1" dirty="0"/>
-              <a:t>low shared memory thresholds</a:t>
-            </a:r>
-            <a:r>
-              <a:rPr lang="en-US" dirty="0"/>
-              <a:t>, where faster memory access is balanced against GPU resource constraints.</a:t>
+              <a:t>BLOCK_SIZE</a:t>
+            </a:r>
+            <a:r>
+              <a:rPr lang="en-US" dirty="0"/>
+              <a:t> values (8, 16) achieve better performance at lower thresholds, while larger sizes (256, 512) suffer sharp slowdowns from resource constraints.</a:t>
             </a:r>
           </a:p>
           <a:p>
@@ -7146,7 +7554,7 @@
           <p:cNvPr id="4" name="Picture 3">
             <a:extLst>
               <a:ext uri="{FF2B5EF4-FFF2-40B4-BE49-F238E27FC236}">
-                <a16:creationId xmlns:a16="http://schemas.microsoft.com/office/drawing/2014/main" id="{604A612A-6E22-4E05-B287-B93E210C97EA}"/>
+                <a16:creationId xmlns:a16="http://schemas.microsoft.com/office/drawing/2014/main" id="{06B0E4D5-7D7C-4FEB-97F7-0EAF0DDA8C06}"/>
               </a:ext>
             </a:extLst>
           </p:cNvPr>
@@ -7163,8 +7571,8 @@
         </p:blipFill>
         <p:spPr>
           <a:xfrm>
-            <a:off x="247126" y="1672467"/>
-            <a:ext cx="4702433" cy="2862759"/>
+            <a:off x="7403" y="1589935"/>
+            <a:ext cx="4906759" cy="3002493"/>
           </a:xfrm>
           <a:prstGeom prst="rect">
             <a:avLst/>
@@ -7174,7 +7582,7 @@
     </p:spTree>
     <p:extLst>
       <p:ext uri="{BB962C8B-B14F-4D97-AF65-F5344CB8AC3E}">
-        <p14:creationId xmlns:p14="http://schemas.microsoft.com/office/powerpoint/2010/main" val="448385802"/>
+        <p14:creationId xmlns:p14="http://schemas.microsoft.com/office/powerpoint/2010/main" val="3401121369"/>
       </p:ext>
     </p:extLst>
   </p:cSld>
@@ -7389,6 +7797,216 @@
           <p:cNvPr id="2" name="Title 1">
             <a:extLst>
               <a:ext uri="{FF2B5EF4-FFF2-40B4-BE49-F238E27FC236}">
+                <a16:creationId xmlns:a16="http://schemas.microsoft.com/office/drawing/2014/main" id="{DF4A7642-9F59-4268-AF08-990F77A20AF9}"/>
+              </a:ext>
+            </a:extLst>
+          </p:cNvPr>
+          <p:cNvSpPr>
+            <a:spLocks noGrp="1"/>
+          </p:cNvSpPr>
+          <p:nvPr>
+            <p:ph type="title"/>
+          </p:nvPr>
+        </p:nvSpPr>
+        <p:spPr>
+          <a:xfrm>
+            <a:off x="4949559" y="286603"/>
+            <a:ext cx="6206121" cy="1450757"/>
+          </a:xfrm>
+        </p:spPr>
+        <p:txBody>
+          <a:bodyPr/>
+          <a:lstStyle/>
+          <a:p>
+            <a:r>
+              <a:rPr lang="en-US" dirty="0"/>
+              <a:t>CUDA Parallel Forward Edge Iterator V2_2</a:t>
+            </a:r>
+            <a:endParaRPr lang="it-IT" dirty="0"/>
+          </a:p>
+        </p:txBody>
+      </p:sp>
+      <p:sp>
+        <p:nvSpPr>
+          <p:cNvPr id="3" name="Content Placeholder 2">
+            <a:extLst>
+              <a:ext uri="{FF2B5EF4-FFF2-40B4-BE49-F238E27FC236}">
+                <a16:creationId xmlns:a16="http://schemas.microsoft.com/office/drawing/2014/main" id="{F30128A7-AB09-4286-859D-705813F4D2BA}"/>
+              </a:ext>
+            </a:extLst>
+          </p:cNvPr>
+          <p:cNvSpPr>
+            <a:spLocks noGrp="1"/>
+          </p:cNvSpPr>
+          <p:nvPr>
+            <p:ph idx="1"/>
+          </p:nvPr>
+        </p:nvSpPr>
+        <p:spPr>
+          <a:xfrm>
+            <a:off x="4949559" y="1845734"/>
+            <a:ext cx="6206121" cy="4023360"/>
+          </a:xfrm>
+        </p:spPr>
+        <p:txBody>
+          <a:bodyPr>
+            <a:normAutofit fontScale="92500" lnSpcReduction="20000"/>
+          </a:bodyPr>
+          <a:lstStyle/>
+          <a:p>
+            <a:r>
+              <a:rPr lang="en-US" dirty="0"/>
+              <a:t>The </a:t>
+            </a:r>
+            <a:r>
+              <a:rPr lang="en-US" b="1" dirty="0"/>
+              <a:t>V2_2 CUDA Edge Iterator</a:t>
+            </a:r>
+            <a:r>
+              <a:rPr lang="en-US" dirty="0"/>
+              <a:t> keeps the </a:t>
+            </a:r>
+            <a:r>
+              <a:rPr lang="en-US" b="1" dirty="0"/>
+              <a:t>two-pointer merge-like algorithm</a:t>
+            </a:r>
+            <a:r>
+              <a:rPr lang="en-US" dirty="0"/>
+              <a:t> and also uses </a:t>
+            </a:r>
+            <a:r>
+              <a:rPr lang="en-US" b="1" dirty="0"/>
+              <a:t>shared memory</a:t>
+            </a:r>
+            <a:r>
+              <a:rPr lang="en-US" dirty="0"/>
+              <a:t>, but with a different mapping than V2_1. Here, </a:t>
+            </a:r>
+            <a:r>
+              <a:rPr lang="en-US" b="1" dirty="0"/>
+              <a:t>one thread manages one edge</a:t>
+            </a:r>
+            <a:r>
+              <a:rPr lang="en-US" dirty="0"/>
+              <a:t> (like V2), but each thread tries to load its edge’s adjacency lists into a </a:t>
+            </a:r>
+            <a:r>
+              <a:rPr lang="en-US" b="1" dirty="0"/>
+              <a:t>dynamically allocated portion of shared memory</a:t>
+            </a:r>
+            <a:r>
+              <a:rPr lang="en-US" dirty="0"/>
+              <a:t> before performing the intersection. This allows multiple edges to be processed in parallel within a block, each gaining faster access if their lists fit in memory.</a:t>
+            </a:r>
+          </a:p>
+          <a:p>
+            <a:r>
+              <a:rPr lang="en-US" dirty="0"/>
+              <a:t>The performance graph shows total execution time versus </a:t>
+            </a:r>
+            <a:r>
+              <a:rPr lang="en-US" b="1" dirty="0"/>
+              <a:t>Max Shared List Per Edge Combined</a:t>
+            </a:r>
+            <a:r>
+              <a:rPr lang="en-US" dirty="0"/>
+              <a:t> for different </a:t>
+            </a:r>
+            <a:r>
+              <a:rPr lang="en-US" b="1" dirty="0"/>
+              <a:t>BLOCK_SIZE</a:t>
+            </a:r>
+            <a:r>
+              <a:rPr lang="en-US" dirty="0"/>
+              <a:t> values. Smaller block sizes (8, 16, 32) achieve lower durations and are less sensitive at low thresholds, while larger block sizes slow down more as memory usage grows. Excessive shared memory per thread reduces concurrency and occupancy, limiting performance. The best results come from </a:t>
+            </a:r>
+            <a:r>
+              <a:rPr lang="en-US" b="1" dirty="0"/>
+              <a:t>small BLOCK_SIZE values</a:t>
+            </a:r>
+            <a:r>
+              <a:rPr lang="en-US" dirty="0"/>
+              <a:t> with </a:t>
+            </a:r>
+            <a:r>
+              <a:rPr lang="en-US" b="1" dirty="0"/>
+              <a:t>low shared memory thresholds</a:t>
+            </a:r>
+            <a:r>
+              <a:rPr lang="en-US" dirty="0"/>
+              <a:t>, where faster memory access is balanced against GPU resource constraints.</a:t>
+            </a:r>
+          </a:p>
+          <a:p>
+            <a:endParaRPr lang="it-IT" dirty="0"/>
+          </a:p>
+        </p:txBody>
+      </p:sp>
+      <p:pic>
+        <p:nvPicPr>
+          <p:cNvPr id="4" name="Picture 3">
+            <a:extLst>
+              <a:ext uri="{FF2B5EF4-FFF2-40B4-BE49-F238E27FC236}">
+                <a16:creationId xmlns:a16="http://schemas.microsoft.com/office/drawing/2014/main" id="{604A612A-6E22-4E05-B287-B93E210C97EA}"/>
+              </a:ext>
+            </a:extLst>
+          </p:cNvPr>
+          <p:cNvPicPr>
+            <a:picLocks noChangeAspect="1"/>
+          </p:cNvPicPr>
+          <p:nvPr/>
+        </p:nvPicPr>
+        <p:blipFill>
+          <a:blip r:embed="rId2"/>
+          <a:stretch>
+            <a:fillRect/>
+          </a:stretch>
+        </p:blipFill>
+        <p:spPr>
+          <a:xfrm>
+            <a:off x="247126" y="1672467"/>
+            <a:ext cx="4702433" cy="2862759"/>
+          </a:xfrm>
+          <a:prstGeom prst="rect">
+            <a:avLst/>
+          </a:prstGeom>
+        </p:spPr>
+      </p:pic>
+    </p:spTree>
+    <p:extLst>
+      <p:ext uri="{BB962C8B-B14F-4D97-AF65-F5344CB8AC3E}">
+        <p14:creationId xmlns:p14="http://schemas.microsoft.com/office/powerpoint/2010/main" val="448385802"/>
+      </p:ext>
+    </p:extLst>
+  </p:cSld>
+  <p:clrMapOvr>
+    <a:masterClrMapping/>
+  </p:clrMapOvr>
+</p:sld>
+</file>
+
+<file path=ppt/slides/slide21.xml><?xml version="1.0" encoding="utf-8"?>
+<p:sld xmlns:a="http://schemas.openxmlformats.org/drawingml/2006/main" xmlns:r="http://schemas.openxmlformats.org/officeDocument/2006/relationships" xmlns:p="http://schemas.openxmlformats.org/presentationml/2006/main">
+  <p:cSld>
+    <p:spTree>
+      <p:nvGrpSpPr>
+        <p:cNvPr id="1" name=""/>
+        <p:cNvGrpSpPr/>
+        <p:nvPr/>
+      </p:nvGrpSpPr>
+      <p:grpSpPr>
+        <a:xfrm>
+          <a:off x="0" y="0"/>
+          <a:ext cx="0" cy="0"/>
+          <a:chOff x="0" y="0"/>
+          <a:chExt cx="0" cy="0"/>
+        </a:xfrm>
+      </p:grpSpPr>
+      <p:sp>
+        <p:nvSpPr>
+          <p:cNvPr id="2" name="Title 1">
+            <a:extLst>
+              <a:ext uri="{FF2B5EF4-FFF2-40B4-BE49-F238E27FC236}">
                 <a16:creationId xmlns:a16="http://schemas.microsoft.com/office/drawing/2014/main" id="{6C6BF2FE-CE66-4CEA-BB81-604B68FFD6A7}"/>
               </a:ext>
             </a:extLst>
@@ -7647,7 +8265,7 @@
 </p:sld>
 </file>
 
-<file path=ppt/slides/slide21.xml><?xml version="1.0" encoding="utf-8"?>
+<file path=ppt/slides/slide22.xml><?xml version="1.0" encoding="utf-8"?>
 <p:sld xmlns:a="http://schemas.openxmlformats.org/drawingml/2006/main" xmlns:r="http://schemas.openxmlformats.org/officeDocument/2006/relationships" xmlns:p="http://schemas.openxmlformats.org/presentationml/2006/main">
   <p:cSld>
     <p:spTree>
@@ -8151,7 +8769,7 @@
 </p:sld>
 </file>
 
-<file path=ppt/slides/slide22.xml><?xml version="1.0" encoding="utf-8"?>
+<file path=ppt/slides/slide23.xml><?xml version="1.0" encoding="utf-8"?>
 <p:sld xmlns:a="http://schemas.openxmlformats.org/drawingml/2006/main" xmlns:r="http://schemas.openxmlformats.org/officeDocument/2006/relationships" xmlns:p="http://schemas.openxmlformats.org/presentationml/2006/main">
   <p:cSld>
     <p:spTree>
@@ -8574,7 +9192,7 @@
 </p:sld>
 </file>
 
-<file path=ppt/slides/slide23.xml><?xml version="1.0" encoding="utf-8"?>
+<file path=ppt/slides/slide24.xml><?xml version="1.0" encoding="utf-8"?>
 <p:sld xmlns:a="http://schemas.openxmlformats.org/drawingml/2006/main" xmlns:r="http://schemas.openxmlformats.org/officeDocument/2006/relationships" xmlns:p="http://schemas.openxmlformats.org/presentationml/2006/main">
   <p:cSld>
     <p:spTree>
@@ -8885,7 +9503,7 @@
 </p:sld>
 </file>
 
-<file path=ppt/slides/slide24.xml><?xml version="1.0" encoding="utf-8"?>
+<file path=ppt/slides/slide25.xml><?xml version="1.0" encoding="utf-8"?>
 <p:sld xmlns:a="http://schemas.openxmlformats.org/drawingml/2006/main" xmlns:r="http://schemas.openxmlformats.org/officeDocument/2006/relationships" xmlns:p="http://schemas.openxmlformats.org/presentationml/2006/main">
   <p:cSld>
     <p:spTree>

</xml_diff>

<commit_message>
feat: new comparison charts for cuda v3 vs sequential, edge iterator
</commit_message>
<xml_diff>
--- a/presentation.pptx
+++ b/presentation.pptx
@@ -26,10 +26,11 @@
     <p:sldId id="271" r:id="rId20"/>
     <p:sldId id="272" r:id="rId21"/>
     <p:sldId id="273" r:id="rId22"/>
-    <p:sldId id="274" r:id="rId23"/>
-    <p:sldId id="275" r:id="rId24"/>
-    <p:sldId id="276" r:id="rId25"/>
-    <p:sldId id="277" r:id="rId26"/>
+    <p:sldId id="281" r:id="rId23"/>
+    <p:sldId id="274" r:id="rId24"/>
+    <p:sldId id="275" r:id="rId25"/>
+    <p:sldId id="276" r:id="rId26"/>
+    <p:sldId id="277" r:id="rId27"/>
   </p:sldIdLst>
   <p:sldSz cx="12192000" cy="6858000"/>
   <p:notesSz cx="6858000" cy="9144000"/>
@@ -6444,7 +6445,7 @@
           <a:lstStyle/>
           <a:p>
             <a:r>
-              <a:rPr lang="en-US" sz="3300">
+              <a:rPr lang="en-US" sz="3300" dirty="0">
                 <a:solidFill>
                   <a:schemeClr val="tx1">
                     <a:lumMod val="85000"/>
@@ -8266,6 +8267,625 @@
 </file>
 
 <file path=ppt/slides/slide22.xml><?xml version="1.0" encoding="utf-8"?>
+<p:sld xmlns:a="http://schemas.openxmlformats.org/drawingml/2006/main" xmlns:r="http://schemas.openxmlformats.org/officeDocument/2006/relationships" xmlns:p="http://schemas.openxmlformats.org/presentationml/2006/main">
+  <p:cSld>
+    <p:bg>
+      <p:bgPr>
+        <a:solidFill>
+          <a:schemeClr val="bg1"/>
+        </a:solidFill>
+        <a:effectLst/>
+      </p:bgPr>
+    </p:bg>
+    <p:spTree>
+      <p:nvGrpSpPr>
+        <p:cNvPr id="1" name=""/>
+        <p:cNvGrpSpPr/>
+        <p:nvPr/>
+      </p:nvGrpSpPr>
+      <p:grpSpPr>
+        <a:xfrm>
+          <a:off x="0" y="0"/>
+          <a:ext cx="0" cy="0"/>
+          <a:chOff x="0" y="0"/>
+          <a:chExt cx="0" cy="0"/>
+        </a:xfrm>
+      </p:grpSpPr>
+      <p:sp>
+        <p:nvSpPr>
+          <p:cNvPr id="27" name="Rectangle 26">
+            <a:extLst>
+              <a:ext uri="{FF2B5EF4-FFF2-40B4-BE49-F238E27FC236}">
+                <a16:creationId xmlns:a16="http://schemas.microsoft.com/office/drawing/2014/main" id="{BB2B8762-61F0-4F1B-9364-D633EE9D6AF5}"/>
+              </a:ext>
+              <a:ext uri="{C183D7F6-B498-43B3-948B-1728B52AA6E4}">
+                <adec:decorative xmlns:adec="http://schemas.microsoft.com/office/drawing/2017/decorative" val="1"/>
+              </a:ext>
+            </a:extLst>
+          </p:cNvPr>
+          <p:cNvSpPr>
+            <a:spLocks noGrp="1" noRot="1" noChangeAspect="1" noMove="1" noResize="1" noEditPoints="1" noAdjustHandles="1" noChangeArrowheads="1" noChangeShapeType="1" noTextEdit="1"/>
+          </p:cNvSpPr>
+          <p:nvPr>
+            <p:extLst>
+              <p:ext uri="{386F3935-93C4-4BCD-93E2-E3B085C9AB24}">
+                <p16:designElem xmlns:p16="http://schemas.microsoft.com/office/powerpoint/2015/main" val="1"/>
+              </p:ext>
+            </p:extLst>
+          </p:nvPr>
+        </p:nvSpPr>
+        <p:spPr>
+          <a:xfrm>
+            <a:off x="3175" y="6400800"/>
+            <a:ext cx="12188825" cy="457200"/>
+          </a:xfrm>
+          <a:prstGeom prst="rect">
+            <a:avLst/>
+          </a:prstGeom>
+          <a:solidFill>
+            <a:schemeClr val="accent2"/>
+          </a:solidFill>
+          <a:ln>
+            <a:noFill/>
+          </a:ln>
+        </p:spPr>
+        <p:style>
+          <a:lnRef idx="2">
+            <a:schemeClr val="accent1">
+              <a:shade val="50000"/>
+            </a:schemeClr>
+          </a:lnRef>
+          <a:fillRef idx="1">
+            <a:schemeClr val="accent1"/>
+          </a:fillRef>
+          <a:effectRef idx="0">
+            <a:schemeClr val="accent1"/>
+          </a:effectRef>
+          <a:fontRef idx="minor">
+            <a:schemeClr val="lt1"/>
+          </a:fontRef>
+        </p:style>
+        <p:txBody>
+          <a:bodyPr/>
+          <a:lstStyle/>
+          <a:p>
+            <a:endParaRPr lang="it-IT"/>
+          </a:p>
+        </p:txBody>
+      </p:sp>
+      <p:sp>
+        <p:nvSpPr>
+          <p:cNvPr id="29" name="Rectangle 28">
+            <a:extLst>
+              <a:ext uri="{FF2B5EF4-FFF2-40B4-BE49-F238E27FC236}">
+                <a16:creationId xmlns:a16="http://schemas.microsoft.com/office/drawing/2014/main" id="{E97675C8-1328-460C-9EBF-6B446B67EAD3}"/>
+              </a:ext>
+              <a:ext uri="{C183D7F6-B498-43B3-948B-1728B52AA6E4}">
+                <adec:decorative xmlns:adec="http://schemas.microsoft.com/office/drawing/2017/decorative" val="1"/>
+              </a:ext>
+            </a:extLst>
+          </p:cNvPr>
+          <p:cNvSpPr>
+            <a:spLocks noGrp="1" noRot="1" noChangeAspect="1" noMove="1" noResize="1" noEditPoints="1" noAdjustHandles="1" noChangeArrowheads="1" noChangeShapeType="1" noTextEdit="1"/>
+          </p:cNvSpPr>
+          <p:nvPr>
+            <p:extLst>
+              <p:ext uri="{386F3935-93C4-4BCD-93E2-E3B085C9AB24}">
+                <p16:designElem xmlns:p16="http://schemas.microsoft.com/office/powerpoint/2015/main" val="1"/>
+              </p:ext>
+            </p:extLst>
+          </p:nvPr>
+        </p:nvSpPr>
+        <p:spPr>
+          <a:xfrm>
+            <a:off x="15" y="6334316"/>
+            <a:ext cx="12188825" cy="64008"/>
+          </a:xfrm>
+          <a:prstGeom prst="rect">
+            <a:avLst/>
+          </a:prstGeom>
+          <a:solidFill>
+            <a:schemeClr val="accent1"/>
+          </a:solidFill>
+          <a:ln>
+            <a:noFill/>
+          </a:ln>
+        </p:spPr>
+        <p:style>
+          <a:lnRef idx="2">
+            <a:schemeClr val="accent1">
+              <a:shade val="50000"/>
+            </a:schemeClr>
+          </a:lnRef>
+          <a:fillRef idx="1">
+            <a:schemeClr val="accent1"/>
+          </a:fillRef>
+          <a:effectRef idx="0">
+            <a:schemeClr val="accent1"/>
+          </a:effectRef>
+          <a:fontRef idx="minor">
+            <a:schemeClr val="lt1"/>
+          </a:fontRef>
+        </p:style>
+        <p:txBody>
+          <a:bodyPr/>
+          <a:lstStyle/>
+          <a:p>
+            <a:endParaRPr lang="it-IT"/>
+          </a:p>
+        </p:txBody>
+      </p:sp>
+      <p:cxnSp>
+        <p:nvCxnSpPr>
+          <p:cNvPr id="31" name="Straight Connector 30">
+            <a:extLst>
+              <a:ext uri="{FF2B5EF4-FFF2-40B4-BE49-F238E27FC236}">
+                <a16:creationId xmlns:a16="http://schemas.microsoft.com/office/drawing/2014/main" id="{514EE78B-AF71-4195-A01B-F1165D9233BF}"/>
+              </a:ext>
+              <a:ext uri="{C183D7F6-B498-43B3-948B-1728B52AA6E4}">
+                <adec:decorative xmlns:adec="http://schemas.microsoft.com/office/drawing/2017/decorative" val="1"/>
+              </a:ext>
+            </a:extLst>
+          </p:cNvPr>
+          <p:cNvCxnSpPr>
+            <a:cxnSpLocks noGrp="1" noRot="1" noChangeAspect="1" noMove="1" noResize="1" noEditPoints="1" noAdjustHandles="1" noChangeArrowheads="1" noChangeShapeType="1"/>
+          </p:cNvCxnSpPr>
+          <p:nvPr>
+            <p:extLst>
+              <p:ext uri="{386F3935-93C4-4BCD-93E2-E3B085C9AB24}">
+                <p16:designElem xmlns:p16="http://schemas.microsoft.com/office/powerpoint/2015/main" val="1"/>
+              </p:ext>
+            </p:extLst>
+          </p:nvPr>
+        </p:nvCxnSpPr>
+        <p:spPr>
+          <a:xfrm>
+            <a:off x="1207658" y="4343400"/>
+            <a:ext cx="9875520" cy="0"/>
+          </a:xfrm>
+          <a:prstGeom prst="line">
+            <a:avLst/>
+          </a:prstGeom>
+          <a:ln w="6350">
+            <a:solidFill>
+              <a:schemeClr val="tx1">
+                <a:lumMod val="50000"/>
+                <a:lumOff val="50000"/>
+              </a:schemeClr>
+            </a:solidFill>
+          </a:ln>
+        </p:spPr>
+        <p:style>
+          <a:lnRef idx="1">
+            <a:schemeClr val="accent1"/>
+          </a:lnRef>
+          <a:fillRef idx="0">
+            <a:schemeClr val="accent1"/>
+          </a:fillRef>
+          <a:effectRef idx="0">
+            <a:schemeClr val="accent1"/>
+          </a:effectRef>
+          <a:fontRef idx="minor">
+            <a:schemeClr val="tx1"/>
+          </a:fontRef>
+        </p:style>
+      </p:cxnSp>
+      <p:sp useBgFill="1">
+        <p:nvSpPr>
+          <p:cNvPr id="33" name="Rectangle 32">
+            <a:extLst>
+              <a:ext uri="{FF2B5EF4-FFF2-40B4-BE49-F238E27FC236}">
+                <a16:creationId xmlns:a16="http://schemas.microsoft.com/office/drawing/2014/main" id="{C6417104-D4C1-4710-9982-2154A7F48492}"/>
+              </a:ext>
+              <a:ext uri="{C183D7F6-B498-43B3-948B-1728B52AA6E4}">
+                <adec:decorative xmlns:adec="http://schemas.microsoft.com/office/drawing/2017/decorative" val="1"/>
+              </a:ext>
+            </a:extLst>
+          </p:cNvPr>
+          <p:cNvSpPr>
+            <a:spLocks noGrp="1" noRot="1" noChangeAspect="1" noMove="1" noResize="1" noEditPoints="1" noAdjustHandles="1" noChangeArrowheads="1" noChangeShapeType="1" noTextEdit="1"/>
+          </p:cNvSpPr>
+          <p:nvPr>
+            <p:extLst>
+              <p:ext uri="{386F3935-93C4-4BCD-93E2-E3B085C9AB24}">
+                <p16:designElem xmlns:p16="http://schemas.microsoft.com/office/powerpoint/2015/main" val="1"/>
+              </p:ext>
+            </p:extLst>
+          </p:nvPr>
+        </p:nvSpPr>
+        <p:spPr>
+          <a:xfrm>
+            <a:off x="0" y="0"/>
+            <a:ext cx="12192001" cy="6334316"/>
+          </a:xfrm>
+          <a:prstGeom prst="rect">
+            <a:avLst/>
+          </a:prstGeom>
+          <a:ln>
+            <a:noFill/>
+          </a:ln>
+        </p:spPr>
+        <p:style>
+          <a:lnRef idx="2">
+            <a:schemeClr val="accent1">
+              <a:shade val="50000"/>
+            </a:schemeClr>
+          </a:lnRef>
+          <a:fillRef idx="1">
+            <a:schemeClr val="accent1"/>
+          </a:fillRef>
+          <a:effectRef idx="0">
+            <a:schemeClr val="accent1"/>
+          </a:effectRef>
+          <a:fontRef idx="minor">
+            <a:schemeClr val="lt1"/>
+          </a:fontRef>
+        </p:style>
+        <p:txBody>
+          <a:bodyPr rtlCol="0" anchor="ctr"/>
+          <a:lstStyle/>
+          <a:p>
+            <a:pPr algn="ctr"/>
+            <a:endParaRPr lang="en-US"/>
+          </a:p>
+        </p:txBody>
+      </p:sp>
+      <p:sp>
+        <p:nvSpPr>
+          <p:cNvPr id="2" name="Title 1">
+            <a:extLst>
+              <a:ext uri="{FF2B5EF4-FFF2-40B4-BE49-F238E27FC236}">
+                <a16:creationId xmlns:a16="http://schemas.microsoft.com/office/drawing/2014/main" id="{459C90C7-3FC4-3302-10BE-14F7FE79F094}"/>
+              </a:ext>
+            </a:extLst>
+          </p:cNvPr>
+          <p:cNvSpPr>
+            <a:spLocks noGrp="1"/>
+          </p:cNvSpPr>
+          <p:nvPr>
+            <p:ph type="title"/>
+          </p:nvPr>
+        </p:nvSpPr>
+        <p:spPr>
+          <a:xfrm>
+            <a:off x="633999" y="4550229"/>
+            <a:ext cx="10909073" cy="1057655"/>
+          </a:xfrm>
+        </p:spPr>
+        <p:txBody>
+          <a:bodyPr vert="horz" lIns="91440" tIns="45720" rIns="91440" bIns="45720" rtlCol="0" anchor="b">
+            <a:normAutofit/>
+          </a:bodyPr>
+          <a:lstStyle/>
+          <a:p>
+            <a:r>
+              <a:rPr lang="en-US" sz="5100">
+                <a:solidFill>
+                  <a:schemeClr val="tx1">
+                    <a:lumMod val="85000"/>
+                    <a:lumOff val="15000"/>
+                  </a:schemeClr>
+                </a:solidFill>
+              </a:rPr>
+              <a:t>CUDA Parallel Edge V3: final comparison</a:t>
+            </a:r>
+          </a:p>
+        </p:txBody>
+      </p:sp>
+      <p:pic>
+        <p:nvPicPr>
+          <p:cNvPr id="5" name="Content Placeholder 4">
+            <a:extLst>
+              <a:ext uri="{FF2B5EF4-FFF2-40B4-BE49-F238E27FC236}">
+                <a16:creationId xmlns:a16="http://schemas.microsoft.com/office/drawing/2014/main" id="{11DF9763-E7D8-E307-960F-E6440E0BDF96}"/>
+              </a:ext>
+            </a:extLst>
+          </p:cNvPr>
+          <p:cNvPicPr>
+            <a:picLocks noGrp="1" noChangeAspect="1"/>
+          </p:cNvPicPr>
+          <p:nvPr>
+            <p:ph idx="1"/>
+          </p:nvPr>
+        </p:nvPicPr>
+        <p:blipFill>
+          <a:blip r:embed="rId2"/>
+          <a:stretch>
+            <a:fillRect/>
+          </a:stretch>
+        </p:blipFill>
+        <p:spPr>
+          <a:xfrm>
+            <a:off x="635457" y="953269"/>
+            <a:ext cx="5131653" cy="2976357"/>
+          </a:xfrm>
+          <a:prstGeom prst="rect">
+            <a:avLst/>
+          </a:prstGeom>
+        </p:spPr>
+      </p:pic>
+      <p:sp>
+        <p:nvSpPr>
+          <p:cNvPr id="35" name="Rectangle 34">
+            <a:extLst>
+              <a:ext uri="{FF2B5EF4-FFF2-40B4-BE49-F238E27FC236}">
+                <a16:creationId xmlns:a16="http://schemas.microsoft.com/office/drawing/2014/main" id="{626F1402-2DEC-4071-84AF-350C7BF00D43}"/>
+              </a:ext>
+              <a:ext uri="{C183D7F6-B498-43B3-948B-1728B52AA6E4}">
+                <adec:decorative xmlns:adec="http://schemas.microsoft.com/office/drawing/2017/decorative" val="1"/>
+              </a:ext>
+            </a:extLst>
+          </p:cNvPr>
+          <p:cNvSpPr>
+            <a:spLocks noGrp="1" noRot="1" noChangeAspect="1" noMove="1" noResize="1" noEditPoints="1" noAdjustHandles="1" noChangeArrowheads="1" noChangeShapeType="1" noTextEdit="1"/>
+          </p:cNvSpPr>
+          <p:nvPr>
+            <p:extLst>
+              <p:ext uri="{386F3935-93C4-4BCD-93E2-E3B085C9AB24}">
+                <p16:designElem xmlns:p16="http://schemas.microsoft.com/office/powerpoint/2015/main" val="1"/>
+              </p:ext>
+            </p:extLst>
+          </p:nvPr>
+        </p:nvSpPr>
+        <p:spPr>
+          <a:xfrm>
+            <a:off x="6063996" y="886968"/>
+            <a:ext cx="64008" cy="3108960"/>
+          </a:xfrm>
+          <a:prstGeom prst="rect">
+            <a:avLst/>
+          </a:prstGeom>
+          <a:ln>
+            <a:noFill/>
+          </a:ln>
+        </p:spPr>
+        <p:style>
+          <a:lnRef idx="2">
+            <a:schemeClr val="accent1">
+              <a:shade val="50000"/>
+            </a:schemeClr>
+          </a:lnRef>
+          <a:fillRef idx="1">
+            <a:schemeClr val="accent1"/>
+          </a:fillRef>
+          <a:effectRef idx="0">
+            <a:schemeClr val="accent1"/>
+          </a:effectRef>
+          <a:fontRef idx="minor">
+            <a:schemeClr val="lt1"/>
+          </a:fontRef>
+        </p:style>
+        <p:txBody>
+          <a:bodyPr rtlCol="0" anchor="ctr"/>
+          <a:lstStyle/>
+          <a:p>
+            <a:pPr algn="ctr"/>
+            <a:endParaRPr lang="en-US"/>
+          </a:p>
+        </p:txBody>
+      </p:sp>
+      <p:pic>
+        <p:nvPicPr>
+          <p:cNvPr id="7" name="Picture 6">
+            <a:extLst>
+              <a:ext uri="{FF2B5EF4-FFF2-40B4-BE49-F238E27FC236}">
+                <a16:creationId xmlns:a16="http://schemas.microsoft.com/office/drawing/2014/main" id="{F8CD4A3A-3F58-12D6-0624-43C2647017FD}"/>
+              </a:ext>
+            </a:extLst>
+          </p:cNvPr>
+          <p:cNvPicPr>
+            <a:picLocks noChangeAspect="1"/>
+          </p:cNvPicPr>
+          <p:nvPr/>
+        </p:nvPicPr>
+        <p:blipFill>
+          <a:blip r:embed="rId3"/>
+          <a:stretch>
+            <a:fillRect/>
+          </a:stretch>
+        </p:blipFill>
+        <p:spPr>
+          <a:xfrm>
+            <a:off x="6424891" y="867607"/>
+            <a:ext cx="5118182" cy="3147681"/>
+          </a:xfrm>
+          <a:prstGeom prst="rect">
+            <a:avLst/>
+          </a:prstGeom>
+        </p:spPr>
+      </p:pic>
+      <p:cxnSp>
+        <p:nvCxnSpPr>
+          <p:cNvPr id="37" name="Straight Connector 36">
+            <a:extLst>
+              <a:ext uri="{FF2B5EF4-FFF2-40B4-BE49-F238E27FC236}">
+                <a16:creationId xmlns:a16="http://schemas.microsoft.com/office/drawing/2014/main" id="{04733B62-1719-4677-A612-CA0AC0AD7482}"/>
+              </a:ext>
+              <a:ext uri="{C183D7F6-B498-43B3-948B-1728B52AA6E4}">
+                <adec:decorative xmlns:adec="http://schemas.microsoft.com/office/drawing/2017/decorative" val="1"/>
+              </a:ext>
+            </a:extLst>
+          </p:cNvPr>
+          <p:cNvCxnSpPr>
+            <a:cxnSpLocks noGrp="1" noRot="1" noChangeAspect="1" noMove="1" noResize="1" noEditPoints="1" noAdjustHandles="1" noChangeArrowheads="1" noChangeShapeType="1"/>
+          </p:cNvCxnSpPr>
+          <p:nvPr>
+            <p:extLst>
+              <p:ext uri="{386F3935-93C4-4BCD-93E2-E3B085C9AB24}">
+                <p16:designElem xmlns:p16="http://schemas.microsoft.com/office/powerpoint/2015/main" val="1"/>
+              </p:ext>
+            </p:extLst>
+          </p:nvPr>
+        </p:nvCxnSpPr>
+        <p:spPr>
+          <a:xfrm>
+            <a:off x="721086" y="5618770"/>
+            <a:ext cx="10515600" cy="0"/>
+          </a:xfrm>
+          <a:prstGeom prst="line">
+            <a:avLst/>
+          </a:prstGeom>
+          <a:ln w="6350">
+            <a:solidFill>
+              <a:schemeClr val="tx2">
+                <a:alpha val="90000"/>
+              </a:schemeClr>
+            </a:solidFill>
+          </a:ln>
+        </p:spPr>
+        <p:style>
+          <a:lnRef idx="1">
+            <a:schemeClr val="accent1"/>
+          </a:lnRef>
+          <a:fillRef idx="0">
+            <a:schemeClr val="accent1"/>
+          </a:fillRef>
+          <a:effectRef idx="0">
+            <a:schemeClr val="accent1"/>
+          </a:effectRef>
+          <a:fontRef idx="minor">
+            <a:schemeClr val="tx1"/>
+          </a:fontRef>
+        </p:style>
+      </p:cxnSp>
+      <p:sp>
+        <p:nvSpPr>
+          <p:cNvPr id="39" name="Rectangle 38">
+            <a:extLst>
+              <a:ext uri="{FF2B5EF4-FFF2-40B4-BE49-F238E27FC236}">
+                <a16:creationId xmlns:a16="http://schemas.microsoft.com/office/drawing/2014/main" id="{DA52A394-10F4-4AA5-90E4-634D1E919DBA}"/>
+              </a:ext>
+              <a:ext uri="{C183D7F6-B498-43B3-948B-1728B52AA6E4}">
+                <adec:decorative xmlns:adec="http://schemas.microsoft.com/office/drawing/2017/decorative" val="1"/>
+              </a:ext>
+            </a:extLst>
+          </p:cNvPr>
+          <p:cNvSpPr>
+            <a:spLocks noGrp="1" noRot="1" noChangeAspect="1" noMove="1" noResize="1" noEditPoints="1" noAdjustHandles="1" noChangeArrowheads="1" noChangeShapeType="1" noTextEdit="1"/>
+          </p:cNvSpPr>
+          <p:nvPr>
+            <p:extLst>
+              <p:ext uri="{386F3935-93C4-4BCD-93E2-E3B085C9AB24}">
+                <p16:designElem xmlns:p16="http://schemas.microsoft.com/office/powerpoint/2015/main" val="1"/>
+              </p:ext>
+            </p:extLst>
+          </p:nvPr>
+        </p:nvSpPr>
+        <p:spPr>
+          <a:xfrm>
+            <a:off x="15" y="6334316"/>
+            <a:ext cx="12191985" cy="66484"/>
+          </a:xfrm>
+          <a:prstGeom prst="rect">
+            <a:avLst/>
+          </a:prstGeom>
+          <a:solidFill>
+            <a:schemeClr val="accent1"/>
+          </a:solidFill>
+          <a:ln>
+            <a:noFill/>
+          </a:ln>
+        </p:spPr>
+        <p:style>
+          <a:lnRef idx="2">
+            <a:schemeClr val="accent1">
+              <a:shade val="50000"/>
+            </a:schemeClr>
+          </a:lnRef>
+          <a:fillRef idx="1">
+            <a:schemeClr val="accent1"/>
+          </a:fillRef>
+          <a:effectRef idx="0">
+            <a:schemeClr val="accent1"/>
+          </a:effectRef>
+          <a:fontRef idx="minor">
+            <a:schemeClr val="lt1"/>
+          </a:fontRef>
+        </p:style>
+        <p:txBody>
+          <a:bodyPr/>
+          <a:lstStyle/>
+          <a:p>
+            <a:endParaRPr lang="it-IT"/>
+          </a:p>
+        </p:txBody>
+      </p:sp>
+      <p:sp>
+        <p:nvSpPr>
+          <p:cNvPr id="41" name="Rectangle 40">
+            <a:extLst>
+              <a:ext uri="{FF2B5EF4-FFF2-40B4-BE49-F238E27FC236}">
+                <a16:creationId xmlns:a16="http://schemas.microsoft.com/office/drawing/2014/main" id="{07BDDC51-8BB2-42BE-8EA8-39B3E9AC1EF6}"/>
+              </a:ext>
+              <a:ext uri="{C183D7F6-B498-43B3-948B-1728B52AA6E4}">
+                <adec:decorative xmlns:adec="http://schemas.microsoft.com/office/drawing/2017/decorative" val="1"/>
+              </a:ext>
+            </a:extLst>
+          </p:cNvPr>
+          <p:cNvSpPr>
+            <a:spLocks noGrp="1" noRot="1" noChangeAspect="1" noMove="1" noResize="1" noEditPoints="1" noAdjustHandles="1" noChangeArrowheads="1" noChangeShapeType="1" noTextEdit="1"/>
+          </p:cNvSpPr>
+          <p:nvPr>
+            <p:extLst>
+              <p:ext uri="{386F3935-93C4-4BCD-93E2-E3B085C9AB24}">
+                <p16:designElem xmlns:p16="http://schemas.microsoft.com/office/powerpoint/2015/main" val="1"/>
+              </p:ext>
+            </p:extLst>
+          </p:nvPr>
+        </p:nvSpPr>
+        <p:spPr>
+          <a:xfrm>
+            <a:off x="1" y="6400800"/>
+            <a:ext cx="12192000" cy="457200"/>
+          </a:xfrm>
+          <a:prstGeom prst="rect">
+            <a:avLst/>
+          </a:prstGeom>
+          <a:solidFill>
+            <a:schemeClr val="accent2"/>
+          </a:solidFill>
+          <a:ln>
+            <a:noFill/>
+          </a:ln>
+        </p:spPr>
+        <p:style>
+          <a:lnRef idx="2">
+            <a:schemeClr val="accent1">
+              <a:shade val="50000"/>
+            </a:schemeClr>
+          </a:lnRef>
+          <a:fillRef idx="1">
+            <a:schemeClr val="accent1"/>
+          </a:fillRef>
+          <a:effectRef idx="0">
+            <a:schemeClr val="accent1"/>
+          </a:effectRef>
+          <a:fontRef idx="minor">
+            <a:schemeClr val="lt1"/>
+          </a:fontRef>
+        </p:style>
+        <p:txBody>
+          <a:bodyPr/>
+          <a:lstStyle/>
+          <a:p>
+            <a:endParaRPr lang="it-IT"/>
+          </a:p>
+        </p:txBody>
+      </p:sp>
+    </p:spTree>
+    <p:extLst>
+      <p:ext uri="{BB962C8B-B14F-4D97-AF65-F5344CB8AC3E}">
+        <p14:creationId xmlns:p14="http://schemas.microsoft.com/office/powerpoint/2010/main" val="2533005870"/>
+      </p:ext>
+    </p:extLst>
+  </p:cSld>
+  <p:clrMapOvr>
+    <a:masterClrMapping/>
+  </p:clrMapOvr>
+</p:sld>
+</file>
+
+<file path=ppt/slides/slide23.xml><?xml version="1.0" encoding="utf-8"?>
 <p:sld xmlns:a="http://schemas.openxmlformats.org/drawingml/2006/main" xmlns:r="http://schemas.openxmlformats.org/officeDocument/2006/relationships" xmlns:p="http://schemas.openxmlformats.org/presentationml/2006/main">
   <p:cSld>
     <p:spTree>
@@ -8769,7 +9389,7 @@
 </p:sld>
 </file>
 
-<file path=ppt/slides/slide23.xml><?xml version="1.0" encoding="utf-8"?>
+<file path=ppt/slides/slide24.xml><?xml version="1.0" encoding="utf-8"?>
 <p:sld xmlns:a="http://schemas.openxmlformats.org/drawingml/2006/main" xmlns:r="http://schemas.openxmlformats.org/officeDocument/2006/relationships" xmlns:p="http://schemas.openxmlformats.org/presentationml/2006/main">
   <p:cSld>
     <p:spTree>
@@ -9192,7 +9812,7 @@
 </p:sld>
 </file>
 
-<file path=ppt/slides/slide24.xml><?xml version="1.0" encoding="utf-8"?>
+<file path=ppt/slides/slide25.xml><?xml version="1.0" encoding="utf-8"?>
 <p:sld xmlns:a="http://schemas.openxmlformats.org/drawingml/2006/main" xmlns:r="http://schemas.openxmlformats.org/officeDocument/2006/relationships" xmlns:p="http://schemas.openxmlformats.org/presentationml/2006/main">
   <p:cSld>
     <p:spTree>
@@ -9503,7 +10123,7 @@
 </p:sld>
 </file>
 
-<file path=ppt/slides/slide25.xml><?xml version="1.0" encoding="utf-8"?>
+<file path=ppt/slides/slide26.xml><?xml version="1.0" encoding="utf-8"?>
 <p:sld xmlns:a="http://schemas.openxmlformats.org/drawingml/2006/main" xmlns:r="http://schemas.openxmlformats.org/officeDocument/2006/relationships" xmlns:p="http://schemas.openxmlformats.org/presentationml/2006/main">
   <p:cSld>
     <p:spTree>

</xml_diff>

<commit_message>
fix: fixed slide node it parallel v1
</commit_message>
<xml_diff>
--- a/presentation.pptx
+++ b/presentation.pptx
@@ -19339,7 +19339,7 @@
               <a:buNone/>
             </a:pPr>
             <a:r>
-              <a:rPr lang="it-IT" sz="4800" b="0" strike="noStrike" spc="-52">
+              <a:rPr lang="it-IT" sz="4800" b="0" strike="noStrike" spc="-52" dirty="0" err="1">
                 <a:solidFill>
                   <a:schemeClr val="dk1">
                     <a:lumMod val="75000"/>
@@ -19348,9 +19348,117 @@
                 </a:solidFill>
                 <a:latin typeface="Calibri Light"/>
               </a:rPr>
-              <a:t>Parallel (C++) Forward Node Iteator Algorithm, V1 </a:t>
-            </a:r>
-            <a:endParaRPr lang="en-US" sz="4800" b="0" strike="noStrike" spc="-1">
+              <a:t>Parallel</a:t>
+            </a:r>
+            <a:r>
+              <a:rPr lang="it-IT" sz="4800" b="0" strike="noStrike" spc="-52" dirty="0">
+                <a:solidFill>
+                  <a:schemeClr val="dk1">
+                    <a:lumMod val="75000"/>
+                    <a:lumOff val="25000"/>
+                  </a:schemeClr>
+                </a:solidFill>
+                <a:latin typeface="Calibri Light"/>
+              </a:rPr>
+              <a:t> (C++) </a:t>
+            </a:r>
+            <a:r>
+              <a:rPr lang="it-IT" sz="4800" b="0" strike="noStrike" spc="-52" dirty="0" err="1">
+                <a:solidFill>
+                  <a:schemeClr val="dk1">
+                    <a:lumMod val="75000"/>
+                    <a:lumOff val="25000"/>
+                  </a:schemeClr>
+                </a:solidFill>
+                <a:latin typeface="Calibri Light"/>
+              </a:rPr>
+              <a:t>Forward</a:t>
+            </a:r>
+            <a:r>
+              <a:rPr lang="it-IT" sz="4800" b="0" strike="noStrike" spc="-52" dirty="0">
+                <a:solidFill>
+                  <a:schemeClr val="dk1">
+                    <a:lumMod val="75000"/>
+                    <a:lumOff val="25000"/>
+                  </a:schemeClr>
+                </a:solidFill>
+                <a:latin typeface="Calibri Light"/>
+              </a:rPr>
+              <a:t> </a:t>
+            </a:r>
+            <a:r>
+              <a:rPr lang="it-IT" sz="4800" b="0" strike="noStrike" spc="-52" dirty="0" err="1">
+                <a:solidFill>
+                  <a:schemeClr val="dk1">
+                    <a:lumMod val="75000"/>
+                    <a:lumOff val="25000"/>
+                  </a:schemeClr>
+                </a:solidFill>
+                <a:latin typeface="Calibri Light"/>
+              </a:rPr>
+              <a:t>Node</a:t>
+            </a:r>
+            <a:r>
+              <a:rPr lang="it-IT" sz="4800" b="0" strike="noStrike" spc="-52" dirty="0">
+                <a:solidFill>
+                  <a:schemeClr val="dk1">
+                    <a:lumMod val="75000"/>
+                    <a:lumOff val="25000"/>
+                  </a:schemeClr>
+                </a:solidFill>
+                <a:latin typeface="Calibri Light"/>
+              </a:rPr>
+              <a:t> </a:t>
+            </a:r>
+            <a:r>
+              <a:rPr lang="it-IT" sz="4800" b="0" strike="noStrike" spc="-52" dirty="0" err="1">
+                <a:solidFill>
+                  <a:schemeClr val="dk1">
+                    <a:lumMod val="75000"/>
+                    <a:lumOff val="25000"/>
+                  </a:schemeClr>
+                </a:solidFill>
+                <a:latin typeface="Calibri Light"/>
+              </a:rPr>
+              <a:t>Iteator</a:t>
+            </a:r>
+            <a:r>
+              <a:rPr lang="it-IT" sz="4800" b="0" strike="noStrike" spc="-52" dirty="0">
+                <a:solidFill>
+                  <a:schemeClr val="dk1">
+                    <a:lumMod val="75000"/>
+                    <a:lumOff val="25000"/>
+                  </a:schemeClr>
+                </a:solidFill>
+                <a:latin typeface="Calibri Light"/>
+              </a:rPr>
+              <a:t> </a:t>
+            </a:r>
+            <a:r>
+              <a:rPr lang="it-IT" sz="4800" b="0" strike="noStrike" spc="-52" dirty="0" err="1">
+                <a:solidFill>
+                  <a:schemeClr val="dk1">
+                    <a:lumMod val="75000"/>
+                    <a:lumOff val="25000"/>
+                  </a:schemeClr>
+                </a:solidFill>
+                <a:latin typeface="Calibri Light"/>
+              </a:rPr>
+              <a:t>Algorithm</a:t>
+            </a:r>
+            <a:r>
+              <a:rPr lang="it-IT" sz="4800" b="0" strike="noStrike" spc="-52" dirty="0">
+                <a:solidFill>
+                  <a:schemeClr val="dk1">
+                    <a:lumMod val="75000"/>
+                    <a:lumOff val="25000"/>
+                  </a:schemeClr>
+                </a:solidFill>
+                <a:latin typeface="Calibri Light"/>
+              </a:rPr>
+              <a:t>, V1 </a:t>
+            </a:r>
+            <a:endParaRPr lang="en-US" sz="4800" b="0" strike="noStrike" spc="-1" dirty="0">
               <a:solidFill>
                 <a:schemeClr val="dk1"/>
               </a:solidFill>
@@ -19367,8 +19475,8 @@
         </p:nvSpPr>
         <p:spPr>
           <a:xfrm>
-            <a:off x="1097280" y="1870920"/>
-            <a:ext cx="10058040" cy="1461240"/>
+            <a:off x="1097280" y="1737000"/>
+            <a:ext cx="10058040" cy="1475873"/>
           </a:xfrm>
           <a:prstGeom prst="rect">
             <a:avLst/>
@@ -19407,7 +19515,7 @@
               <a:buChar char="•"/>
             </a:pPr>
             <a:r>
-              <a:rPr lang="it-IT" sz="1800" b="0" strike="noStrike" spc="-1">
+              <a:rPr lang="it-IT" sz="1800" b="0" strike="noStrike" spc="-1" dirty="0">
                 <a:solidFill>
                   <a:schemeClr val="dk1"/>
                 </a:solidFill>
@@ -19416,24 +19524,780 @@
               <a:t>In the </a:t>
             </a:r>
             <a:r>
-              <a:rPr lang="it-IT" sz="1800" b="1" strike="noStrike" spc="-1">
+              <a:rPr lang="it-IT" sz="1800" b="1" strike="noStrike" spc="-1" dirty="0">
                 <a:solidFill>
                   <a:schemeClr val="dk1"/>
                 </a:solidFill>
                 <a:latin typeface="Calibri"/>
               </a:rPr>
-              <a:t>first version </a:t>
-            </a:r>
-            <a:r>
-              <a:rPr lang="it-IT" sz="1800" b="0" strike="noStrike" spc="-1">
+              <a:t>first </a:t>
+            </a:r>
+            <a:r>
+              <a:rPr lang="it-IT" sz="1800" b="1" strike="noStrike" spc="-1" dirty="0" err="1">
                 <a:solidFill>
                   <a:schemeClr val="dk1"/>
                 </a:solidFill>
                 <a:latin typeface="Calibri"/>
               </a:rPr>
-              <a:t>of the algorithm, more naive and simple case, the part that gets parallelized is the For-ward algorithm function. More in detail, the outer loopthat iterates through the nodes in the ordered list is still sequential, running N times, but the iteration overeach node neighbors t is parallelized: this is achievedby dividing the neighbors of s into chunks, with eachchunk processed by a separate worker thread usingstd::async.</a:t>
-            </a:r>
-            <a:endParaRPr lang="en-US" sz="1800" b="0" strike="noStrike" spc="-1">
+              <a:t>version</a:t>
+            </a:r>
+            <a:r>
+              <a:rPr lang="it-IT" sz="1800" b="1" strike="noStrike" spc="-1" dirty="0">
+                <a:solidFill>
+                  <a:schemeClr val="dk1"/>
+                </a:solidFill>
+                <a:latin typeface="Calibri"/>
+              </a:rPr>
+              <a:t> </a:t>
+            </a:r>
+            <a:r>
+              <a:rPr lang="it-IT" sz="1800" b="0" strike="noStrike" spc="-1" dirty="0">
+                <a:solidFill>
+                  <a:schemeClr val="dk1"/>
+                </a:solidFill>
+                <a:latin typeface="Calibri"/>
+              </a:rPr>
+              <a:t>of the </a:t>
+            </a:r>
+            <a:r>
+              <a:rPr lang="it-IT" sz="1800" b="0" strike="noStrike" spc="-1" dirty="0" err="1">
+                <a:solidFill>
+                  <a:schemeClr val="dk1"/>
+                </a:solidFill>
+                <a:latin typeface="Calibri"/>
+              </a:rPr>
+              <a:t>algorithm</a:t>
+            </a:r>
+            <a:r>
+              <a:rPr lang="it-IT" sz="1800" b="0" strike="noStrike" spc="-1" dirty="0">
+                <a:solidFill>
+                  <a:schemeClr val="dk1"/>
+                </a:solidFill>
+                <a:latin typeface="Calibri"/>
+              </a:rPr>
+              <a:t>, more </a:t>
+            </a:r>
+            <a:r>
+              <a:rPr lang="it-IT" sz="1800" b="0" strike="noStrike" spc="-1" dirty="0" err="1">
+                <a:solidFill>
+                  <a:schemeClr val="dk1"/>
+                </a:solidFill>
+                <a:latin typeface="Calibri"/>
+              </a:rPr>
+              <a:t>naive</a:t>
+            </a:r>
+            <a:r>
+              <a:rPr lang="it-IT" sz="1800" b="0" strike="noStrike" spc="-1" dirty="0">
+                <a:solidFill>
+                  <a:schemeClr val="dk1"/>
+                </a:solidFill>
+                <a:latin typeface="Calibri"/>
+              </a:rPr>
+              <a:t> and </a:t>
+            </a:r>
+            <a:r>
+              <a:rPr lang="it-IT" sz="1800" b="0" strike="noStrike" spc="-1" dirty="0" err="1">
+                <a:solidFill>
+                  <a:schemeClr val="dk1"/>
+                </a:solidFill>
+                <a:latin typeface="Calibri"/>
+              </a:rPr>
+              <a:t>simple</a:t>
+            </a:r>
+            <a:r>
+              <a:rPr lang="it-IT" sz="1800" b="0" strike="noStrike" spc="-1" dirty="0">
+                <a:solidFill>
+                  <a:schemeClr val="dk1"/>
+                </a:solidFill>
+                <a:latin typeface="Calibri"/>
+              </a:rPr>
+              <a:t> case, the part </a:t>
+            </a:r>
+            <a:r>
+              <a:rPr lang="it-IT" sz="1800" b="0" strike="noStrike" spc="-1" dirty="0" err="1">
+                <a:solidFill>
+                  <a:schemeClr val="dk1"/>
+                </a:solidFill>
+                <a:latin typeface="Calibri"/>
+              </a:rPr>
+              <a:t>that</a:t>
+            </a:r>
+            <a:r>
+              <a:rPr lang="it-IT" sz="1800" b="0" strike="noStrike" spc="-1" dirty="0">
+                <a:solidFill>
+                  <a:schemeClr val="dk1"/>
+                </a:solidFill>
+                <a:latin typeface="Calibri"/>
+              </a:rPr>
+              <a:t> </a:t>
+            </a:r>
+            <a:r>
+              <a:rPr lang="it-IT" sz="1800" b="0" strike="noStrike" spc="-1" dirty="0" err="1">
+                <a:solidFill>
+                  <a:schemeClr val="dk1"/>
+                </a:solidFill>
+                <a:latin typeface="Calibri"/>
+              </a:rPr>
+              <a:t>gets</a:t>
+            </a:r>
+            <a:r>
+              <a:rPr lang="it-IT" sz="1800" b="0" strike="noStrike" spc="-1" dirty="0">
+                <a:solidFill>
+                  <a:schemeClr val="dk1"/>
+                </a:solidFill>
+                <a:latin typeface="Calibri"/>
+              </a:rPr>
+              <a:t> </a:t>
+            </a:r>
+            <a:r>
+              <a:rPr lang="it-IT" sz="1800" b="0" strike="noStrike" spc="-1" dirty="0" err="1">
+                <a:solidFill>
+                  <a:schemeClr val="dk1"/>
+                </a:solidFill>
+                <a:latin typeface="Calibri"/>
+              </a:rPr>
+              <a:t>parallelized</a:t>
+            </a:r>
+            <a:r>
+              <a:rPr lang="it-IT" sz="1800" b="0" strike="noStrike" spc="-1" dirty="0">
+                <a:solidFill>
+                  <a:schemeClr val="dk1"/>
+                </a:solidFill>
+                <a:latin typeface="Calibri"/>
+              </a:rPr>
+              <a:t> </a:t>
+            </a:r>
+            <a:r>
+              <a:rPr lang="it-IT" sz="1800" b="0" strike="noStrike" spc="-1" dirty="0" err="1">
+                <a:solidFill>
+                  <a:schemeClr val="dk1"/>
+                </a:solidFill>
+                <a:latin typeface="Calibri"/>
+              </a:rPr>
+              <a:t>is</a:t>
+            </a:r>
+            <a:r>
+              <a:rPr lang="it-IT" sz="1800" b="0" strike="noStrike" spc="-1" dirty="0">
+                <a:solidFill>
+                  <a:schemeClr val="dk1"/>
+                </a:solidFill>
+                <a:latin typeface="Calibri"/>
+              </a:rPr>
+              <a:t> the </a:t>
+            </a:r>
+            <a:r>
+              <a:rPr lang="it-IT" sz="1800" b="0" strike="noStrike" spc="-1" dirty="0" err="1">
+                <a:solidFill>
+                  <a:schemeClr val="dk1"/>
+                </a:solidFill>
+                <a:latin typeface="Calibri"/>
+              </a:rPr>
+              <a:t>Forward</a:t>
+            </a:r>
+            <a:r>
+              <a:rPr lang="it-IT" sz="1800" b="0" strike="noStrike" spc="-1" dirty="0">
+                <a:solidFill>
+                  <a:schemeClr val="dk1"/>
+                </a:solidFill>
+                <a:latin typeface="Calibri"/>
+              </a:rPr>
+              <a:t> </a:t>
+            </a:r>
+            <a:r>
+              <a:rPr lang="it-IT" sz="1800" b="0" strike="noStrike" spc="-1" dirty="0" err="1">
+                <a:solidFill>
+                  <a:schemeClr val="dk1"/>
+                </a:solidFill>
+                <a:latin typeface="Calibri"/>
+              </a:rPr>
+              <a:t>algorithm</a:t>
+            </a:r>
+            <a:r>
+              <a:rPr lang="it-IT" sz="1800" b="0" strike="noStrike" spc="-1" dirty="0">
+                <a:solidFill>
+                  <a:schemeClr val="dk1"/>
+                </a:solidFill>
+                <a:latin typeface="Calibri"/>
+              </a:rPr>
+              <a:t> </a:t>
+            </a:r>
+            <a:r>
+              <a:rPr lang="it-IT" sz="1800" b="0" strike="noStrike" spc="-1" dirty="0" err="1">
+                <a:solidFill>
+                  <a:schemeClr val="dk1"/>
+                </a:solidFill>
+                <a:latin typeface="Calibri"/>
+              </a:rPr>
+              <a:t>function</a:t>
+            </a:r>
+            <a:r>
+              <a:rPr lang="it-IT" sz="1800" b="0" strike="noStrike" spc="-1" dirty="0">
+                <a:solidFill>
+                  <a:schemeClr val="dk1"/>
+                </a:solidFill>
+                <a:latin typeface="Calibri"/>
+              </a:rPr>
+              <a:t>. More in </a:t>
+            </a:r>
+            <a:r>
+              <a:rPr lang="it-IT" sz="1800" b="0" strike="noStrike" spc="-1" dirty="0" err="1">
+                <a:solidFill>
+                  <a:schemeClr val="dk1"/>
+                </a:solidFill>
+                <a:latin typeface="Calibri"/>
+              </a:rPr>
+              <a:t>detail</a:t>
+            </a:r>
+            <a:r>
+              <a:rPr lang="it-IT" sz="1800" b="0" strike="noStrike" spc="-1" dirty="0">
+                <a:solidFill>
+                  <a:schemeClr val="dk1"/>
+                </a:solidFill>
+                <a:latin typeface="Calibri"/>
+              </a:rPr>
+              <a:t>, the </a:t>
+            </a:r>
+            <a:r>
+              <a:rPr lang="it-IT" sz="1800" b="0" strike="noStrike" spc="-1" dirty="0" err="1">
+                <a:solidFill>
+                  <a:schemeClr val="dk1"/>
+                </a:solidFill>
+                <a:latin typeface="Calibri"/>
+              </a:rPr>
+              <a:t>outer</a:t>
+            </a:r>
+            <a:r>
+              <a:rPr lang="it-IT" sz="1800" b="0" strike="noStrike" spc="-1" dirty="0">
+                <a:solidFill>
+                  <a:schemeClr val="dk1"/>
+                </a:solidFill>
+                <a:latin typeface="Calibri"/>
+              </a:rPr>
+              <a:t> loop </a:t>
+            </a:r>
+            <a:r>
+              <a:rPr lang="it-IT" sz="1800" b="0" strike="noStrike" spc="-1" dirty="0" err="1">
+                <a:solidFill>
+                  <a:schemeClr val="dk1"/>
+                </a:solidFill>
+                <a:latin typeface="Calibri"/>
+              </a:rPr>
+              <a:t>that</a:t>
+            </a:r>
+            <a:r>
+              <a:rPr lang="it-IT" sz="1800" b="0" strike="noStrike" spc="-1" dirty="0">
+                <a:solidFill>
+                  <a:schemeClr val="dk1"/>
+                </a:solidFill>
+                <a:latin typeface="Calibri"/>
+              </a:rPr>
+              <a:t> </a:t>
+            </a:r>
+            <a:r>
+              <a:rPr lang="it-IT" sz="1800" b="0" strike="noStrike" spc="-1" dirty="0" err="1">
+                <a:solidFill>
+                  <a:schemeClr val="dk1"/>
+                </a:solidFill>
+                <a:latin typeface="Calibri"/>
+              </a:rPr>
+              <a:t>iterates</a:t>
+            </a:r>
+            <a:r>
+              <a:rPr lang="it-IT" sz="1800" b="0" strike="noStrike" spc="-1" dirty="0">
+                <a:solidFill>
+                  <a:schemeClr val="dk1"/>
+                </a:solidFill>
+                <a:latin typeface="Calibri"/>
+              </a:rPr>
+              <a:t> </a:t>
+            </a:r>
+            <a:r>
+              <a:rPr lang="it-IT" sz="1800" b="0" strike="noStrike" spc="-1" dirty="0" err="1">
+                <a:solidFill>
+                  <a:schemeClr val="dk1"/>
+                </a:solidFill>
+                <a:latin typeface="Calibri"/>
+              </a:rPr>
+              <a:t>through</a:t>
+            </a:r>
+            <a:r>
+              <a:rPr lang="it-IT" sz="1800" b="0" strike="noStrike" spc="-1" dirty="0">
+                <a:solidFill>
+                  <a:schemeClr val="dk1"/>
+                </a:solidFill>
+                <a:latin typeface="Calibri"/>
+              </a:rPr>
+              <a:t> the </a:t>
+            </a:r>
+            <a:r>
+              <a:rPr lang="it-IT" sz="1800" b="0" strike="noStrike" spc="-1" dirty="0" err="1">
+                <a:solidFill>
+                  <a:schemeClr val="dk1"/>
+                </a:solidFill>
+                <a:latin typeface="Calibri"/>
+              </a:rPr>
+              <a:t>nodes</a:t>
+            </a:r>
+            <a:r>
+              <a:rPr lang="it-IT" sz="1800" b="0" strike="noStrike" spc="-1" dirty="0">
+                <a:solidFill>
+                  <a:schemeClr val="dk1"/>
+                </a:solidFill>
+                <a:latin typeface="Calibri"/>
+              </a:rPr>
+              <a:t> in the </a:t>
+            </a:r>
+            <a:r>
+              <a:rPr lang="it-IT" sz="1800" b="0" strike="noStrike" spc="-1" dirty="0" err="1">
+                <a:solidFill>
+                  <a:schemeClr val="dk1"/>
+                </a:solidFill>
+                <a:latin typeface="Calibri"/>
+              </a:rPr>
+              <a:t>ordered</a:t>
+            </a:r>
+            <a:r>
+              <a:rPr lang="it-IT" sz="1800" b="0" strike="noStrike" spc="-1" dirty="0">
+                <a:solidFill>
+                  <a:schemeClr val="dk1"/>
+                </a:solidFill>
+                <a:latin typeface="Calibri"/>
+              </a:rPr>
+              <a:t> list </a:t>
+            </a:r>
+            <a:r>
+              <a:rPr lang="it-IT" sz="1800" b="0" strike="noStrike" spc="-1" dirty="0" err="1">
+                <a:solidFill>
+                  <a:schemeClr val="dk1"/>
+                </a:solidFill>
+                <a:latin typeface="Calibri"/>
+              </a:rPr>
+              <a:t>is</a:t>
+            </a:r>
+            <a:r>
+              <a:rPr lang="it-IT" sz="1800" b="0" strike="noStrike" spc="-1" dirty="0">
+                <a:solidFill>
+                  <a:schemeClr val="dk1"/>
+                </a:solidFill>
+                <a:latin typeface="Calibri"/>
+              </a:rPr>
+              <a:t> </a:t>
+            </a:r>
+            <a:r>
+              <a:rPr lang="it-IT" sz="1800" b="0" strike="noStrike" spc="-1" dirty="0" err="1">
+                <a:solidFill>
+                  <a:schemeClr val="dk1"/>
+                </a:solidFill>
+                <a:latin typeface="Calibri"/>
+              </a:rPr>
+              <a:t>still</a:t>
+            </a:r>
+            <a:r>
+              <a:rPr lang="it-IT" sz="1800" b="0" strike="noStrike" spc="-1" dirty="0">
+                <a:solidFill>
+                  <a:schemeClr val="dk1"/>
+                </a:solidFill>
+                <a:latin typeface="Calibri"/>
+              </a:rPr>
+              <a:t> </a:t>
+            </a:r>
+            <a:r>
+              <a:rPr lang="it-IT" sz="1800" b="0" strike="noStrike" spc="-1" dirty="0" err="1">
+                <a:solidFill>
+                  <a:schemeClr val="dk1"/>
+                </a:solidFill>
+                <a:latin typeface="Calibri"/>
+              </a:rPr>
+              <a:t>sequential</a:t>
+            </a:r>
+            <a:r>
+              <a:rPr lang="it-IT" sz="1800" b="0" strike="noStrike" spc="-1" dirty="0">
+                <a:solidFill>
+                  <a:schemeClr val="dk1"/>
+                </a:solidFill>
+                <a:latin typeface="Calibri"/>
+              </a:rPr>
+              <a:t>, running N times, </a:t>
+            </a:r>
+            <a:r>
+              <a:rPr lang="it-IT" sz="1800" b="0" strike="noStrike" spc="-1" dirty="0" err="1">
+                <a:solidFill>
+                  <a:schemeClr val="dk1"/>
+                </a:solidFill>
+                <a:latin typeface="Calibri"/>
+              </a:rPr>
+              <a:t>but</a:t>
+            </a:r>
+            <a:r>
+              <a:rPr lang="it-IT" sz="1800" b="0" strike="noStrike" spc="-1" dirty="0">
+                <a:solidFill>
+                  <a:schemeClr val="dk1"/>
+                </a:solidFill>
+                <a:latin typeface="Calibri"/>
+              </a:rPr>
+              <a:t> the </a:t>
+            </a:r>
+            <a:r>
+              <a:rPr lang="it-IT" sz="1800" b="0" strike="noStrike" spc="-1" dirty="0" err="1">
+                <a:solidFill>
+                  <a:schemeClr val="dk1"/>
+                </a:solidFill>
+                <a:latin typeface="Calibri"/>
+              </a:rPr>
+              <a:t>iteration</a:t>
+            </a:r>
+            <a:r>
+              <a:rPr lang="it-IT" sz="1800" b="0" strike="noStrike" spc="-1" dirty="0">
+                <a:solidFill>
+                  <a:schemeClr val="dk1"/>
+                </a:solidFill>
+                <a:latin typeface="Calibri"/>
+              </a:rPr>
+              <a:t> over </a:t>
+            </a:r>
+            <a:r>
+              <a:rPr lang="it-IT" sz="1800" b="0" strike="noStrike" spc="-1" dirty="0" err="1">
+                <a:solidFill>
+                  <a:schemeClr val="dk1"/>
+                </a:solidFill>
+                <a:latin typeface="Calibri"/>
+              </a:rPr>
+              <a:t>each</a:t>
+            </a:r>
+            <a:r>
+              <a:rPr lang="it-IT" sz="1800" b="0" strike="noStrike" spc="-1" dirty="0">
+                <a:solidFill>
+                  <a:schemeClr val="dk1"/>
+                </a:solidFill>
+                <a:latin typeface="Calibri"/>
+              </a:rPr>
+              <a:t> </a:t>
+            </a:r>
+            <a:r>
+              <a:rPr lang="it-IT" sz="1800" b="0" strike="noStrike" spc="-1" dirty="0" err="1">
+                <a:solidFill>
+                  <a:schemeClr val="dk1"/>
+                </a:solidFill>
+                <a:latin typeface="Calibri"/>
+              </a:rPr>
+              <a:t>node</a:t>
+            </a:r>
+            <a:r>
+              <a:rPr lang="it-IT" sz="1800" b="0" strike="noStrike" spc="-1" dirty="0">
+                <a:solidFill>
+                  <a:schemeClr val="dk1"/>
+                </a:solidFill>
+                <a:latin typeface="Calibri"/>
+              </a:rPr>
+              <a:t> </a:t>
+            </a:r>
+            <a:r>
+              <a:rPr lang="it-IT" sz="1800" b="0" strike="noStrike" spc="-1" dirty="0" err="1">
+                <a:solidFill>
+                  <a:schemeClr val="dk1"/>
+                </a:solidFill>
+                <a:latin typeface="Calibri"/>
+              </a:rPr>
+              <a:t>neighbors</a:t>
+            </a:r>
+            <a:r>
+              <a:rPr lang="it-IT" sz="1800" b="0" strike="noStrike" spc="-1" dirty="0">
+                <a:solidFill>
+                  <a:schemeClr val="dk1"/>
+                </a:solidFill>
+                <a:latin typeface="Calibri"/>
+              </a:rPr>
+              <a:t> t </a:t>
+            </a:r>
+            <a:r>
+              <a:rPr lang="it-IT" sz="1800" b="0" strike="noStrike" spc="-1" dirty="0" err="1">
+                <a:solidFill>
+                  <a:schemeClr val="dk1"/>
+                </a:solidFill>
+                <a:latin typeface="Calibri"/>
+              </a:rPr>
+              <a:t>is</a:t>
+            </a:r>
+            <a:r>
+              <a:rPr lang="it-IT" sz="1800" b="0" strike="noStrike" spc="-1" dirty="0">
+                <a:solidFill>
+                  <a:schemeClr val="dk1"/>
+                </a:solidFill>
+                <a:latin typeface="Calibri"/>
+              </a:rPr>
+              <a:t> </a:t>
+            </a:r>
+            <a:r>
+              <a:rPr lang="it-IT" sz="1800" b="0" strike="noStrike" spc="-1" dirty="0" err="1">
+                <a:solidFill>
+                  <a:schemeClr val="dk1"/>
+                </a:solidFill>
+                <a:latin typeface="Calibri"/>
+              </a:rPr>
+              <a:t>parallelized</a:t>
+            </a:r>
+            <a:r>
+              <a:rPr lang="it-IT" sz="1800" b="0" strike="noStrike" spc="-1" dirty="0">
+                <a:solidFill>
+                  <a:schemeClr val="dk1"/>
+                </a:solidFill>
+                <a:latin typeface="Calibri"/>
+              </a:rPr>
+              <a:t>: </a:t>
+            </a:r>
+            <a:r>
+              <a:rPr lang="it-IT" sz="1800" b="0" strike="noStrike" spc="-1" dirty="0" err="1">
+                <a:solidFill>
+                  <a:schemeClr val="dk1"/>
+                </a:solidFill>
+                <a:latin typeface="Calibri"/>
+              </a:rPr>
+              <a:t>this</a:t>
+            </a:r>
+            <a:r>
+              <a:rPr lang="it-IT" sz="1800" b="0" strike="noStrike" spc="-1" dirty="0">
+                <a:solidFill>
+                  <a:schemeClr val="dk1"/>
+                </a:solidFill>
+                <a:latin typeface="Calibri"/>
+              </a:rPr>
+              <a:t> </a:t>
+            </a:r>
+            <a:r>
+              <a:rPr lang="it-IT" sz="1800" b="0" strike="noStrike" spc="-1" dirty="0" err="1">
+                <a:solidFill>
+                  <a:schemeClr val="dk1"/>
+                </a:solidFill>
+                <a:latin typeface="Calibri"/>
+              </a:rPr>
+              <a:t>is</a:t>
+            </a:r>
+            <a:r>
+              <a:rPr lang="it-IT" sz="1800" b="0" strike="noStrike" spc="-1" dirty="0">
+                <a:solidFill>
+                  <a:schemeClr val="dk1"/>
+                </a:solidFill>
+                <a:latin typeface="Calibri"/>
+              </a:rPr>
+              <a:t> </a:t>
+            </a:r>
+            <a:r>
+              <a:rPr lang="it-IT" sz="1800" b="0" strike="noStrike" spc="-1" dirty="0" err="1">
+                <a:solidFill>
+                  <a:schemeClr val="dk1"/>
+                </a:solidFill>
+                <a:latin typeface="Calibri"/>
+              </a:rPr>
+              <a:t>achieved</a:t>
+            </a:r>
+            <a:r>
+              <a:rPr lang="it-IT" sz="1800" b="0" strike="noStrike" spc="-1" dirty="0">
+                <a:solidFill>
+                  <a:schemeClr val="dk1"/>
+                </a:solidFill>
+                <a:latin typeface="Calibri"/>
+              </a:rPr>
+              <a:t> by </a:t>
+            </a:r>
+            <a:r>
+              <a:rPr lang="it-IT" sz="1800" b="0" strike="noStrike" spc="-1" dirty="0" err="1">
+                <a:solidFill>
+                  <a:schemeClr val="dk1"/>
+                </a:solidFill>
+                <a:latin typeface="Calibri"/>
+              </a:rPr>
+              <a:t>dividing</a:t>
+            </a:r>
+            <a:r>
+              <a:rPr lang="it-IT" sz="1800" b="0" strike="noStrike" spc="-1" dirty="0">
+                <a:solidFill>
+                  <a:schemeClr val="dk1"/>
+                </a:solidFill>
+                <a:latin typeface="Calibri"/>
+              </a:rPr>
+              <a:t> the </a:t>
+            </a:r>
+            <a:r>
+              <a:rPr lang="it-IT" sz="1800" b="0" strike="noStrike" spc="-1" dirty="0" err="1">
+                <a:solidFill>
+                  <a:schemeClr val="dk1"/>
+                </a:solidFill>
+                <a:latin typeface="Calibri"/>
+              </a:rPr>
+              <a:t>neighbors</a:t>
+            </a:r>
+            <a:r>
+              <a:rPr lang="it-IT" sz="1800" b="0" strike="noStrike" spc="-1" dirty="0">
+                <a:solidFill>
+                  <a:schemeClr val="dk1"/>
+                </a:solidFill>
+                <a:latin typeface="Calibri"/>
+              </a:rPr>
+              <a:t> of s </a:t>
+            </a:r>
+            <a:r>
+              <a:rPr lang="it-IT" sz="1800" b="0" strike="noStrike" spc="-1" dirty="0" err="1">
+                <a:solidFill>
+                  <a:schemeClr val="dk1"/>
+                </a:solidFill>
+                <a:latin typeface="Calibri"/>
+              </a:rPr>
+              <a:t>into</a:t>
+            </a:r>
+            <a:r>
+              <a:rPr lang="it-IT" sz="1800" b="0" strike="noStrike" spc="-1" dirty="0">
+                <a:solidFill>
+                  <a:schemeClr val="dk1"/>
+                </a:solidFill>
+                <a:latin typeface="Calibri"/>
+              </a:rPr>
+              <a:t> </a:t>
+            </a:r>
+            <a:r>
+              <a:rPr lang="it-IT" sz="1800" b="0" strike="noStrike" spc="-1" dirty="0" err="1">
+                <a:solidFill>
+                  <a:schemeClr val="dk1"/>
+                </a:solidFill>
+                <a:latin typeface="Calibri"/>
+              </a:rPr>
+              <a:t>chunks</a:t>
+            </a:r>
+            <a:r>
+              <a:rPr lang="it-IT" sz="1800" b="0" strike="noStrike" spc="-1" dirty="0">
+                <a:solidFill>
+                  <a:schemeClr val="dk1"/>
+                </a:solidFill>
+                <a:latin typeface="Calibri"/>
+              </a:rPr>
+              <a:t>, with </a:t>
+            </a:r>
+            <a:r>
+              <a:rPr lang="it-IT" sz="1800" b="0" strike="noStrike" spc="-1" dirty="0" err="1">
+                <a:solidFill>
+                  <a:schemeClr val="dk1"/>
+                </a:solidFill>
+                <a:latin typeface="Calibri"/>
+              </a:rPr>
+              <a:t>each</a:t>
+            </a:r>
+            <a:r>
+              <a:rPr lang="it-IT" sz="1800" b="0" strike="noStrike" spc="-1" dirty="0">
+                <a:solidFill>
+                  <a:schemeClr val="dk1"/>
+                </a:solidFill>
+                <a:latin typeface="Calibri"/>
+              </a:rPr>
+              <a:t> </a:t>
+            </a:r>
+            <a:r>
+              <a:rPr lang="it-IT" sz="1800" b="0" strike="noStrike" spc="-1" dirty="0" err="1">
+                <a:solidFill>
+                  <a:schemeClr val="dk1"/>
+                </a:solidFill>
+                <a:latin typeface="Calibri"/>
+              </a:rPr>
+              <a:t>chunk</a:t>
+            </a:r>
+            <a:r>
+              <a:rPr lang="it-IT" sz="1800" b="0" strike="noStrike" spc="-1" dirty="0">
+                <a:solidFill>
+                  <a:schemeClr val="dk1"/>
+                </a:solidFill>
+                <a:latin typeface="Calibri"/>
+              </a:rPr>
+              <a:t> </a:t>
+            </a:r>
+            <a:r>
+              <a:rPr lang="it-IT" sz="1800" b="0" strike="noStrike" spc="-1" dirty="0" err="1">
+                <a:solidFill>
+                  <a:schemeClr val="dk1"/>
+                </a:solidFill>
+                <a:latin typeface="Calibri"/>
+              </a:rPr>
+              <a:t>processed</a:t>
+            </a:r>
+            <a:r>
+              <a:rPr lang="it-IT" sz="1800" b="0" strike="noStrike" spc="-1" dirty="0">
+                <a:solidFill>
+                  <a:schemeClr val="dk1"/>
+                </a:solidFill>
+                <a:latin typeface="Calibri"/>
+              </a:rPr>
+              <a:t> by a separate worker </a:t>
+            </a:r>
+            <a:r>
+              <a:rPr lang="it-IT" sz="1800" b="0" strike="noStrike" spc="-1" dirty="0" err="1">
+                <a:solidFill>
+                  <a:schemeClr val="dk1"/>
+                </a:solidFill>
+                <a:latin typeface="Calibri"/>
+              </a:rPr>
+              <a:t>thread</a:t>
+            </a:r>
+            <a:r>
+              <a:rPr lang="it-IT" sz="1800" b="0" strike="noStrike" spc="-1" dirty="0">
+                <a:solidFill>
+                  <a:schemeClr val="dk1"/>
+                </a:solidFill>
+                <a:latin typeface="Calibri"/>
+              </a:rPr>
+              <a:t> </a:t>
+            </a:r>
+            <a:r>
+              <a:rPr lang="it-IT" sz="1800" b="0" strike="noStrike" spc="-1" dirty="0" err="1">
+                <a:solidFill>
+                  <a:schemeClr val="dk1"/>
+                </a:solidFill>
+                <a:latin typeface="Calibri"/>
+              </a:rPr>
+              <a:t>using</a:t>
+            </a:r>
+            <a:r>
+              <a:rPr lang="it-IT" sz="1800" b="0" strike="noStrike" spc="-1" dirty="0">
+                <a:solidFill>
+                  <a:schemeClr val="dk1"/>
+                </a:solidFill>
+                <a:latin typeface="Calibri"/>
+              </a:rPr>
+              <a:t> </a:t>
+            </a:r>
+            <a:r>
+              <a:rPr lang="it-IT" sz="1800" b="0" strike="noStrike" spc="-1" dirty="0" err="1">
+                <a:solidFill>
+                  <a:schemeClr val="dk1"/>
+                </a:solidFill>
+                <a:latin typeface="Calibri"/>
+              </a:rPr>
+              <a:t>std</a:t>
+            </a:r>
+            <a:r>
+              <a:rPr lang="it-IT" sz="1800" b="0" strike="noStrike" spc="-1" dirty="0">
+                <a:solidFill>
+                  <a:schemeClr val="dk1"/>
+                </a:solidFill>
+                <a:latin typeface="Calibri"/>
+              </a:rPr>
+              <a:t>::</a:t>
+            </a:r>
+            <a:r>
+              <a:rPr lang="it-IT" sz="1800" b="0" strike="noStrike" spc="-1" dirty="0" err="1">
+                <a:solidFill>
+                  <a:schemeClr val="dk1"/>
+                </a:solidFill>
+                <a:latin typeface="Calibri"/>
+              </a:rPr>
+              <a:t>async</a:t>
+            </a:r>
+            <a:r>
+              <a:rPr lang="it-IT" sz="1800" b="0" strike="noStrike" spc="-1" dirty="0">
+                <a:solidFill>
+                  <a:schemeClr val="dk1"/>
+                </a:solidFill>
+                <a:latin typeface="Calibri"/>
+              </a:rPr>
+              <a:t>.</a:t>
+            </a:r>
+            <a:endParaRPr lang="en-US" sz="1800" b="0" strike="noStrike" spc="-1" dirty="0">
               <a:solidFill>
                 <a:srgbClr val="000000"/>
               </a:solidFill>
@@ -19454,7 +20318,7 @@
         </p:blipFill>
         <p:spPr>
           <a:xfrm>
-            <a:off x="158760" y="3056760"/>
+            <a:off x="87640" y="3180560"/>
             <a:ext cx="5552280" cy="3331080"/>
           </a:xfrm>
           <a:prstGeom prst="rect">
@@ -19508,7 +20372,7 @@
               </a:lnSpc>
             </a:pPr>
             <a:r>
-              <a:rPr lang="en-US" sz="1800" b="0" strike="noStrike" spc="-1">
+              <a:rPr lang="en-US" sz="1800" b="0" strike="noStrike" spc="-1" dirty="0">
                 <a:solidFill>
                   <a:schemeClr val="dk1"/>
                 </a:solidFill>
@@ -19517,7 +20381,7 @@
               <a:t>Using multiple threads with mutexes to operate on shared data is often counterproductive. The </a:t>
             </a:r>
             <a:r>
-              <a:rPr lang="en-US" sz="1800" b="1" strike="noStrike" spc="-1">
+              <a:rPr lang="en-US" sz="1800" b="1" strike="noStrike" spc="-1" dirty="0">
                 <a:solidFill>
                   <a:schemeClr val="dk1"/>
                 </a:solidFill>
@@ -19526,7 +20390,7 @@
               <a:t>mutexes</a:t>
             </a:r>
             <a:r>
-              <a:rPr lang="en-US" sz="1800" b="0" strike="noStrike" spc="-1">
+              <a:rPr lang="en-US" sz="1800" b="0" strike="noStrike" spc="-1" dirty="0">
                 <a:solidFill>
                   <a:schemeClr val="dk1"/>
                 </a:solidFill>
@@ -19535,7 +20399,7 @@
               <a:t> force the operations to run </a:t>
             </a:r>
             <a:r>
-              <a:rPr lang="en-US" sz="1800" b="1" strike="noStrike" spc="-1">
+              <a:rPr lang="en-US" sz="1800" b="1" strike="noStrike" spc="-1" dirty="0">
                 <a:solidFill>
                   <a:schemeClr val="dk1"/>
                 </a:solidFill>
@@ -19544,7 +20408,7 @@
               <a:t>one after another</a:t>
             </a:r>
             <a:r>
-              <a:rPr lang="en-US" sz="1800" b="0" strike="noStrike" spc="-1">
+              <a:rPr lang="en-US" sz="1800" b="0" strike="noStrike" spc="-1" dirty="0">
                 <a:solidFill>
                   <a:schemeClr val="dk1"/>
                 </a:solidFill>
@@ -19553,7 +20417,7 @@
               <a:t> (serially), which eliminates the speed advantage of using parallel threads. Also, the process of creating and managing the threads adds its own </a:t>
             </a:r>
             <a:r>
-              <a:rPr lang="en-US" sz="1800" b="1" strike="noStrike" spc="-1">
+              <a:rPr lang="en-US" sz="1800" b="1" strike="noStrike" spc="-1" dirty="0">
                 <a:solidFill>
                   <a:schemeClr val="dk1"/>
                 </a:solidFill>
@@ -19562,7 +20426,7 @@
               <a:t>computational overhead</a:t>
             </a:r>
             <a:r>
-              <a:rPr lang="en-US" sz="1800" b="0" strike="noStrike" spc="-1">
+              <a:rPr lang="en-US" sz="1800" b="0" strike="noStrike" spc="-1" dirty="0">
                 <a:solidFill>
                   <a:schemeClr val="dk1"/>
                 </a:solidFill>
@@ -19570,7 +20434,7 @@
               </a:rPr>
               <a:t>, further slowing down the entire process.</a:t>
             </a:r>
-            <a:endParaRPr lang="en-US" sz="1800" b="0" strike="noStrike" spc="-1">
+            <a:endParaRPr lang="en-US" sz="1800" b="0" strike="noStrike" spc="-1" dirty="0">
               <a:solidFill>
                 <a:srgbClr val="000000"/>
               </a:solidFill>
@@ -19706,7 +20570,7 @@
               <a:buNone/>
             </a:pPr>
             <a:r>
-              <a:rPr lang="en-US" sz="3700" b="0" strike="noStrike" spc="-52">
+              <a:rPr lang="en-US" sz="3700" b="0" strike="noStrike" spc="-52" dirty="0">
                 <a:solidFill>
                   <a:schemeClr val="dk1">
                     <a:lumMod val="75000"/>
@@ -19715,9 +20579,33 @@
                 </a:solidFill>
                 <a:latin typeface="Calibri Light"/>
               </a:rPr>
-              <a:t>Parallel (C++) Forward Node Iteator Algorithm, V3 (Final Version) </a:t>
-            </a:r>
-            <a:endParaRPr lang="en-US" sz="3700" b="0" strike="noStrike" spc="-1">
+              <a:t>Parallel (C++) Forward Node </a:t>
+            </a:r>
+            <a:r>
+              <a:rPr lang="en-US" sz="3700" b="0" strike="noStrike" spc="-52" dirty="0" err="1">
+                <a:solidFill>
+                  <a:schemeClr val="dk1">
+                    <a:lumMod val="75000"/>
+                    <a:lumOff val="25000"/>
+                  </a:schemeClr>
+                </a:solidFill>
+                <a:latin typeface="Calibri Light"/>
+              </a:rPr>
+              <a:t>Iteator</a:t>
+            </a:r>
+            <a:r>
+              <a:rPr lang="en-US" sz="3700" b="0" strike="noStrike" spc="-52" dirty="0">
+                <a:solidFill>
+                  <a:schemeClr val="dk1">
+                    <a:lumMod val="75000"/>
+                    <a:lumOff val="25000"/>
+                  </a:schemeClr>
+                </a:solidFill>
+                <a:latin typeface="Calibri Light"/>
+              </a:rPr>
+              <a:t> Algorithm, V3 (Final Version) </a:t>
+            </a:r>
+            <a:endParaRPr lang="en-US" sz="3700" b="0" strike="noStrike" spc="-1" dirty="0">
               <a:solidFill>
                 <a:schemeClr val="dk1"/>
               </a:solidFill>
@@ -19875,19 +20763,43 @@
               </a:spcAft>
             </a:pPr>
             <a:r>
-              <a:rPr lang="en-US" sz="1700" b="0" strike="noStrike" spc="-1">
-                <a:solidFill>
-                  <a:schemeClr val="dk1">
-                    <a:lumMod val="75000"/>
-                    <a:lumOff val="25000"/>
-                  </a:schemeClr>
-                </a:solidFill>
-                <a:latin typeface="Calibri"/>
-              </a:rPr>
-              <a:t>The final version of our algorithm is the most efficient and scalable. Amdahl’s Law states that the speedup of a program from parallelization is limited by the sequential fraction ofthe program. </a:t>
-            </a:r>
-            <a:r>
-              <a:rPr lang="en-US" sz="1700" b="1" strike="noStrike" spc="-1">
+              <a:rPr lang="en-US" sz="1700" b="0" strike="noStrike" spc="-1" dirty="0">
+                <a:solidFill>
+                  <a:schemeClr val="dk1">
+                    <a:lumMod val="75000"/>
+                    <a:lumOff val="25000"/>
+                  </a:schemeClr>
+                </a:solidFill>
+                <a:latin typeface="Calibri"/>
+              </a:rPr>
+              <a:t>The final version of our algorithm is the most efficient and scalable. Amdahl’s Law states that the speedup of a program from parallelization is limited by the sequential fraction </a:t>
+            </a:r>
+            <a:r>
+              <a:rPr lang="en-US" sz="1700" b="0" strike="noStrike" spc="-1" dirty="0" err="1">
+                <a:solidFill>
+                  <a:schemeClr val="dk1">
+                    <a:lumMod val="75000"/>
+                    <a:lumOff val="25000"/>
+                  </a:schemeClr>
+                </a:solidFill>
+                <a:latin typeface="Calibri"/>
+              </a:rPr>
+              <a:t>ofthe</a:t>
+            </a:r>
+            <a:r>
+              <a:rPr lang="en-US" sz="1700" b="0" strike="noStrike" spc="-1" dirty="0">
+                <a:solidFill>
+                  <a:schemeClr val="dk1">
+                    <a:lumMod val="75000"/>
+                    <a:lumOff val="25000"/>
+                  </a:schemeClr>
+                </a:solidFill>
+                <a:latin typeface="Calibri"/>
+              </a:rPr>
+              <a:t> program. </a:t>
+            </a:r>
+            <a:r>
+              <a:rPr lang="en-US" sz="1700" b="1" strike="noStrike" spc="-1" dirty="0">
                 <a:solidFill>
                   <a:schemeClr val="dk1">
                     <a:lumMod val="75000"/>
@@ -19898,7 +20810,7 @@
               </a:rPr>
               <a:t>The new algorithm has a much smaller sequential fraction.</a:t>
             </a:r>
-            <a:endParaRPr lang="en-US" sz="1700" b="0" strike="noStrike" spc="-1">
+            <a:endParaRPr lang="en-US" sz="1700" b="0" strike="noStrike" spc="-1" dirty="0">
               <a:solidFill>
                 <a:srgbClr val="000000"/>
               </a:solidFill>
@@ -19915,19 +20827,43 @@
               </a:spcAft>
             </a:pPr>
             <a:r>
-              <a:rPr lang="en-US" sz="1700" b="0" strike="noStrike" spc="-1">
-                <a:solidFill>
-                  <a:schemeClr val="dk1">
-                    <a:lumMod val="75000"/>
-                    <a:lumOff val="25000"/>
-                  </a:schemeClr>
-                </a:solidFill>
-                <a:latin typeface="Calibri"/>
-              </a:rPr>
-              <a:t>We resorted to C++ std::async tasks, and </a:t>
-            </a:r>
-            <a:r>
-              <a:rPr lang="en-US" sz="1700" b="1" strike="noStrike" spc="-1">
+              <a:rPr lang="en-US" sz="1700" b="0" strike="noStrike" spc="-1" dirty="0">
+                <a:solidFill>
+                  <a:schemeClr val="dk1">
+                    <a:lumMod val="75000"/>
+                    <a:lumOff val="25000"/>
+                  </a:schemeClr>
+                </a:solidFill>
+                <a:latin typeface="Calibri"/>
+              </a:rPr>
+              <a:t>We resorted to C++ </a:t>
+            </a:r>
+            <a:r>
+              <a:rPr lang="en-US" sz="1700" b="1" strike="noStrike" spc="-1" dirty="0">
+                <a:solidFill>
+                  <a:schemeClr val="dk1">
+                    <a:lumMod val="75000"/>
+                    <a:lumOff val="25000"/>
+                  </a:schemeClr>
+                </a:solidFill>
+                <a:latin typeface="Calibri"/>
+              </a:rPr>
+              <a:t>std::async tasks</a:t>
+            </a:r>
+            <a:r>
+              <a:rPr lang="en-US" sz="1700" b="0" strike="noStrike" spc="-1" dirty="0">
+                <a:solidFill>
+                  <a:schemeClr val="dk1">
+                    <a:lumMod val="75000"/>
+                    <a:lumOff val="25000"/>
+                  </a:schemeClr>
+                </a:solidFill>
+                <a:latin typeface="Calibri"/>
+              </a:rPr>
+              <a:t>, and </a:t>
+            </a:r>
+            <a:r>
+              <a:rPr lang="en-US" sz="1700" b="1" strike="noStrike" spc="-1" dirty="0">
                 <a:solidFill>
                   <a:schemeClr val="dk1">
                     <a:lumMod val="75000"/>
@@ -19939,19 +20875,79 @@
               <a:t>thread-local counts</a:t>
             </a:r>
             <a:r>
-              <a:rPr lang="en-US" sz="1700" b="0" strike="noStrike" spc="-1">
-                <a:solidFill>
-                  <a:schemeClr val="dk1">
-                    <a:lumMod val="75000"/>
-                    <a:lumOff val="25000"/>
-                  </a:schemeClr>
-                </a:solidFill>
-                <a:latin typeface="Calibri"/>
-              </a:rPr>
-              <a:t> were used to eliminate contention between them (mutexes not needed anymore). The core algorithm was also rewritten using std::unordered_set, which dramatically improved data lookup speeds from O(logN) to an average of </a:t>
-            </a:r>
-            <a:r>
-              <a:rPr lang="en-US" sz="1700" b="1" strike="noStrike" spc="-1">
+              <a:rPr lang="en-US" sz="1700" b="0" strike="noStrike" spc="-1" dirty="0">
+                <a:solidFill>
+                  <a:schemeClr val="dk1">
+                    <a:lumMod val="75000"/>
+                    <a:lumOff val="25000"/>
+                  </a:schemeClr>
+                </a:solidFill>
+                <a:latin typeface="Calibri"/>
+              </a:rPr>
+              <a:t> were used to eliminate contention between them (mutexes not needed anymore). The core algorithm was also rewritten using </a:t>
+            </a:r>
+            <a:r>
+              <a:rPr lang="en-US" sz="1700" b="1" strike="noStrike" spc="-1" dirty="0">
+                <a:solidFill>
+                  <a:schemeClr val="dk1">
+                    <a:lumMod val="75000"/>
+                    <a:lumOff val="25000"/>
+                  </a:schemeClr>
+                </a:solidFill>
+                <a:latin typeface="Calibri"/>
+              </a:rPr>
+              <a:t>std::</a:t>
+            </a:r>
+            <a:r>
+              <a:rPr lang="en-US" sz="1700" b="1" strike="noStrike" spc="-1" dirty="0" err="1">
+                <a:solidFill>
+                  <a:schemeClr val="dk1">
+                    <a:lumMod val="75000"/>
+                    <a:lumOff val="25000"/>
+                  </a:schemeClr>
+                </a:solidFill>
+                <a:latin typeface="Calibri"/>
+              </a:rPr>
+              <a:t>unordered_set</a:t>
+            </a:r>
+            <a:r>
+              <a:rPr lang="en-US" sz="1700" b="0" strike="noStrike" spc="-1" dirty="0">
+                <a:solidFill>
+                  <a:schemeClr val="dk1">
+                    <a:lumMod val="75000"/>
+                    <a:lumOff val="25000"/>
+                  </a:schemeClr>
+                </a:solidFill>
+                <a:latin typeface="Calibri"/>
+              </a:rPr>
+              <a:t>, which dramatically improved data lookup speeds from O(</a:t>
+            </a:r>
+            <a:r>
+              <a:rPr lang="en-US" sz="1700" b="0" strike="noStrike" spc="-1" dirty="0" err="1">
+                <a:solidFill>
+                  <a:schemeClr val="dk1">
+                    <a:lumMod val="75000"/>
+                    <a:lumOff val="25000"/>
+                  </a:schemeClr>
+                </a:solidFill>
+                <a:latin typeface="Calibri"/>
+              </a:rPr>
+              <a:t>logN</a:t>
+            </a:r>
+            <a:r>
+              <a:rPr lang="en-US" sz="1700" b="0" strike="noStrike" spc="-1" dirty="0">
+                <a:solidFill>
+                  <a:schemeClr val="dk1">
+                    <a:lumMod val="75000"/>
+                    <a:lumOff val="25000"/>
+                  </a:schemeClr>
+                </a:solidFill>
+                <a:latin typeface="Calibri"/>
+              </a:rPr>
+              <a:t>) to an average of </a:t>
+            </a:r>
+            <a:r>
+              <a:rPr lang="en-US" sz="1700" b="1" strike="noStrike" spc="-1" dirty="0">
                 <a:solidFill>
                   <a:schemeClr val="dk1">
                     <a:lumMod val="75000"/>
@@ -19963,7 +20959,7 @@
               <a:t>O(1)</a:t>
             </a:r>
             <a:r>
-              <a:rPr lang="en-US" sz="1700" b="0" strike="noStrike" spc="-1">
+              <a:rPr lang="en-US" sz="1700" b="0" strike="noStrike" spc="-1" dirty="0">
                 <a:solidFill>
                   <a:schemeClr val="dk1">
                     <a:lumMod val="75000"/>
@@ -19974,7 +20970,7 @@
               </a:rPr>
               <a:t> and made memory usage more efficient.</a:t>
             </a:r>
-            <a:endParaRPr lang="en-US" sz="1700" b="0" strike="noStrike" spc="-1">
+            <a:endParaRPr lang="en-US" sz="1700" b="0" strike="noStrike" spc="-1" dirty="0">
               <a:solidFill>
                 <a:srgbClr val="000000"/>
               </a:solidFill>
@@ -19991,19 +20987,43 @@
               </a:spcAft>
             </a:pPr>
             <a:r>
-              <a:rPr lang="en-US" sz="1700" b="0" strike="noStrike" spc="-1">
-                <a:solidFill>
-                  <a:schemeClr val="dk1">
-                    <a:lumMod val="75000"/>
-                    <a:lumOff val="25000"/>
-                  </a:schemeClr>
-                </a:solidFill>
-                <a:latin typeface="Calibri"/>
-              </a:rPr>
-              <a:t>We immediately see the scalability issues are solved: if we increase the thread number, the execution time always gets lower. This also represents a substantial performance gain over the V2 version, with a time reduction of approximately </a:t>
-            </a:r>
-            <a:r>
-              <a:rPr lang="en-US" sz="1700" b="1" strike="noStrike" spc="-1">
+              <a:rPr lang="en-US" sz="1700" b="0" strike="noStrike" spc="-1" dirty="0">
+                <a:solidFill>
+                  <a:schemeClr val="dk1">
+                    <a:lumMod val="75000"/>
+                    <a:lumOff val="25000"/>
+                  </a:schemeClr>
+                </a:solidFill>
+                <a:latin typeface="Calibri"/>
+              </a:rPr>
+              <a:t>We immediately see the </a:t>
+            </a:r>
+            <a:r>
+              <a:rPr lang="en-US" sz="1700" b="1" strike="noStrike" spc="-1" dirty="0">
+                <a:solidFill>
+                  <a:schemeClr val="dk1">
+                    <a:lumMod val="75000"/>
+                    <a:lumOff val="25000"/>
+                  </a:schemeClr>
+                </a:solidFill>
+                <a:latin typeface="Calibri"/>
+              </a:rPr>
+              <a:t>scalability issues are solved</a:t>
+            </a:r>
+            <a:r>
+              <a:rPr lang="en-US" sz="1700" b="0" strike="noStrike" spc="-1" dirty="0">
+                <a:solidFill>
+                  <a:schemeClr val="dk1">
+                    <a:lumMod val="75000"/>
+                    <a:lumOff val="25000"/>
+                  </a:schemeClr>
+                </a:solidFill>
+                <a:latin typeface="Calibri"/>
+              </a:rPr>
+              <a:t>: if we increase the thread number, the execution time always gets lower. This also represents a substantial performance gain over the V2 version, with a time reduction of approximately </a:t>
+            </a:r>
+            <a:r>
+              <a:rPr lang="en-US" sz="1700" b="1" strike="noStrike" spc="-1" dirty="0">
                 <a:solidFill>
                   <a:schemeClr val="dk1">
                     <a:lumMod val="75000"/>
@@ -20015,7 +21035,7 @@
               <a:t>82-89%</a:t>
             </a:r>
             <a:r>
-              <a:rPr lang="en-US" sz="1700" b="0" strike="noStrike" spc="-1">
+              <a:rPr lang="en-US" sz="1700" b="0" strike="noStrike" spc="-1" dirty="0">
                 <a:solidFill>
                   <a:schemeClr val="dk1">
                     <a:lumMod val="75000"/>
@@ -20026,7 +21046,7 @@
               </a:rPr>
               <a:t> observed across all thread configurations for a 10k node graph.</a:t>
             </a:r>
-            <a:endParaRPr lang="en-US" sz="1700" b="0" strike="noStrike" spc="-1">
+            <a:endParaRPr lang="en-US" sz="1700" b="0" strike="noStrike" spc="-1" dirty="0">
               <a:solidFill>
                 <a:srgbClr val="000000"/>
               </a:solidFill>

</xml_diff>

<commit_message>
feat: added details in slides for parallel node v3
</commit_message>
<xml_diff>
--- a/presentation.pptx
+++ b/presentation.pptx
@@ -20894,7 +20894,31 @@
                 </a:solidFill>
                 <a:latin typeface="Calibri"/>
               </a:rPr>
-              <a:t> were used to eliminate contention between them (mutexes not needed anymore). The core algorithm was also rewritten using </a:t>
+              <a:t> were used to eliminate contention between them (mutexes not needed anymore). Each worker processes a chunk of nodes. The core algorithm was also rewritten using a </a:t>
+            </a:r>
+            <a:r>
+              <a:rPr lang="en-US" sz="1700" b="1" strike="noStrike" spc="-1" dirty="0">
+                <a:solidFill>
+                  <a:schemeClr val="dk1">
+                    <a:lumMod val="75000"/>
+                    <a:lumOff val="25000"/>
+                  </a:schemeClr>
+                </a:solidFill>
+                <a:latin typeface="Calibri"/>
+              </a:rPr>
+              <a:t>Merge Like approach</a:t>
+            </a:r>
+            <a:r>
+              <a:rPr lang="en-US" sz="1700" b="0" strike="noStrike" spc="-1" dirty="0">
+                <a:solidFill>
+                  <a:schemeClr val="dk1">
+                    <a:lumMod val="75000"/>
+                    <a:lumOff val="25000"/>
+                  </a:schemeClr>
+                </a:solidFill>
+                <a:latin typeface="Calibri"/>
+              </a:rPr>
+              <a:t> for fast intersection of the two neighbors vectors. </a:t>
             </a:r>
             <a:r>
               <a:rPr lang="en-US" sz="1700" b="1" strike="noStrike" spc="-1" dirty="0">

</xml_diff>